<commit_message>
Talk deck: four detailed findings in the 5-minute talk, everything else on extra pages for Q&A
PROPOSAL_slides.pptx: title, problem, findings 1-4 (each with its example and numbers), the recipe,
"Thank you: questions?" with the takeaway and an index of 9 extra pages (results, small models, reuse,
proofs, published methods, limits, all findings, words). Each full-deck slide is a function in
poc/make_slides.js, so both decks share the same slides.

Co-Authored-By: Claude Opus 5.5 (1M context) <noreply@anthropic.com>
</commit_message>
<xml_diff>
--- a/PROPOSAL_slides_full.pptx
+++ b/PROPOSAL_slides_full.pptx
@@ -121,14 +121,14 @@
   <p:extLst>
     <p:ext uri="{521415D9-36F7-43E2-AB2F-B90AF26B5E84}">
       <p14:sectionLst xmlns:p14="http://schemas.microsoft.com/office/powerpoint/2010/main">
-        <p14:section name="Problem" id="{3d790067-d4d3-b332-5787-d953b87df4d4}">
+        <p14:section name="Problem" id="{ffd27bd6-821c-32a1-668f-1fd9027126d4}">
           <p14:sldIdLst>
             <p14:sldId id="256"/>
             <p14:sldId id="257"/>
             <p14:sldId id="258"/>
           </p14:sldIdLst>
         </p14:section>
-        <p14:section name="Findings" id="{f16bd605-410e-4659-8a10-2478132b3ebf}">
+        <p14:section name="Findings" id="{34169f70-2db4-f9bc-cf96-2fc70b506923}">
           <p14:sldIdLst>
             <p14:sldId id="259"/>
             <p14:sldId id="260"/>
@@ -140,14 +140,14 @@
             <p14:sldId id="266"/>
           </p14:sldIdLst>
         </p14:section>
-        <p14:section name="Method" id="{37261370-4065-f0d5-7704-12c1e8f12f8c}">
+        <p14:section name="Method" id="{e662cfa1-01ec-094c-5443-fdc624230d33}">
           <p14:sldIdLst>
             <p14:sldId id="267"/>
             <p14:sldId id="268"/>
             <p14:sldId id="269"/>
           </p14:sldIdLst>
         </p14:section>
-        <p14:section name="Next" id="{109c73b0-2bcf-7ae0-9279-c92cb6e0dd24}">
+        <p14:section name="Next" id="{12c3fdc7-4fee-5747-7309-09088e71ee23}">
           <p14:sldIdLst>
             <p14:sldId id="270"/>
           </p14:sldIdLst>

</xml_diff>

<commit_message>
Method explained step by step: one real problem through the recipe, and the free check per problem type
New slide "How the recipe runs on one problem" (talk and full deck): mine the fact once, program +
fact (316 tokens), a second version agrees (+312), no thinking needed (thinking alone 5.3k), reuse;
with a table of what the free check is for contest, geometry, routing and word problems. The same
table is in PROPOSAL / PROPOSAL_ko section 4. The extra-page index on the questions slide is computed.

Co-Authored-By: Claude Opus 5.5 (1M context) <noreply@anthropic.com>
</commit_message>
<xml_diff>
--- a/PROPOSAL_slides_full.pptx
+++ b/PROPOSAL_slides_full.pptx
@@ -20,9 +20,10 @@
     <p:sldId id="268" r:id="rId14"/>
     <p:sldId id="269" r:id="rId15"/>
     <p:sldId id="270" r:id="rId16"/>
+    <p:sldId id="271" r:id="rId17"/>
   </p:sldIdLst>
   <p:notesMasterIdLst>
-    <p:notesMasterId r:id="rId17"/>
+    <p:notesMasterId r:id="rId18"/>
   </p:notesMasterIdLst>
   <p:sldSz cx="12192000" cy="6858000"/>
   <p:notesSz cx="6858000" cy="12192000"/>
@@ -121,14 +122,14 @@
   <p:extLst>
     <p:ext uri="{521415D9-36F7-43E2-AB2F-B90AF26B5E84}">
       <p14:sectionLst xmlns:p14="http://schemas.microsoft.com/office/powerpoint/2010/main">
-        <p14:section name="Problem" id="{ffd27bd6-821c-32a1-668f-1fd9027126d4}">
+        <p14:section name="Problem" id="{8e692120-ab03-75d1-2aaf-b34335fbae38}">
           <p14:sldIdLst>
             <p14:sldId id="256"/>
             <p14:sldId id="257"/>
             <p14:sldId id="258"/>
           </p14:sldIdLst>
         </p14:section>
-        <p14:section name="Findings" id="{34169f70-2db4-f9bc-cf96-2fc70b506923}">
+        <p14:section name="Findings" id="{cd3fec84-dbda-37f3-64e4-ff43384eaf96}">
           <p14:sldIdLst>
             <p14:sldId id="259"/>
             <p14:sldId id="260"/>
@@ -140,16 +141,17 @@
             <p14:sldId id="266"/>
           </p14:sldIdLst>
         </p14:section>
-        <p14:section name="Method" id="{e662cfa1-01ec-094c-5443-fdc624230d33}">
+        <p14:section name="Method" id="{be9fbc08-b3f3-6690-8dee-c60a479cd1cf}">
           <p14:sldIdLst>
             <p14:sldId id="267"/>
             <p14:sldId id="268"/>
             <p14:sldId id="269"/>
+            <p14:sldId id="270"/>
           </p14:sldIdLst>
         </p14:section>
-        <p14:section name="Next" id="{12c3fdc7-4fee-5747-7309-09088e71ee23}">
+        <p14:section name="Next" id="{96883ec0-791b-92cb-27a0-301be7bf39ef}">
           <p14:sldIdLst>
-            <p14:sldId id="270"/>
+            <p14:sldId id="271"/>
           </p14:sldIdLst>
         </p14:section>
       </p14:sectionLst>
@@ -1728,7 +1730,7 @@
           <a:p>
             <a:r>
               <a:rPr lang="en-US" dirty="0"/>
-              <a:t>Right panel (MODEL, 63 model x task x seed cells; 0.5 points per 1k tokens): fact first, think on failure is the best fixed default (1.4 points from each cell's best policy; always thinking 8.4); choosing among 4 policies on 30 labelled problems of the new task cuts it to 0.6 (MAMO: 0.8-1.4). U1 / U1r / U2 (pre-registered). Qwen3-8B, Qwen3-32B and Qwen3.6 on the generated geometry and optimization suites, 624 problems, cure seed 1 shown; the order is the same on seeds 2 and 3. Thinking on the hardest-looking problems (difficulty-based allocation, as in compute-optimal scaling work) is even below thinking whenever the check fails. Giving the fact first and thinking only when the check fails is the most accurate and uses fewer tokens than any thinking policy; with automatically retrieved facts (BM25) it still reaches 84%.</a:t>
+              <a:t>Real run (Qwen3-8B, MAMO easy-189). Step 0 happens once per kind of problem: the model's own shortest program for another benchmark problem that passed the label-free check becomes the fact. Steps 1-2: with it the program calls solver.Minimize(10*x + 15*y + 20*z) and prints 20000 (316 tokens); without it, it calls Objective().Minimize() and crashes. Step 3: a second program (312 tokens) also prints 20000, so they agree. Step 4: thinking is used only when the two disagree or a program crashes; here it is skipped (thinking alone took 5,323 tokens). Step 5: if the same kind of problem comes back with new data, the checked program is reused. Table: what the free check is in each domain; none needs the answer.</a:t>
             </a:r>
             <a:endParaRPr lang="en-US" dirty="0"/>
           </a:p>
@@ -1816,7 +1818,7 @@
           <a:p>
             <a:r>
               <a:rPr lang="en-US" dirty="0"/>
-              <a:t>All baselines were run by us on our benchmarks. Models: U1 policies over Qwen3-8B / Qwen3-32B / Qwen3.6 (624 problems); contest geometry gpt-oss-120b (311); selection Qwen3-8B (300 geometry instances, 3 candidates); documentation Qwen3-32B on CVRP; tools Qwen3-32B on 5 geometry tasks; daily routing gpt-oss-120b on 48 held-out Solomon instances. Tokens are output tokens per problem. More rows (MBR-exec, majority vote, DeepConf, Self-Debugging, Mixture-of-Thought cascade, BM25 retrieval) are in PROPOSAL.md section 7.</a:t>
+              <a:t>Right panel (MODEL, 63 model x task x seed cells; 0.5 points per 1k tokens): fact first, think on failure is the best fixed default (1.4 points from each cell's best policy; always thinking 8.4); choosing among 4 policies on 30 labelled problems of the new task cuts it to 0.6 (MAMO: 0.8-1.4). U1 / U1r / U2 (pre-registered). Qwen3-8B, Qwen3-32B and Qwen3.6 on the generated geometry and optimization suites, 624 problems, cure seed 1 shown; the order is the same on seeds 2 and 3. Thinking on the hardest-looking problems (difficulty-based allocation, as in compute-optimal scaling work) is even below thinking whenever the check fails. Giving the fact first and thinking only when the check fails is the most accurate and uses fewer tokens than any thinking policy; with automatically retrieved facts (BM25) it still reaches 84%.</a:t>
             </a:r>
             <a:endParaRPr lang="en-US" dirty="0"/>
           </a:p>
@@ -1904,7 +1906,7 @@
           <a:p>
             <a:r>
               <a:rPr lang="en-US" dirty="0"/>
-              <a:t>Updated 2026-10-19. Done since the last version: contest geometry and competition math on 24 GB GPUs, Qwen3.6 with the model card settings (headline unchanged), automatic facts and the held-out MAMO test, the policy model, proofs. Older notes: for Lean proofs an invented lemma stands for a missing proof step (similar-name feedback fixes 2.7%, a fresh try 3.2%); for PopQA thinking adds 1.8-5 points at 70-200 times the tokens, only for well-known facts. Checks leak, which caps every policy. Facts were hand-written; BM25 retrieval recovers most of the gain. Next: SIZE-CC (gpt-oss-20b on contest geometry with check-gated escalation), X1-SIZE (competition math for Qwen3-4B/8B/14B), automatic facts, a closed API model, final report.</a:t>
+              <a:t>All baselines were run by us on our benchmarks. Models: U1 policies over Qwen3-8B / Qwen3-32B / Qwen3.6 (624 problems); contest geometry gpt-oss-120b (311); selection Qwen3-8B (300 geometry instances, 3 candidates); documentation Qwen3-32B on CVRP; tools Qwen3-32B on 5 geometry tasks; daily routing gpt-oss-120b on 48 held-out Solomon instances. Tokens are output tokens per problem. More rows (MBR-exec, majority vote, DeepConf, Self-Debugging, Mixture-of-Thought cascade, BM25 retrieval) are in PROPOSAL.md section 7.</a:t>
             </a:r>
             <a:endParaRPr lang="en-US" dirty="0"/>
           </a:p>
@@ -1928,6 +1930,94 @@
             <a:fld id="{F7021451-1387-4CA6-816F-3879F97B5CBC}" type="slidenum">
               <a:rPr lang="en-US"/>
               <a:t>15</a:t>
+            </a:fld>
+            <a:endParaRPr lang="en-US"/>
+          </a:p>
+        </p:txBody>
+      </p:sp>
+    </p:spTree>
+    <p:extLst>
+      <p:ext uri="{BB962C8B-B14F-4D97-AF65-F5344CB8AC3E}">
+        <p14:creationId xmlns:p14="http://schemas.microsoft.com/office/powerpoint/2010/main" val="1024086991"/>
+      </p:ext>
+    </p:extLst>
+  </p:cSld>
+  <p:clrMapOvr>
+    <a:masterClrMapping/>
+  </p:clrMapOvr>
+</p:notes>
+</file>
+
+<file path=ppt/notesSlides/notesSlide16.xml><?xml version="1.0" encoding="utf-8"?>
+<p:notes xmlns:a="http://schemas.openxmlformats.org/drawingml/2006/main" xmlns:r="http://schemas.openxmlformats.org/officeDocument/2006/relationships" xmlns:p="http://schemas.openxmlformats.org/presentationml/2006/main">
+  <p:cSld>
+    <p:spTree>
+      <p:nvGrpSpPr>
+        <p:cNvPr id="1" name=""/>
+        <p:cNvGrpSpPr/>
+        <p:nvPr/>
+      </p:nvGrpSpPr>
+      <p:grpSpPr>
+        <a:xfrm>
+          <a:off x="0" y="0"/>
+          <a:ext cx="0" cy="0"/>
+          <a:chOff x="0" y="0"/>
+          <a:chExt cx="0" cy="0"/>
+        </a:xfrm>
+      </p:grpSpPr>
+      <p:sp>
+        <p:nvSpPr>
+          <p:cNvPr id="2" name="Slide Image Placeholder 1"/>
+          <p:cNvSpPr>
+            <a:spLocks noGrp="1" noRot="1" noChangeAspect="1"/>
+          </p:cNvSpPr>
+          <p:nvPr>
+            <p:ph type="sldImg"/>
+          </p:nvPr>
+        </p:nvSpPr>
+        <p:spPr/>
+      </p:sp>
+      <p:sp>
+        <p:nvSpPr>
+          <p:cNvPr id="3" name="Notes Placeholder 2"/>
+          <p:cNvSpPr>
+            <a:spLocks noGrp="1"/>
+          </p:cNvSpPr>
+          <p:nvPr>
+            <p:ph type="body" idx="1"/>
+          </p:nvPr>
+        </p:nvSpPr>
+        <p:spPr/>
+        <p:txBody>
+          <a:bodyPr/>
+          <a:lstStyle/>
+          <a:p>
+            <a:r>
+              <a:rPr lang="en-US" dirty="0"/>
+              <a:t>Updated 2026-10-19. Done since the last version: contest geometry and competition math on 24 GB GPUs, Qwen3.6 with the model card settings (headline unchanged), automatic facts and the held-out MAMO test, the policy model, proofs. Older notes: for Lean proofs an invented lemma stands for a missing proof step (similar-name feedback fixes 2.7%, a fresh try 3.2%); for PopQA thinking adds 1.8-5 points at 70-200 times the tokens, only for well-known facts. Checks leak, which caps every policy. Facts were hand-written; BM25 retrieval recovers most of the gain. Next: SIZE-CC (gpt-oss-20b on contest geometry with check-gated escalation), X1-SIZE (competition math for Qwen3-4B/8B/14B), automatic facts, a closed API model, final report.</a:t>
+            </a:r>
+            <a:endParaRPr lang="en-US" dirty="0"/>
+          </a:p>
+        </p:txBody>
+      </p:sp>
+      <p:sp>
+        <p:nvSpPr>
+          <p:cNvPr id="4" name="Slide Number Placeholder 3"/>
+          <p:cNvSpPr>
+            <a:spLocks noGrp="1"/>
+          </p:cNvSpPr>
+          <p:nvPr>
+            <p:ph type="sldNum" sz="quarter" idx="10"/>
+          </p:nvPr>
+        </p:nvSpPr>
+        <p:spPr/>
+        <p:txBody>
+          <a:bodyPr/>
+          <a:lstStyle/>
+          <a:p>
+            <a:fld id="{F7021451-1387-4CA6-816F-3879F97B5CBC}" type="slidenum">
+              <a:rPr lang="en-US"/>
+              <a:t>16</a:t>
             </a:fld>
             <a:endParaRPr lang="en-US"/>
           </a:p>
@@ -6351,7 +6441,7 @@
                   <a:schemeClr val="tx1"/>
                 </a:solidFill>
               </a:rPr>
-              <a:t>All together: facts first, think only on failure</a:t>
+              <a:t>How the recipe runs on one problem</a:t>
             </a:r>
             <a:endParaRPr lang="en-US" sz="3600" dirty="0"/>
           </a:p>
@@ -6365,8 +6455,8 @@
         </p:nvSpPr>
         <p:spPr>
           <a:xfrm>
-            <a:off x="548640" y="1234440"/>
-            <a:ext cx="11064240" cy="411480"/>
+            <a:off x="548640" y="1188720"/>
+            <a:ext cx="11064240" cy="365760"/>
           </a:xfrm>
           <a:prstGeom prst="rect">
             <a:avLst/>
@@ -6382,48 +6472,12 @@
               <a:buNone/>
             </a:pPr>
             <a:r>
-              <a:rPr lang="en-US" sz="1800" dirty="0">
+              <a:rPr lang="en-US" sz="1600" dirty="0">
                 <a:solidFill>
                   <a:schemeClr val="tx1"/>
                 </a:solidFill>
               </a:rPr>
-              <a:t>Same 624 geometry and optimization problems, 3 models: % solved · tokens per problem</a:t>
-            </a:r>
-            <a:endParaRPr lang="en-US" sz="1800" dirty="0"/>
-          </a:p>
-        </p:txBody>
-      </p:sp>
-      <p:sp>
-        <p:nvSpPr>
-          <p:cNvPr id="4" name="Text 2"/>
-          <p:cNvSpPr txBox="1"/>
-          <p:nvPr/>
-        </p:nvSpPr>
-        <p:spPr>
-          <a:xfrm>
-            <a:off x="548640" y="1783080"/>
-            <a:ext cx="2651760" cy="453542"/>
-          </a:xfrm>
-          <a:prstGeom prst="rect">
-            <a:avLst/>
-          </a:prstGeom>
-          <a:noFill/>
-          <a:ln/>
-        </p:spPr>
-        <p:txBody>
-          <a:bodyPr wrap="square" lIns="0" tIns="0" rIns="0" bIns="0" rtlCol="0" anchor="ctr"/>
-          <a:lstStyle/>
-          <a:p>
-            <a:pPr algn="r" indent="0" marL="0">
-              <a:buNone/>
-            </a:pPr>
-            <a:r>
-              <a:rPr lang="en-US" sz="1600" dirty="0">
-                <a:solidFill>
-                  <a:schemeClr val="tx1"/>
-                </a:solidFill>
-              </a:rPr>
-              <a:t>First program, no help</a:t>
+              <a:t>Qwen3-8B on a MAMO word problem: products X, Y, Z cost $10, $15, $20 under three limits; minimum cost? (answer 20000)</a:t>
             </a:r>
             <a:endParaRPr lang="en-US" sz="1600" dirty="0"/>
           </a:p>
@@ -6431,24 +6485,26 @@
       </p:sp>
       <p:sp>
         <p:nvSpPr>
-          <p:cNvPr id="5" name="bar First program, no help"/>
-          <p:cNvSpPr/>
-          <p:nvPr/>
-        </p:nvSpPr>
-        <p:spPr>
-          <a:xfrm>
-            <a:off x="3337560" y="1868119"/>
-            <a:ext cx="1958645" cy="283464"/>
-          </a:xfrm>
-          <a:prstGeom prst="rect">
-            <a:avLst/>
+          <p:cNvPr id="4" name="walk 0"/>
+          <p:cNvSpPr/>
+          <p:nvPr/>
+        </p:nvSpPr>
+        <p:spPr>
+          <a:xfrm>
+            <a:off x="548640" y="1691640"/>
+            <a:ext cx="2514600" cy="1920240"/>
+          </a:xfrm>
+          <a:prstGeom prst="roundRect">
+            <a:avLst>
+              <a:gd name="adj" fmla="val 3810"/>
+            </a:avLst>
           </a:prstGeom>
           <a:solidFill>
-            <a:srgbClr val="A5A5A5"/>
+            <a:srgbClr val="E2F0D9"/>
           </a:solidFill>
-          <a:ln w="6350">
+          <a:ln w="9525">
             <a:solidFill>
-              <a:srgbClr val="A5A5A5"/>
+              <a:srgbClr val="BFBFBF"/>
             </a:solidFill>
             <a:prstDash val="solid"/>
           </a:ln>
@@ -6456,482 +6512,22 @@
       </p:sp>
       <p:sp>
         <p:nvSpPr>
-          <p:cNvPr id="6" name="Text 4"/>
-          <p:cNvSpPr txBox="1"/>
-          <p:nvPr/>
-        </p:nvSpPr>
-        <p:spPr>
-          <a:xfrm>
-            <a:off x="5387645" y="1783080"/>
-            <a:ext cx="1554480" cy="453542"/>
-          </a:xfrm>
-          <a:prstGeom prst="rect">
-            <a:avLst/>
-          </a:prstGeom>
-          <a:noFill/>
-          <a:ln/>
-        </p:spPr>
-        <p:txBody>
-          <a:bodyPr wrap="square" lIns="0" tIns="0" rIns="0" bIns="0" rtlCol="0" anchor="ctr"/>
-          <a:lstStyle/>
-          <a:p>
-            <a:pPr indent="0" marL="0">
-              <a:buNone/>
-            </a:pPr>
-            <a:r>
-              <a:rPr lang="en-US" sz="1800" b="1" dirty="0">
-                <a:solidFill>
-                  <a:srgbClr val="A5A5A5"/>
-                </a:solidFill>
-              </a:rPr>
-              <a:t>63% · 0.7k</a:t>
-            </a:r>
-            <a:endParaRPr lang="en-US" sz="1800" dirty="0"/>
-          </a:p>
-        </p:txBody>
-      </p:sp>
-      <p:sp>
-        <p:nvSpPr>
-          <p:cNvPr id="7" name="Text 5"/>
-          <p:cNvSpPr txBox="1"/>
-          <p:nvPr/>
-        </p:nvSpPr>
-        <p:spPr>
-          <a:xfrm>
-            <a:off x="548640" y="2350008"/>
-            <a:ext cx="2651760" cy="453542"/>
-          </a:xfrm>
-          <a:prstGeom prst="rect">
-            <a:avLst/>
-          </a:prstGeom>
-          <a:noFill/>
-          <a:ln/>
-        </p:spPr>
-        <p:txBody>
-          <a:bodyPr wrap="square" lIns="0" tIns="0" rIns="0" bIns="0" rtlCol="0" anchor="ctr"/>
-          <a:lstStyle/>
-          <a:p>
-            <a:pPr algn="r" indent="0" marL="0">
-              <a:buNone/>
-            </a:pPr>
-            <a:r>
-              <a:rPr lang="en-US" sz="1600" dirty="0">
-                <a:solidFill>
-                  <a:schemeClr val="tx1"/>
-                </a:solidFill>
-              </a:rPr>
-              <a:t>Think on hardest-looking</a:t>
-            </a:r>
-            <a:endParaRPr lang="en-US" sz="1600" dirty="0"/>
-          </a:p>
-        </p:txBody>
-      </p:sp>
-      <p:sp>
-        <p:nvSpPr>
-          <p:cNvPr id="8" name="bar Think on hardest-looking"/>
-          <p:cNvSpPr/>
-          <p:nvPr/>
-        </p:nvSpPr>
-        <p:spPr>
-          <a:xfrm>
-            <a:off x="3337560" y="2435047"/>
-            <a:ext cx="2300630" cy="283464"/>
-          </a:xfrm>
-          <a:prstGeom prst="rect">
-            <a:avLst/>
-          </a:prstGeom>
-          <a:solidFill>
-            <a:srgbClr val="7F7F7F"/>
-          </a:solidFill>
-          <a:ln w="6350">
-            <a:solidFill>
-              <a:srgbClr val="7F7F7F"/>
-            </a:solidFill>
-            <a:prstDash val="solid"/>
-          </a:ln>
-        </p:spPr>
-      </p:sp>
-      <p:sp>
-        <p:nvSpPr>
-          <p:cNvPr id="9" name="Text 7"/>
-          <p:cNvSpPr txBox="1"/>
-          <p:nvPr/>
-        </p:nvSpPr>
-        <p:spPr>
-          <a:xfrm>
-            <a:off x="5729630" y="2350008"/>
-            <a:ext cx="1554480" cy="453542"/>
-          </a:xfrm>
-          <a:prstGeom prst="rect">
-            <a:avLst/>
-          </a:prstGeom>
-          <a:noFill/>
-          <a:ln/>
-        </p:spPr>
-        <p:txBody>
-          <a:bodyPr wrap="square" lIns="0" tIns="0" rIns="0" bIns="0" rtlCol="0" anchor="ctr"/>
-          <a:lstStyle/>
-          <a:p>
-            <a:pPr indent="0" marL="0">
-              <a:buNone/>
-            </a:pPr>
-            <a:r>
-              <a:rPr lang="en-US" sz="1800" b="1" dirty="0">
-                <a:solidFill>
-                  <a:srgbClr val="7F7F7F"/>
-                </a:solidFill>
-              </a:rPr>
-              <a:t>74% · 4.1k</a:t>
-            </a:r>
-            <a:endParaRPr lang="en-US" sz="1800" dirty="0"/>
-          </a:p>
-        </p:txBody>
-      </p:sp>
-      <p:sp>
-        <p:nvSpPr>
-          <p:cNvPr id="10" name="Text 8"/>
-          <p:cNvSpPr txBox="1"/>
-          <p:nvPr/>
-        </p:nvSpPr>
-        <p:spPr>
-          <a:xfrm>
-            <a:off x="548640" y="2916936"/>
-            <a:ext cx="2651760" cy="453542"/>
-          </a:xfrm>
-          <a:prstGeom prst="rect">
-            <a:avLst/>
-          </a:prstGeom>
-          <a:noFill/>
-          <a:ln/>
-        </p:spPr>
-        <p:txBody>
-          <a:bodyPr wrap="square" lIns="0" tIns="0" rIns="0" bIns="0" rtlCol="0" anchor="ctr"/>
-          <a:lstStyle/>
-          <a:p>
-            <a:pPr algn="r" indent="0" marL="0">
-              <a:buNone/>
-            </a:pPr>
-            <a:r>
-              <a:rPr lang="en-US" sz="1600" dirty="0">
-                <a:solidFill>
-                  <a:schemeClr val="tx1"/>
-                </a:solidFill>
-              </a:rPr>
-              <a:t>Think when check fails</a:t>
-            </a:r>
-            <a:endParaRPr lang="en-US" sz="1600" dirty="0"/>
-          </a:p>
-        </p:txBody>
-      </p:sp>
-      <p:sp>
-        <p:nvSpPr>
-          <p:cNvPr id="11" name="bar Think when check fails"/>
-          <p:cNvSpPr/>
-          <p:nvPr/>
-        </p:nvSpPr>
-        <p:spPr>
-          <a:xfrm>
-            <a:off x="3337560" y="3001975"/>
-            <a:ext cx="2393899" cy="283464"/>
-          </a:xfrm>
-          <a:prstGeom prst="rect">
-            <a:avLst/>
-          </a:prstGeom>
-          <a:solidFill>
-            <a:srgbClr val="7F7F7F"/>
-          </a:solidFill>
-          <a:ln w="6350">
-            <a:solidFill>
-              <a:srgbClr val="7F7F7F"/>
-            </a:solidFill>
-            <a:prstDash val="solid"/>
-          </a:ln>
-        </p:spPr>
-      </p:sp>
-      <p:sp>
-        <p:nvSpPr>
-          <p:cNvPr id="12" name="Text 10"/>
-          <p:cNvSpPr txBox="1"/>
-          <p:nvPr/>
-        </p:nvSpPr>
-        <p:spPr>
-          <a:xfrm>
-            <a:off x="5822899" y="2916936"/>
-            <a:ext cx="1554480" cy="453542"/>
-          </a:xfrm>
-          <a:prstGeom prst="rect">
-            <a:avLst/>
-          </a:prstGeom>
-          <a:noFill/>
-          <a:ln/>
-        </p:spPr>
-        <p:txBody>
-          <a:bodyPr wrap="square" lIns="0" tIns="0" rIns="0" bIns="0" rtlCol="0" anchor="ctr"/>
-          <a:lstStyle/>
-          <a:p>
-            <a:pPr indent="0" marL="0">
-              <a:buNone/>
-            </a:pPr>
-            <a:r>
-              <a:rPr lang="en-US" sz="1800" b="1" dirty="0">
-                <a:solidFill>
-                  <a:srgbClr val="7F7F7F"/>
-                </a:solidFill>
-              </a:rPr>
-              <a:t>77% · 4.2k</a:t>
-            </a:r>
-            <a:endParaRPr lang="en-US" sz="1800" dirty="0"/>
-          </a:p>
-        </p:txBody>
-      </p:sp>
-      <p:sp>
-        <p:nvSpPr>
-          <p:cNvPr id="13" name="Text 11"/>
-          <p:cNvSpPr txBox="1"/>
-          <p:nvPr/>
-        </p:nvSpPr>
-        <p:spPr>
-          <a:xfrm>
-            <a:off x="548640" y="3483864"/>
-            <a:ext cx="2651760" cy="453542"/>
-          </a:xfrm>
-          <a:prstGeom prst="rect">
-            <a:avLst/>
-          </a:prstGeom>
-          <a:noFill/>
-          <a:ln/>
-        </p:spPr>
-        <p:txBody>
-          <a:bodyPr wrap="square" lIns="0" tIns="0" rIns="0" bIns="0" rtlCol="0" anchor="ctr"/>
-          <a:lstStyle/>
-          <a:p>
-            <a:pPr algn="r" indent="0" marL="0">
-              <a:buNone/>
-            </a:pPr>
-            <a:r>
-              <a:rPr lang="en-US" sz="1600" dirty="0">
-                <a:solidFill>
-                  <a:schemeClr val="tx1"/>
-                </a:solidFill>
-              </a:rPr>
-              <a:t>Fix by failure type</a:t>
-            </a:r>
-            <a:endParaRPr lang="en-US" sz="1600" dirty="0"/>
-          </a:p>
-        </p:txBody>
-      </p:sp>
-      <p:sp>
-        <p:nvSpPr>
-          <p:cNvPr id="14" name="bar Fix by failure type"/>
-          <p:cNvSpPr/>
-          <p:nvPr/>
-        </p:nvSpPr>
-        <p:spPr>
-          <a:xfrm>
-            <a:off x="3337560" y="3568903"/>
-            <a:ext cx="2580437" cy="283464"/>
-          </a:xfrm>
-          <a:prstGeom prst="rect">
-            <a:avLst/>
-          </a:prstGeom>
-          <a:solidFill>
-            <a:srgbClr val="ED7D31"/>
-          </a:solidFill>
-          <a:ln w="6350">
-            <a:solidFill>
-              <a:srgbClr val="ED7D31"/>
-            </a:solidFill>
-            <a:prstDash val="solid"/>
-          </a:ln>
-        </p:spPr>
-      </p:sp>
-      <p:sp>
-        <p:nvSpPr>
-          <p:cNvPr id="15" name="Text 13"/>
-          <p:cNvSpPr txBox="1"/>
-          <p:nvPr/>
-        </p:nvSpPr>
-        <p:spPr>
-          <a:xfrm>
-            <a:off x="6009437" y="3483864"/>
-            <a:ext cx="1554480" cy="453542"/>
-          </a:xfrm>
-          <a:prstGeom prst="rect">
-            <a:avLst/>
-          </a:prstGeom>
-          <a:noFill/>
-          <a:ln/>
-        </p:spPr>
-        <p:txBody>
-          <a:bodyPr wrap="square" lIns="0" tIns="0" rIns="0" bIns="0" rtlCol="0" anchor="ctr"/>
-          <a:lstStyle/>
-          <a:p>
-            <a:pPr indent="0" marL="0">
-              <a:buNone/>
-            </a:pPr>
-            <a:r>
-              <a:rPr lang="en-US" sz="1800" b="1" dirty="0">
-                <a:solidFill>
-                  <a:srgbClr val="ED7D31"/>
-                </a:solidFill>
-              </a:rPr>
-              <a:t>83% · 4.2k</a:t>
-            </a:r>
-            <a:endParaRPr lang="en-US" sz="1800" dirty="0"/>
-          </a:p>
-        </p:txBody>
-      </p:sp>
-      <p:sp>
-        <p:nvSpPr>
-          <p:cNvPr id="16" name="Text 14"/>
-          <p:cNvSpPr txBox="1"/>
-          <p:nvPr/>
-        </p:nvSpPr>
-        <p:spPr>
-          <a:xfrm>
-            <a:off x="548640" y="4050792"/>
-            <a:ext cx="2651760" cy="453542"/>
-          </a:xfrm>
-          <a:prstGeom prst="rect">
-            <a:avLst/>
-          </a:prstGeom>
-          <a:noFill/>
-          <a:ln/>
-        </p:spPr>
-        <p:txBody>
-          <a:bodyPr wrap="square" lIns="0" tIns="0" rIns="0" bIns="0" rtlCol="0" anchor="ctr"/>
-          <a:lstStyle/>
-          <a:p>
-            <a:pPr algn="r" indent="0" marL="0">
-              <a:buNone/>
-            </a:pPr>
-            <a:r>
-              <a:rPr lang="en-US" sz="1600" dirty="0">
-                <a:solidFill>
-                  <a:schemeClr val="tx1"/>
-                </a:solidFill>
-              </a:rPr>
-              <a:t>Retrieved fact, then think</a:t>
-            </a:r>
-            <a:endParaRPr lang="en-US" sz="1600" dirty="0"/>
-          </a:p>
-        </p:txBody>
-      </p:sp>
-      <p:sp>
-        <p:nvSpPr>
-          <p:cNvPr id="17" name="bar Retrieved fact, then think"/>
-          <p:cNvSpPr/>
-          <p:nvPr/>
-        </p:nvSpPr>
-        <p:spPr>
-          <a:xfrm>
-            <a:off x="3337560" y="4135831"/>
-            <a:ext cx="2611526" cy="283464"/>
-          </a:xfrm>
-          <a:prstGeom prst="rect">
-            <a:avLst/>
-          </a:prstGeom>
-          <a:solidFill>
-            <a:srgbClr val="5B9BD5"/>
-          </a:solidFill>
-          <a:ln w="6350">
-            <a:solidFill>
-              <a:srgbClr val="5B9BD5"/>
-            </a:solidFill>
-            <a:prstDash val="solid"/>
-          </a:ln>
-        </p:spPr>
-      </p:sp>
-      <p:sp>
-        <p:nvSpPr>
-          <p:cNvPr id="18" name="Text 16"/>
-          <p:cNvSpPr txBox="1"/>
-          <p:nvPr/>
-        </p:nvSpPr>
-        <p:spPr>
-          <a:xfrm>
-            <a:off x="6040526" y="4050792"/>
-            <a:ext cx="1554480" cy="453542"/>
-          </a:xfrm>
-          <a:prstGeom prst="rect">
-            <a:avLst/>
-          </a:prstGeom>
-          <a:noFill/>
-          <a:ln/>
-        </p:spPr>
-        <p:txBody>
-          <a:bodyPr wrap="square" lIns="0" tIns="0" rIns="0" bIns="0" rtlCol="0" anchor="ctr"/>
-          <a:lstStyle/>
-          <a:p>
-            <a:pPr indent="0" marL="0">
-              <a:buNone/>
-            </a:pPr>
-            <a:r>
-              <a:rPr lang="en-US" sz="1800" b="1" dirty="0">
-                <a:solidFill>
-                  <a:srgbClr val="5B9BD5"/>
-                </a:solidFill>
-              </a:rPr>
-              <a:t>84% · 3.3k</a:t>
-            </a:r>
-            <a:endParaRPr lang="en-US" sz="1800" dirty="0"/>
-          </a:p>
-        </p:txBody>
-      </p:sp>
-      <p:sp>
-        <p:nvSpPr>
-          <p:cNvPr id="19" name="Text 17"/>
-          <p:cNvSpPr txBox="1"/>
-          <p:nvPr/>
-        </p:nvSpPr>
-        <p:spPr>
-          <a:xfrm>
-            <a:off x="548640" y="4617720"/>
-            <a:ext cx="2651760" cy="453542"/>
-          </a:xfrm>
-          <a:prstGeom prst="rect">
-            <a:avLst/>
-          </a:prstGeom>
-          <a:noFill/>
-          <a:ln/>
-        </p:spPr>
-        <p:txBody>
-          <a:bodyPr wrap="square" lIns="0" tIns="0" rIns="0" bIns="0" rtlCol="0" anchor="ctr"/>
-          <a:lstStyle/>
-          <a:p>
-            <a:pPr algn="r" indent="0" marL="0">
-              <a:buNone/>
-            </a:pPr>
-            <a:r>
-              <a:rPr lang="en-US" sz="1600" dirty="0">
-                <a:solidFill>
-                  <a:schemeClr val="tx1"/>
-                </a:solidFill>
-              </a:rPr>
-              <a:t>Fact first, then think</a:t>
-            </a:r>
-            <a:endParaRPr lang="en-US" sz="1600" dirty="0"/>
-          </a:p>
-        </p:txBody>
-      </p:sp>
-      <p:sp>
-        <p:nvSpPr>
-          <p:cNvPr id="20" name="bar Fact first, then think"/>
-          <p:cNvSpPr/>
-          <p:nvPr/>
-        </p:nvSpPr>
-        <p:spPr>
-          <a:xfrm>
-            <a:off x="3337560" y="4702759"/>
-            <a:ext cx="2704795" cy="283464"/>
-          </a:xfrm>
-          <a:prstGeom prst="rect">
+          <p:cNvPr id="5" name="walk badge 0"/>
+          <p:cNvSpPr/>
+          <p:nvPr/>
+        </p:nvSpPr>
+        <p:spPr>
+          <a:xfrm>
+            <a:off x="640080" y="1801368"/>
+            <a:ext cx="411480" cy="411480"/>
+          </a:xfrm>
+          <a:prstGeom prst="ellipse">
             <a:avLst/>
           </a:prstGeom>
           <a:solidFill>
             <a:srgbClr val="4472C4"/>
           </a:solidFill>
-          <a:ln w="6350">
+          <a:ln w="12700">
             <a:solidFill>
               <a:srgbClr val="4472C4"/>
             </a:solidFill>
@@ -6941,14 +6537,14 @@
       </p:sp>
       <p:sp>
         <p:nvSpPr>
-          <p:cNvPr id="21" name="Text 19"/>
-          <p:cNvSpPr txBox="1"/>
-          <p:nvPr/>
-        </p:nvSpPr>
-        <p:spPr>
-          <a:xfrm>
-            <a:off x="6133795" y="4617720"/>
-            <a:ext cx="1554480" cy="453542"/>
+          <p:cNvPr id="6" name="Text 4"/>
+          <p:cNvSpPr txBox="1"/>
+          <p:nvPr/>
+        </p:nvSpPr>
+        <p:spPr>
+          <a:xfrm>
+            <a:off x="640080" y="1801368"/>
+            <a:ext cx="411480" cy="411480"/>
           </a:xfrm>
           <a:prstGeom prst="rect">
             <a:avLst/>
@@ -6960,35 +6556,827 @@
           <a:bodyPr wrap="square" lIns="0" tIns="0" rIns="0" bIns="0" rtlCol="0" anchor="ctr"/>
           <a:lstStyle/>
           <a:p>
+            <a:pPr algn="ctr" indent="0" marL="0">
+              <a:buNone/>
+            </a:pPr>
+            <a:r>
+              <a:rPr lang="en-US" sz="1500" b="1" dirty="0">
+                <a:solidFill>
+                  <a:srgbClr val="FFFFFF"/>
+                </a:solidFill>
+              </a:rPr>
+              <a:t>0</a:t>
+            </a:r>
+            <a:endParaRPr lang="en-US" sz="1500" dirty="0"/>
+          </a:p>
+        </p:txBody>
+      </p:sp>
+      <p:sp>
+        <p:nvSpPr>
+          <p:cNvPr id="7" name="Text 5"/>
+          <p:cNvSpPr txBox="1"/>
+          <p:nvPr/>
+        </p:nvSpPr>
+        <p:spPr>
+          <a:xfrm>
+            <a:off x="1115568" y="1783080"/>
+            <a:ext cx="1874520" cy="457200"/>
+          </a:xfrm>
+          <a:prstGeom prst="rect">
+            <a:avLst/>
+          </a:prstGeom>
+          <a:noFill/>
+          <a:ln/>
+        </p:spPr>
+        <p:txBody>
+          <a:bodyPr wrap="square" lIns="0" tIns="0" rIns="0" bIns="0" rtlCol="0" anchor="ctr"/>
+          <a:lstStyle/>
+          <a:p>
             <a:pPr indent="0" marL="0">
               <a:buNone/>
             </a:pPr>
             <a:r>
-              <a:rPr lang="en-US" sz="1800" b="1" dirty="0">
-                <a:solidFill>
-                  <a:srgbClr val="4472C4"/>
-                </a:solidFill>
-              </a:rPr>
-              <a:t>87% · 2.5k</a:t>
-            </a:r>
-            <a:endParaRPr lang="en-US" sz="1800" dirty="0"/>
-          </a:p>
-        </p:txBody>
-      </p:sp>
-      <p:sp>
-        <p:nvSpPr>
-          <p:cNvPr id="22" name="new task"/>
-          <p:cNvSpPr/>
-          <p:nvPr/>
-        </p:nvSpPr>
-        <p:spPr>
-          <a:xfrm>
-            <a:off x="8229600" y="1737360"/>
-            <a:ext cx="3383280" cy="3566160"/>
+              <a:rPr lang="en-US" sz="1500" b="1" dirty="0">
+                <a:solidFill>
+                  <a:schemeClr val="tx1"/>
+                </a:solidFill>
+              </a:rPr>
+              <a:t>Mine the fact (once)</a:t>
+            </a:r>
+            <a:endParaRPr lang="en-US" sz="1500" dirty="0"/>
+          </a:p>
+        </p:txBody>
+      </p:sp>
+      <p:sp>
+        <p:nvSpPr>
+          <p:cNvPr id="8" name="Text 6"/>
+          <p:cNvSpPr txBox="1"/>
+          <p:nvPr/>
+        </p:nvSpPr>
+        <p:spPr>
+          <a:xfrm>
+            <a:off x="676656" y="2331720"/>
+            <a:ext cx="2258568" cy="1234440"/>
+          </a:xfrm>
+          <a:prstGeom prst="rect">
+            <a:avLst/>
+          </a:prstGeom>
+          <a:noFill/>
+          <a:ln/>
+        </p:spPr>
+        <p:txBody>
+          <a:bodyPr wrap="square" lIns="0" tIns="0" rIns="0" bIns="0" rtlCol="0" anchor="t"/>
+          <a:lstStyle/>
+          <a:p>
+            <a:pPr indent="0" marL="0">
+              <a:buNone/>
+            </a:pPr>
+            <a:r>
+              <a:rPr lang="en-US" sz="1350" dirty="0">
+                <a:solidFill>
+                  <a:schemeClr val="tx1"/>
+                </a:solidFill>
+              </a:rPr>
+              <a:t>for this kind of problem: the model's own program for another problem (vans and trucks) that passed the check; it shows solver.Minimize(...)</a:t>
+            </a:r>
+            <a:endParaRPr lang="en-US" sz="1350" dirty="0"/>
+          </a:p>
+        </p:txBody>
+      </p:sp>
+      <p:sp>
+        <p:nvSpPr>
+          <p:cNvPr id="9" name="Text 7"/>
+          <p:cNvSpPr txBox="1"/>
+          <p:nvPr/>
+        </p:nvSpPr>
+        <p:spPr>
+          <a:xfrm>
+            <a:off x="548640" y="3675888"/>
+            <a:ext cx="2514600" cy="320040"/>
+          </a:xfrm>
+          <a:prstGeom prst="rect">
+            <a:avLst/>
+          </a:prstGeom>
+          <a:noFill/>
+          <a:ln/>
+        </p:spPr>
+        <p:txBody>
+          <a:bodyPr wrap="square" lIns="0" tIns="0" rIns="0" bIns="0" rtlCol="0" anchor="ctr"/>
+          <a:lstStyle/>
+          <a:p>
+            <a:pPr algn="ctr" indent="0" marL="0">
+              <a:buNone/>
+            </a:pPr>
+            <a:r>
+              <a:rPr lang="en-US" sz="1500" b="1" dirty="0">
+                <a:solidFill>
+                  <a:schemeClr val="tx2"/>
+                </a:solidFill>
+              </a:rPr>
+              <a:t>paid once</a:t>
+            </a:r>
+            <a:endParaRPr lang="en-US" sz="1500" dirty="0"/>
+          </a:p>
+        </p:txBody>
+      </p:sp>
+      <p:sp>
+        <p:nvSpPr>
+          <p:cNvPr id="10" name="Shape 8"/>
+          <p:cNvSpPr/>
+          <p:nvPr/>
+        </p:nvSpPr>
+        <p:spPr>
+          <a:xfrm>
+            <a:off x="3063240" y="2468880"/>
+            <a:ext cx="182880" cy="0"/>
+          </a:xfrm>
+          <a:prstGeom prst="line">
+            <a:avLst/>
+          </a:prstGeom>
+          <a:noFill/>
+          <a:ln w="25400">
+            <a:solidFill>
+              <a:srgbClr val="7F7F7F"/>
+            </a:solidFill>
+            <a:prstDash val="solid"/>
+            <a:tailEnd type="triangle"/>
+          </a:ln>
+        </p:spPr>
+      </p:sp>
+      <p:sp>
+        <p:nvSpPr>
+          <p:cNvPr id="11" name="walk 1-2"/>
+          <p:cNvSpPr/>
+          <p:nvPr/>
+        </p:nvSpPr>
+        <p:spPr>
+          <a:xfrm>
+            <a:off x="3246120" y="1691640"/>
+            <a:ext cx="2148840" cy="1920240"/>
           </a:xfrm>
           <a:prstGeom prst="roundRect">
             <a:avLst>
-              <a:gd name="adj" fmla="val 2162"/>
+              <a:gd name="adj" fmla="val 3810"/>
+            </a:avLst>
+          </a:prstGeom>
+          <a:solidFill>
+            <a:srgbClr val="DEEBF7"/>
+          </a:solidFill>
+          <a:ln w="9525">
+            <a:solidFill>
+              <a:srgbClr val="BFBFBF"/>
+            </a:solidFill>
+            <a:prstDash val="solid"/>
+          </a:ln>
+        </p:spPr>
+      </p:sp>
+      <p:sp>
+        <p:nvSpPr>
+          <p:cNvPr id="12" name="walk badge 1-2"/>
+          <p:cNvSpPr/>
+          <p:nvPr/>
+        </p:nvSpPr>
+        <p:spPr>
+          <a:xfrm>
+            <a:off x="3337560" y="1801368"/>
+            <a:ext cx="411480" cy="411480"/>
+          </a:xfrm>
+          <a:prstGeom prst="ellipse">
+            <a:avLst/>
+          </a:prstGeom>
+          <a:solidFill>
+            <a:srgbClr val="4472C4"/>
+          </a:solidFill>
+          <a:ln w="12700">
+            <a:solidFill>
+              <a:srgbClr val="4472C4"/>
+            </a:solidFill>
+            <a:prstDash val="solid"/>
+          </a:ln>
+        </p:spPr>
+      </p:sp>
+      <p:sp>
+        <p:nvSpPr>
+          <p:cNvPr id="13" name="Text 11"/>
+          <p:cNvSpPr txBox="1"/>
+          <p:nvPr/>
+        </p:nvSpPr>
+        <p:spPr>
+          <a:xfrm>
+            <a:off x="3337560" y="1801368"/>
+            <a:ext cx="411480" cy="411480"/>
+          </a:xfrm>
+          <a:prstGeom prst="rect">
+            <a:avLst/>
+          </a:prstGeom>
+          <a:noFill/>
+          <a:ln/>
+        </p:spPr>
+        <p:txBody>
+          <a:bodyPr wrap="square" lIns="0" tIns="0" rIns="0" bIns="0" rtlCol="0" anchor="ctr"/>
+          <a:lstStyle/>
+          <a:p>
+            <a:pPr algn="ctr" indent="0" marL="0">
+              <a:buNone/>
+            </a:pPr>
+            <a:r>
+              <a:rPr lang="en-US" sz="1500" b="1" dirty="0">
+                <a:solidFill>
+                  <a:srgbClr val="FFFFFF"/>
+                </a:solidFill>
+              </a:rPr>
+              <a:t>1-2</a:t>
+            </a:r>
+            <a:endParaRPr lang="en-US" sz="1500" dirty="0"/>
+          </a:p>
+        </p:txBody>
+      </p:sp>
+      <p:sp>
+        <p:nvSpPr>
+          <p:cNvPr id="14" name="Text 12"/>
+          <p:cNvSpPr txBox="1"/>
+          <p:nvPr/>
+        </p:nvSpPr>
+        <p:spPr>
+          <a:xfrm>
+            <a:off x="3813048" y="1783080"/>
+            <a:ext cx="1508760" cy="457200"/>
+          </a:xfrm>
+          <a:prstGeom prst="rect">
+            <a:avLst/>
+          </a:prstGeom>
+          <a:noFill/>
+          <a:ln/>
+        </p:spPr>
+        <p:txBody>
+          <a:bodyPr wrap="square" lIns="0" tIns="0" rIns="0" bIns="0" rtlCol="0" anchor="ctr"/>
+          <a:lstStyle/>
+          <a:p>
+            <a:pPr indent="0" marL="0">
+              <a:buNone/>
+            </a:pPr>
+            <a:r>
+              <a:rPr lang="en-US" sz="1500" b="1" dirty="0">
+                <a:solidFill>
+                  <a:schemeClr val="tx1"/>
+                </a:solidFill>
+              </a:rPr>
+              <a:t>Program + fact</a:t>
+            </a:r>
+            <a:endParaRPr lang="en-US" sz="1500" dirty="0"/>
+          </a:p>
+        </p:txBody>
+      </p:sp>
+      <p:sp>
+        <p:nvSpPr>
+          <p:cNvPr id="15" name="Text 13"/>
+          <p:cNvSpPr txBox="1"/>
+          <p:nvPr/>
+        </p:nvSpPr>
+        <p:spPr>
+          <a:xfrm>
+            <a:off x="3374136" y="2331720"/>
+            <a:ext cx="1892808" cy="1234440"/>
+          </a:xfrm>
+          <a:prstGeom prst="rect">
+            <a:avLst/>
+          </a:prstGeom>
+          <a:noFill/>
+          <a:ln/>
+        </p:spPr>
+        <p:txBody>
+          <a:bodyPr wrap="square" lIns="0" tIns="0" rIns="0" bIns="0" rtlCol="0" anchor="t"/>
+          <a:lstStyle/>
+          <a:p>
+            <a:pPr indent="0" marL="0">
+              <a:buNone/>
+            </a:pPr>
+            <a:r>
+              <a:rPr lang="en-US" sz="1350" dirty="0">
+                <a:solidFill>
+                  <a:schemeClr val="tx1"/>
+                </a:solidFill>
+              </a:rPr>
+              <a:t>writes solver.Minimize(10*x + 15*y + 20*z) and prints 20000 (without the fact it crashes)</a:t>
+            </a:r>
+            <a:endParaRPr lang="en-US" sz="1350" dirty="0"/>
+          </a:p>
+        </p:txBody>
+      </p:sp>
+      <p:sp>
+        <p:nvSpPr>
+          <p:cNvPr id="16" name="Text 14"/>
+          <p:cNvSpPr txBox="1"/>
+          <p:nvPr/>
+        </p:nvSpPr>
+        <p:spPr>
+          <a:xfrm>
+            <a:off x="3246120" y="3675888"/>
+            <a:ext cx="2148840" cy="320040"/>
+          </a:xfrm>
+          <a:prstGeom prst="rect">
+            <a:avLst/>
+          </a:prstGeom>
+          <a:noFill/>
+          <a:ln/>
+        </p:spPr>
+        <p:txBody>
+          <a:bodyPr wrap="square" lIns="0" tIns="0" rIns="0" bIns="0" rtlCol="0" anchor="ctr"/>
+          <a:lstStyle/>
+          <a:p>
+            <a:pPr algn="ctr" indent="0" marL="0">
+              <a:buNone/>
+            </a:pPr>
+            <a:r>
+              <a:rPr lang="en-US" sz="1500" b="1" dirty="0">
+                <a:solidFill>
+                  <a:srgbClr val="4472C4"/>
+                </a:solidFill>
+              </a:rPr>
+              <a:t>316 tokens</a:t>
+            </a:r>
+            <a:endParaRPr lang="en-US" sz="1500" dirty="0"/>
+          </a:p>
+        </p:txBody>
+      </p:sp>
+      <p:sp>
+        <p:nvSpPr>
+          <p:cNvPr id="17" name="Shape 15"/>
+          <p:cNvSpPr/>
+          <p:nvPr/>
+        </p:nvSpPr>
+        <p:spPr>
+          <a:xfrm>
+            <a:off x="5394960" y="2468880"/>
+            <a:ext cx="182880" cy="0"/>
+          </a:xfrm>
+          <a:prstGeom prst="line">
+            <a:avLst/>
+          </a:prstGeom>
+          <a:noFill/>
+          <a:ln w="25400">
+            <a:solidFill>
+              <a:srgbClr val="7F7F7F"/>
+            </a:solidFill>
+            <a:prstDash val="solid"/>
+            <a:tailEnd type="triangle"/>
+          </a:ln>
+        </p:spPr>
+      </p:sp>
+      <p:sp>
+        <p:nvSpPr>
+          <p:cNvPr id="18" name="walk 3"/>
+          <p:cNvSpPr/>
+          <p:nvPr/>
+        </p:nvSpPr>
+        <p:spPr>
+          <a:xfrm>
+            <a:off x="5577840" y="1691640"/>
+            <a:ext cx="2011680" cy="1920240"/>
+          </a:xfrm>
+          <a:prstGeom prst="roundRect">
+            <a:avLst>
+              <a:gd name="adj" fmla="val 3810"/>
+            </a:avLst>
+          </a:prstGeom>
+          <a:solidFill>
+            <a:srgbClr val="DEEBF7"/>
+          </a:solidFill>
+          <a:ln w="9525">
+            <a:solidFill>
+              <a:srgbClr val="BFBFBF"/>
+            </a:solidFill>
+            <a:prstDash val="solid"/>
+          </a:ln>
+        </p:spPr>
+      </p:sp>
+      <p:sp>
+        <p:nvSpPr>
+          <p:cNvPr id="19" name="walk badge 3"/>
+          <p:cNvSpPr/>
+          <p:nvPr/>
+        </p:nvSpPr>
+        <p:spPr>
+          <a:xfrm>
+            <a:off x="5669280" y="1801368"/>
+            <a:ext cx="411480" cy="411480"/>
+          </a:xfrm>
+          <a:prstGeom prst="ellipse">
+            <a:avLst/>
+          </a:prstGeom>
+          <a:solidFill>
+            <a:srgbClr val="4472C4"/>
+          </a:solidFill>
+          <a:ln w="12700">
+            <a:solidFill>
+              <a:srgbClr val="4472C4"/>
+            </a:solidFill>
+            <a:prstDash val="solid"/>
+          </a:ln>
+        </p:spPr>
+      </p:sp>
+      <p:sp>
+        <p:nvSpPr>
+          <p:cNvPr id="20" name="Text 18"/>
+          <p:cNvSpPr txBox="1"/>
+          <p:nvPr/>
+        </p:nvSpPr>
+        <p:spPr>
+          <a:xfrm>
+            <a:off x="5669280" y="1801368"/>
+            <a:ext cx="411480" cy="411480"/>
+          </a:xfrm>
+          <a:prstGeom prst="rect">
+            <a:avLst/>
+          </a:prstGeom>
+          <a:noFill/>
+          <a:ln/>
+        </p:spPr>
+        <p:txBody>
+          <a:bodyPr wrap="square" lIns="0" tIns="0" rIns="0" bIns="0" rtlCol="0" anchor="ctr"/>
+          <a:lstStyle/>
+          <a:p>
+            <a:pPr algn="ctr" indent="0" marL="0">
+              <a:buNone/>
+            </a:pPr>
+            <a:r>
+              <a:rPr lang="en-US" sz="1500" b="1" dirty="0">
+                <a:solidFill>
+                  <a:srgbClr val="FFFFFF"/>
+                </a:solidFill>
+              </a:rPr>
+              <a:t>3</a:t>
+            </a:r>
+            <a:endParaRPr lang="en-US" sz="1500" dirty="0"/>
+          </a:p>
+        </p:txBody>
+      </p:sp>
+      <p:sp>
+        <p:nvSpPr>
+          <p:cNvPr id="21" name="Text 19"/>
+          <p:cNvSpPr txBox="1"/>
+          <p:nvPr/>
+        </p:nvSpPr>
+        <p:spPr>
+          <a:xfrm>
+            <a:off x="6144768" y="1783080"/>
+            <a:ext cx="1371600" cy="457200"/>
+          </a:xfrm>
+          <a:prstGeom prst="rect">
+            <a:avLst/>
+          </a:prstGeom>
+          <a:noFill/>
+          <a:ln/>
+        </p:spPr>
+        <p:txBody>
+          <a:bodyPr wrap="square" lIns="0" tIns="0" rIns="0" bIns="0" rtlCol="0" anchor="ctr"/>
+          <a:lstStyle/>
+          <a:p>
+            <a:pPr indent="0" marL="0">
+              <a:buNone/>
+            </a:pPr>
+            <a:r>
+              <a:rPr lang="en-US" sz="1500" b="1" dirty="0">
+                <a:solidFill>
+                  <a:schemeClr val="tx1"/>
+                </a:solidFill>
+              </a:rPr>
+              <a:t>Free check</a:t>
+            </a:r>
+            <a:endParaRPr lang="en-US" sz="1500" dirty="0"/>
+          </a:p>
+        </p:txBody>
+      </p:sp>
+      <p:sp>
+        <p:nvSpPr>
+          <p:cNvPr id="22" name="Text 20"/>
+          <p:cNvSpPr txBox="1"/>
+          <p:nvPr/>
+        </p:nvSpPr>
+        <p:spPr>
+          <a:xfrm>
+            <a:off x="5705856" y="2331720"/>
+            <a:ext cx="1755648" cy="1234440"/>
+          </a:xfrm>
+          <a:prstGeom prst="rect">
+            <a:avLst/>
+          </a:prstGeom>
+          <a:noFill/>
+          <a:ln/>
+        </p:spPr>
+        <p:txBody>
+          <a:bodyPr wrap="square" lIns="0" tIns="0" rIns="0" bIns="0" rtlCol="0" anchor="t"/>
+          <a:lstStyle/>
+          <a:p>
+            <a:pPr indent="0" marL="0">
+              <a:buNone/>
+            </a:pPr>
+            <a:r>
+              <a:rPr lang="en-US" sz="1350" dirty="0">
+                <a:solidFill>
+                  <a:schemeClr val="tx1"/>
+                </a:solidFill>
+              </a:rPr>
+              <a:t>a second version also runs and prints 20000: the two agree</a:t>
+            </a:r>
+            <a:endParaRPr lang="en-US" sz="1350" dirty="0"/>
+          </a:p>
+        </p:txBody>
+      </p:sp>
+      <p:sp>
+        <p:nvSpPr>
+          <p:cNvPr id="23" name="Text 21"/>
+          <p:cNvSpPr txBox="1"/>
+          <p:nvPr/>
+        </p:nvSpPr>
+        <p:spPr>
+          <a:xfrm>
+            <a:off x="5577840" y="3675888"/>
+            <a:ext cx="2011680" cy="320040"/>
+          </a:xfrm>
+          <a:prstGeom prst="rect">
+            <a:avLst/>
+          </a:prstGeom>
+          <a:noFill/>
+          <a:ln/>
+        </p:spPr>
+        <p:txBody>
+          <a:bodyPr wrap="square" lIns="0" tIns="0" rIns="0" bIns="0" rtlCol="0" anchor="ctr"/>
+          <a:lstStyle/>
+          <a:p>
+            <a:pPr algn="ctr" indent="0" marL="0">
+              <a:buNone/>
+            </a:pPr>
+            <a:r>
+              <a:rPr lang="en-US" sz="1500" b="1" dirty="0">
+                <a:solidFill>
+                  <a:srgbClr val="4472C4"/>
+                </a:solidFill>
+              </a:rPr>
+              <a:t>+312 tokens</a:t>
+            </a:r>
+            <a:endParaRPr lang="en-US" sz="1500" dirty="0"/>
+          </a:p>
+        </p:txBody>
+      </p:sp>
+      <p:sp>
+        <p:nvSpPr>
+          <p:cNvPr id="24" name="Shape 22"/>
+          <p:cNvSpPr/>
+          <p:nvPr/>
+        </p:nvSpPr>
+        <p:spPr>
+          <a:xfrm>
+            <a:off x="7589520" y="2468880"/>
+            <a:ext cx="182880" cy="0"/>
+          </a:xfrm>
+          <a:prstGeom prst="line">
+            <a:avLst/>
+          </a:prstGeom>
+          <a:noFill/>
+          <a:ln w="25400">
+            <a:solidFill>
+              <a:srgbClr val="7F7F7F"/>
+            </a:solidFill>
+            <a:prstDash val="solid"/>
+            <a:tailEnd type="triangle"/>
+          </a:ln>
+        </p:spPr>
+      </p:sp>
+      <p:sp>
+        <p:nvSpPr>
+          <p:cNvPr id="25" name="walk 4"/>
+          <p:cNvSpPr/>
+          <p:nvPr/>
+        </p:nvSpPr>
+        <p:spPr>
+          <a:xfrm>
+            <a:off x="7772400" y="1691640"/>
+            <a:ext cx="2103120" cy="1920240"/>
+          </a:xfrm>
+          <a:prstGeom prst="roundRect">
+            <a:avLst>
+              <a:gd name="adj" fmla="val 3810"/>
+            </a:avLst>
+          </a:prstGeom>
+          <a:solidFill>
+            <a:srgbClr val="FFFFFF"/>
+          </a:solidFill>
+          <a:ln w="9525">
+            <a:solidFill>
+              <a:srgbClr val="BFBFBF"/>
+            </a:solidFill>
+            <a:prstDash val="solid"/>
+          </a:ln>
+        </p:spPr>
+      </p:sp>
+      <p:sp>
+        <p:nvSpPr>
+          <p:cNvPr id="26" name="walk badge 4"/>
+          <p:cNvSpPr/>
+          <p:nvPr/>
+        </p:nvSpPr>
+        <p:spPr>
+          <a:xfrm>
+            <a:off x="7863840" y="1801368"/>
+            <a:ext cx="411480" cy="411480"/>
+          </a:xfrm>
+          <a:prstGeom prst="ellipse">
+            <a:avLst/>
+          </a:prstGeom>
+          <a:solidFill>
+            <a:srgbClr val="4472C4"/>
+          </a:solidFill>
+          <a:ln w="12700">
+            <a:solidFill>
+              <a:srgbClr val="4472C4"/>
+            </a:solidFill>
+            <a:prstDash val="solid"/>
+          </a:ln>
+        </p:spPr>
+      </p:sp>
+      <p:sp>
+        <p:nvSpPr>
+          <p:cNvPr id="27" name="Text 25"/>
+          <p:cNvSpPr txBox="1"/>
+          <p:nvPr/>
+        </p:nvSpPr>
+        <p:spPr>
+          <a:xfrm>
+            <a:off x="7863840" y="1801368"/>
+            <a:ext cx="411480" cy="411480"/>
+          </a:xfrm>
+          <a:prstGeom prst="rect">
+            <a:avLst/>
+          </a:prstGeom>
+          <a:noFill/>
+          <a:ln/>
+        </p:spPr>
+        <p:txBody>
+          <a:bodyPr wrap="square" lIns="0" tIns="0" rIns="0" bIns="0" rtlCol="0" anchor="ctr"/>
+          <a:lstStyle/>
+          <a:p>
+            <a:pPr algn="ctr" indent="0" marL="0">
+              <a:buNone/>
+            </a:pPr>
+            <a:r>
+              <a:rPr lang="en-US" sz="1500" b="1" dirty="0">
+                <a:solidFill>
+                  <a:srgbClr val="FFFFFF"/>
+                </a:solidFill>
+              </a:rPr>
+              <a:t>4</a:t>
+            </a:r>
+            <a:endParaRPr lang="en-US" sz="1500" dirty="0"/>
+          </a:p>
+        </p:txBody>
+      </p:sp>
+      <p:sp>
+        <p:nvSpPr>
+          <p:cNvPr id="28" name="Text 26"/>
+          <p:cNvSpPr txBox="1"/>
+          <p:nvPr/>
+        </p:nvSpPr>
+        <p:spPr>
+          <a:xfrm>
+            <a:off x="8339328" y="1783080"/>
+            <a:ext cx="1463040" cy="457200"/>
+          </a:xfrm>
+          <a:prstGeom prst="rect">
+            <a:avLst/>
+          </a:prstGeom>
+          <a:noFill/>
+          <a:ln/>
+        </p:spPr>
+        <p:txBody>
+          <a:bodyPr wrap="square" lIns="0" tIns="0" rIns="0" bIns="0" rtlCol="0" anchor="ctr"/>
+          <a:lstStyle/>
+          <a:p>
+            <a:pPr indent="0" marL="0">
+              <a:buNone/>
+            </a:pPr>
+            <a:r>
+              <a:rPr lang="en-US" sz="1500" b="1" dirty="0">
+                <a:solidFill>
+                  <a:schemeClr val="tx1"/>
+                </a:solidFill>
+              </a:rPr>
+              <a:t>Think? No</a:t>
+            </a:r>
+            <a:endParaRPr lang="en-US" sz="1500" dirty="0"/>
+          </a:p>
+        </p:txBody>
+      </p:sp>
+      <p:sp>
+        <p:nvSpPr>
+          <p:cNvPr id="29" name="Text 27"/>
+          <p:cNvSpPr txBox="1"/>
+          <p:nvPr/>
+        </p:nvSpPr>
+        <p:spPr>
+          <a:xfrm>
+            <a:off x="7900416" y="2331720"/>
+            <a:ext cx="1847088" cy="1234440"/>
+          </a:xfrm>
+          <a:prstGeom prst="rect">
+            <a:avLst/>
+          </a:prstGeom>
+          <a:noFill/>
+          <a:ln/>
+        </p:spPr>
+        <p:txBody>
+          <a:bodyPr wrap="square" lIns="0" tIns="0" rIns="0" bIns="0" rtlCol="0" anchor="t"/>
+          <a:lstStyle/>
+          <a:p>
+            <a:pPr indent="0" marL="0">
+              <a:buNone/>
+            </a:pPr>
+            <a:r>
+              <a:rPr lang="en-US" sz="1350" dirty="0">
+                <a:solidFill>
+                  <a:schemeClr val="tx1"/>
+                </a:solidFill>
+              </a:rPr>
+              <a:t>think harder only if they disagree or crash; here accept 20000 (thinking alone: 5.3k tokens)</a:t>
+            </a:r>
+            <a:endParaRPr lang="en-US" sz="1350" dirty="0"/>
+          </a:p>
+        </p:txBody>
+      </p:sp>
+      <p:sp>
+        <p:nvSpPr>
+          <p:cNvPr id="30" name="Text 28"/>
+          <p:cNvSpPr txBox="1"/>
+          <p:nvPr/>
+        </p:nvSpPr>
+        <p:spPr>
+          <a:xfrm>
+            <a:off x="7772400" y="3675888"/>
+            <a:ext cx="2103120" cy="320040"/>
+          </a:xfrm>
+          <a:prstGeom prst="rect">
+            <a:avLst/>
+          </a:prstGeom>
+          <a:noFill/>
+          <a:ln/>
+        </p:spPr>
+        <p:txBody>
+          <a:bodyPr wrap="square" lIns="0" tIns="0" rIns="0" bIns="0" rtlCol="0" anchor="ctr"/>
+          <a:lstStyle/>
+          <a:p>
+            <a:pPr algn="ctr" indent="0" marL="0">
+              <a:buNone/>
+            </a:pPr>
+            <a:r>
+              <a:rPr lang="en-US" sz="1500" b="1" dirty="0">
+                <a:solidFill>
+                  <a:srgbClr val="38761D"/>
+                </a:solidFill>
+              </a:rPr>
+              <a:t>total 0.6k</a:t>
+            </a:r>
+            <a:endParaRPr lang="en-US" sz="1500" dirty="0"/>
+          </a:p>
+        </p:txBody>
+      </p:sp>
+      <p:sp>
+        <p:nvSpPr>
+          <p:cNvPr id="31" name="Shape 29"/>
+          <p:cNvSpPr/>
+          <p:nvPr/>
+        </p:nvSpPr>
+        <p:spPr>
+          <a:xfrm>
+            <a:off x="9875520" y="2468880"/>
+            <a:ext cx="182880" cy="0"/>
+          </a:xfrm>
+          <a:prstGeom prst="line">
+            <a:avLst/>
+          </a:prstGeom>
+          <a:noFill/>
+          <a:ln w="25400">
+            <a:solidFill>
+              <a:srgbClr val="7F7F7F"/>
+            </a:solidFill>
+            <a:prstDash val="solid"/>
+            <a:tailEnd type="triangle"/>
+          </a:ln>
+        </p:spPr>
+      </p:sp>
+      <p:sp>
+        <p:nvSpPr>
+          <p:cNvPr id="32" name="walk 5"/>
+          <p:cNvSpPr/>
+          <p:nvPr/>
+        </p:nvSpPr>
+        <p:spPr>
+          <a:xfrm>
+            <a:off x="10058400" y="1691640"/>
+            <a:ext cx="1554480" cy="1920240"/>
+          </a:xfrm>
+          <a:prstGeom prst="roundRect">
+            <a:avLst>
+              <a:gd name="adj" fmla="val 4706"/>
             </a:avLst>
           </a:prstGeom>
           <a:solidFill>
@@ -6996,7 +7384,7 @@
           </a:solidFill>
           <a:ln w="9525">
             <a:solidFill>
-              <a:srgbClr val="D9D9D9"/>
+              <a:srgbClr val="BFBFBF"/>
             </a:solidFill>
             <a:prstDash val="solid"/>
           </a:ln>
@@ -7004,227 +7392,22 @@
       </p:sp>
       <p:sp>
         <p:nvSpPr>
-          <p:cNvPr id="23" name="Text 21"/>
-          <p:cNvSpPr txBox="1"/>
-          <p:nvPr/>
-        </p:nvSpPr>
-        <p:spPr>
-          <a:xfrm>
-            <a:off x="8412480" y="1828800"/>
-            <a:ext cx="3017520" cy="685800"/>
-          </a:xfrm>
-          <a:prstGeom prst="rect">
-            <a:avLst/>
-          </a:prstGeom>
-          <a:noFill/>
-          <a:ln/>
-        </p:spPr>
-        <p:txBody>
-          <a:bodyPr wrap="square" lIns="0" tIns="0" rIns="0" bIns="0" rtlCol="0" anchor="t"/>
-          <a:lstStyle/>
-          <a:p>
-            <a:pPr indent="0" marL="0">
-              <a:buNone/>
-            </a:pPr>
-            <a:r>
-              <a:rPr lang="en-US" sz="1700" b="1" dirty="0">
-                <a:solidFill>
-                  <a:schemeClr val="tx1"/>
-                </a:solidFill>
-              </a:rPr>
-              <a:t>A new task? Label 30 problems</a:t>
-            </a:r>
-            <a:endParaRPr lang="en-US" sz="1700" dirty="0"/>
-          </a:p>
-        </p:txBody>
-      </p:sp>
-      <p:sp>
-        <p:nvSpPr>
-          <p:cNvPr id="24" name="Text 22"/>
-          <p:cNvSpPr txBox="1"/>
-          <p:nvPr/>
-        </p:nvSpPr>
-        <p:spPr>
-          <a:xfrm>
-            <a:off x="8412480" y="2514600"/>
-            <a:ext cx="3017520" cy="548640"/>
-          </a:xfrm>
-          <a:prstGeom prst="rect">
-            <a:avLst/>
-          </a:prstGeom>
-          <a:noFill/>
-          <a:ln/>
-        </p:spPr>
-        <p:txBody>
-          <a:bodyPr wrap="square" lIns="0" tIns="0" rIns="0" bIns="0" rtlCol="0" anchor="t"/>
-          <a:lstStyle/>
-          <a:p>
-            <a:pPr indent="0" marL="0">
-              <a:buNone/>
-            </a:pPr>
-            <a:r>
-              <a:rPr lang="en-US" sz="1300" dirty="0">
-                <a:solidFill>
-                  <a:schemeClr val="tx2"/>
-                </a:solidFill>
-              </a:rPr>
-              <a:t>points lost vs the best policy, over 63 settings (lower is better)</a:t>
-            </a:r>
-            <a:endParaRPr lang="en-US" sz="1300" dirty="0"/>
-          </a:p>
-        </p:txBody>
-      </p:sp>
-      <p:sp>
-        <p:nvSpPr>
-          <p:cNvPr id="25" name="Text 23"/>
-          <p:cNvSpPr txBox="1"/>
-          <p:nvPr/>
-        </p:nvSpPr>
-        <p:spPr>
-          <a:xfrm>
-            <a:off x="8412480" y="3200400"/>
-            <a:ext cx="3017520" cy="274320"/>
-          </a:xfrm>
-          <a:prstGeom prst="rect">
-            <a:avLst/>
-          </a:prstGeom>
-          <a:noFill/>
-          <a:ln/>
-        </p:spPr>
-        <p:txBody>
-          <a:bodyPr wrap="square" lIns="0" tIns="0" rIns="0" bIns="0" rtlCol="0" anchor="ctr"/>
-          <a:lstStyle/>
-          <a:p>
-            <a:pPr indent="0" marL="0">
-              <a:buNone/>
-            </a:pPr>
-            <a:r>
-              <a:rPr lang="en-US" sz="1400" dirty="0">
-                <a:solidFill>
-                  <a:schemeClr val="tx1"/>
-                </a:solidFill>
-              </a:rPr>
-              <a:t>always think</a:t>
-            </a:r>
-            <a:endParaRPr lang="en-US" sz="1400" dirty="0"/>
-          </a:p>
-        </p:txBody>
-      </p:sp>
-      <p:sp>
-        <p:nvSpPr>
-          <p:cNvPr id="26" name="loss always think"/>
-          <p:cNvSpPr/>
-          <p:nvPr/>
-        </p:nvSpPr>
-        <p:spPr>
-          <a:xfrm>
-            <a:off x="8412480" y="3493008"/>
-            <a:ext cx="2304288" cy="201168"/>
-          </a:xfrm>
-          <a:prstGeom prst="rect">
-            <a:avLst/>
-          </a:prstGeom>
-          <a:solidFill>
-            <a:srgbClr val="A5A5A5"/>
-          </a:solidFill>
-          <a:ln w="6350">
-            <a:solidFill>
-              <a:srgbClr val="A5A5A5"/>
-            </a:solidFill>
-            <a:prstDash val="solid"/>
-          </a:ln>
-        </p:spPr>
-      </p:sp>
-      <p:sp>
-        <p:nvSpPr>
-          <p:cNvPr id="27" name="Text 25"/>
-          <p:cNvSpPr txBox="1"/>
-          <p:nvPr/>
-        </p:nvSpPr>
-        <p:spPr>
-          <a:xfrm>
-            <a:off x="10808208" y="3429000"/>
-            <a:ext cx="548640" cy="320040"/>
-          </a:xfrm>
-          <a:prstGeom prst="rect">
-            <a:avLst/>
-          </a:prstGeom>
-          <a:noFill/>
-          <a:ln/>
-        </p:spPr>
-        <p:txBody>
-          <a:bodyPr wrap="square" lIns="0" tIns="0" rIns="0" bIns="0" rtlCol="0" anchor="ctr"/>
-          <a:lstStyle/>
-          <a:p>
-            <a:pPr indent="0" marL="0">
-              <a:buNone/>
-            </a:pPr>
-            <a:r>
-              <a:rPr lang="en-US" sz="1400" b="1" dirty="0">
-                <a:solidFill>
-                  <a:srgbClr val="595959"/>
-                </a:solidFill>
-              </a:rPr>
-              <a:t>8.4</a:t>
-            </a:r>
-            <a:endParaRPr lang="en-US" sz="1400" dirty="0"/>
-          </a:p>
-        </p:txBody>
-      </p:sp>
-      <p:sp>
-        <p:nvSpPr>
-          <p:cNvPr id="28" name="Text 26"/>
-          <p:cNvSpPr txBox="1"/>
-          <p:nvPr/>
-        </p:nvSpPr>
-        <p:spPr>
-          <a:xfrm>
-            <a:off x="8412480" y="3840480"/>
-            <a:ext cx="3017520" cy="274320"/>
-          </a:xfrm>
-          <a:prstGeom prst="rect">
-            <a:avLst/>
-          </a:prstGeom>
-          <a:noFill/>
-          <a:ln/>
-        </p:spPr>
-        <p:txBody>
-          <a:bodyPr wrap="square" lIns="0" tIns="0" rIns="0" bIns="0" rtlCol="0" anchor="ctr"/>
-          <a:lstStyle/>
-          <a:p>
-            <a:pPr indent="0" marL="0">
-              <a:buNone/>
-            </a:pPr>
-            <a:r>
-              <a:rPr lang="en-US" sz="1400" dirty="0">
-                <a:solidFill>
-                  <a:schemeClr val="tx1"/>
-                </a:solidFill>
-              </a:rPr>
-              <a:t>fact first (default)</a:t>
-            </a:r>
-            <a:endParaRPr lang="en-US" sz="1400" dirty="0"/>
-          </a:p>
-        </p:txBody>
-      </p:sp>
-      <p:sp>
-        <p:nvSpPr>
-          <p:cNvPr id="29" name="loss fact first (default)"/>
-          <p:cNvSpPr/>
-          <p:nvPr/>
-        </p:nvSpPr>
-        <p:spPr>
-          <a:xfrm>
-            <a:off x="8412480" y="4133088"/>
-            <a:ext cx="384048" cy="201168"/>
-          </a:xfrm>
-          <a:prstGeom prst="rect">
+          <p:cNvPr id="33" name="walk badge 5"/>
+          <p:cNvSpPr/>
+          <p:nvPr/>
+        </p:nvSpPr>
+        <p:spPr>
+          <a:xfrm>
+            <a:off x="10149840" y="1801368"/>
+            <a:ext cx="411480" cy="411480"/>
+          </a:xfrm>
+          <a:prstGeom prst="ellipse">
             <a:avLst/>
           </a:prstGeom>
           <a:solidFill>
             <a:srgbClr val="4472C4"/>
           </a:solidFill>
-          <a:ln w="6350">
+          <a:ln w="12700">
             <a:solidFill>
               <a:srgbClr val="4472C4"/>
             </a:solidFill>
@@ -7234,14 +7417,14 @@
       </p:sp>
       <p:sp>
         <p:nvSpPr>
-          <p:cNvPr id="30" name="Text 28"/>
-          <p:cNvSpPr txBox="1"/>
-          <p:nvPr/>
-        </p:nvSpPr>
-        <p:spPr>
-          <a:xfrm>
-            <a:off x="8887968" y="4069080"/>
-            <a:ext cx="548640" cy="320040"/>
+          <p:cNvPr id="34" name="Text 32"/>
+          <p:cNvSpPr txBox="1"/>
+          <p:nvPr/>
+        </p:nvSpPr>
+        <p:spPr>
+          <a:xfrm>
+            <a:off x="10149840" y="1801368"/>
+            <a:ext cx="411480" cy="411480"/>
           </a:xfrm>
           <a:prstGeom prst="rect">
             <a:avLst/>
@@ -7253,31 +7436,103 @@
           <a:bodyPr wrap="square" lIns="0" tIns="0" rIns="0" bIns="0" rtlCol="0" anchor="ctr"/>
           <a:lstStyle/>
           <a:p>
+            <a:pPr algn="ctr" indent="0" marL="0">
+              <a:buNone/>
+            </a:pPr>
+            <a:r>
+              <a:rPr lang="en-US" sz="1500" b="1" dirty="0">
+                <a:solidFill>
+                  <a:srgbClr val="FFFFFF"/>
+                </a:solidFill>
+              </a:rPr>
+              <a:t>5</a:t>
+            </a:r>
+            <a:endParaRPr lang="en-US" sz="1500" dirty="0"/>
+          </a:p>
+        </p:txBody>
+      </p:sp>
+      <p:sp>
+        <p:nvSpPr>
+          <p:cNvPr id="35" name="Text 33"/>
+          <p:cNvSpPr txBox="1"/>
+          <p:nvPr/>
+        </p:nvSpPr>
+        <p:spPr>
+          <a:xfrm>
+            <a:off x="10625328" y="1783080"/>
+            <a:ext cx="914400" cy="457200"/>
+          </a:xfrm>
+          <a:prstGeom prst="rect">
+            <a:avLst/>
+          </a:prstGeom>
+          <a:noFill/>
+          <a:ln/>
+        </p:spPr>
+        <p:txBody>
+          <a:bodyPr wrap="square" lIns="0" tIns="0" rIns="0" bIns="0" rtlCol="0" anchor="ctr"/>
+          <a:lstStyle/>
+          <a:p>
             <a:pPr indent="0" marL="0">
               <a:buNone/>
             </a:pPr>
             <a:r>
-              <a:rPr lang="en-US" sz="1400" b="1" dirty="0">
-                <a:solidFill>
-                  <a:srgbClr val="4472C4"/>
-                </a:solidFill>
-              </a:rPr>
-              <a:t>1.4</a:t>
-            </a:r>
-            <a:endParaRPr lang="en-US" sz="1400" dirty="0"/>
-          </a:p>
-        </p:txBody>
-      </p:sp>
-      <p:sp>
-        <p:nvSpPr>
-          <p:cNvPr id="31" name="Text 29"/>
-          <p:cNvSpPr txBox="1"/>
-          <p:nvPr/>
-        </p:nvSpPr>
-        <p:spPr>
-          <a:xfrm>
-            <a:off x="8412480" y="4480560"/>
-            <a:ext cx="3017520" cy="274320"/>
+              <a:rPr lang="en-US" sz="1500" b="1" dirty="0">
+                <a:solidFill>
+                  <a:schemeClr val="tx1"/>
+                </a:solidFill>
+              </a:rPr>
+              <a:t>Reuse</a:t>
+            </a:r>
+            <a:endParaRPr lang="en-US" sz="1500" dirty="0"/>
+          </a:p>
+        </p:txBody>
+      </p:sp>
+      <p:sp>
+        <p:nvSpPr>
+          <p:cNvPr id="36" name="Text 34"/>
+          <p:cNvSpPr txBox="1"/>
+          <p:nvPr/>
+        </p:nvSpPr>
+        <p:spPr>
+          <a:xfrm>
+            <a:off x="10186416" y="2331720"/>
+            <a:ext cx="1298448" cy="1234440"/>
+          </a:xfrm>
+          <a:prstGeom prst="rect">
+            <a:avLst/>
+          </a:prstGeom>
+          <a:noFill/>
+          <a:ln/>
+        </p:spPr>
+        <p:txBody>
+          <a:bodyPr wrap="square" lIns="0" tIns="0" rIns="0" bIns="0" rtlCol="0" anchor="t"/>
+          <a:lstStyle/>
+          <a:p>
+            <a:pPr indent="0" marL="0">
+              <a:buNone/>
+            </a:pPr>
+            <a:r>
+              <a:rPr lang="en-US" sz="1350" dirty="0">
+                <a:solidFill>
+                  <a:schemeClr val="tx1"/>
+                </a:solidFill>
+              </a:rPr>
+              <a:t>same kind of problem with new data: run the checked program again</a:t>
+            </a:r>
+            <a:endParaRPr lang="en-US" sz="1350" dirty="0"/>
+          </a:p>
+        </p:txBody>
+      </p:sp>
+      <p:sp>
+        <p:nvSpPr>
+          <p:cNvPr id="37" name="Text 35"/>
+          <p:cNvSpPr txBox="1"/>
+          <p:nvPr/>
+        </p:nvSpPr>
+        <p:spPr>
+          <a:xfrm>
+            <a:off x="10058400" y="3675888"/>
+            <a:ext cx="1554480" cy="320040"/>
           </a:xfrm>
           <a:prstGeom prst="rect">
             <a:avLst/>
@@ -7289,85 +7544,572 @@
           <a:bodyPr wrap="square" lIns="0" tIns="0" rIns="0" bIns="0" rtlCol="0" anchor="ctr"/>
           <a:lstStyle/>
           <a:p>
+            <a:pPr algn="ctr" indent="0" marL="0">
+              <a:buNone/>
+            </a:pPr>
+            <a:r>
+              <a:rPr lang="en-US" sz="1500" b="1" dirty="0">
+                <a:solidFill>
+                  <a:schemeClr val="tx2"/>
+                </a:solidFill>
+              </a:rPr>
+              <a:t>≈ 0 tokens</a:t>
+            </a:r>
+            <a:endParaRPr lang="en-US" sz="1500" dirty="0"/>
+          </a:p>
+        </p:txBody>
+      </p:sp>
+      <p:sp>
+        <p:nvSpPr>
+          <p:cNvPr id="38" name="Text 36"/>
+          <p:cNvSpPr txBox="1"/>
+          <p:nvPr/>
+        </p:nvSpPr>
+        <p:spPr>
+          <a:xfrm>
+            <a:off x="548640" y="4114800"/>
+            <a:ext cx="11064240" cy="365760"/>
+          </a:xfrm>
+          <a:prstGeom prst="rect">
+            <a:avLst/>
+          </a:prstGeom>
+          <a:noFill/>
+          <a:ln/>
+        </p:spPr>
+        <p:txBody>
+          <a:bodyPr wrap="square" lIns="0" tIns="0" rIns="0" bIns="0" rtlCol="0" anchor="ctr"/>
+          <a:lstStyle/>
+          <a:p>
             <a:pPr indent="0" marL="0">
               <a:buNone/>
             </a:pPr>
             <a:r>
-              <a:rPr lang="en-US" sz="1400" dirty="0">
+              <a:rPr lang="en-US" sz="1600" b="1" dirty="0">
                 <a:solidFill>
                   <a:schemeClr val="tx1"/>
                 </a:solidFill>
               </a:rPr>
-              <a:t>pick on 30 labels</a:t>
-            </a:r>
-            <a:endParaRPr lang="en-US" sz="1400" dirty="0"/>
-          </a:p>
-        </p:txBody>
-      </p:sp>
-      <p:sp>
-        <p:nvSpPr>
-          <p:cNvPr id="32" name="loss pick on 30 labels"/>
-          <p:cNvSpPr/>
-          <p:nvPr/>
-        </p:nvSpPr>
-        <p:spPr>
-          <a:xfrm>
-            <a:off x="8412480" y="4773168"/>
-            <a:ext cx="164592" cy="201168"/>
-          </a:xfrm>
-          <a:prstGeom prst="rect">
-            <a:avLst/>
-          </a:prstGeom>
-          <a:solidFill>
-            <a:srgbClr val="4472C4"/>
-          </a:solidFill>
-          <a:ln w="6350">
-            <a:solidFill>
-              <a:srgbClr val="4472C4"/>
-            </a:solidFill>
-            <a:prstDash val="solid"/>
-          </a:ln>
-        </p:spPr>
-      </p:sp>
-      <p:sp>
-        <p:nvSpPr>
-          <p:cNvPr id="33" name="Text 31"/>
-          <p:cNvSpPr txBox="1"/>
-          <p:nvPr/>
-        </p:nvSpPr>
-        <p:spPr>
-          <a:xfrm>
-            <a:off x="8668512" y="4709160"/>
-            <a:ext cx="548640" cy="320040"/>
-          </a:xfrm>
-          <a:prstGeom prst="rect">
-            <a:avLst/>
-          </a:prstGeom>
-          <a:noFill/>
-          <a:ln/>
-        </p:spPr>
-        <p:txBody>
-          <a:bodyPr wrap="square" lIns="0" tIns="0" rIns="0" bIns="0" rtlCol="0" anchor="ctr"/>
-          <a:lstStyle/>
-          <a:p>
-            <a:pPr indent="0" marL="0">
-              <a:buNone/>
-            </a:pPr>
-            <a:r>
-              <a:rPr lang="en-US" sz="1400" b="1" dirty="0">
-                <a:solidFill>
-                  <a:srgbClr val="4472C4"/>
-                </a:solidFill>
-              </a:rPr>
-              <a:t>0.6</a:t>
-            </a:r>
-            <a:endParaRPr lang="en-US" sz="1400" dirty="0"/>
-          </a:p>
-        </p:txBody>
-      </p:sp>
-      <p:sp>
-        <p:nvSpPr>
-          <p:cNvPr id="34" name="Text 32"/>
+              <a:t>The free check depends on the kind of problem (no answers needed)</a:t>
+            </a:r>
+            <a:endParaRPr lang="en-US" sz="1600" dirty="0"/>
+          </a:p>
+        </p:txBody>
+      </p:sp>
+      <p:graphicFrame>
+        <p:nvGraphicFramePr>
+          <p:cNvPr id="14" name="Table 0"/>
+          <p:cNvGraphicFramePr>
+            <a:graphicFrameLocks noGrp="1"/>
+          </p:cNvGraphicFramePr>
+          <p:nvPr>
+            <p:extLst>
+              <p:ext uri="{D42A27DB-BD31-4B8C-83A1-F6EECF244321}">
+                <p14:modId xmlns:p14="http://schemas.microsoft.com/office/powerpoint/2010/main" val="1579011935"/>
+              </p:ext>
+            </p:extLst>
+          </p:nvPr>
+        </p:nvGraphicFramePr>
+        <p:xfrm>
+          <a:off x="548640" y="4498848"/>
+          <a:ext cx="11064240" cy="914400"/>
+        </p:xfrm>
+        <a:graphic>
+          <a:graphicData uri="http://schemas.openxmlformats.org/drawingml/2006/table">
+            <a:tbl>
+              <a:tblPr/>
+              <a:tblGrid>
+                <a:gridCol w="2743200"/>
+                <a:gridCol w="2834640"/>
+                <a:gridCol w="2743200"/>
+                <a:gridCol w="2743200"/>
+              </a:tblGrid>
+              <a:tr h="384048">
+                <a:tc>
+                  <a:txBody>
+                    <a:bodyPr/>
+                    <a:lstStyle/>
+                    <a:p>
+                      <a:pPr indent="0" marL="0">
+                        <a:buNone/>
+                      </a:pPr>
+                      <a:r>
+                        <a:rPr lang="en-US" sz="1400" b="1" dirty="0">
+                          <a:solidFill>
+                            <a:srgbClr val="FFFFFF"/>
+                          </a:solidFill>
+                        </a:rPr>
+                        <a:t>Contest problems</a:t>
+                      </a:r>
+                      <a:endParaRPr lang="en-US" sz="1400" dirty="0"/>
+                    </a:p>
+                  </a:txBody>
+                  <a:tcPr marL="54864" marR="54864" marT="54864" marB="54864" anchor="ctr">
+                    <a:lnL w="9525" cap="flat" cmpd="sng" algn="ctr">
+                      <a:solidFill>
+                        <a:srgbClr val="BFBFBF"/>
+                      </a:solidFill>
+                      <a:prstDash val="solid"/>
+                      <a:round/>
+                      <a:headEnd type="none" w="med" len="med"/>
+                      <a:tailEnd type="none" w="med" len="med"/>
+                    </a:lnL>
+                    <a:lnR w="9525" cap="flat" cmpd="sng" algn="ctr">
+                      <a:solidFill>
+                        <a:srgbClr val="BFBFBF"/>
+                      </a:solidFill>
+                      <a:prstDash val="solid"/>
+                      <a:round/>
+                      <a:headEnd type="none" w="med" len="med"/>
+                      <a:tailEnd type="none" w="med" len="med"/>
+                    </a:lnR>
+                    <a:lnT w="9525" cap="flat" cmpd="sng" algn="ctr">
+                      <a:solidFill>
+                        <a:srgbClr val="BFBFBF"/>
+                      </a:solidFill>
+                      <a:prstDash val="solid"/>
+                      <a:round/>
+                      <a:headEnd type="none" w="med" len="med"/>
+                      <a:tailEnd type="none" w="med" len="med"/>
+                    </a:lnT>
+                    <a:lnB w="9525" cap="flat" cmpd="sng" algn="ctr">
+                      <a:solidFill>
+                        <a:srgbClr val="BFBFBF"/>
+                      </a:solidFill>
+                      <a:prstDash val="solid"/>
+                      <a:round/>
+                      <a:headEnd type="none" w="med" len="med"/>
+                      <a:tailEnd type="none" w="med" len="med"/>
+                    </a:lnB>
+                    <a:solidFill>
+                      <a:srgbClr val="4472C4"/>
+                    </a:solidFill>
+                  </a:tcPr>
+                </a:tc>
+                <a:tc>
+                  <a:txBody>
+                    <a:bodyPr/>
+                    <a:lstStyle/>
+                    <a:p>
+                      <a:pPr indent="0" marL="0">
+                        <a:buNone/>
+                      </a:pPr>
+                      <a:r>
+                        <a:rPr lang="en-US" sz="1400" b="1" dirty="0">
+                          <a:solidFill>
+                            <a:srgbClr val="FFFFFF"/>
+                          </a:solidFill>
+                        </a:rPr>
+                        <a:t>Geometry</a:t>
+                      </a:r>
+                      <a:endParaRPr lang="en-US" sz="1400" dirty="0"/>
+                    </a:p>
+                  </a:txBody>
+                  <a:tcPr marL="54864" marR="54864" marT="54864" marB="54864" anchor="ctr">
+                    <a:lnL w="9525" cap="flat" cmpd="sng" algn="ctr">
+                      <a:solidFill>
+                        <a:srgbClr val="BFBFBF"/>
+                      </a:solidFill>
+                      <a:prstDash val="solid"/>
+                      <a:round/>
+                      <a:headEnd type="none" w="med" len="med"/>
+                      <a:tailEnd type="none" w="med" len="med"/>
+                    </a:lnL>
+                    <a:lnR w="9525" cap="flat" cmpd="sng" algn="ctr">
+                      <a:solidFill>
+                        <a:srgbClr val="BFBFBF"/>
+                      </a:solidFill>
+                      <a:prstDash val="solid"/>
+                      <a:round/>
+                      <a:headEnd type="none" w="med" len="med"/>
+                      <a:tailEnd type="none" w="med" len="med"/>
+                    </a:lnR>
+                    <a:lnT w="9525" cap="flat" cmpd="sng" algn="ctr">
+                      <a:solidFill>
+                        <a:srgbClr val="BFBFBF"/>
+                      </a:solidFill>
+                      <a:prstDash val="solid"/>
+                      <a:round/>
+                      <a:headEnd type="none" w="med" len="med"/>
+                      <a:tailEnd type="none" w="med" len="med"/>
+                    </a:lnT>
+                    <a:lnB w="9525" cap="flat" cmpd="sng" algn="ctr">
+                      <a:solidFill>
+                        <a:srgbClr val="BFBFBF"/>
+                      </a:solidFill>
+                      <a:prstDash val="solid"/>
+                      <a:round/>
+                      <a:headEnd type="none" w="med" len="med"/>
+                      <a:tailEnd type="none" w="med" len="med"/>
+                    </a:lnB>
+                    <a:solidFill>
+                      <a:srgbClr val="4472C4"/>
+                    </a:solidFill>
+                  </a:tcPr>
+                </a:tc>
+                <a:tc>
+                  <a:txBody>
+                    <a:bodyPr/>
+                    <a:lstStyle/>
+                    <a:p>
+                      <a:pPr indent="0" marL="0">
+                        <a:buNone/>
+                      </a:pPr>
+                      <a:r>
+                        <a:rPr lang="en-US" sz="1400" b="1" dirty="0">
+                          <a:solidFill>
+                            <a:srgbClr val="FFFFFF"/>
+                          </a:solidFill>
+                        </a:rPr>
+                        <a:t>Routing and scheduling</a:t>
+                      </a:r>
+                      <a:endParaRPr lang="en-US" sz="1400" dirty="0"/>
+                    </a:p>
+                  </a:txBody>
+                  <a:tcPr marL="54864" marR="54864" marT="54864" marB="54864" anchor="ctr">
+                    <a:lnL w="9525" cap="flat" cmpd="sng" algn="ctr">
+                      <a:solidFill>
+                        <a:srgbClr val="BFBFBF"/>
+                      </a:solidFill>
+                      <a:prstDash val="solid"/>
+                      <a:round/>
+                      <a:headEnd type="none" w="med" len="med"/>
+                      <a:tailEnd type="none" w="med" len="med"/>
+                    </a:lnL>
+                    <a:lnR w="9525" cap="flat" cmpd="sng" algn="ctr">
+                      <a:solidFill>
+                        <a:srgbClr val="BFBFBF"/>
+                      </a:solidFill>
+                      <a:prstDash val="solid"/>
+                      <a:round/>
+                      <a:headEnd type="none" w="med" len="med"/>
+                      <a:tailEnd type="none" w="med" len="med"/>
+                    </a:lnR>
+                    <a:lnT w="9525" cap="flat" cmpd="sng" algn="ctr">
+                      <a:solidFill>
+                        <a:srgbClr val="BFBFBF"/>
+                      </a:solidFill>
+                      <a:prstDash val="solid"/>
+                      <a:round/>
+                      <a:headEnd type="none" w="med" len="med"/>
+                      <a:tailEnd type="none" w="med" len="med"/>
+                    </a:lnT>
+                    <a:lnB w="9525" cap="flat" cmpd="sng" algn="ctr">
+                      <a:solidFill>
+                        <a:srgbClr val="BFBFBF"/>
+                      </a:solidFill>
+                      <a:prstDash val="solid"/>
+                      <a:round/>
+                      <a:headEnd type="none" w="med" len="med"/>
+                      <a:tailEnd type="none" w="med" len="med"/>
+                    </a:lnB>
+                    <a:solidFill>
+                      <a:srgbClr val="4472C4"/>
+                    </a:solidFill>
+                  </a:tcPr>
+                </a:tc>
+                <a:tc>
+                  <a:txBody>
+                    <a:bodyPr/>
+                    <a:lstStyle/>
+                    <a:p>
+                      <a:pPr indent="0" marL="0">
+                        <a:buNone/>
+                      </a:pPr>
+                      <a:r>
+                        <a:rPr lang="en-US" sz="1400" b="1" dirty="0">
+                          <a:solidFill>
+                            <a:srgbClr val="FFFFFF"/>
+                          </a:solidFill>
+                        </a:rPr>
+                        <a:t>Word problems and math</a:t>
+                      </a:r>
+                      <a:endParaRPr lang="en-US" sz="1400" dirty="0"/>
+                    </a:p>
+                  </a:txBody>
+                  <a:tcPr marL="54864" marR="54864" marT="54864" marB="54864" anchor="ctr">
+                    <a:lnL w="9525" cap="flat" cmpd="sng" algn="ctr">
+                      <a:solidFill>
+                        <a:srgbClr val="BFBFBF"/>
+                      </a:solidFill>
+                      <a:prstDash val="solid"/>
+                      <a:round/>
+                      <a:headEnd type="none" w="med" len="med"/>
+                      <a:tailEnd type="none" w="med" len="med"/>
+                    </a:lnL>
+                    <a:lnR w="9525" cap="flat" cmpd="sng" algn="ctr">
+                      <a:solidFill>
+                        <a:srgbClr val="BFBFBF"/>
+                      </a:solidFill>
+                      <a:prstDash val="solid"/>
+                      <a:round/>
+                      <a:headEnd type="none" w="med" len="med"/>
+                      <a:tailEnd type="none" w="med" len="med"/>
+                    </a:lnR>
+                    <a:lnT w="9525" cap="flat" cmpd="sng" algn="ctr">
+                      <a:solidFill>
+                        <a:srgbClr val="BFBFBF"/>
+                      </a:solidFill>
+                      <a:prstDash val="solid"/>
+                      <a:round/>
+                      <a:headEnd type="none" w="med" len="med"/>
+                      <a:tailEnd type="none" w="med" len="med"/>
+                    </a:lnT>
+                    <a:lnB w="9525" cap="flat" cmpd="sng" algn="ctr">
+                      <a:solidFill>
+                        <a:srgbClr val="BFBFBF"/>
+                      </a:solidFill>
+                      <a:prstDash val="solid"/>
+                      <a:round/>
+                      <a:headEnd type="none" w="med" len="med"/>
+                      <a:tailEnd type="none" w="med" len="med"/>
+                    </a:lnB>
+                    <a:solidFill>
+                      <a:srgbClr val="4472C4"/>
+                    </a:solidFill>
+                  </a:tcPr>
+                </a:tc>
+              </a:tr>
+              <a:tr h="777240">
+                <a:tc>
+                  <a:txBody>
+                    <a:bodyPr/>
+                    <a:lstStyle/>
+                    <a:p>
+                      <a:pPr indent="0" marL="0">
+                        <a:buNone/>
+                      </a:pPr>
+                      <a:r>
+                        <a:rPr lang="en-US" sz="1400" dirty="0">
+                          <a:solidFill>
+                            <a:schemeClr val="tx1"/>
+                          </a:solidFill>
+                        </a:rPr>
+                        <a:t>run the sample tests printed in the statement</a:t>
+                      </a:r>
+                      <a:endParaRPr lang="en-US" sz="1400" dirty="0"/>
+                    </a:p>
+                  </a:txBody>
+                  <a:tcPr marL="54864" marR="54864" marT="54864" marB="54864" anchor="ctr">
+                    <a:lnL w="9525" cap="flat" cmpd="sng" algn="ctr">
+                      <a:solidFill>
+                        <a:srgbClr val="BFBFBF"/>
+                      </a:solidFill>
+                      <a:prstDash val="solid"/>
+                      <a:round/>
+                      <a:headEnd type="none" w="med" len="med"/>
+                      <a:tailEnd type="none" w="med" len="med"/>
+                    </a:lnL>
+                    <a:lnR w="9525" cap="flat" cmpd="sng" algn="ctr">
+                      <a:solidFill>
+                        <a:srgbClr val="BFBFBF"/>
+                      </a:solidFill>
+                      <a:prstDash val="solid"/>
+                      <a:round/>
+                      <a:headEnd type="none" w="med" len="med"/>
+                      <a:tailEnd type="none" w="med" len="med"/>
+                    </a:lnR>
+                    <a:lnT w="9525" cap="flat" cmpd="sng" algn="ctr">
+                      <a:solidFill>
+                        <a:srgbClr val="BFBFBF"/>
+                      </a:solidFill>
+                      <a:prstDash val="solid"/>
+                      <a:round/>
+                      <a:headEnd type="none" w="med" len="med"/>
+                      <a:tailEnd type="none" w="med" len="med"/>
+                    </a:lnT>
+                    <a:lnB w="9525" cap="flat" cmpd="sng" algn="ctr">
+                      <a:solidFill>
+                        <a:srgbClr val="BFBFBF"/>
+                      </a:solidFill>
+                      <a:prstDash val="solid"/>
+                      <a:round/>
+                      <a:headEnd type="none" w="med" len="med"/>
+                      <a:tailEnd type="none" w="med" len="med"/>
+                    </a:lnB>
+                  </a:tcPr>
+                </a:tc>
+                <a:tc>
+                  <a:txBody>
+                    <a:bodyPr/>
+                    <a:lstStyle/>
+                    <a:p>
+                      <a:pPr indent="0" marL="0">
+                        <a:buNone/>
+                      </a:pPr>
+                      <a:r>
+                        <a:rPr lang="en-US" sz="1400" dirty="0">
+                          <a:solidFill>
+                            <a:schemeClr val="tx1"/>
+                          </a:solidFill>
+                        </a:rPr>
+                        <a:t>same answer on moved, turned and mirrored copies; or two versions agree</a:t>
+                      </a:r>
+                      <a:endParaRPr lang="en-US" sz="1400" dirty="0"/>
+                    </a:p>
+                  </a:txBody>
+                  <a:tcPr marL="54864" marR="54864" marT="54864" marB="54864" anchor="ctr">
+                    <a:lnL w="9525" cap="flat" cmpd="sng" algn="ctr">
+                      <a:solidFill>
+                        <a:srgbClr val="BFBFBF"/>
+                      </a:solidFill>
+                      <a:prstDash val="solid"/>
+                      <a:round/>
+                      <a:headEnd type="none" w="med" len="med"/>
+                      <a:tailEnd type="none" w="med" len="med"/>
+                    </a:lnL>
+                    <a:lnR w="9525" cap="flat" cmpd="sng" algn="ctr">
+                      <a:solidFill>
+                        <a:srgbClr val="BFBFBF"/>
+                      </a:solidFill>
+                      <a:prstDash val="solid"/>
+                      <a:round/>
+                      <a:headEnd type="none" w="med" len="med"/>
+                      <a:tailEnd type="none" w="med" len="med"/>
+                    </a:lnR>
+                    <a:lnT w="9525" cap="flat" cmpd="sng" algn="ctr">
+                      <a:solidFill>
+                        <a:srgbClr val="BFBFBF"/>
+                      </a:solidFill>
+                      <a:prstDash val="solid"/>
+                      <a:round/>
+                      <a:headEnd type="none" w="med" len="med"/>
+                      <a:tailEnd type="none" w="med" len="med"/>
+                    </a:lnT>
+                    <a:lnB w="9525" cap="flat" cmpd="sng" algn="ctr">
+                      <a:solidFill>
+                        <a:srgbClr val="BFBFBF"/>
+                      </a:solidFill>
+                      <a:prstDash val="solid"/>
+                      <a:round/>
+                      <a:headEnd type="none" w="med" len="med"/>
+                      <a:tailEnd type="none" w="med" len="med"/>
+                    </a:lnB>
+                  </a:tcPr>
+                </a:tc>
+                <a:tc>
+                  <a:txBody>
+                    <a:bodyPr/>
+                    <a:lstStyle/>
+                    <a:p>
+                      <a:pPr indent="0" marL="0">
+                        <a:buNone/>
+                      </a:pPr>
+                      <a:r>
+                        <a:rPr lang="en-US" sz="1400" dirty="0">
+                          <a:solidFill>
+                            <a:schemeClr val="tx1"/>
+                          </a:solidFill>
+                        </a:rPr>
+                        <a:t>the plan obeys every rule (capacity, time windows)</a:t>
+                      </a:r>
+                      <a:endParaRPr lang="en-US" sz="1400" dirty="0"/>
+                    </a:p>
+                  </a:txBody>
+                  <a:tcPr marL="54864" marR="54864" marT="54864" marB="54864" anchor="ctr">
+                    <a:lnL w="9525" cap="flat" cmpd="sng" algn="ctr">
+                      <a:solidFill>
+                        <a:srgbClr val="BFBFBF"/>
+                      </a:solidFill>
+                      <a:prstDash val="solid"/>
+                      <a:round/>
+                      <a:headEnd type="none" w="med" len="med"/>
+                      <a:tailEnd type="none" w="med" len="med"/>
+                    </a:lnL>
+                    <a:lnR w="9525" cap="flat" cmpd="sng" algn="ctr">
+                      <a:solidFill>
+                        <a:srgbClr val="BFBFBF"/>
+                      </a:solidFill>
+                      <a:prstDash val="solid"/>
+                      <a:round/>
+                      <a:headEnd type="none" w="med" len="med"/>
+                      <a:tailEnd type="none" w="med" len="med"/>
+                    </a:lnR>
+                    <a:lnT w="9525" cap="flat" cmpd="sng" algn="ctr">
+                      <a:solidFill>
+                        <a:srgbClr val="BFBFBF"/>
+                      </a:solidFill>
+                      <a:prstDash val="solid"/>
+                      <a:round/>
+                      <a:headEnd type="none" w="med" len="med"/>
+                      <a:tailEnd type="none" w="med" len="med"/>
+                    </a:lnT>
+                    <a:lnB w="9525" cap="flat" cmpd="sng" algn="ctr">
+                      <a:solidFill>
+                        <a:srgbClr val="BFBFBF"/>
+                      </a:solidFill>
+                      <a:prstDash val="solid"/>
+                      <a:round/>
+                      <a:headEnd type="none" w="med" len="med"/>
+                      <a:tailEnd type="none" w="med" len="med"/>
+                    </a:lnB>
+                  </a:tcPr>
+                </a:tc>
+                <a:tc>
+                  <a:txBody>
+                    <a:bodyPr/>
+                    <a:lstStyle/>
+                    <a:p>
+                      <a:pPr indent="0" marL="0">
+                        <a:buNone/>
+                      </a:pPr>
+                      <a:r>
+                        <a:rPr lang="en-US" sz="1400" dirty="0">
+                          <a:solidFill>
+                            <a:schemeClr val="tx1"/>
+                          </a:solidFill>
+                        </a:rPr>
+                        <a:t>the program runs and prints a value; two versions (or text and program) agree</a:t>
+                      </a:r>
+                      <a:endParaRPr lang="en-US" sz="1400" dirty="0"/>
+                    </a:p>
+                  </a:txBody>
+                  <a:tcPr marL="54864" marR="54864" marT="54864" marB="54864" anchor="ctr">
+                    <a:lnL w="9525" cap="flat" cmpd="sng" algn="ctr">
+                      <a:solidFill>
+                        <a:srgbClr val="BFBFBF"/>
+                      </a:solidFill>
+                      <a:prstDash val="solid"/>
+                      <a:round/>
+                      <a:headEnd type="none" w="med" len="med"/>
+                      <a:tailEnd type="none" w="med" len="med"/>
+                    </a:lnL>
+                    <a:lnR w="9525" cap="flat" cmpd="sng" algn="ctr">
+                      <a:solidFill>
+                        <a:srgbClr val="BFBFBF"/>
+                      </a:solidFill>
+                      <a:prstDash val="solid"/>
+                      <a:round/>
+                      <a:headEnd type="none" w="med" len="med"/>
+                      <a:tailEnd type="none" w="med" len="med"/>
+                    </a:lnR>
+                    <a:lnT w="9525" cap="flat" cmpd="sng" algn="ctr">
+                      <a:solidFill>
+                        <a:srgbClr val="BFBFBF"/>
+                      </a:solidFill>
+                      <a:prstDash val="solid"/>
+                      <a:round/>
+                      <a:headEnd type="none" w="med" len="med"/>
+                      <a:tailEnd type="none" w="med" len="med"/>
+                    </a:lnT>
+                    <a:lnB w="9525" cap="flat" cmpd="sng" algn="ctr">
+                      <a:solidFill>
+                        <a:srgbClr val="BFBFBF"/>
+                      </a:solidFill>
+                      <a:prstDash val="solid"/>
+                      <a:round/>
+                      <a:headEnd type="none" w="med" len="med"/>
+                      <a:tailEnd type="none" w="med" len="med"/>
+                    </a:lnB>
+                  </a:tcPr>
+                </a:tc>
+              </a:tr>
+            </a:tbl>
+          </a:graphicData>
+        </a:graphic>
+      </p:graphicFrame>
+      <p:sp>
+        <p:nvSpPr>
+          <p:cNvPr id="40" name="Text 37"/>
           <p:cNvSpPr txBox="1"/>
           <p:nvPr/>
         </p:nvSpPr>
@@ -7395,7 +8137,7 @@
                   <a:schemeClr val="tx1"/>
                 </a:solidFill>
               </a:rPr>
-              <a:t>Most accurate and among the cheapest on all 3 seeds: spend thinking where a check fails</a:t>
+              <a:t>Cheap steps first: this problem cost 0.6k tokens instead of 5.3k, and it is right</a:t>
             </a:r>
             <a:endParaRPr lang="en-US" sz="2000" dirty="0"/>
           </a:p>
@@ -7503,6 +8245,1158 @@
                   <a:schemeClr val="tx1"/>
                 </a:solidFill>
               </a:rPr>
+              <a:t>All together: facts first, think only on failure</a:t>
+            </a:r>
+            <a:endParaRPr lang="en-US" sz="3600" dirty="0"/>
+          </a:p>
+        </p:txBody>
+      </p:sp>
+      <p:sp>
+        <p:nvSpPr>
+          <p:cNvPr id="3" name="Text 1"/>
+          <p:cNvSpPr txBox="1"/>
+          <p:nvPr/>
+        </p:nvSpPr>
+        <p:spPr>
+          <a:xfrm>
+            <a:off x="548640" y="1234440"/>
+            <a:ext cx="11064240" cy="411480"/>
+          </a:xfrm>
+          <a:prstGeom prst="rect">
+            <a:avLst/>
+          </a:prstGeom>
+          <a:noFill/>
+          <a:ln/>
+        </p:spPr>
+        <p:txBody>
+          <a:bodyPr wrap="square" lIns="0" tIns="0" rIns="0" bIns="0" rtlCol="0" anchor="ctr"/>
+          <a:lstStyle/>
+          <a:p>
+            <a:pPr indent="0" marL="0">
+              <a:buNone/>
+            </a:pPr>
+            <a:r>
+              <a:rPr lang="en-US" sz="1800" dirty="0">
+                <a:solidFill>
+                  <a:schemeClr val="tx1"/>
+                </a:solidFill>
+              </a:rPr>
+              <a:t>Same 624 geometry and optimization problems, 3 models: % solved · tokens per problem</a:t>
+            </a:r>
+            <a:endParaRPr lang="en-US" sz="1800" dirty="0"/>
+          </a:p>
+        </p:txBody>
+      </p:sp>
+      <p:sp>
+        <p:nvSpPr>
+          <p:cNvPr id="4" name="Text 2"/>
+          <p:cNvSpPr txBox="1"/>
+          <p:nvPr/>
+        </p:nvSpPr>
+        <p:spPr>
+          <a:xfrm>
+            <a:off x="548640" y="1783080"/>
+            <a:ext cx="2651760" cy="453542"/>
+          </a:xfrm>
+          <a:prstGeom prst="rect">
+            <a:avLst/>
+          </a:prstGeom>
+          <a:noFill/>
+          <a:ln/>
+        </p:spPr>
+        <p:txBody>
+          <a:bodyPr wrap="square" lIns="0" tIns="0" rIns="0" bIns="0" rtlCol="0" anchor="ctr"/>
+          <a:lstStyle/>
+          <a:p>
+            <a:pPr algn="r" indent="0" marL="0">
+              <a:buNone/>
+            </a:pPr>
+            <a:r>
+              <a:rPr lang="en-US" sz="1600" dirty="0">
+                <a:solidFill>
+                  <a:schemeClr val="tx1"/>
+                </a:solidFill>
+              </a:rPr>
+              <a:t>First program, no help</a:t>
+            </a:r>
+            <a:endParaRPr lang="en-US" sz="1600" dirty="0"/>
+          </a:p>
+        </p:txBody>
+      </p:sp>
+      <p:sp>
+        <p:nvSpPr>
+          <p:cNvPr id="5" name="bar First program, no help"/>
+          <p:cNvSpPr/>
+          <p:nvPr/>
+        </p:nvSpPr>
+        <p:spPr>
+          <a:xfrm>
+            <a:off x="3337560" y="1868119"/>
+            <a:ext cx="1958645" cy="283464"/>
+          </a:xfrm>
+          <a:prstGeom prst="rect">
+            <a:avLst/>
+          </a:prstGeom>
+          <a:solidFill>
+            <a:srgbClr val="A5A5A5"/>
+          </a:solidFill>
+          <a:ln w="6350">
+            <a:solidFill>
+              <a:srgbClr val="A5A5A5"/>
+            </a:solidFill>
+            <a:prstDash val="solid"/>
+          </a:ln>
+        </p:spPr>
+      </p:sp>
+      <p:sp>
+        <p:nvSpPr>
+          <p:cNvPr id="6" name="Text 4"/>
+          <p:cNvSpPr txBox="1"/>
+          <p:nvPr/>
+        </p:nvSpPr>
+        <p:spPr>
+          <a:xfrm>
+            <a:off x="5387645" y="1783080"/>
+            <a:ext cx="1554480" cy="453542"/>
+          </a:xfrm>
+          <a:prstGeom prst="rect">
+            <a:avLst/>
+          </a:prstGeom>
+          <a:noFill/>
+          <a:ln/>
+        </p:spPr>
+        <p:txBody>
+          <a:bodyPr wrap="square" lIns="0" tIns="0" rIns="0" bIns="0" rtlCol="0" anchor="ctr"/>
+          <a:lstStyle/>
+          <a:p>
+            <a:pPr indent="0" marL="0">
+              <a:buNone/>
+            </a:pPr>
+            <a:r>
+              <a:rPr lang="en-US" sz="1800" b="1" dirty="0">
+                <a:solidFill>
+                  <a:srgbClr val="A5A5A5"/>
+                </a:solidFill>
+              </a:rPr>
+              <a:t>63% · 0.7k</a:t>
+            </a:r>
+            <a:endParaRPr lang="en-US" sz="1800" dirty="0"/>
+          </a:p>
+        </p:txBody>
+      </p:sp>
+      <p:sp>
+        <p:nvSpPr>
+          <p:cNvPr id="7" name="Text 5"/>
+          <p:cNvSpPr txBox="1"/>
+          <p:nvPr/>
+        </p:nvSpPr>
+        <p:spPr>
+          <a:xfrm>
+            <a:off x="548640" y="2350008"/>
+            <a:ext cx="2651760" cy="453542"/>
+          </a:xfrm>
+          <a:prstGeom prst="rect">
+            <a:avLst/>
+          </a:prstGeom>
+          <a:noFill/>
+          <a:ln/>
+        </p:spPr>
+        <p:txBody>
+          <a:bodyPr wrap="square" lIns="0" tIns="0" rIns="0" bIns="0" rtlCol="0" anchor="ctr"/>
+          <a:lstStyle/>
+          <a:p>
+            <a:pPr algn="r" indent="0" marL="0">
+              <a:buNone/>
+            </a:pPr>
+            <a:r>
+              <a:rPr lang="en-US" sz="1600" dirty="0">
+                <a:solidFill>
+                  <a:schemeClr val="tx1"/>
+                </a:solidFill>
+              </a:rPr>
+              <a:t>Think on hardest-looking</a:t>
+            </a:r>
+            <a:endParaRPr lang="en-US" sz="1600" dirty="0"/>
+          </a:p>
+        </p:txBody>
+      </p:sp>
+      <p:sp>
+        <p:nvSpPr>
+          <p:cNvPr id="8" name="bar Think on hardest-looking"/>
+          <p:cNvSpPr/>
+          <p:nvPr/>
+        </p:nvSpPr>
+        <p:spPr>
+          <a:xfrm>
+            <a:off x="3337560" y="2435047"/>
+            <a:ext cx="2300630" cy="283464"/>
+          </a:xfrm>
+          <a:prstGeom prst="rect">
+            <a:avLst/>
+          </a:prstGeom>
+          <a:solidFill>
+            <a:srgbClr val="7F7F7F"/>
+          </a:solidFill>
+          <a:ln w="6350">
+            <a:solidFill>
+              <a:srgbClr val="7F7F7F"/>
+            </a:solidFill>
+            <a:prstDash val="solid"/>
+          </a:ln>
+        </p:spPr>
+      </p:sp>
+      <p:sp>
+        <p:nvSpPr>
+          <p:cNvPr id="9" name="Text 7"/>
+          <p:cNvSpPr txBox="1"/>
+          <p:nvPr/>
+        </p:nvSpPr>
+        <p:spPr>
+          <a:xfrm>
+            <a:off x="5729630" y="2350008"/>
+            <a:ext cx="1554480" cy="453542"/>
+          </a:xfrm>
+          <a:prstGeom prst="rect">
+            <a:avLst/>
+          </a:prstGeom>
+          <a:noFill/>
+          <a:ln/>
+        </p:spPr>
+        <p:txBody>
+          <a:bodyPr wrap="square" lIns="0" tIns="0" rIns="0" bIns="0" rtlCol="0" anchor="ctr"/>
+          <a:lstStyle/>
+          <a:p>
+            <a:pPr indent="0" marL="0">
+              <a:buNone/>
+            </a:pPr>
+            <a:r>
+              <a:rPr lang="en-US" sz="1800" b="1" dirty="0">
+                <a:solidFill>
+                  <a:srgbClr val="7F7F7F"/>
+                </a:solidFill>
+              </a:rPr>
+              <a:t>74% · 4.1k</a:t>
+            </a:r>
+            <a:endParaRPr lang="en-US" sz="1800" dirty="0"/>
+          </a:p>
+        </p:txBody>
+      </p:sp>
+      <p:sp>
+        <p:nvSpPr>
+          <p:cNvPr id="10" name="Text 8"/>
+          <p:cNvSpPr txBox="1"/>
+          <p:nvPr/>
+        </p:nvSpPr>
+        <p:spPr>
+          <a:xfrm>
+            <a:off x="548640" y="2916936"/>
+            <a:ext cx="2651760" cy="453542"/>
+          </a:xfrm>
+          <a:prstGeom prst="rect">
+            <a:avLst/>
+          </a:prstGeom>
+          <a:noFill/>
+          <a:ln/>
+        </p:spPr>
+        <p:txBody>
+          <a:bodyPr wrap="square" lIns="0" tIns="0" rIns="0" bIns="0" rtlCol="0" anchor="ctr"/>
+          <a:lstStyle/>
+          <a:p>
+            <a:pPr algn="r" indent="0" marL="0">
+              <a:buNone/>
+            </a:pPr>
+            <a:r>
+              <a:rPr lang="en-US" sz="1600" dirty="0">
+                <a:solidFill>
+                  <a:schemeClr val="tx1"/>
+                </a:solidFill>
+              </a:rPr>
+              <a:t>Think when check fails</a:t>
+            </a:r>
+            <a:endParaRPr lang="en-US" sz="1600" dirty="0"/>
+          </a:p>
+        </p:txBody>
+      </p:sp>
+      <p:sp>
+        <p:nvSpPr>
+          <p:cNvPr id="11" name="bar Think when check fails"/>
+          <p:cNvSpPr/>
+          <p:nvPr/>
+        </p:nvSpPr>
+        <p:spPr>
+          <a:xfrm>
+            <a:off x="3337560" y="3001975"/>
+            <a:ext cx="2393899" cy="283464"/>
+          </a:xfrm>
+          <a:prstGeom prst="rect">
+            <a:avLst/>
+          </a:prstGeom>
+          <a:solidFill>
+            <a:srgbClr val="7F7F7F"/>
+          </a:solidFill>
+          <a:ln w="6350">
+            <a:solidFill>
+              <a:srgbClr val="7F7F7F"/>
+            </a:solidFill>
+            <a:prstDash val="solid"/>
+          </a:ln>
+        </p:spPr>
+      </p:sp>
+      <p:sp>
+        <p:nvSpPr>
+          <p:cNvPr id="12" name="Text 10"/>
+          <p:cNvSpPr txBox="1"/>
+          <p:nvPr/>
+        </p:nvSpPr>
+        <p:spPr>
+          <a:xfrm>
+            <a:off x="5822899" y="2916936"/>
+            <a:ext cx="1554480" cy="453542"/>
+          </a:xfrm>
+          <a:prstGeom prst="rect">
+            <a:avLst/>
+          </a:prstGeom>
+          <a:noFill/>
+          <a:ln/>
+        </p:spPr>
+        <p:txBody>
+          <a:bodyPr wrap="square" lIns="0" tIns="0" rIns="0" bIns="0" rtlCol="0" anchor="ctr"/>
+          <a:lstStyle/>
+          <a:p>
+            <a:pPr indent="0" marL="0">
+              <a:buNone/>
+            </a:pPr>
+            <a:r>
+              <a:rPr lang="en-US" sz="1800" b="1" dirty="0">
+                <a:solidFill>
+                  <a:srgbClr val="7F7F7F"/>
+                </a:solidFill>
+              </a:rPr>
+              <a:t>77% · 4.2k</a:t>
+            </a:r>
+            <a:endParaRPr lang="en-US" sz="1800" dirty="0"/>
+          </a:p>
+        </p:txBody>
+      </p:sp>
+      <p:sp>
+        <p:nvSpPr>
+          <p:cNvPr id="13" name="Text 11"/>
+          <p:cNvSpPr txBox="1"/>
+          <p:nvPr/>
+        </p:nvSpPr>
+        <p:spPr>
+          <a:xfrm>
+            <a:off x="548640" y="3483864"/>
+            <a:ext cx="2651760" cy="453542"/>
+          </a:xfrm>
+          <a:prstGeom prst="rect">
+            <a:avLst/>
+          </a:prstGeom>
+          <a:noFill/>
+          <a:ln/>
+        </p:spPr>
+        <p:txBody>
+          <a:bodyPr wrap="square" lIns="0" tIns="0" rIns="0" bIns="0" rtlCol="0" anchor="ctr"/>
+          <a:lstStyle/>
+          <a:p>
+            <a:pPr algn="r" indent="0" marL="0">
+              <a:buNone/>
+            </a:pPr>
+            <a:r>
+              <a:rPr lang="en-US" sz="1600" dirty="0">
+                <a:solidFill>
+                  <a:schemeClr val="tx1"/>
+                </a:solidFill>
+              </a:rPr>
+              <a:t>Fix by failure type</a:t>
+            </a:r>
+            <a:endParaRPr lang="en-US" sz="1600" dirty="0"/>
+          </a:p>
+        </p:txBody>
+      </p:sp>
+      <p:sp>
+        <p:nvSpPr>
+          <p:cNvPr id="14" name="bar Fix by failure type"/>
+          <p:cNvSpPr/>
+          <p:nvPr/>
+        </p:nvSpPr>
+        <p:spPr>
+          <a:xfrm>
+            <a:off x="3337560" y="3568903"/>
+            <a:ext cx="2580437" cy="283464"/>
+          </a:xfrm>
+          <a:prstGeom prst="rect">
+            <a:avLst/>
+          </a:prstGeom>
+          <a:solidFill>
+            <a:srgbClr val="ED7D31"/>
+          </a:solidFill>
+          <a:ln w="6350">
+            <a:solidFill>
+              <a:srgbClr val="ED7D31"/>
+            </a:solidFill>
+            <a:prstDash val="solid"/>
+          </a:ln>
+        </p:spPr>
+      </p:sp>
+      <p:sp>
+        <p:nvSpPr>
+          <p:cNvPr id="15" name="Text 13"/>
+          <p:cNvSpPr txBox="1"/>
+          <p:nvPr/>
+        </p:nvSpPr>
+        <p:spPr>
+          <a:xfrm>
+            <a:off x="6009437" y="3483864"/>
+            <a:ext cx="1554480" cy="453542"/>
+          </a:xfrm>
+          <a:prstGeom prst="rect">
+            <a:avLst/>
+          </a:prstGeom>
+          <a:noFill/>
+          <a:ln/>
+        </p:spPr>
+        <p:txBody>
+          <a:bodyPr wrap="square" lIns="0" tIns="0" rIns="0" bIns="0" rtlCol="0" anchor="ctr"/>
+          <a:lstStyle/>
+          <a:p>
+            <a:pPr indent="0" marL="0">
+              <a:buNone/>
+            </a:pPr>
+            <a:r>
+              <a:rPr lang="en-US" sz="1800" b="1" dirty="0">
+                <a:solidFill>
+                  <a:srgbClr val="ED7D31"/>
+                </a:solidFill>
+              </a:rPr>
+              <a:t>83% · 4.2k</a:t>
+            </a:r>
+            <a:endParaRPr lang="en-US" sz="1800" dirty="0"/>
+          </a:p>
+        </p:txBody>
+      </p:sp>
+      <p:sp>
+        <p:nvSpPr>
+          <p:cNvPr id="16" name="Text 14"/>
+          <p:cNvSpPr txBox="1"/>
+          <p:nvPr/>
+        </p:nvSpPr>
+        <p:spPr>
+          <a:xfrm>
+            <a:off x="548640" y="4050792"/>
+            <a:ext cx="2651760" cy="453542"/>
+          </a:xfrm>
+          <a:prstGeom prst="rect">
+            <a:avLst/>
+          </a:prstGeom>
+          <a:noFill/>
+          <a:ln/>
+        </p:spPr>
+        <p:txBody>
+          <a:bodyPr wrap="square" lIns="0" tIns="0" rIns="0" bIns="0" rtlCol="0" anchor="ctr"/>
+          <a:lstStyle/>
+          <a:p>
+            <a:pPr algn="r" indent="0" marL="0">
+              <a:buNone/>
+            </a:pPr>
+            <a:r>
+              <a:rPr lang="en-US" sz="1600" dirty="0">
+                <a:solidFill>
+                  <a:schemeClr val="tx1"/>
+                </a:solidFill>
+              </a:rPr>
+              <a:t>Retrieved fact, then think</a:t>
+            </a:r>
+            <a:endParaRPr lang="en-US" sz="1600" dirty="0"/>
+          </a:p>
+        </p:txBody>
+      </p:sp>
+      <p:sp>
+        <p:nvSpPr>
+          <p:cNvPr id="17" name="bar Retrieved fact, then think"/>
+          <p:cNvSpPr/>
+          <p:nvPr/>
+        </p:nvSpPr>
+        <p:spPr>
+          <a:xfrm>
+            <a:off x="3337560" y="4135831"/>
+            <a:ext cx="2611526" cy="283464"/>
+          </a:xfrm>
+          <a:prstGeom prst="rect">
+            <a:avLst/>
+          </a:prstGeom>
+          <a:solidFill>
+            <a:srgbClr val="5B9BD5"/>
+          </a:solidFill>
+          <a:ln w="6350">
+            <a:solidFill>
+              <a:srgbClr val="5B9BD5"/>
+            </a:solidFill>
+            <a:prstDash val="solid"/>
+          </a:ln>
+        </p:spPr>
+      </p:sp>
+      <p:sp>
+        <p:nvSpPr>
+          <p:cNvPr id="18" name="Text 16"/>
+          <p:cNvSpPr txBox="1"/>
+          <p:nvPr/>
+        </p:nvSpPr>
+        <p:spPr>
+          <a:xfrm>
+            <a:off x="6040526" y="4050792"/>
+            <a:ext cx="1554480" cy="453542"/>
+          </a:xfrm>
+          <a:prstGeom prst="rect">
+            <a:avLst/>
+          </a:prstGeom>
+          <a:noFill/>
+          <a:ln/>
+        </p:spPr>
+        <p:txBody>
+          <a:bodyPr wrap="square" lIns="0" tIns="0" rIns="0" bIns="0" rtlCol="0" anchor="ctr"/>
+          <a:lstStyle/>
+          <a:p>
+            <a:pPr indent="0" marL="0">
+              <a:buNone/>
+            </a:pPr>
+            <a:r>
+              <a:rPr lang="en-US" sz="1800" b="1" dirty="0">
+                <a:solidFill>
+                  <a:srgbClr val="5B9BD5"/>
+                </a:solidFill>
+              </a:rPr>
+              <a:t>84% · 3.3k</a:t>
+            </a:r>
+            <a:endParaRPr lang="en-US" sz="1800" dirty="0"/>
+          </a:p>
+        </p:txBody>
+      </p:sp>
+      <p:sp>
+        <p:nvSpPr>
+          <p:cNvPr id="19" name="Text 17"/>
+          <p:cNvSpPr txBox="1"/>
+          <p:nvPr/>
+        </p:nvSpPr>
+        <p:spPr>
+          <a:xfrm>
+            <a:off x="548640" y="4617720"/>
+            <a:ext cx="2651760" cy="453542"/>
+          </a:xfrm>
+          <a:prstGeom prst="rect">
+            <a:avLst/>
+          </a:prstGeom>
+          <a:noFill/>
+          <a:ln/>
+        </p:spPr>
+        <p:txBody>
+          <a:bodyPr wrap="square" lIns="0" tIns="0" rIns="0" bIns="0" rtlCol="0" anchor="ctr"/>
+          <a:lstStyle/>
+          <a:p>
+            <a:pPr algn="r" indent="0" marL="0">
+              <a:buNone/>
+            </a:pPr>
+            <a:r>
+              <a:rPr lang="en-US" sz="1600" dirty="0">
+                <a:solidFill>
+                  <a:schemeClr val="tx1"/>
+                </a:solidFill>
+              </a:rPr>
+              <a:t>Fact first, then think</a:t>
+            </a:r>
+            <a:endParaRPr lang="en-US" sz="1600" dirty="0"/>
+          </a:p>
+        </p:txBody>
+      </p:sp>
+      <p:sp>
+        <p:nvSpPr>
+          <p:cNvPr id="20" name="bar Fact first, then think"/>
+          <p:cNvSpPr/>
+          <p:nvPr/>
+        </p:nvSpPr>
+        <p:spPr>
+          <a:xfrm>
+            <a:off x="3337560" y="4702759"/>
+            <a:ext cx="2704795" cy="283464"/>
+          </a:xfrm>
+          <a:prstGeom prst="rect">
+            <a:avLst/>
+          </a:prstGeom>
+          <a:solidFill>
+            <a:srgbClr val="4472C4"/>
+          </a:solidFill>
+          <a:ln w="6350">
+            <a:solidFill>
+              <a:srgbClr val="4472C4"/>
+            </a:solidFill>
+            <a:prstDash val="solid"/>
+          </a:ln>
+        </p:spPr>
+      </p:sp>
+      <p:sp>
+        <p:nvSpPr>
+          <p:cNvPr id="21" name="Text 19"/>
+          <p:cNvSpPr txBox="1"/>
+          <p:nvPr/>
+        </p:nvSpPr>
+        <p:spPr>
+          <a:xfrm>
+            <a:off x="6133795" y="4617720"/>
+            <a:ext cx="1554480" cy="453542"/>
+          </a:xfrm>
+          <a:prstGeom prst="rect">
+            <a:avLst/>
+          </a:prstGeom>
+          <a:noFill/>
+          <a:ln/>
+        </p:spPr>
+        <p:txBody>
+          <a:bodyPr wrap="square" lIns="0" tIns="0" rIns="0" bIns="0" rtlCol="0" anchor="ctr"/>
+          <a:lstStyle/>
+          <a:p>
+            <a:pPr indent="0" marL="0">
+              <a:buNone/>
+            </a:pPr>
+            <a:r>
+              <a:rPr lang="en-US" sz="1800" b="1" dirty="0">
+                <a:solidFill>
+                  <a:srgbClr val="4472C4"/>
+                </a:solidFill>
+              </a:rPr>
+              <a:t>87% · 2.5k</a:t>
+            </a:r>
+            <a:endParaRPr lang="en-US" sz="1800" dirty="0"/>
+          </a:p>
+        </p:txBody>
+      </p:sp>
+      <p:sp>
+        <p:nvSpPr>
+          <p:cNvPr id="22" name="new task"/>
+          <p:cNvSpPr/>
+          <p:nvPr/>
+        </p:nvSpPr>
+        <p:spPr>
+          <a:xfrm>
+            <a:off x="8229600" y="1737360"/>
+            <a:ext cx="3383280" cy="3566160"/>
+          </a:xfrm>
+          <a:prstGeom prst="roundRect">
+            <a:avLst>
+              <a:gd name="adj" fmla="val 2162"/>
+            </a:avLst>
+          </a:prstGeom>
+          <a:solidFill>
+            <a:srgbClr val="F2F2F2"/>
+          </a:solidFill>
+          <a:ln w="9525">
+            <a:solidFill>
+              <a:srgbClr val="D9D9D9"/>
+            </a:solidFill>
+            <a:prstDash val="solid"/>
+          </a:ln>
+        </p:spPr>
+      </p:sp>
+      <p:sp>
+        <p:nvSpPr>
+          <p:cNvPr id="23" name="Text 21"/>
+          <p:cNvSpPr txBox="1"/>
+          <p:nvPr/>
+        </p:nvSpPr>
+        <p:spPr>
+          <a:xfrm>
+            <a:off x="8412480" y="1828800"/>
+            <a:ext cx="3017520" cy="685800"/>
+          </a:xfrm>
+          <a:prstGeom prst="rect">
+            <a:avLst/>
+          </a:prstGeom>
+          <a:noFill/>
+          <a:ln/>
+        </p:spPr>
+        <p:txBody>
+          <a:bodyPr wrap="square" lIns="0" tIns="0" rIns="0" bIns="0" rtlCol="0" anchor="t"/>
+          <a:lstStyle/>
+          <a:p>
+            <a:pPr indent="0" marL="0">
+              <a:buNone/>
+            </a:pPr>
+            <a:r>
+              <a:rPr lang="en-US" sz="1700" b="1" dirty="0">
+                <a:solidFill>
+                  <a:schemeClr val="tx1"/>
+                </a:solidFill>
+              </a:rPr>
+              <a:t>A new task? Label 30 problems</a:t>
+            </a:r>
+            <a:endParaRPr lang="en-US" sz="1700" dirty="0"/>
+          </a:p>
+        </p:txBody>
+      </p:sp>
+      <p:sp>
+        <p:nvSpPr>
+          <p:cNvPr id="24" name="Text 22"/>
+          <p:cNvSpPr txBox="1"/>
+          <p:nvPr/>
+        </p:nvSpPr>
+        <p:spPr>
+          <a:xfrm>
+            <a:off x="8412480" y="2514600"/>
+            <a:ext cx="3017520" cy="548640"/>
+          </a:xfrm>
+          <a:prstGeom prst="rect">
+            <a:avLst/>
+          </a:prstGeom>
+          <a:noFill/>
+          <a:ln/>
+        </p:spPr>
+        <p:txBody>
+          <a:bodyPr wrap="square" lIns="0" tIns="0" rIns="0" bIns="0" rtlCol="0" anchor="t"/>
+          <a:lstStyle/>
+          <a:p>
+            <a:pPr indent="0" marL="0">
+              <a:buNone/>
+            </a:pPr>
+            <a:r>
+              <a:rPr lang="en-US" sz="1300" dirty="0">
+                <a:solidFill>
+                  <a:schemeClr val="tx2"/>
+                </a:solidFill>
+              </a:rPr>
+              <a:t>points lost vs the best policy, over 63 settings (lower is better)</a:t>
+            </a:r>
+            <a:endParaRPr lang="en-US" sz="1300" dirty="0"/>
+          </a:p>
+        </p:txBody>
+      </p:sp>
+      <p:sp>
+        <p:nvSpPr>
+          <p:cNvPr id="25" name="Text 23"/>
+          <p:cNvSpPr txBox="1"/>
+          <p:nvPr/>
+        </p:nvSpPr>
+        <p:spPr>
+          <a:xfrm>
+            <a:off x="8412480" y="3200400"/>
+            <a:ext cx="3017520" cy="274320"/>
+          </a:xfrm>
+          <a:prstGeom prst="rect">
+            <a:avLst/>
+          </a:prstGeom>
+          <a:noFill/>
+          <a:ln/>
+        </p:spPr>
+        <p:txBody>
+          <a:bodyPr wrap="square" lIns="0" tIns="0" rIns="0" bIns="0" rtlCol="0" anchor="ctr"/>
+          <a:lstStyle/>
+          <a:p>
+            <a:pPr indent="0" marL="0">
+              <a:buNone/>
+            </a:pPr>
+            <a:r>
+              <a:rPr lang="en-US" sz="1400" dirty="0">
+                <a:solidFill>
+                  <a:schemeClr val="tx1"/>
+                </a:solidFill>
+              </a:rPr>
+              <a:t>always think</a:t>
+            </a:r>
+            <a:endParaRPr lang="en-US" sz="1400" dirty="0"/>
+          </a:p>
+        </p:txBody>
+      </p:sp>
+      <p:sp>
+        <p:nvSpPr>
+          <p:cNvPr id="26" name="loss always think"/>
+          <p:cNvSpPr/>
+          <p:nvPr/>
+        </p:nvSpPr>
+        <p:spPr>
+          <a:xfrm>
+            <a:off x="8412480" y="3493008"/>
+            <a:ext cx="2304288" cy="201168"/>
+          </a:xfrm>
+          <a:prstGeom prst="rect">
+            <a:avLst/>
+          </a:prstGeom>
+          <a:solidFill>
+            <a:srgbClr val="A5A5A5"/>
+          </a:solidFill>
+          <a:ln w="6350">
+            <a:solidFill>
+              <a:srgbClr val="A5A5A5"/>
+            </a:solidFill>
+            <a:prstDash val="solid"/>
+          </a:ln>
+        </p:spPr>
+      </p:sp>
+      <p:sp>
+        <p:nvSpPr>
+          <p:cNvPr id="27" name="Text 25"/>
+          <p:cNvSpPr txBox="1"/>
+          <p:nvPr/>
+        </p:nvSpPr>
+        <p:spPr>
+          <a:xfrm>
+            <a:off x="10808208" y="3429000"/>
+            <a:ext cx="548640" cy="320040"/>
+          </a:xfrm>
+          <a:prstGeom prst="rect">
+            <a:avLst/>
+          </a:prstGeom>
+          <a:noFill/>
+          <a:ln/>
+        </p:spPr>
+        <p:txBody>
+          <a:bodyPr wrap="square" lIns="0" tIns="0" rIns="0" bIns="0" rtlCol="0" anchor="ctr"/>
+          <a:lstStyle/>
+          <a:p>
+            <a:pPr indent="0" marL="0">
+              <a:buNone/>
+            </a:pPr>
+            <a:r>
+              <a:rPr lang="en-US" sz="1400" b="1" dirty="0">
+                <a:solidFill>
+                  <a:srgbClr val="595959"/>
+                </a:solidFill>
+              </a:rPr>
+              <a:t>8.4</a:t>
+            </a:r>
+            <a:endParaRPr lang="en-US" sz="1400" dirty="0"/>
+          </a:p>
+        </p:txBody>
+      </p:sp>
+      <p:sp>
+        <p:nvSpPr>
+          <p:cNvPr id="28" name="Text 26"/>
+          <p:cNvSpPr txBox="1"/>
+          <p:nvPr/>
+        </p:nvSpPr>
+        <p:spPr>
+          <a:xfrm>
+            <a:off x="8412480" y="3840480"/>
+            <a:ext cx="3017520" cy="274320"/>
+          </a:xfrm>
+          <a:prstGeom prst="rect">
+            <a:avLst/>
+          </a:prstGeom>
+          <a:noFill/>
+          <a:ln/>
+        </p:spPr>
+        <p:txBody>
+          <a:bodyPr wrap="square" lIns="0" tIns="0" rIns="0" bIns="0" rtlCol="0" anchor="ctr"/>
+          <a:lstStyle/>
+          <a:p>
+            <a:pPr indent="0" marL="0">
+              <a:buNone/>
+            </a:pPr>
+            <a:r>
+              <a:rPr lang="en-US" sz="1400" dirty="0">
+                <a:solidFill>
+                  <a:schemeClr val="tx1"/>
+                </a:solidFill>
+              </a:rPr>
+              <a:t>fact first (default)</a:t>
+            </a:r>
+            <a:endParaRPr lang="en-US" sz="1400" dirty="0"/>
+          </a:p>
+        </p:txBody>
+      </p:sp>
+      <p:sp>
+        <p:nvSpPr>
+          <p:cNvPr id="29" name="loss fact first (default)"/>
+          <p:cNvSpPr/>
+          <p:nvPr/>
+        </p:nvSpPr>
+        <p:spPr>
+          <a:xfrm>
+            <a:off x="8412480" y="4133088"/>
+            <a:ext cx="384048" cy="201168"/>
+          </a:xfrm>
+          <a:prstGeom prst="rect">
+            <a:avLst/>
+          </a:prstGeom>
+          <a:solidFill>
+            <a:srgbClr val="4472C4"/>
+          </a:solidFill>
+          <a:ln w="6350">
+            <a:solidFill>
+              <a:srgbClr val="4472C4"/>
+            </a:solidFill>
+            <a:prstDash val="solid"/>
+          </a:ln>
+        </p:spPr>
+      </p:sp>
+      <p:sp>
+        <p:nvSpPr>
+          <p:cNvPr id="30" name="Text 28"/>
+          <p:cNvSpPr txBox="1"/>
+          <p:nvPr/>
+        </p:nvSpPr>
+        <p:spPr>
+          <a:xfrm>
+            <a:off x="8887968" y="4069080"/>
+            <a:ext cx="548640" cy="320040"/>
+          </a:xfrm>
+          <a:prstGeom prst="rect">
+            <a:avLst/>
+          </a:prstGeom>
+          <a:noFill/>
+          <a:ln/>
+        </p:spPr>
+        <p:txBody>
+          <a:bodyPr wrap="square" lIns="0" tIns="0" rIns="0" bIns="0" rtlCol="0" anchor="ctr"/>
+          <a:lstStyle/>
+          <a:p>
+            <a:pPr indent="0" marL="0">
+              <a:buNone/>
+            </a:pPr>
+            <a:r>
+              <a:rPr lang="en-US" sz="1400" b="1" dirty="0">
+                <a:solidFill>
+                  <a:srgbClr val="4472C4"/>
+                </a:solidFill>
+              </a:rPr>
+              <a:t>1.4</a:t>
+            </a:r>
+            <a:endParaRPr lang="en-US" sz="1400" dirty="0"/>
+          </a:p>
+        </p:txBody>
+      </p:sp>
+      <p:sp>
+        <p:nvSpPr>
+          <p:cNvPr id="31" name="Text 29"/>
+          <p:cNvSpPr txBox="1"/>
+          <p:nvPr/>
+        </p:nvSpPr>
+        <p:spPr>
+          <a:xfrm>
+            <a:off x="8412480" y="4480560"/>
+            <a:ext cx="3017520" cy="274320"/>
+          </a:xfrm>
+          <a:prstGeom prst="rect">
+            <a:avLst/>
+          </a:prstGeom>
+          <a:noFill/>
+          <a:ln/>
+        </p:spPr>
+        <p:txBody>
+          <a:bodyPr wrap="square" lIns="0" tIns="0" rIns="0" bIns="0" rtlCol="0" anchor="ctr"/>
+          <a:lstStyle/>
+          <a:p>
+            <a:pPr indent="0" marL="0">
+              <a:buNone/>
+            </a:pPr>
+            <a:r>
+              <a:rPr lang="en-US" sz="1400" dirty="0">
+                <a:solidFill>
+                  <a:schemeClr val="tx1"/>
+                </a:solidFill>
+              </a:rPr>
+              <a:t>pick on 30 labels</a:t>
+            </a:r>
+            <a:endParaRPr lang="en-US" sz="1400" dirty="0"/>
+          </a:p>
+        </p:txBody>
+      </p:sp>
+      <p:sp>
+        <p:nvSpPr>
+          <p:cNvPr id="32" name="loss pick on 30 labels"/>
+          <p:cNvSpPr/>
+          <p:nvPr/>
+        </p:nvSpPr>
+        <p:spPr>
+          <a:xfrm>
+            <a:off x="8412480" y="4773168"/>
+            <a:ext cx="164592" cy="201168"/>
+          </a:xfrm>
+          <a:prstGeom prst="rect">
+            <a:avLst/>
+          </a:prstGeom>
+          <a:solidFill>
+            <a:srgbClr val="4472C4"/>
+          </a:solidFill>
+          <a:ln w="6350">
+            <a:solidFill>
+              <a:srgbClr val="4472C4"/>
+            </a:solidFill>
+            <a:prstDash val="solid"/>
+          </a:ln>
+        </p:spPr>
+      </p:sp>
+      <p:sp>
+        <p:nvSpPr>
+          <p:cNvPr id="33" name="Text 31"/>
+          <p:cNvSpPr txBox="1"/>
+          <p:nvPr/>
+        </p:nvSpPr>
+        <p:spPr>
+          <a:xfrm>
+            <a:off x="8668512" y="4709160"/>
+            <a:ext cx="548640" cy="320040"/>
+          </a:xfrm>
+          <a:prstGeom prst="rect">
+            <a:avLst/>
+          </a:prstGeom>
+          <a:noFill/>
+          <a:ln/>
+        </p:spPr>
+        <p:txBody>
+          <a:bodyPr wrap="square" lIns="0" tIns="0" rIns="0" bIns="0" rtlCol="0" anchor="ctr"/>
+          <a:lstStyle/>
+          <a:p>
+            <a:pPr indent="0" marL="0">
+              <a:buNone/>
+            </a:pPr>
+            <a:r>
+              <a:rPr lang="en-US" sz="1400" b="1" dirty="0">
+                <a:solidFill>
+                  <a:srgbClr val="4472C4"/>
+                </a:solidFill>
+              </a:rPr>
+              <a:t>0.6</a:t>
+            </a:r>
+            <a:endParaRPr lang="en-US" sz="1400" dirty="0"/>
+          </a:p>
+        </p:txBody>
+      </p:sp>
+      <p:sp>
+        <p:nvSpPr>
+          <p:cNvPr id="34" name="Text 32"/>
+          <p:cNvSpPr txBox="1"/>
+          <p:nvPr/>
+        </p:nvSpPr>
+        <p:spPr>
+          <a:xfrm>
+            <a:off x="548640" y="5669280"/>
+            <a:ext cx="11064240" cy="548640"/>
+          </a:xfrm>
+          <a:prstGeom prst="rect">
+            <a:avLst/>
+          </a:prstGeom>
+          <a:noFill/>
+          <a:ln/>
+        </p:spPr>
+        <p:txBody>
+          <a:bodyPr wrap="square" lIns="0" tIns="0" rIns="0" bIns="0" rtlCol="0" anchor="ctr"/>
+          <a:lstStyle/>
+          <a:p>
+            <a:pPr algn="ctr" indent="0" marL="0">
+              <a:buNone/>
+            </a:pPr>
+            <a:r>
+              <a:rPr lang="en-US" sz="2000" dirty="0">
+                <a:solidFill>
+                  <a:schemeClr val="tx1"/>
+                </a:solidFill>
+              </a:rPr>
+              <a:t>Most accurate and among the cheapest on all 3 seeds: spend thinking where a check fails</a:t>
+            </a:r>
+            <a:endParaRPr lang="en-US" sz="2000" dirty="0"/>
+          </a:p>
+        </p:txBody>
+      </p:sp>
+      <p:sp>
+        <p:nvSpPr>
+          <p:cNvPr id="25" name="Slide Number Placeholder 0"/>
+          <p:cNvSpPr>
+            <a:spLocks noGrp="1"/>
+          </p:cNvSpPr>
+          <p:nvPr>
+            <p:ph type="sldNum" sz="quarter" idx="4294967295"/>
+          </p:nvPr>
+        </p:nvSpPr>
+        <p:spPr>
+          <a:xfrm>
+            <a:off x="11155680" y="6355080"/>
+            <a:ext cx="731520" cy="320040"/>
+          </a:xfrm>
+          <a:prstGeom prst="rect">
+            <a:avLst/>
+          </a:prstGeom>
+          <a:extLst>
+            <a:ext uri="{C572A759-6A51-4108-AA02-DFA0A04FC94B}">
+              <ma14:wrappingTextBoxFlag xmlns:ma14="http://schemas.microsoft.com/office/mac/drawingml/2011/main" val="0"/>
+            </a:ext>
+          </a:extLst>
+        </p:spPr>
+        <p:txBody>
+          <a:bodyPr/>
+          <a:lstStyle>
+            <a:lvl1pPr>
+              <a:defRPr sz="1200">
+                <a:solidFill>
+                  <a:srgbClr val="8C8C8C"/>
+                </a:solidFill>
+              </a:defRPr>
+            </a:lvl1pPr>
+          </a:lstStyle>
+          <a:p>
+            <a:pPr algn="r"/>
+            <a:fld id="{F7021451-1387-4CA6-816F-3879F97B5CBC}" type="slidenum">
+              <a:rPr b="0" lang="en-US"/>
+              <a:t>14</a:t>
+            </a:fld>
+            <a:endParaRPr lang="en-US"/>
+          </a:p>
+        </p:txBody>
+      </p:sp>
+    </p:spTree>
+  </p:cSld>
+  <p:clrMapOvr>
+    <a:masterClrMapping/>
+  </p:clrMapOvr>
+</p:sld>
+</file>
+
+<file path=ppt/slides/slide15.xml><?xml version="1.0" encoding="utf-8"?>
+<p:sld xmlns:a="http://schemas.openxmlformats.org/drawingml/2006/main" xmlns:r="http://schemas.openxmlformats.org/officeDocument/2006/relationships" xmlns:p="http://schemas.openxmlformats.org/presentationml/2006/main">
+  <p:cSld name="Slide 15">
+    <p:spTree>
+      <p:nvGrpSpPr>
+        <p:cNvPr id="1" name=""/>
+        <p:cNvGrpSpPr/>
+        <p:nvPr/>
+      </p:nvGrpSpPr>
+      <p:grpSpPr>
+        <a:xfrm>
+          <a:off x="0" y="0"/>
+          <a:ext cx="0" cy="0"/>
+          <a:chOff x="0" y="0"/>
+          <a:chExt cx="0" cy="0"/>
+        </a:xfrm>
+      </p:grpSpPr>
+      <p:sp>
+        <p:nvSpPr>
+          <p:cNvPr id="2" name="Text 0"/>
+          <p:cNvSpPr/>
+          <p:nvPr>
+            <p:ph idx="100" type="title" hasCustomPrompt="1"/>
+          </p:nvPr>
+        </p:nvSpPr>
+        <p:spPr>
+          <a:xfrm>
+            <a:off x="548640" y="274320"/>
+            <a:ext cx="11064240" cy="914400"/>
+          </a:xfrm>
+          <a:prstGeom prst="rect">
+            <a:avLst/>
+          </a:prstGeom>
+          <a:noFill/>
+          <a:ln/>
+        </p:spPr>
+        <p:txBody>
+          <a:bodyPr wrap="square" rtlCol="0" anchor="ctr"/>
+          <a:lstStyle/>
+          <a:p>
+            <a:pPr algn="l" indent="0" marL="0">
+              <a:buNone/>
+            </a:pPr>
+            <a:r>
+              <a:rPr lang="en-US" sz="3600" dirty="0">
+                <a:solidFill>
+                  <a:schemeClr val="tx1"/>
+                </a:solidFill>
+              </a:rPr>
               <a:t>Compared with published methods</a:t>
             </a:r>
             <a:endParaRPr lang="en-US" sz="3600" dirty="0"/>
@@ -7511,7 +9405,7 @@
       </p:sp>
       <p:graphicFrame>
         <p:nvGraphicFramePr>
-          <p:cNvPr id="15" name="Table 0"/>
+          <p:cNvPr id="16" name="Table 0"/>
           <p:cNvGraphicFramePr>
             <a:graphicFrameLocks noGrp="1"/>
           </p:cNvGraphicFramePr>
@@ -9266,7 +11160,7 @@
             <a:pPr algn="r"/>
             <a:fld id="{F7021451-1387-4CA6-816F-3879F97B5CBC}" type="slidenum">
               <a:rPr b="0" lang="en-US"/>
-              <a:t>14</a:t>
+              <a:t>15</a:t>
             </a:fld>
             <a:endParaRPr lang="en-US"/>
           </a:p>
@@ -9280,9 +11174,9 @@
 </p:sld>
 </file>
 
-<file path=ppt/slides/slide15.xml><?xml version="1.0" encoding="utf-8"?>
+<file path=ppt/slides/slide16.xml><?xml version="1.0" encoding="utf-8"?>
 <p:sld xmlns:a="http://schemas.openxmlformats.org/drawingml/2006/main" xmlns:r="http://schemas.openxmlformats.org/officeDocument/2006/relationships" xmlns:p="http://schemas.openxmlformats.org/presentationml/2006/main">
-  <p:cSld name="Slide 15">
+  <p:cSld name="Slide 16">
     <p:spTree>
       <p:nvGrpSpPr>
         <p:cNvPr id="1" name=""/>
@@ -9706,7 +11600,7 @@
             <a:pPr algn="r"/>
             <a:fld id="{F7021451-1387-4CA6-816F-3879F97B5CBC}" type="slidenum">
               <a:rPr b="0" lang="en-US"/>
-              <a:t>15</a:t>
+              <a:t>16</a:t>
             </a:fld>
             <a:endParaRPr lang="en-US"/>
           </a:p>

</xml_diff>

<commit_message>
Method on one slide: five steps on a real problem, with what each produced, its tokens and the result
Talk: "Our method: cheap steps first" replaces the recipe and walk-through slides (8 slides + 9 extra
pages). The full deck keeps the recipe and adds this slide; it is exported as figs/ex_method.png and
replaces the text walk-through and check table in PROPOSAL / PROPOSAL_ko section 4.

Co-Authored-By: Claude Opus 5.5 (1M context) <noreply@anthropic.com>
</commit_message>
<xml_diff>
--- a/PROPOSAL_slides_full.pptx
+++ b/PROPOSAL_slides_full.pptx
@@ -122,14 +122,14 @@
   <p:extLst>
     <p:ext uri="{521415D9-36F7-43E2-AB2F-B90AF26B5E84}">
       <p14:sectionLst xmlns:p14="http://schemas.microsoft.com/office/powerpoint/2010/main">
-        <p14:section name="Problem" id="{8e692120-ab03-75d1-2aaf-b34335fbae38}">
+        <p14:section name="Problem" id="{0bdecb0b-d3b8-96c1-042c-70c0fe612fdb}">
           <p14:sldIdLst>
             <p14:sldId id="256"/>
             <p14:sldId id="257"/>
             <p14:sldId id="258"/>
           </p14:sldIdLst>
         </p14:section>
-        <p14:section name="Findings" id="{cd3fec84-dbda-37f3-64e4-ff43384eaf96}">
+        <p14:section name="Findings" id="{267cb479-4171-bda6-6e4a-c3f0fbd5c6ec}">
           <p14:sldIdLst>
             <p14:sldId id="259"/>
             <p14:sldId id="260"/>
@@ -141,7 +141,7 @@
             <p14:sldId id="266"/>
           </p14:sldIdLst>
         </p14:section>
-        <p14:section name="Method" id="{be9fbc08-b3f3-6690-8dee-c60a479cd1cf}">
+        <p14:section name="Method" id="{e966aa3e-fadb-29aa-4859-8f9ffd0a7d0b}">
           <p14:sldIdLst>
             <p14:sldId id="267"/>
             <p14:sldId id="268"/>
@@ -149,7 +149,7 @@
             <p14:sldId id="270"/>
           </p14:sldIdLst>
         </p14:section>
-        <p14:section name="Next" id="{96883ec0-791b-92cb-27a0-301be7bf39ef}">
+        <p14:section name="Next" id="{36cdafd7-d6ef-62b1-02da-f1fecc1734c8}">
           <p14:sldIdLst>
             <p14:sldId id="271"/>
           </p14:sldIdLst>
@@ -1730,7 +1730,7 @@
           <a:p>
             <a:r>
               <a:rPr lang="en-US" dirty="0"/>
-              <a:t>Real run (Qwen3-8B, MAMO easy-189). Step 0 happens once per kind of problem: the model's own shortest program for another benchmark problem that passed the label-free check becomes the fact. Steps 1-2: with it the program calls solver.Minimize(10*x + 15*y + 20*z) and prints 20000 (316 tokens); without it, it calls Objective().Minimize() and crashes. Step 3: a second program (312 tokens) also prints 20000, so they agree. Step 4: thinking is used only when the two disagree or a program crashes; here it is skipped (thinking alone took 5,323 tokens). Step 5: if the same kind of problem comes back with new data, the checked program is reused. Table: what the free check is in each domain; none needs the answer.</a:t>
+              <a:t>Real run (Qwen3-8B, MAMO easy-189, answer 20000). 1: without a fact the program calls Objective().Minimize(), which does not exist, and crashes. 2: the fact is the model's own earlier program for another problem (vans and trucks) that passed the check; with it the program writes solver.Minimize(10*x + 15*y + 20*z) and prints 20000 (316 tokens). 3: the free check, a second version, also prints 20000 (312 tokens): they agree. 4: so no thinking (thinking alone took 5,323 tokens). 5: the same kind of problem with new data reuses the checked program. Bottom: this problem 0.6k vs 5.3k tokens; over 624 geometry and optimization problems (Qwen3-8B, Qwen3-32B, Qwen3.6, 3 seeds) 87% at 2.5k vs 74% at 4.1k for thinking on the hardest-looking problems. The free check in each domain needs no answers: contest sample tests, geometry copies that must agree, routing plans that must obey every rule, word problems with two versions that must agree.</a:t>
             </a:r>
             <a:endParaRPr lang="en-US" dirty="0"/>
           </a:p>
@@ -6441,7 +6441,7 @@
                   <a:schemeClr val="tx1"/>
                 </a:solidFill>
               </a:rPr>
-              <a:t>How the recipe runs on one problem</a:t>
+              <a:t>Our method on one real problem</a:t>
             </a:r>
             <a:endParaRPr lang="en-US" sz="3600" dirty="0"/>
           </a:p>
@@ -6455,7 +6455,7 @@
         </p:nvSpPr>
         <p:spPr>
           <a:xfrm>
-            <a:off x="548640" y="1188720"/>
+            <a:off x="548640" y="1170432"/>
             <a:ext cx="11064240" cy="365760"/>
           </a:xfrm>
           <a:prstGeom prst="rect">
@@ -6477,7 +6477,7 @@
                   <a:schemeClr val="tx1"/>
                 </a:solidFill>
               </a:rPr>
-              <a:t>Qwen3-8B on a MAMO word problem: products X, Y, Z cost $10, $15, $20 under three limits; minimum cost? (answer 20000)</a:t>
+              <a:t>One real problem (Qwen3-8B): products X, Y, Z cost $10, $15, $20 under three limits. Minimum cost? → 20000</a:t>
             </a:r>
             <a:endParaRPr lang="en-US" sz="1600" dirty="0"/>
           </a:p>
@@ -6485,41 +6485,14 @@
       </p:sp>
       <p:sp>
         <p:nvSpPr>
-          <p:cNvPr id="4" name="walk 0"/>
-          <p:cNvSpPr/>
-          <p:nvPr/>
-        </p:nvSpPr>
-        <p:spPr>
-          <a:xfrm>
-            <a:off x="548640" y="1691640"/>
-            <a:ext cx="2514600" cy="1920240"/>
-          </a:xfrm>
-          <a:prstGeom prst="roundRect">
-            <a:avLst>
-              <a:gd name="adj" fmla="val 3810"/>
-            </a:avLst>
-          </a:prstGeom>
-          <a:solidFill>
-            <a:srgbClr val="E2F0D9"/>
-          </a:solidFill>
-          <a:ln w="9525">
-            <a:solidFill>
-              <a:srgbClr val="BFBFBF"/>
-            </a:solidFill>
-            <a:prstDash val="solid"/>
-          </a:ln>
-        </p:spPr>
-      </p:sp>
-      <p:sp>
-        <p:nvSpPr>
-          <p:cNvPr id="5" name="walk badge 0"/>
-          <p:cNvSpPr/>
-          <p:nvPr/>
-        </p:nvSpPr>
-        <p:spPr>
-          <a:xfrm>
-            <a:off x="640080" y="1801368"/>
-            <a:ext cx="411480" cy="411480"/>
+          <p:cNvPr id="4" name="method badge 1"/>
+          <p:cNvSpPr/>
+          <p:nvPr/>
+        </p:nvSpPr>
+        <p:spPr>
+          <a:xfrm>
+            <a:off x="548640" y="1673352"/>
+            <a:ext cx="457200" cy="457200"/>
           </a:xfrm>
           <a:prstGeom prst="ellipse">
             <a:avLst/>
@@ -6537,14 +6510,113 @@
       </p:sp>
       <p:sp>
         <p:nvSpPr>
+          <p:cNvPr id="5" name="Text 3"/>
+          <p:cNvSpPr txBox="1"/>
+          <p:nvPr/>
+        </p:nvSpPr>
+        <p:spPr>
+          <a:xfrm>
+            <a:off x="548640" y="1673352"/>
+            <a:ext cx="457200" cy="457200"/>
+          </a:xfrm>
+          <a:prstGeom prst="rect">
+            <a:avLst/>
+          </a:prstGeom>
+          <a:noFill/>
+          <a:ln/>
+        </p:spPr>
+        <p:txBody>
+          <a:bodyPr wrap="square" lIns="0" tIns="0" rIns="0" bIns="0" rtlCol="0" anchor="ctr"/>
+          <a:lstStyle/>
+          <a:p>
+            <a:pPr algn="ctr" indent="0" marL="0">
+              <a:buNone/>
+            </a:pPr>
+            <a:r>
+              <a:rPr lang="en-US" sz="1800" b="1" dirty="0">
+                <a:solidFill>
+                  <a:srgbClr val="FFFFFF"/>
+                </a:solidFill>
+              </a:rPr>
+              <a:t>1</a:t>
+            </a:r>
+            <a:endParaRPr lang="en-US" sz="1800" dirty="0"/>
+          </a:p>
+        </p:txBody>
+      </p:sp>
+      <p:sp>
+        <p:nvSpPr>
           <p:cNvPr id="6" name="Text 4"/>
           <p:cNvSpPr txBox="1"/>
           <p:nvPr/>
         </p:nvSpPr>
         <p:spPr>
           <a:xfrm>
-            <a:off x="640080" y="1801368"/>
-            <a:ext cx="411480" cy="411480"/>
+            <a:off x="1097280" y="1673352"/>
+            <a:ext cx="1600200" cy="457200"/>
+          </a:xfrm>
+          <a:prstGeom prst="rect">
+            <a:avLst/>
+          </a:prstGeom>
+          <a:noFill/>
+          <a:ln/>
+        </p:spPr>
+        <p:txBody>
+          <a:bodyPr wrap="square" lIns="0" tIns="0" rIns="0" bIns="0" rtlCol="0" anchor="ctr"/>
+          <a:lstStyle/>
+          <a:p>
+            <a:pPr indent="0" marL="0">
+              <a:buNone/>
+            </a:pPr>
+            <a:r>
+              <a:rPr lang="en-US" sz="1700" b="1" dirty="0">
+                <a:solidFill>
+                  <a:schemeClr val="tx1"/>
+                </a:solidFill>
+              </a:rPr>
+              <a:t>Write a program</a:t>
+            </a:r>
+            <a:endParaRPr lang="en-US" sz="1700" dirty="0"/>
+          </a:p>
+        </p:txBody>
+      </p:sp>
+      <p:sp>
+        <p:nvSpPr>
+          <p:cNvPr id="7" name="method step Write a program"/>
+          <p:cNvSpPr/>
+          <p:nvPr/>
+        </p:nvSpPr>
+        <p:spPr>
+          <a:xfrm>
+            <a:off x="548640" y="2240280"/>
+            <a:ext cx="2103120" cy="1188720"/>
+          </a:xfrm>
+          <a:prstGeom prst="roundRect">
+            <a:avLst>
+              <a:gd name="adj" fmla="val 6154"/>
+            </a:avLst>
+          </a:prstGeom>
+          <a:solidFill>
+            <a:srgbClr val="FADBD8"/>
+          </a:solidFill>
+          <a:ln w="12700">
+            <a:solidFill>
+              <a:srgbClr val="C00000"/>
+            </a:solidFill>
+            <a:prstDash val="solid"/>
+          </a:ln>
+        </p:spPr>
+      </p:sp>
+      <p:sp>
+        <p:nvSpPr>
+          <p:cNvPr id="8" name="Text 6"/>
+          <p:cNvSpPr txBox="1"/>
+          <p:nvPr/>
+        </p:nvSpPr>
+        <p:spPr>
+          <a:xfrm>
+            <a:off x="640080" y="2286000"/>
+            <a:ext cx="1920240" cy="457200"/>
           </a:xfrm>
           <a:prstGeom prst="rect">
             <a:avLst/>
@@ -6560,99 +6632,66 @@
               <a:buNone/>
             </a:pPr>
             <a:r>
-              <a:rPr lang="en-US" sz="1500" b="1" dirty="0">
-                <a:solidFill>
-                  <a:srgbClr val="FFFFFF"/>
-                </a:solidFill>
-              </a:rPr>
-              <a:t>0</a:t>
-            </a:r>
-            <a:endParaRPr lang="en-US" sz="1500" dirty="0"/>
-          </a:p>
-        </p:txBody>
-      </p:sp>
-      <p:sp>
-        <p:nvSpPr>
-          <p:cNvPr id="7" name="Text 5"/>
-          <p:cNvSpPr txBox="1"/>
-          <p:nvPr/>
-        </p:nvSpPr>
-        <p:spPr>
-          <a:xfrm>
-            <a:off x="1115568" y="1783080"/>
-            <a:ext cx="1874520" cy="457200"/>
-          </a:xfrm>
-          <a:prstGeom prst="rect">
-            <a:avLst/>
-          </a:prstGeom>
-          <a:noFill/>
-          <a:ln/>
-        </p:spPr>
-        <p:txBody>
-          <a:bodyPr wrap="square" lIns="0" tIns="0" rIns="0" bIns="0" rtlCol="0" anchor="ctr"/>
-          <a:lstStyle/>
-          <a:p>
-            <a:pPr indent="0" marL="0">
-              <a:buNone/>
-            </a:pPr>
-            <a:r>
-              <a:rPr lang="en-US" sz="1500" b="1" dirty="0">
+              <a:rPr lang="en-US" sz="1050" b="1" dirty="0">
+                <a:solidFill>
+                  <a:srgbClr val="C00000"/>
+                </a:solidFill>
+                <a:latin typeface="Courier New" pitchFamily="34" charset="0"/>
+                <a:ea typeface="Courier New" pitchFamily="34" charset="-122"/>
+                <a:cs typeface="Courier New" pitchFamily="34" charset="-120"/>
+              </a:rPr>
+              <a:t>Objective().Minimize()</a:t>
+            </a:r>
+            <a:endParaRPr lang="en-US" sz="1050" dirty="0"/>
+          </a:p>
+        </p:txBody>
+      </p:sp>
+      <p:sp>
+        <p:nvSpPr>
+          <p:cNvPr id="9" name="Text 7"/>
+          <p:cNvSpPr txBox="1"/>
+          <p:nvPr/>
+        </p:nvSpPr>
+        <p:spPr>
+          <a:xfrm>
+            <a:off x="640080" y="2761488"/>
+            <a:ext cx="1920240" cy="621792"/>
+          </a:xfrm>
+          <a:prstGeom prst="rect">
+            <a:avLst/>
+          </a:prstGeom>
+          <a:noFill/>
+          <a:ln/>
+        </p:spPr>
+        <p:txBody>
+          <a:bodyPr wrap="square" lIns="0" tIns="0" rIns="0" bIns="0" rtlCol="0" anchor="t"/>
+          <a:lstStyle/>
+          <a:p>
+            <a:pPr algn="ctr" indent="0" marL="0">
+              <a:buNone/>
+            </a:pPr>
+            <a:r>
+              <a:rPr lang="en-US" sz="1300" dirty="0">
                 <a:solidFill>
                   <a:schemeClr val="tx1"/>
                 </a:solidFill>
               </a:rPr>
-              <a:t>Mine the fact (once)</a:t>
-            </a:r>
-            <a:endParaRPr lang="en-US" sz="1500" dirty="0"/>
-          </a:p>
-        </p:txBody>
-      </p:sp>
-      <p:sp>
-        <p:nvSpPr>
-          <p:cNvPr id="8" name="Text 6"/>
-          <p:cNvSpPr txBox="1"/>
-          <p:nvPr/>
-        </p:nvSpPr>
-        <p:spPr>
-          <a:xfrm>
-            <a:off x="676656" y="2331720"/>
-            <a:ext cx="2258568" cy="1234440"/>
-          </a:xfrm>
-          <a:prstGeom prst="rect">
-            <a:avLst/>
-          </a:prstGeom>
-          <a:noFill/>
-          <a:ln/>
-        </p:spPr>
-        <p:txBody>
-          <a:bodyPr wrap="square" lIns="0" tIns="0" rIns="0" bIns="0" rtlCol="0" anchor="t"/>
-          <a:lstStyle/>
-          <a:p>
-            <a:pPr indent="0" marL="0">
-              <a:buNone/>
-            </a:pPr>
-            <a:r>
-              <a:rPr lang="en-US" sz="1350" dirty="0">
-                <a:solidFill>
-                  <a:schemeClr val="tx1"/>
-                </a:solidFill>
-              </a:rPr>
-              <a:t>for this kind of problem: the model's own program for another problem (vans and trucks) that passed the check; it shows solver.Minimize(...)</a:t>
-            </a:r>
-            <a:endParaRPr lang="en-US" sz="1350" dirty="0"/>
-          </a:p>
-        </p:txBody>
-      </p:sp>
-      <p:sp>
-        <p:nvSpPr>
-          <p:cNvPr id="9" name="Text 7"/>
-          <p:cNvSpPr txBox="1"/>
-          <p:nvPr/>
-        </p:nvSpPr>
-        <p:spPr>
-          <a:xfrm>
-            <a:off x="548640" y="3675888"/>
-            <a:ext cx="2514600" cy="320040"/>
+              <a:t>✗ crash: no such method</a:t>
+            </a:r>
+            <a:endParaRPr lang="en-US" sz="1300" dirty="0"/>
+          </a:p>
+        </p:txBody>
+      </p:sp>
+      <p:sp>
+        <p:nvSpPr>
+          <p:cNvPr id="10" name="Text 8"/>
+          <p:cNvSpPr txBox="1"/>
+          <p:nvPr/>
+        </p:nvSpPr>
+        <p:spPr>
+          <a:xfrm>
+            <a:off x="548640" y="3474720"/>
+            <a:ext cx="2103120" cy="274320"/>
           </a:xfrm>
           <a:prstGeom prst="rect">
             <a:avLst/>
@@ -6668,27 +6707,27 @@
               <a:buNone/>
             </a:pPr>
             <a:r>
-              <a:rPr lang="en-US" sz="1500" b="1" dirty="0">
+              <a:rPr lang="en-US" sz="1400" b="1" dirty="0">
                 <a:solidFill>
                   <a:schemeClr val="tx2"/>
                 </a:solidFill>
               </a:rPr>
-              <a:t>paid once</a:t>
-            </a:r>
-            <a:endParaRPr lang="en-US" sz="1500" dirty="0"/>
-          </a:p>
-        </p:txBody>
-      </p:sp>
-      <p:sp>
-        <p:nvSpPr>
-          <p:cNvPr id="10" name="Shape 8"/>
-          <p:cNvSpPr/>
-          <p:nvPr/>
-        </p:nvSpPr>
-        <p:spPr>
-          <a:xfrm>
-            <a:off x="3063240" y="2468880"/>
-            <a:ext cx="182880" cy="0"/>
+              <a:t>without a fact</a:t>
+            </a:r>
+            <a:endParaRPr lang="en-US" sz="1400" dirty="0"/>
+          </a:p>
+        </p:txBody>
+      </p:sp>
+      <p:sp>
+        <p:nvSpPr>
+          <p:cNvPr id="11" name="Shape 9"/>
+          <p:cNvSpPr/>
+          <p:nvPr/>
+        </p:nvSpPr>
+        <p:spPr>
+          <a:xfrm>
+            <a:off x="2651760" y="2807208"/>
+            <a:ext cx="137160" cy="0"/>
           </a:xfrm>
           <a:prstGeom prst="line">
             <a:avLst/>
@@ -6705,41 +6744,14 @@
       </p:sp>
       <p:sp>
         <p:nvSpPr>
-          <p:cNvPr id="11" name="walk 1-2"/>
-          <p:cNvSpPr/>
-          <p:nvPr/>
-        </p:nvSpPr>
-        <p:spPr>
-          <a:xfrm>
-            <a:off x="3246120" y="1691640"/>
-            <a:ext cx="2148840" cy="1920240"/>
-          </a:xfrm>
-          <a:prstGeom prst="roundRect">
-            <a:avLst>
-              <a:gd name="adj" fmla="val 3810"/>
-            </a:avLst>
-          </a:prstGeom>
-          <a:solidFill>
-            <a:srgbClr val="DEEBF7"/>
-          </a:solidFill>
-          <a:ln w="9525">
-            <a:solidFill>
-              <a:srgbClr val="BFBFBF"/>
-            </a:solidFill>
-            <a:prstDash val="solid"/>
-          </a:ln>
-        </p:spPr>
-      </p:sp>
-      <p:sp>
-        <p:nvSpPr>
-          <p:cNvPr id="12" name="walk badge 1-2"/>
-          <p:cNvSpPr/>
-          <p:nvPr/>
-        </p:nvSpPr>
-        <p:spPr>
-          <a:xfrm>
-            <a:off x="3337560" y="1801368"/>
-            <a:ext cx="411480" cy="411480"/>
+          <p:cNvPr id="12" name="method badge 2"/>
+          <p:cNvSpPr/>
+          <p:nvPr/>
+        </p:nvSpPr>
+        <p:spPr>
+          <a:xfrm>
+            <a:off x="2788920" y="1673352"/>
+            <a:ext cx="457200" cy="457200"/>
           </a:xfrm>
           <a:prstGeom prst="ellipse">
             <a:avLst/>
@@ -6763,8 +6775,8 @@
         </p:nvSpPr>
         <p:spPr>
           <a:xfrm>
-            <a:off x="3337560" y="1801368"/>
-            <a:ext cx="411480" cy="411480"/>
+            <a:off x="2788920" y="1673352"/>
+            <a:ext cx="457200" cy="457200"/>
           </a:xfrm>
           <a:prstGeom prst="rect">
             <a:avLst/>
@@ -6780,14 +6792,14 @@
               <a:buNone/>
             </a:pPr>
             <a:r>
-              <a:rPr lang="en-US" sz="1500" b="1" dirty="0">
+              <a:rPr lang="en-US" sz="1800" b="1" dirty="0">
                 <a:solidFill>
                   <a:srgbClr val="FFFFFF"/>
                 </a:solidFill>
               </a:rPr>
-              <a:t>1-2</a:t>
-            </a:r>
-            <a:endParaRPr lang="en-US" sz="1500" dirty="0"/>
+              <a:t>2</a:t>
+            </a:r>
+            <a:endParaRPr lang="en-US" sz="1800" dirty="0"/>
           </a:p>
         </p:txBody>
       </p:sp>
@@ -6799,8 +6811,8 @@
         </p:nvSpPr>
         <p:spPr>
           <a:xfrm>
-            <a:off x="3813048" y="1783080"/>
-            <a:ext cx="1508760" cy="457200"/>
+            <a:off x="3337560" y="1673352"/>
+            <a:ext cx="1600200" cy="457200"/>
           </a:xfrm>
           <a:prstGeom prst="rect">
             <a:avLst/>
@@ -6816,27 +6828,93 @@
               <a:buNone/>
             </a:pPr>
             <a:r>
-              <a:rPr lang="en-US" sz="1500" b="1" dirty="0">
+              <a:rPr lang="en-US" sz="1700" b="1" dirty="0">
                 <a:solidFill>
                   <a:schemeClr val="tx1"/>
                 </a:solidFill>
               </a:rPr>
-              <a:t>Program + fact</a:t>
-            </a:r>
-            <a:endParaRPr lang="en-US" sz="1500" dirty="0"/>
-          </a:p>
-        </p:txBody>
-      </p:sp>
-      <p:sp>
-        <p:nvSpPr>
-          <p:cNvPr id="15" name="Text 13"/>
-          <p:cNvSpPr txBox="1"/>
-          <p:nvPr/>
-        </p:nvSpPr>
-        <p:spPr>
-          <a:xfrm>
-            <a:off x="3374136" y="2331720"/>
-            <a:ext cx="1892808" cy="1234440"/>
+              <a:t>Add the fact</a:t>
+            </a:r>
+            <a:endParaRPr lang="en-US" sz="1700" dirty="0"/>
+          </a:p>
+        </p:txBody>
+      </p:sp>
+      <p:sp>
+        <p:nvSpPr>
+          <p:cNvPr id="15" name="method step Add the fact"/>
+          <p:cNvSpPr/>
+          <p:nvPr/>
+        </p:nvSpPr>
+        <p:spPr>
+          <a:xfrm>
+            <a:off x="2788920" y="2240280"/>
+            <a:ext cx="2103120" cy="1188720"/>
+          </a:xfrm>
+          <a:prstGeom prst="roundRect">
+            <a:avLst>
+              <a:gd name="adj" fmla="val 6154"/>
+            </a:avLst>
+          </a:prstGeom>
+          <a:solidFill>
+            <a:srgbClr val="E2F0D9"/>
+          </a:solidFill>
+          <a:ln w="12700">
+            <a:solidFill>
+              <a:srgbClr val="38761D"/>
+            </a:solidFill>
+            <a:prstDash val="solid"/>
+          </a:ln>
+        </p:spPr>
+      </p:sp>
+      <p:sp>
+        <p:nvSpPr>
+          <p:cNvPr id="16" name="Text 14"/>
+          <p:cNvSpPr txBox="1"/>
+          <p:nvPr/>
+        </p:nvSpPr>
+        <p:spPr>
+          <a:xfrm>
+            <a:off x="2880360" y="2286000"/>
+            <a:ext cx="1920240" cy="457200"/>
+          </a:xfrm>
+          <a:prstGeom prst="rect">
+            <a:avLst/>
+          </a:prstGeom>
+          <a:noFill/>
+          <a:ln/>
+        </p:spPr>
+        <p:txBody>
+          <a:bodyPr wrap="square" lIns="0" tIns="0" rIns="0" bIns="0" rtlCol="0" anchor="ctr"/>
+          <a:lstStyle/>
+          <a:p>
+            <a:pPr algn="ctr" indent="0" marL="0">
+              <a:buNone/>
+            </a:pPr>
+            <a:r>
+              <a:rPr lang="en-US" sz="1300" b="1" dirty="0">
+                <a:solidFill>
+                  <a:srgbClr val="38761D"/>
+                </a:solidFill>
+                <a:latin typeface="Courier New" pitchFamily="34" charset="0"/>
+                <a:ea typeface="Courier New" pitchFamily="34" charset="-122"/>
+                <a:cs typeface="Courier New" pitchFamily="34" charset="-120"/>
+              </a:rPr>
+              <a:t>solver.Minimize(v)</a:t>
+            </a:r>
+            <a:endParaRPr lang="en-US" sz="1300" dirty="0"/>
+          </a:p>
+        </p:txBody>
+      </p:sp>
+      <p:sp>
+        <p:nvSpPr>
+          <p:cNvPr id="17" name="Text 15"/>
+          <p:cNvSpPr txBox="1"/>
+          <p:nvPr/>
+        </p:nvSpPr>
+        <p:spPr>
+          <a:xfrm>
+            <a:off x="2880360" y="2761488"/>
+            <a:ext cx="1920240" cy="621792"/>
           </a:xfrm>
           <a:prstGeom prst="rect">
             <a:avLst/>
@@ -6848,31 +6926,31 @@
           <a:bodyPr wrap="square" lIns="0" tIns="0" rIns="0" bIns="0" rtlCol="0" anchor="t"/>
           <a:lstStyle/>
           <a:p>
-            <a:pPr indent="0" marL="0">
-              <a:buNone/>
-            </a:pPr>
-            <a:r>
-              <a:rPr lang="en-US" sz="1350" dirty="0">
+            <a:pPr algn="ctr" indent="0" marL="0">
+              <a:buNone/>
+            </a:pPr>
+            <a:r>
+              <a:rPr lang="en-US" sz="1300" dirty="0">
                 <a:solidFill>
                   <a:schemeClr val="tx1"/>
                 </a:solidFill>
               </a:rPr>
-              <a:t>writes solver.Minimize(10*x + 15*y + 20*z) and prints 20000 (without the fact it crashes)</a:t>
-            </a:r>
-            <a:endParaRPr lang="en-US" sz="1350" dirty="0"/>
-          </a:p>
-        </p:txBody>
-      </p:sp>
-      <p:sp>
-        <p:nvSpPr>
-          <p:cNvPr id="16" name="Text 14"/>
-          <p:cNvSpPr txBox="1"/>
-          <p:nvPr/>
-        </p:nvSpPr>
-        <p:spPr>
-          <a:xfrm>
-            <a:off x="3246120" y="3675888"/>
-            <a:ext cx="2148840" cy="320040"/>
+              <a:t>the call, from its own checked program → prints 20000 ✓</a:t>
+            </a:r>
+            <a:endParaRPr lang="en-US" sz="1300" dirty="0"/>
+          </a:p>
+        </p:txBody>
+      </p:sp>
+      <p:sp>
+        <p:nvSpPr>
+          <p:cNvPr id="18" name="Text 16"/>
+          <p:cNvSpPr txBox="1"/>
+          <p:nvPr/>
+        </p:nvSpPr>
+        <p:spPr>
+          <a:xfrm>
+            <a:off x="2788920" y="3474720"/>
+            <a:ext cx="2103120" cy="274320"/>
           </a:xfrm>
           <a:prstGeom prst="rect">
             <a:avLst/>
@@ -6888,27 +6966,27 @@
               <a:buNone/>
             </a:pPr>
             <a:r>
-              <a:rPr lang="en-US" sz="1500" b="1" dirty="0">
-                <a:solidFill>
-                  <a:srgbClr val="4472C4"/>
+              <a:rPr lang="en-US" sz="1400" b="1" dirty="0">
+                <a:solidFill>
+                  <a:schemeClr val="tx2"/>
                 </a:solidFill>
               </a:rPr>
               <a:t>316 tokens</a:t>
             </a:r>
-            <a:endParaRPr lang="en-US" sz="1500" dirty="0"/>
-          </a:p>
-        </p:txBody>
-      </p:sp>
-      <p:sp>
-        <p:nvSpPr>
-          <p:cNvPr id="17" name="Shape 15"/>
-          <p:cNvSpPr/>
-          <p:nvPr/>
-        </p:nvSpPr>
-        <p:spPr>
-          <a:xfrm>
-            <a:off x="5394960" y="2468880"/>
-            <a:ext cx="182880" cy="0"/>
+            <a:endParaRPr lang="en-US" sz="1400" dirty="0"/>
+          </a:p>
+        </p:txBody>
+      </p:sp>
+      <p:sp>
+        <p:nvSpPr>
+          <p:cNvPr id="19" name="Shape 17"/>
+          <p:cNvSpPr/>
+          <p:nvPr/>
+        </p:nvSpPr>
+        <p:spPr>
+          <a:xfrm>
+            <a:off x="4892040" y="2807208"/>
+            <a:ext cx="137160" cy="0"/>
           </a:xfrm>
           <a:prstGeom prst="line">
             <a:avLst/>
@@ -6925,41 +7003,14 @@
       </p:sp>
       <p:sp>
         <p:nvSpPr>
-          <p:cNvPr id="18" name="walk 3"/>
-          <p:cNvSpPr/>
-          <p:nvPr/>
-        </p:nvSpPr>
-        <p:spPr>
-          <a:xfrm>
-            <a:off x="5577840" y="1691640"/>
-            <a:ext cx="2011680" cy="1920240"/>
-          </a:xfrm>
-          <a:prstGeom prst="roundRect">
-            <a:avLst>
-              <a:gd name="adj" fmla="val 3810"/>
-            </a:avLst>
-          </a:prstGeom>
-          <a:solidFill>
-            <a:srgbClr val="DEEBF7"/>
-          </a:solidFill>
-          <a:ln w="9525">
-            <a:solidFill>
-              <a:srgbClr val="BFBFBF"/>
-            </a:solidFill>
-            <a:prstDash val="solid"/>
-          </a:ln>
-        </p:spPr>
-      </p:sp>
-      <p:sp>
-        <p:nvSpPr>
-          <p:cNvPr id="19" name="walk badge 3"/>
-          <p:cNvSpPr/>
-          <p:nvPr/>
-        </p:nvSpPr>
-        <p:spPr>
-          <a:xfrm>
-            <a:off x="5669280" y="1801368"/>
-            <a:ext cx="411480" cy="411480"/>
+          <p:cNvPr id="20" name="method badge 3"/>
+          <p:cNvSpPr/>
+          <p:nvPr/>
+        </p:nvSpPr>
+        <p:spPr>
+          <a:xfrm>
+            <a:off x="5029200" y="1673352"/>
+            <a:ext cx="457200" cy="457200"/>
           </a:xfrm>
           <a:prstGeom prst="ellipse">
             <a:avLst/>
@@ -6977,14 +7028,14 @@
       </p:sp>
       <p:sp>
         <p:nvSpPr>
-          <p:cNvPr id="20" name="Text 18"/>
-          <p:cNvSpPr txBox="1"/>
-          <p:nvPr/>
-        </p:nvSpPr>
-        <p:spPr>
-          <a:xfrm>
-            <a:off x="5669280" y="1801368"/>
-            <a:ext cx="411480" cy="411480"/>
+          <p:cNvPr id="21" name="Text 19"/>
+          <p:cNvSpPr txBox="1"/>
+          <p:nvPr/>
+        </p:nvSpPr>
+        <p:spPr>
+          <a:xfrm>
+            <a:off x="5029200" y="1673352"/>
+            <a:ext cx="457200" cy="457200"/>
           </a:xfrm>
           <a:prstGeom prst="rect">
             <a:avLst/>
@@ -7000,27 +7051,27 @@
               <a:buNone/>
             </a:pPr>
             <a:r>
-              <a:rPr lang="en-US" sz="1500" b="1" dirty="0">
+              <a:rPr lang="en-US" sz="1800" b="1" dirty="0">
                 <a:solidFill>
                   <a:srgbClr val="FFFFFF"/>
                 </a:solidFill>
               </a:rPr>
               <a:t>3</a:t>
             </a:r>
-            <a:endParaRPr lang="en-US" sz="1500" dirty="0"/>
-          </a:p>
-        </p:txBody>
-      </p:sp>
-      <p:sp>
-        <p:nvSpPr>
-          <p:cNvPr id="21" name="Text 19"/>
-          <p:cNvSpPr txBox="1"/>
-          <p:nvPr/>
-        </p:nvSpPr>
-        <p:spPr>
-          <a:xfrm>
-            <a:off x="6144768" y="1783080"/>
-            <a:ext cx="1371600" cy="457200"/>
+            <a:endParaRPr lang="en-US" sz="1800" dirty="0"/>
+          </a:p>
+        </p:txBody>
+      </p:sp>
+      <p:sp>
+        <p:nvSpPr>
+          <p:cNvPr id="22" name="Text 20"/>
+          <p:cNvSpPr txBox="1"/>
+          <p:nvPr/>
+        </p:nvSpPr>
+        <p:spPr>
+          <a:xfrm>
+            <a:off x="5577840" y="1673352"/>
+            <a:ext cx="1600200" cy="457200"/>
           </a:xfrm>
           <a:prstGeom prst="rect">
             <a:avLst/>
@@ -7036,27 +7087,93 @@
               <a:buNone/>
             </a:pPr>
             <a:r>
-              <a:rPr lang="en-US" sz="1500" b="1" dirty="0">
+              <a:rPr lang="en-US" sz="1700" b="1" dirty="0">
                 <a:solidFill>
                   <a:schemeClr val="tx1"/>
                 </a:solidFill>
               </a:rPr>
               <a:t>Free check</a:t>
             </a:r>
-            <a:endParaRPr lang="en-US" sz="1500" dirty="0"/>
-          </a:p>
-        </p:txBody>
-      </p:sp>
-      <p:sp>
-        <p:nvSpPr>
-          <p:cNvPr id="22" name="Text 20"/>
-          <p:cNvSpPr txBox="1"/>
-          <p:nvPr/>
-        </p:nvSpPr>
-        <p:spPr>
-          <a:xfrm>
-            <a:off x="5705856" y="2331720"/>
-            <a:ext cx="1755648" cy="1234440"/>
+            <a:endParaRPr lang="en-US" sz="1700" dirty="0"/>
+          </a:p>
+        </p:txBody>
+      </p:sp>
+      <p:sp>
+        <p:nvSpPr>
+          <p:cNvPr id="23" name="method step Free check"/>
+          <p:cNvSpPr/>
+          <p:nvPr/>
+        </p:nvSpPr>
+        <p:spPr>
+          <a:xfrm>
+            <a:off x="5029200" y="2240280"/>
+            <a:ext cx="2103120" cy="1188720"/>
+          </a:xfrm>
+          <a:prstGeom prst="roundRect">
+            <a:avLst>
+              <a:gd name="adj" fmla="val 6154"/>
+            </a:avLst>
+          </a:prstGeom>
+          <a:solidFill>
+            <a:srgbClr val="E2F0D9"/>
+          </a:solidFill>
+          <a:ln w="12700">
+            <a:solidFill>
+              <a:srgbClr val="38761D"/>
+            </a:solidFill>
+            <a:prstDash val="solid"/>
+          </a:ln>
+        </p:spPr>
+      </p:sp>
+      <p:sp>
+        <p:nvSpPr>
+          <p:cNvPr id="24" name="Text 22"/>
+          <p:cNvSpPr txBox="1"/>
+          <p:nvPr/>
+        </p:nvSpPr>
+        <p:spPr>
+          <a:xfrm>
+            <a:off x="5120640" y="2286000"/>
+            <a:ext cx="1920240" cy="457200"/>
+          </a:xfrm>
+          <a:prstGeom prst="rect">
+            <a:avLst/>
+          </a:prstGeom>
+          <a:noFill/>
+          <a:ln/>
+        </p:spPr>
+        <p:txBody>
+          <a:bodyPr wrap="square" lIns="0" tIns="0" rIns="0" bIns="0" rtlCol="0" anchor="ctr"/>
+          <a:lstStyle/>
+          <a:p>
+            <a:pPr algn="ctr" indent="0" marL="0">
+              <a:buNone/>
+            </a:pPr>
+            <a:r>
+              <a:rPr lang="en-US" sz="1800" b="1" dirty="0">
+                <a:solidFill>
+                  <a:srgbClr val="38761D"/>
+                </a:solidFill>
+                <a:latin typeface="Calibri" pitchFamily="34" charset="0"/>
+                <a:ea typeface="Calibri" pitchFamily="34" charset="-122"/>
+                <a:cs typeface="Calibri" pitchFamily="34" charset="-120"/>
+              </a:rPr>
+              <a:t>20000 = 20000</a:t>
+            </a:r>
+            <a:endParaRPr lang="en-US" sz="1800" dirty="0"/>
+          </a:p>
+        </p:txBody>
+      </p:sp>
+      <p:sp>
+        <p:nvSpPr>
+          <p:cNvPr id="25" name="Text 23"/>
+          <p:cNvSpPr txBox="1"/>
+          <p:nvPr/>
+        </p:nvSpPr>
+        <p:spPr>
+          <a:xfrm>
+            <a:off x="5120640" y="2761488"/>
+            <a:ext cx="1920240" cy="621792"/>
           </a:xfrm>
           <a:prstGeom prst="rect">
             <a:avLst/>
@@ -7068,31 +7185,31 @@
           <a:bodyPr wrap="square" lIns="0" tIns="0" rIns="0" bIns="0" rtlCol="0" anchor="t"/>
           <a:lstStyle/>
           <a:p>
-            <a:pPr indent="0" marL="0">
-              <a:buNone/>
-            </a:pPr>
-            <a:r>
-              <a:rPr lang="en-US" sz="1350" dirty="0">
+            <a:pPr algn="ctr" indent="0" marL="0">
+              <a:buNone/>
+            </a:pPr>
+            <a:r>
+              <a:rPr lang="en-US" sz="1300" dirty="0">
                 <a:solidFill>
                   <a:schemeClr val="tx1"/>
                 </a:solidFill>
               </a:rPr>
-              <a:t>a second version also runs and prints 20000: the two agree</a:t>
-            </a:r>
-            <a:endParaRPr lang="en-US" sz="1350" dirty="0"/>
-          </a:p>
-        </p:txBody>
-      </p:sp>
-      <p:sp>
-        <p:nvSpPr>
-          <p:cNvPr id="23" name="Text 21"/>
-          <p:cNvSpPr txBox="1"/>
-          <p:nvPr/>
-        </p:nvSpPr>
-        <p:spPr>
-          <a:xfrm>
-            <a:off x="5577840" y="3675888"/>
-            <a:ext cx="2011680" cy="320040"/>
+              <a:t>a 2nd version agrees ✓</a:t>
+            </a:r>
+            <a:endParaRPr lang="en-US" sz="1300" dirty="0"/>
+          </a:p>
+        </p:txBody>
+      </p:sp>
+      <p:sp>
+        <p:nvSpPr>
+          <p:cNvPr id="26" name="Text 24"/>
+          <p:cNvSpPr txBox="1"/>
+          <p:nvPr/>
+        </p:nvSpPr>
+        <p:spPr>
+          <a:xfrm>
+            <a:off x="5029200" y="3474720"/>
+            <a:ext cx="2103120" cy="274320"/>
           </a:xfrm>
           <a:prstGeom prst="rect">
             <a:avLst/>
@@ -7108,27 +7225,27 @@
               <a:buNone/>
             </a:pPr>
             <a:r>
-              <a:rPr lang="en-US" sz="1500" b="1" dirty="0">
-                <a:solidFill>
-                  <a:srgbClr val="4472C4"/>
+              <a:rPr lang="en-US" sz="1400" b="1" dirty="0">
+                <a:solidFill>
+                  <a:schemeClr val="tx2"/>
                 </a:solidFill>
               </a:rPr>
               <a:t>+312 tokens</a:t>
             </a:r>
-            <a:endParaRPr lang="en-US" sz="1500" dirty="0"/>
-          </a:p>
-        </p:txBody>
-      </p:sp>
-      <p:sp>
-        <p:nvSpPr>
-          <p:cNvPr id="24" name="Shape 22"/>
-          <p:cNvSpPr/>
-          <p:nvPr/>
-        </p:nvSpPr>
-        <p:spPr>
-          <a:xfrm>
-            <a:off x="7589520" y="2468880"/>
-            <a:ext cx="182880" cy="0"/>
+            <a:endParaRPr lang="en-US" sz="1400" dirty="0"/>
+          </a:p>
+        </p:txBody>
+      </p:sp>
+      <p:sp>
+        <p:nvSpPr>
+          <p:cNvPr id="27" name="Shape 25"/>
+          <p:cNvSpPr/>
+          <p:nvPr/>
+        </p:nvSpPr>
+        <p:spPr>
+          <a:xfrm>
+            <a:off x="7132320" y="2807208"/>
+            <a:ext cx="137160" cy="0"/>
           </a:xfrm>
           <a:prstGeom prst="line">
             <a:avLst/>
@@ -7145,41 +7262,14 @@
       </p:sp>
       <p:sp>
         <p:nvSpPr>
-          <p:cNvPr id="25" name="walk 4"/>
-          <p:cNvSpPr/>
-          <p:nvPr/>
-        </p:nvSpPr>
-        <p:spPr>
-          <a:xfrm>
-            <a:off x="7772400" y="1691640"/>
-            <a:ext cx="2103120" cy="1920240"/>
-          </a:xfrm>
-          <a:prstGeom prst="roundRect">
-            <a:avLst>
-              <a:gd name="adj" fmla="val 3810"/>
-            </a:avLst>
-          </a:prstGeom>
-          <a:solidFill>
-            <a:srgbClr val="FFFFFF"/>
-          </a:solidFill>
-          <a:ln w="9525">
-            <a:solidFill>
-              <a:srgbClr val="BFBFBF"/>
-            </a:solidFill>
-            <a:prstDash val="solid"/>
-          </a:ln>
-        </p:spPr>
-      </p:sp>
-      <p:sp>
-        <p:nvSpPr>
-          <p:cNvPr id="26" name="walk badge 4"/>
-          <p:cNvSpPr/>
-          <p:nvPr/>
-        </p:nvSpPr>
-        <p:spPr>
-          <a:xfrm>
-            <a:off x="7863840" y="1801368"/>
-            <a:ext cx="411480" cy="411480"/>
+          <p:cNvPr id="28" name="method badge 4"/>
+          <p:cNvSpPr/>
+          <p:nvPr/>
+        </p:nvSpPr>
+        <p:spPr>
+          <a:xfrm>
+            <a:off x="7269480" y="1673352"/>
+            <a:ext cx="457200" cy="457200"/>
           </a:xfrm>
           <a:prstGeom prst="ellipse">
             <a:avLst/>
@@ -7197,14 +7287,14 @@
       </p:sp>
       <p:sp>
         <p:nvSpPr>
-          <p:cNvPr id="27" name="Text 25"/>
-          <p:cNvSpPr txBox="1"/>
-          <p:nvPr/>
-        </p:nvSpPr>
-        <p:spPr>
-          <a:xfrm>
-            <a:off x="7863840" y="1801368"/>
-            <a:ext cx="411480" cy="411480"/>
+          <p:cNvPr id="29" name="Text 27"/>
+          <p:cNvSpPr txBox="1"/>
+          <p:nvPr/>
+        </p:nvSpPr>
+        <p:spPr>
+          <a:xfrm>
+            <a:off x="7269480" y="1673352"/>
+            <a:ext cx="457200" cy="457200"/>
           </a:xfrm>
           <a:prstGeom prst="rect">
             <a:avLst/>
@@ -7220,27 +7310,27 @@
               <a:buNone/>
             </a:pPr>
             <a:r>
-              <a:rPr lang="en-US" sz="1500" b="1" dirty="0">
+              <a:rPr lang="en-US" sz="1800" b="1" dirty="0">
                 <a:solidFill>
                   <a:srgbClr val="FFFFFF"/>
                 </a:solidFill>
               </a:rPr>
               <a:t>4</a:t>
             </a:r>
-            <a:endParaRPr lang="en-US" sz="1500" dirty="0"/>
-          </a:p>
-        </p:txBody>
-      </p:sp>
-      <p:sp>
-        <p:nvSpPr>
-          <p:cNvPr id="28" name="Text 26"/>
-          <p:cNvSpPr txBox="1"/>
-          <p:nvPr/>
-        </p:nvSpPr>
-        <p:spPr>
-          <a:xfrm>
-            <a:off x="8339328" y="1783080"/>
-            <a:ext cx="1463040" cy="457200"/>
+            <a:endParaRPr lang="en-US" sz="1800" dirty="0"/>
+          </a:p>
+        </p:txBody>
+      </p:sp>
+      <p:sp>
+        <p:nvSpPr>
+          <p:cNvPr id="30" name="Text 28"/>
+          <p:cNvSpPr txBox="1"/>
+          <p:nvPr/>
+        </p:nvSpPr>
+        <p:spPr>
+          <a:xfrm>
+            <a:off x="7818120" y="1673352"/>
+            <a:ext cx="1600200" cy="457200"/>
           </a:xfrm>
           <a:prstGeom prst="rect">
             <a:avLst/>
@@ -7256,27 +7346,93 @@
               <a:buNone/>
             </a:pPr>
             <a:r>
-              <a:rPr lang="en-US" sz="1500" b="1" dirty="0">
+              <a:rPr lang="en-US" sz="1700" b="1" dirty="0">
                 <a:solidFill>
                   <a:schemeClr val="tx1"/>
                 </a:solidFill>
               </a:rPr>
-              <a:t>Think? No</a:t>
-            </a:r>
-            <a:endParaRPr lang="en-US" sz="1500" dirty="0"/>
-          </a:p>
-        </p:txBody>
-      </p:sp>
-      <p:sp>
-        <p:nvSpPr>
-          <p:cNvPr id="29" name="Text 27"/>
-          <p:cNvSpPr txBox="1"/>
-          <p:nvPr/>
-        </p:nvSpPr>
-        <p:spPr>
-          <a:xfrm>
-            <a:off x="7900416" y="2331720"/>
-            <a:ext cx="1847088" cy="1234440"/>
+              <a:t>Think harder?</a:t>
+            </a:r>
+            <a:endParaRPr lang="en-US" sz="1700" dirty="0"/>
+          </a:p>
+        </p:txBody>
+      </p:sp>
+      <p:sp>
+        <p:nvSpPr>
+          <p:cNvPr id="31" name="method step Think harder?"/>
+          <p:cNvSpPr/>
+          <p:nvPr/>
+        </p:nvSpPr>
+        <p:spPr>
+          <a:xfrm>
+            <a:off x="7269480" y="2240280"/>
+            <a:ext cx="2103120" cy="1188720"/>
+          </a:xfrm>
+          <a:prstGeom prst="roundRect">
+            <a:avLst>
+              <a:gd name="adj" fmla="val 6154"/>
+            </a:avLst>
+          </a:prstGeom>
+          <a:solidFill>
+            <a:srgbClr val="F2F2F2"/>
+          </a:solidFill>
+          <a:ln w="12700">
+            <a:solidFill>
+              <a:srgbClr val="7F7F7F"/>
+            </a:solidFill>
+            <a:prstDash val="solid"/>
+          </a:ln>
+        </p:spPr>
+      </p:sp>
+      <p:sp>
+        <p:nvSpPr>
+          <p:cNvPr id="32" name="Text 30"/>
+          <p:cNvSpPr txBox="1"/>
+          <p:nvPr/>
+        </p:nvSpPr>
+        <p:spPr>
+          <a:xfrm>
+            <a:off x="7360920" y="2286000"/>
+            <a:ext cx="1920240" cy="457200"/>
+          </a:xfrm>
+          <a:prstGeom prst="rect">
+            <a:avLst/>
+          </a:prstGeom>
+          <a:noFill/>
+          <a:ln/>
+        </p:spPr>
+        <p:txBody>
+          <a:bodyPr wrap="square" lIns="0" tIns="0" rIns="0" bIns="0" rtlCol="0" anchor="ctr"/>
+          <a:lstStyle/>
+          <a:p>
+            <a:pPr algn="ctr" indent="0" marL="0">
+              <a:buNone/>
+            </a:pPr>
+            <a:r>
+              <a:rPr lang="en-US" sz="1800" b="1" dirty="0">
+                <a:solidFill>
+                  <a:srgbClr val="7F7F7F"/>
+                </a:solidFill>
+                <a:latin typeface="Calibri" pitchFamily="34" charset="0"/>
+                <a:ea typeface="Calibri" pitchFamily="34" charset="-122"/>
+                <a:cs typeface="Calibri" pitchFamily="34" charset="-120"/>
+              </a:rPr>
+              <a:t>skipped</a:t>
+            </a:r>
+            <a:endParaRPr lang="en-US" sz="1800" dirty="0"/>
+          </a:p>
+        </p:txBody>
+      </p:sp>
+      <p:sp>
+        <p:nvSpPr>
+          <p:cNvPr id="33" name="Text 31"/>
+          <p:cNvSpPr txBox="1"/>
+          <p:nvPr/>
+        </p:nvSpPr>
+        <p:spPr>
+          <a:xfrm>
+            <a:off x="7360920" y="2761488"/>
+            <a:ext cx="1920240" cy="621792"/>
           </a:xfrm>
           <a:prstGeom prst="rect">
             <a:avLst/>
@@ -7288,31 +7444,31 @@
           <a:bodyPr wrap="square" lIns="0" tIns="0" rIns="0" bIns="0" rtlCol="0" anchor="t"/>
           <a:lstStyle/>
           <a:p>
-            <a:pPr indent="0" marL="0">
-              <a:buNone/>
-            </a:pPr>
-            <a:r>
-              <a:rPr lang="en-US" sz="1350" dirty="0">
+            <a:pPr algn="ctr" indent="0" marL="0">
+              <a:buNone/>
+            </a:pPr>
+            <a:r>
+              <a:rPr lang="en-US" sz="1300" dirty="0">
                 <a:solidFill>
                   <a:schemeClr val="tx1"/>
                 </a:solidFill>
               </a:rPr>
-              <a:t>think harder only if they disagree or crash; here accept 20000 (thinking alone: 5.3k tokens)</a:t>
-            </a:r>
-            <a:endParaRPr lang="en-US" sz="1350" dirty="0"/>
-          </a:p>
-        </p:txBody>
-      </p:sp>
-      <p:sp>
-        <p:nvSpPr>
-          <p:cNvPr id="30" name="Text 28"/>
-          <p:cNvSpPr txBox="1"/>
-          <p:nvPr/>
-        </p:nvSpPr>
-        <p:spPr>
-          <a:xfrm>
-            <a:off x="7772400" y="3675888"/>
-            <a:ext cx="2103120" cy="320040"/>
+              <a:t>only if the versions differ or crash</a:t>
+            </a:r>
+            <a:endParaRPr lang="en-US" sz="1300" dirty="0"/>
+          </a:p>
+        </p:txBody>
+      </p:sp>
+      <p:sp>
+        <p:nvSpPr>
+          <p:cNvPr id="34" name="Text 32"/>
+          <p:cNvSpPr txBox="1"/>
+          <p:nvPr/>
+        </p:nvSpPr>
+        <p:spPr>
+          <a:xfrm>
+            <a:off x="7269480" y="3474720"/>
+            <a:ext cx="2103120" cy="274320"/>
           </a:xfrm>
           <a:prstGeom prst="rect">
             <a:avLst/>
@@ -7328,27 +7484,27 @@
               <a:buNone/>
             </a:pPr>
             <a:r>
-              <a:rPr lang="en-US" sz="1500" b="1" dirty="0">
-                <a:solidFill>
-                  <a:srgbClr val="38761D"/>
-                </a:solidFill>
-              </a:rPr>
-              <a:t>total 0.6k</a:t>
-            </a:r>
-            <a:endParaRPr lang="en-US" sz="1500" dirty="0"/>
-          </a:p>
-        </p:txBody>
-      </p:sp>
-      <p:sp>
-        <p:nvSpPr>
-          <p:cNvPr id="31" name="Shape 29"/>
-          <p:cNvSpPr/>
-          <p:nvPr/>
-        </p:nvSpPr>
-        <p:spPr>
-          <a:xfrm>
-            <a:off x="9875520" y="2468880"/>
-            <a:ext cx="182880" cy="0"/>
+              <a:rPr lang="en-US" sz="1400" b="1" dirty="0">
+                <a:solidFill>
+                  <a:schemeClr val="tx2"/>
+                </a:solidFill>
+              </a:rPr>
+              <a:t>0 tokens</a:t>
+            </a:r>
+            <a:endParaRPr lang="en-US" sz="1400" dirty="0"/>
+          </a:p>
+        </p:txBody>
+      </p:sp>
+      <p:sp>
+        <p:nvSpPr>
+          <p:cNvPr id="35" name="Shape 33"/>
+          <p:cNvSpPr/>
+          <p:nvPr/>
+        </p:nvSpPr>
+        <p:spPr>
+          <a:xfrm>
+            <a:off x="9372600" y="2807208"/>
+            <a:ext cx="137160" cy="0"/>
           </a:xfrm>
           <a:prstGeom prst="line">
             <a:avLst/>
@@ -7365,18 +7521,749 @@
       </p:sp>
       <p:sp>
         <p:nvSpPr>
-          <p:cNvPr id="32" name="walk 5"/>
-          <p:cNvSpPr/>
-          <p:nvPr/>
-        </p:nvSpPr>
-        <p:spPr>
-          <a:xfrm>
-            <a:off x="10058400" y="1691640"/>
-            <a:ext cx="1554480" cy="1920240"/>
+          <p:cNvPr id="36" name="method badge 5"/>
+          <p:cNvSpPr/>
+          <p:nvPr/>
+        </p:nvSpPr>
+        <p:spPr>
+          <a:xfrm>
+            <a:off x="9509760" y="1673352"/>
+            <a:ext cx="457200" cy="457200"/>
+          </a:xfrm>
+          <a:prstGeom prst="ellipse">
+            <a:avLst/>
+          </a:prstGeom>
+          <a:solidFill>
+            <a:srgbClr val="4472C4"/>
+          </a:solidFill>
+          <a:ln w="12700">
+            <a:solidFill>
+              <a:srgbClr val="4472C4"/>
+            </a:solidFill>
+            <a:prstDash val="solid"/>
+          </a:ln>
+        </p:spPr>
+      </p:sp>
+      <p:sp>
+        <p:nvSpPr>
+          <p:cNvPr id="37" name="Text 35"/>
+          <p:cNvSpPr txBox="1"/>
+          <p:nvPr/>
+        </p:nvSpPr>
+        <p:spPr>
+          <a:xfrm>
+            <a:off x="9509760" y="1673352"/>
+            <a:ext cx="457200" cy="457200"/>
+          </a:xfrm>
+          <a:prstGeom prst="rect">
+            <a:avLst/>
+          </a:prstGeom>
+          <a:noFill/>
+          <a:ln/>
+        </p:spPr>
+        <p:txBody>
+          <a:bodyPr wrap="square" lIns="0" tIns="0" rIns="0" bIns="0" rtlCol="0" anchor="ctr"/>
+          <a:lstStyle/>
+          <a:p>
+            <a:pPr algn="ctr" indent="0" marL="0">
+              <a:buNone/>
+            </a:pPr>
+            <a:r>
+              <a:rPr lang="en-US" sz="1800" b="1" dirty="0">
+                <a:solidFill>
+                  <a:srgbClr val="FFFFFF"/>
+                </a:solidFill>
+              </a:rPr>
+              <a:t>5</a:t>
+            </a:r>
+            <a:endParaRPr lang="en-US" sz="1800" dirty="0"/>
+          </a:p>
+        </p:txBody>
+      </p:sp>
+      <p:sp>
+        <p:nvSpPr>
+          <p:cNvPr id="38" name="Text 36"/>
+          <p:cNvSpPr txBox="1"/>
+          <p:nvPr/>
+        </p:nvSpPr>
+        <p:spPr>
+          <a:xfrm>
+            <a:off x="10058400" y="1673352"/>
+            <a:ext cx="1600200" cy="457200"/>
+          </a:xfrm>
+          <a:prstGeom prst="rect">
+            <a:avLst/>
+          </a:prstGeom>
+          <a:noFill/>
+          <a:ln/>
+        </p:spPr>
+        <p:txBody>
+          <a:bodyPr wrap="square" lIns="0" tIns="0" rIns="0" bIns="0" rtlCol="0" anchor="ctr"/>
+          <a:lstStyle/>
+          <a:p>
+            <a:pPr indent="0" marL="0">
+              <a:buNone/>
+            </a:pPr>
+            <a:r>
+              <a:rPr lang="en-US" sz="1700" b="1" dirty="0">
+                <a:solidFill>
+                  <a:schemeClr val="tx1"/>
+                </a:solidFill>
+              </a:rPr>
+              <a:t>Reuse</a:t>
+            </a:r>
+            <a:endParaRPr lang="en-US" sz="1700" dirty="0"/>
+          </a:p>
+        </p:txBody>
+      </p:sp>
+      <p:sp>
+        <p:nvSpPr>
+          <p:cNvPr id="39" name="method step Reuse"/>
+          <p:cNvSpPr/>
+          <p:nvPr/>
+        </p:nvSpPr>
+        <p:spPr>
+          <a:xfrm>
+            <a:off x="9509760" y="2240280"/>
+            <a:ext cx="2103120" cy="1188720"/>
           </a:xfrm>
           <a:prstGeom prst="roundRect">
             <a:avLst>
-              <a:gd name="adj" fmla="val 4706"/>
+              <a:gd name="adj" fmla="val 6154"/>
+            </a:avLst>
+          </a:prstGeom>
+          <a:solidFill>
+            <a:srgbClr val="DEEBF7"/>
+          </a:solidFill>
+          <a:ln w="12700">
+            <a:solidFill>
+              <a:srgbClr val="4472C4"/>
+            </a:solidFill>
+            <a:prstDash val="solid"/>
+          </a:ln>
+        </p:spPr>
+      </p:sp>
+      <p:sp>
+        <p:nvSpPr>
+          <p:cNvPr id="40" name="Text 38"/>
+          <p:cNvSpPr txBox="1"/>
+          <p:nvPr/>
+        </p:nvSpPr>
+        <p:spPr>
+          <a:xfrm>
+            <a:off x="9601200" y="2286000"/>
+            <a:ext cx="1920240" cy="457200"/>
+          </a:xfrm>
+          <a:prstGeom prst="rect">
+            <a:avLst/>
+          </a:prstGeom>
+          <a:noFill/>
+          <a:ln/>
+        </p:spPr>
+        <p:txBody>
+          <a:bodyPr wrap="square" lIns="0" tIns="0" rIns="0" bIns="0" rtlCol="0" anchor="ctr"/>
+          <a:lstStyle/>
+          <a:p>
+            <a:pPr algn="ctr" indent="0" marL="0">
+              <a:buNone/>
+            </a:pPr>
+            <a:r>
+              <a:rPr lang="en-US" sz="1800" b="1" dirty="0">
+                <a:solidFill>
+                  <a:srgbClr val="4472C4"/>
+                </a:solidFill>
+                <a:latin typeface="Calibri" pitchFamily="34" charset="0"/>
+                <a:ea typeface="Calibri" pitchFamily="34" charset="-122"/>
+                <a:cs typeface="Calibri" pitchFamily="34" charset="-120"/>
+              </a:rPr>
+              <a:t>same program</a:t>
+            </a:r>
+            <a:endParaRPr lang="en-US" sz="1800" dirty="0"/>
+          </a:p>
+        </p:txBody>
+      </p:sp>
+      <p:sp>
+        <p:nvSpPr>
+          <p:cNvPr id="41" name="Text 39"/>
+          <p:cNvSpPr txBox="1"/>
+          <p:nvPr/>
+        </p:nvSpPr>
+        <p:spPr>
+          <a:xfrm>
+            <a:off x="9601200" y="2761488"/>
+            <a:ext cx="1920240" cy="621792"/>
+          </a:xfrm>
+          <a:prstGeom prst="rect">
+            <a:avLst/>
+          </a:prstGeom>
+          <a:noFill/>
+          <a:ln/>
+        </p:spPr>
+        <p:txBody>
+          <a:bodyPr wrap="square" lIns="0" tIns="0" rIns="0" bIns="0" rtlCol="0" anchor="t"/>
+          <a:lstStyle/>
+          <a:p>
+            <a:pPr algn="ctr" indent="0" marL="0">
+              <a:buNone/>
+            </a:pPr>
+            <a:r>
+              <a:rPr lang="en-US" sz="1300" dirty="0">
+                <a:solidFill>
+                  <a:schemeClr val="tx1"/>
+                </a:solidFill>
+              </a:rPr>
+              <a:t>same kind of problem, new data</a:t>
+            </a:r>
+            <a:endParaRPr lang="en-US" sz="1300" dirty="0"/>
+          </a:p>
+        </p:txBody>
+      </p:sp>
+      <p:sp>
+        <p:nvSpPr>
+          <p:cNvPr id="42" name="Text 40"/>
+          <p:cNvSpPr txBox="1"/>
+          <p:nvPr/>
+        </p:nvSpPr>
+        <p:spPr>
+          <a:xfrm>
+            <a:off x="9509760" y="3474720"/>
+            <a:ext cx="2103120" cy="274320"/>
+          </a:xfrm>
+          <a:prstGeom prst="rect">
+            <a:avLst/>
+          </a:prstGeom>
+          <a:noFill/>
+          <a:ln/>
+        </p:spPr>
+        <p:txBody>
+          <a:bodyPr wrap="square" lIns="0" tIns="0" rIns="0" bIns="0" rtlCol="0" anchor="ctr"/>
+          <a:lstStyle/>
+          <a:p>
+            <a:pPr algn="ctr" indent="0" marL="0">
+              <a:buNone/>
+            </a:pPr>
+            <a:r>
+              <a:rPr lang="en-US" sz="1400" b="1" dirty="0">
+                <a:solidFill>
+                  <a:schemeClr val="tx2"/>
+                </a:solidFill>
+              </a:rPr>
+              <a:t>≈ 0 tokens</a:t>
+            </a:r>
+            <a:endParaRPr lang="en-US" sz="1400" dirty="0"/>
+          </a:p>
+        </p:txBody>
+      </p:sp>
+      <p:sp>
+        <p:nvSpPr>
+          <p:cNvPr id="43" name="Text 41"/>
+          <p:cNvSpPr txBox="1"/>
+          <p:nvPr/>
+        </p:nvSpPr>
+        <p:spPr>
+          <a:xfrm>
+            <a:off x="548640" y="3886200"/>
+            <a:ext cx="5394960" cy="365760"/>
+          </a:xfrm>
+          <a:prstGeom prst="rect">
+            <a:avLst/>
+          </a:prstGeom>
+          <a:noFill/>
+          <a:ln/>
+        </p:spPr>
+        <p:txBody>
+          <a:bodyPr wrap="square" lIns="0" tIns="0" rIns="0" bIns="0" rtlCol="0" anchor="ctr"/>
+          <a:lstStyle/>
+          <a:p>
+            <a:pPr indent="0" marL="0">
+              <a:buNone/>
+            </a:pPr>
+            <a:r>
+              <a:rPr lang="en-US" sz="1500" b="1" dirty="0">
+                <a:solidFill>
+                  <a:schemeClr val="tx1"/>
+                </a:solidFill>
+              </a:rPr>
+              <a:t>This problem: tokens (both answers right)</a:t>
+            </a:r>
+            <a:endParaRPr lang="en-US" sz="1500" dirty="0"/>
+          </a:p>
+        </p:txBody>
+      </p:sp>
+      <p:sp>
+        <p:nvSpPr>
+          <p:cNvPr id="44" name="Text 42"/>
+          <p:cNvSpPr txBox="1"/>
+          <p:nvPr/>
+        </p:nvSpPr>
+        <p:spPr>
+          <a:xfrm>
+            <a:off x="548640" y="4315968"/>
+            <a:ext cx="2103120" cy="365760"/>
+          </a:xfrm>
+          <a:prstGeom prst="rect">
+            <a:avLst/>
+          </a:prstGeom>
+          <a:noFill/>
+          <a:ln/>
+        </p:spPr>
+        <p:txBody>
+          <a:bodyPr wrap="square" lIns="0" tIns="0" rIns="0" bIns="0" rtlCol="0" anchor="ctr"/>
+          <a:lstStyle/>
+          <a:p>
+            <a:pPr algn="r" indent="0" marL="0">
+              <a:buNone/>
+            </a:pPr>
+            <a:r>
+              <a:rPr lang="en-US" sz="1400" dirty="0">
+                <a:solidFill>
+                  <a:schemeClr val="tx1"/>
+                </a:solidFill>
+              </a:rPr>
+              <a:t>always think</a:t>
+            </a:r>
+            <a:endParaRPr lang="en-US" sz="1400" dirty="0"/>
+          </a:p>
+        </p:txBody>
+      </p:sp>
+      <p:sp>
+        <p:nvSpPr>
+          <p:cNvPr id="45" name="This problem: tokens (both answers right) always think"/>
+          <p:cNvSpPr/>
+          <p:nvPr/>
+        </p:nvSpPr>
+        <p:spPr>
+          <a:xfrm>
+            <a:off x="2743200" y="4389120"/>
+            <a:ext cx="2194560" cy="237744"/>
+          </a:xfrm>
+          <a:prstGeom prst="rect">
+            <a:avLst/>
+          </a:prstGeom>
+          <a:solidFill>
+            <a:srgbClr val="7F7F7F"/>
+          </a:solidFill>
+          <a:ln w="6350">
+            <a:solidFill>
+              <a:srgbClr val="7F7F7F"/>
+            </a:solidFill>
+            <a:prstDash val="solid"/>
+          </a:ln>
+        </p:spPr>
+      </p:sp>
+      <p:sp>
+        <p:nvSpPr>
+          <p:cNvPr id="46" name="Text 44"/>
+          <p:cNvSpPr txBox="1"/>
+          <p:nvPr/>
+        </p:nvSpPr>
+        <p:spPr>
+          <a:xfrm>
+            <a:off x="5029200" y="4315968"/>
+            <a:ext cx="1188720" cy="365760"/>
+          </a:xfrm>
+          <a:prstGeom prst="rect">
+            <a:avLst/>
+          </a:prstGeom>
+          <a:noFill/>
+          <a:ln/>
+        </p:spPr>
+        <p:txBody>
+          <a:bodyPr wrap="square" lIns="0" tIns="0" rIns="0" bIns="0" rtlCol="0" anchor="ctr"/>
+          <a:lstStyle/>
+          <a:p>
+            <a:pPr indent="0" marL="0">
+              <a:buNone/>
+            </a:pPr>
+            <a:r>
+              <a:rPr lang="en-US" sz="1400" b="1" dirty="0">
+                <a:solidFill>
+                  <a:srgbClr val="7F7F7F"/>
+                </a:solidFill>
+              </a:rPr>
+              <a:t>5.3k</a:t>
+            </a:r>
+            <a:endParaRPr lang="en-US" sz="1400" dirty="0"/>
+          </a:p>
+        </p:txBody>
+      </p:sp>
+      <p:sp>
+        <p:nvSpPr>
+          <p:cNvPr id="47" name="Text 45"/>
+          <p:cNvSpPr txBox="1"/>
+          <p:nvPr/>
+        </p:nvSpPr>
+        <p:spPr>
+          <a:xfrm>
+            <a:off x="548640" y="4754880"/>
+            <a:ext cx="2103120" cy="365760"/>
+          </a:xfrm>
+          <a:prstGeom prst="rect">
+            <a:avLst/>
+          </a:prstGeom>
+          <a:noFill/>
+          <a:ln/>
+        </p:spPr>
+        <p:txBody>
+          <a:bodyPr wrap="square" lIns="0" tIns="0" rIns="0" bIns="0" rtlCol="0" anchor="ctr"/>
+          <a:lstStyle/>
+          <a:p>
+            <a:pPr algn="r" indent="0" marL="0">
+              <a:buNone/>
+            </a:pPr>
+            <a:r>
+              <a:rPr lang="en-US" sz="1400" dirty="0">
+                <a:solidFill>
+                  <a:schemeClr val="tx1"/>
+                </a:solidFill>
+              </a:rPr>
+              <a:t>our method</a:t>
+            </a:r>
+            <a:endParaRPr lang="en-US" sz="1400" dirty="0"/>
+          </a:p>
+        </p:txBody>
+      </p:sp>
+      <p:sp>
+        <p:nvSpPr>
+          <p:cNvPr id="48" name="This problem: tokens (both answers right) our method"/>
+          <p:cNvSpPr/>
+          <p:nvPr/>
+        </p:nvSpPr>
+        <p:spPr>
+          <a:xfrm>
+            <a:off x="2743200" y="4828032"/>
+            <a:ext cx="263347" cy="237744"/>
+          </a:xfrm>
+          <a:prstGeom prst="rect">
+            <a:avLst/>
+          </a:prstGeom>
+          <a:solidFill>
+            <a:srgbClr val="4472C4"/>
+          </a:solidFill>
+          <a:ln w="6350">
+            <a:solidFill>
+              <a:srgbClr val="4472C4"/>
+            </a:solidFill>
+            <a:prstDash val="solid"/>
+          </a:ln>
+        </p:spPr>
+      </p:sp>
+      <p:sp>
+        <p:nvSpPr>
+          <p:cNvPr id="49" name="Text 47"/>
+          <p:cNvSpPr txBox="1"/>
+          <p:nvPr/>
+        </p:nvSpPr>
+        <p:spPr>
+          <a:xfrm>
+            <a:off x="3097987" y="4754880"/>
+            <a:ext cx="1188720" cy="365760"/>
+          </a:xfrm>
+          <a:prstGeom prst="rect">
+            <a:avLst/>
+          </a:prstGeom>
+          <a:noFill/>
+          <a:ln/>
+        </p:spPr>
+        <p:txBody>
+          <a:bodyPr wrap="square" lIns="0" tIns="0" rIns="0" bIns="0" rtlCol="0" anchor="ctr"/>
+          <a:lstStyle/>
+          <a:p>
+            <a:pPr indent="0" marL="0">
+              <a:buNone/>
+            </a:pPr>
+            <a:r>
+              <a:rPr lang="en-US" sz="1400" b="1" dirty="0">
+                <a:solidFill>
+                  <a:srgbClr val="4472C4"/>
+                </a:solidFill>
+              </a:rPr>
+              <a:t>0.6k</a:t>
+            </a:r>
+            <a:endParaRPr lang="en-US" sz="1400" dirty="0"/>
+          </a:p>
+        </p:txBody>
+      </p:sp>
+      <p:sp>
+        <p:nvSpPr>
+          <p:cNvPr id="50" name="Text 48"/>
+          <p:cNvSpPr txBox="1"/>
+          <p:nvPr/>
+        </p:nvSpPr>
+        <p:spPr>
+          <a:xfrm>
+            <a:off x="6217920" y="3886200"/>
+            <a:ext cx="5394960" cy="365760"/>
+          </a:xfrm>
+          <a:prstGeom prst="rect">
+            <a:avLst/>
+          </a:prstGeom>
+          <a:noFill/>
+          <a:ln/>
+        </p:spPr>
+        <p:txBody>
+          <a:bodyPr wrap="square" lIns="0" tIns="0" rIns="0" bIns="0" rtlCol="0" anchor="ctr"/>
+          <a:lstStyle/>
+          <a:p>
+            <a:pPr indent="0" marL="0">
+              <a:buNone/>
+            </a:pPr>
+            <a:r>
+              <a:rPr lang="en-US" sz="1500" b="1" dirty="0">
+                <a:solidFill>
+                  <a:schemeClr val="tx1"/>
+                </a:solidFill>
+              </a:rPr>
+              <a:t>All 624 problems, 3 models: % solved · tokens</a:t>
+            </a:r>
+            <a:endParaRPr lang="en-US" sz="1500" dirty="0"/>
+          </a:p>
+        </p:txBody>
+      </p:sp>
+      <p:sp>
+        <p:nvSpPr>
+          <p:cNvPr id="51" name="Text 49"/>
+          <p:cNvSpPr txBox="1"/>
+          <p:nvPr/>
+        </p:nvSpPr>
+        <p:spPr>
+          <a:xfrm>
+            <a:off x="6217920" y="4315968"/>
+            <a:ext cx="2103120" cy="365760"/>
+          </a:xfrm>
+          <a:prstGeom prst="rect">
+            <a:avLst/>
+          </a:prstGeom>
+          <a:noFill/>
+          <a:ln/>
+        </p:spPr>
+        <p:txBody>
+          <a:bodyPr wrap="square" lIns="0" tIns="0" rIns="0" bIns="0" rtlCol="0" anchor="ctr"/>
+          <a:lstStyle/>
+          <a:p>
+            <a:pPr algn="r" indent="0" marL="0">
+              <a:buNone/>
+            </a:pPr>
+            <a:r>
+              <a:rPr lang="en-US" sz="1400" dirty="0">
+                <a:solidFill>
+                  <a:schemeClr val="tx1"/>
+                </a:solidFill>
+              </a:rPr>
+              <a:t>think on hardest</a:t>
+            </a:r>
+            <a:endParaRPr lang="en-US" sz="1400" dirty="0"/>
+          </a:p>
+        </p:txBody>
+      </p:sp>
+      <p:sp>
+        <p:nvSpPr>
+          <p:cNvPr id="52" name="All 624 problems, 3 models: % solved · tokens think on hardest"/>
+          <p:cNvSpPr/>
+          <p:nvPr/>
+        </p:nvSpPr>
+        <p:spPr>
+          <a:xfrm>
+            <a:off x="8412480" y="4389120"/>
+            <a:ext cx="1623974" cy="237744"/>
+          </a:xfrm>
+          <a:prstGeom prst="rect">
+            <a:avLst/>
+          </a:prstGeom>
+          <a:solidFill>
+            <a:srgbClr val="7F7F7F"/>
+          </a:solidFill>
+          <a:ln w="6350">
+            <a:solidFill>
+              <a:srgbClr val="7F7F7F"/>
+            </a:solidFill>
+            <a:prstDash val="solid"/>
+          </a:ln>
+        </p:spPr>
+      </p:sp>
+      <p:sp>
+        <p:nvSpPr>
+          <p:cNvPr id="53" name="Text 51"/>
+          <p:cNvSpPr txBox="1"/>
+          <p:nvPr/>
+        </p:nvSpPr>
+        <p:spPr>
+          <a:xfrm>
+            <a:off x="10127894" y="4315968"/>
+            <a:ext cx="1188720" cy="365760"/>
+          </a:xfrm>
+          <a:prstGeom prst="rect">
+            <a:avLst/>
+          </a:prstGeom>
+          <a:noFill/>
+          <a:ln/>
+        </p:spPr>
+        <p:txBody>
+          <a:bodyPr wrap="square" lIns="0" tIns="0" rIns="0" bIns="0" rtlCol="0" anchor="ctr"/>
+          <a:lstStyle/>
+          <a:p>
+            <a:pPr indent="0" marL="0">
+              <a:buNone/>
+            </a:pPr>
+            <a:r>
+              <a:rPr lang="en-US" sz="1400" b="1" dirty="0">
+                <a:solidFill>
+                  <a:srgbClr val="7F7F7F"/>
+                </a:solidFill>
+              </a:rPr>
+              <a:t>74% · 4.1k</a:t>
+            </a:r>
+            <a:endParaRPr lang="en-US" sz="1400" dirty="0"/>
+          </a:p>
+        </p:txBody>
+      </p:sp>
+      <p:sp>
+        <p:nvSpPr>
+          <p:cNvPr id="54" name="Text 52"/>
+          <p:cNvSpPr txBox="1"/>
+          <p:nvPr/>
+        </p:nvSpPr>
+        <p:spPr>
+          <a:xfrm>
+            <a:off x="6217920" y="4754880"/>
+            <a:ext cx="2103120" cy="365760"/>
+          </a:xfrm>
+          <a:prstGeom prst="rect">
+            <a:avLst/>
+          </a:prstGeom>
+          <a:noFill/>
+          <a:ln/>
+        </p:spPr>
+        <p:txBody>
+          <a:bodyPr wrap="square" lIns="0" tIns="0" rIns="0" bIns="0" rtlCol="0" anchor="ctr"/>
+          <a:lstStyle/>
+          <a:p>
+            <a:pPr algn="r" indent="0" marL="0">
+              <a:buNone/>
+            </a:pPr>
+            <a:r>
+              <a:rPr lang="en-US" sz="1400" dirty="0">
+                <a:solidFill>
+                  <a:schemeClr val="tx1"/>
+                </a:solidFill>
+              </a:rPr>
+              <a:t>our method</a:t>
+            </a:r>
+            <a:endParaRPr lang="en-US" sz="1400" dirty="0"/>
+          </a:p>
+        </p:txBody>
+      </p:sp>
+      <p:sp>
+        <p:nvSpPr>
+          <p:cNvPr id="55" name="All 624 problems, 3 models: % solved · tokens our method"/>
+          <p:cNvSpPr/>
+          <p:nvPr/>
+        </p:nvSpPr>
+        <p:spPr>
+          <a:xfrm>
+            <a:off x="8412480" y="4828032"/>
+            <a:ext cx="1909267" cy="237744"/>
+          </a:xfrm>
+          <a:prstGeom prst="rect">
+            <a:avLst/>
+          </a:prstGeom>
+          <a:solidFill>
+            <a:srgbClr val="4472C4"/>
+          </a:solidFill>
+          <a:ln w="6350">
+            <a:solidFill>
+              <a:srgbClr val="4472C4"/>
+            </a:solidFill>
+            <a:prstDash val="solid"/>
+          </a:ln>
+        </p:spPr>
+      </p:sp>
+      <p:sp>
+        <p:nvSpPr>
+          <p:cNvPr id="56" name="Text 54"/>
+          <p:cNvSpPr txBox="1"/>
+          <p:nvPr/>
+        </p:nvSpPr>
+        <p:spPr>
+          <a:xfrm>
+            <a:off x="10413187" y="4754880"/>
+            <a:ext cx="1188720" cy="365760"/>
+          </a:xfrm>
+          <a:prstGeom prst="rect">
+            <a:avLst/>
+          </a:prstGeom>
+          <a:noFill/>
+          <a:ln/>
+        </p:spPr>
+        <p:txBody>
+          <a:bodyPr wrap="square" lIns="0" tIns="0" rIns="0" bIns="0" rtlCol="0" anchor="ctr"/>
+          <a:lstStyle/>
+          <a:p>
+            <a:pPr indent="0" marL="0">
+              <a:buNone/>
+            </a:pPr>
+            <a:r>
+              <a:rPr lang="en-US" sz="1400" b="1" dirty="0">
+                <a:solidFill>
+                  <a:srgbClr val="4472C4"/>
+                </a:solidFill>
+              </a:rPr>
+              <a:t>87% · 2.5k</a:t>
+            </a:r>
+            <a:endParaRPr lang="en-US" sz="1400" dirty="0"/>
+          </a:p>
+        </p:txBody>
+      </p:sp>
+      <p:sp>
+        <p:nvSpPr>
+          <p:cNvPr id="57" name="Text 55"/>
+          <p:cNvSpPr txBox="1"/>
+          <p:nvPr/>
+        </p:nvSpPr>
+        <p:spPr>
+          <a:xfrm>
+            <a:off x="548640" y="5349240"/>
+            <a:ext cx="2834640" cy="411480"/>
+          </a:xfrm>
+          <a:prstGeom prst="rect">
+            <a:avLst/>
+          </a:prstGeom>
+          <a:noFill/>
+          <a:ln/>
+        </p:spPr>
+        <p:txBody>
+          <a:bodyPr wrap="square" lIns="0" tIns="0" rIns="0" bIns="0" rtlCol="0" anchor="ctr"/>
+          <a:lstStyle/>
+          <a:p>
+            <a:pPr indent="0" marL="0">
+              <a:buNone/>
+            </a:pPr>
+            <a:r>
+              <a:rPr lang="en-US" sz="1400" b="1" dirty="0">
+                <a:solidFill>
+                  <a:schemeClr val="tx1"/>
+                </a:solidFill>
+              </a:rPr>
+              <a:t>Free check, no answers needed:</a:t>
+            </a:r>
+            <a:endParaRPr lang="en-US" sz="1400" dirty="0"/>
+          </a:p>
+        </p:txBody>
+      </p:sp>
+      <p:sp>
+        <p:nvSpPr>
+          <p:cNvPr id="58" name="box "/>
+          <p:cNvSpPr/>
+          <p:nvPr/>
+        </p:nvSpPr>
+        <p:spPr>
+          <a:xfrm>
+            <a:off x="3383280" y="5330952"/>
+            <a:ext cx="1984248" cy="457200"/>
+          </a:xfrm>
+          <a:prstGeom prst="roundRect">
+            <a:avLst>
+              <a:gd name="adj" fmla="val 12000"/>
             </a:avLst>
           </a:prstGeom>
           <a:solidFill>
@@ -7392,24 +8279,101 @@
       </p:sp>
       <p:sp>
         <p:nvSpPr>
-          <p:cNvPr id="33" name="walk badge 5"/>
-          <p:cNvSpPr/>
-          <p:nvPr/>
-        </p:nvSpPr>
-        <p:spPr>
-          <a:xfrm>
-            <a:off x="10149840" y="1801368"/>
-            <a:ext cx="411480" cy="411480"/>
-          </a:xfrm>
-          <a:prstGeom prst="ellipse">
-            <a:avLst/>
+          <p:cNvPr id="59" name="Text 57"/>
+          <p:cNvSpPr txBox="1"/>
+          <p:nvPr/>
+        </p:nvSpPr>
+        <p:spPr>
+          <a:xfrm>
+            <a:off x="3456432" y="5330952"/>
+            <a:ext cx="1837944" cy="457200"/>
+          </a:xfrm>
+          <a:prstGeom prst="rect">
+            <a:avLst/>
+          </a:prstGeom>
+          <a:noFill/>
+          <a:ln/>
+        </p:spPr>
+        <p:txBody>
+          <a:bodyPr wrap="square" lIns="0" tIns="0" rIns="0" bIns="0" rtlCol="0" anchor="ctr"/>
+          <a:lstStyle/>
+          <a:p>
+            <a:pPr algn="ctr" indent="0" marL="0">
+              <a:buNone/>
+            </a:pPr>
+            <a:endParaRPr lang="en-US" sz="1500" dirty="0"/>
+          </a:p>
+        </p:txBody>
+      </p:sp>
+      <p:sp>
+        <p:nvSpPr>
+          <p:cNvPr id="60" name="Text 58"/>
+          <p:cNvSpPr txBox="1"/>
+          <p:nvPr/>
+        </p:nvSpPr>
+        <p:spPr>
+          <a:xfrm>
+            <a:off x="3429000" y="5330952"/>
+            <a:ext cx="1892808" cy="457200"/>
+          </a:xfrm>
+          <a:prstGeom prst="rect">
+            <a:avLst/>
+          </a:prstGeom>
+          <a:noFill/>
+          <a:ln/>
+        </p:spPr>
+        <p:txBody>
+          <a:bodyPr wrap="square" lIns="0" tIns="0" rIns="0" bIns="0" rtlCol="0" anchor="ctr"/>
+          <a:lstStyle/>
+          <a:p>
+            <a:pPr algn="ctr" indent="0" marL="0">
+              <a:buNone/>
+            </a:pPr>
+            <a:r>
+              <a:rPr lang="en-US" sz="1300" b="1" dirty="0">
+                <a:solidFill>
+                  <a:schemeClr val="tx1"/>
+                </a:solidFill>
+              </a:rPr>
+              <a:t>contest: </a:t>
+            </a:r>
+            <a:pPr algn="ctr" indent="0" marL="0">
+              <a:buNone/>
+            </a:pPr>
+            <a:r>
+              <a:rPr lang="en-US" sz="1300" dirty="0">
+                <a:solidFill>
+                  <a:schemeClr val="tx1"/>
+                </a:solidFill>
+              </a:rPr>
+              <a:t>sample tests pass</a:t>
+            </a:r>
+            <a:endParaRPr lang="en-US" sz="1300" dirty="0"/>
+          </a:p>
+        </p:txBody>
+      </p:sp>
+      <p:sp>
+        <p:nvSpPr>
+          <p:cNvPr id="61" name="box "/>
+          <p:cNvSpPr/>
+          <p:nvPr/>
+        </p:nvSpPr>
+        <p:spPr>
+          <a:xfrm>
+            <a:off x="5458968" y="5330952"/>
+            <a:ext cx="1984248" cy="457200"/>
+          </a:xfrm>
+          <a:prstGeom prst="roundRect">
+            <a:avLst>
+              <a:gd name="adj" fmla="val 12000"/>
+            </a:avLst>
           </a:prstGeom>
           <a:solidFill>
-            <a:srgbClr val="4472C4"/>
+            <a:srgbClr val="F2F2F2"/>
           </a:solidFill>
-          <a:ln w="12700">
+          <a:ln w="9525">
             <a:solidFill>
-              <a:srgbClr val="4472C4"/>
+              <a:srgbClr val="BFBFBF"/>
             </a:solidFill>
             <a:prstDash val="solid"/>
           </a:ln>
@@ -7417,14 +8381,14 @@
       </p:sp>
       <p:sp>
         <p:nvSpPr>
-          <p:cNvPr id="34" name="Text 32"/>
-          <p:cNvSpPr txBox="1"/>
-          <p:nvPr/>
-        </p:nvSpPr>
-        <p:spPr>
-          <a:xfrm>
-            <a:off x="10149840" y="1801368"/>
-            <a:ext cx="411480" cy="411480"/>
+          <p:cNvPr id="62" name="Text 60"/>
+          <p:cNvSpPr txBox="1"/>
+          <p:nvPr/>
+        </p:nvSpPr>
+        <p:spPr>
+          <a:xfrm>
+            <a:off x="5532120" y="5330952"/>
+            <a:ext cx="1837944" cy="457200"/>
           </a:xfrm>
           <a:prstGeom prst="rect">
             <a:avLst/>
@@ -7439,707 +8403,258 @@
             <a:pPr algn="ctr" indent="0" marL="0">
               <a:buNone/>
             </a:pPr>
-            <a:r>
-              <a:rPr lang="en-US" sz="1500" b="1" dirty="0">
-                <a:solidFill>
-                  <a:srgbClr val="FFFFFF"/>
-                </a:solidFill>
-              </a:rPr>
-              <a:t>5</a:t>
-            </a:r>
             <a:endParaRPr lang="en-US" sz="1500" dirty="0"/>
           </a:p>
         </p:txBody>
       </p:sp>
       <p:sp>
         <p:nvSpPr>
-          <p:cNvPr id="35" name="Text 33"/>
-          <p:cNvSpPr txBox="1"/>
-          <p:nvPr/>
-        </p:nvSpPr>
-        <p:spPr>
-          <a:xfrm>
-            <a:off x="10625328" y="1783080"/>
-            <a:ext cx="914400" cy="457200"/>
-          </a:xfrm>
-          <a:prstGeom prst="rect">
-            <a:avLst/>
-          </a:prstGeom>
-          <a:noFill/>
-          <a:ln/>
-        </p:spPr>
-        <p:txBody>
-          <a:bodyPr wrap="square" lIns="0" tIns="0" rIns="0" bIns="0" rtlCol="0" anchor="ctr"/>
-          <a:lstStyle/>
-          <a:p>
-            <a:pPr indent="0" marL="0">
-              <a:buNone/>
-            </a:pPr>
-            <a:r>
-              <a:rPr lang="en-US" sz="1500" b="1" dirty="0">
+          <p:cNvPr id="63" name="Text 61"/>
+          <p:cNvSpPr txBox="1"/>
+          <p:nvPr/>
+        </p:nvSpPr>
+        <p:spPr>
+          <a:xfrm>
+            <a:off x="5504688" y="5330952"/>
+            <a:ext cx="1892808" cy="457200"/>
+          </a:xfrm>
+          <a:prstGeom prst="rect">
+            <a:avLst/>
+          </a:prstGeom>
+          <a:noFill/>
+          <a:ln/>
+        </p:spPr>
+        <p:txBody>
+          <a:bodyPr wrap="square" lIns="0" tIns="0" rIns="0" bIns="0" rtlCol="0" anchor="ctr"/>
+          <a:lstStyle/>
+          <a:p>
+            <a:pPr algn="ctr" indent="0" marL="0">
+              <a:buNone/>
+            </a:pPr>
+            <a:r>
+              <a:rPr lang="en-US" sz="1300" b="1" dirty="0">
                 <a:solidFill>
                   <a:schemeClr val="tx1"/>
                 </a:solidFill>
               </a:rPr>
-              <a:t>Reuse</a:t>
-            </a:r>
+              <a:t>geometry: </a:t>
+            </a:r>
+            <a:pPr algn="ctr" indent="0" marL="0">
+              <a:buNone/>
+            </a:pPr>
+            <a:r>
+              <a:rPr lang="en-US" sz="1300" dirty="0">
+                <a:solidFill>
+                  <a:schemeClr val="tx1"/>
+                </a:solidFill>
+              </a:rPr>
+              <a:t>moved copies agree</a:t>
+            </a:r>
+            <a:endParaRPr lang="en-US" sz="1300" dirty="0"/>
+          </a:p>
+        </p:txBody>
+      </p:sp>
+      <p:sp>
+        <p:nvSpPr>
+          <p:cNvPr id="64" name="box "/>
+          <p:cNvSpPr/>
+          <p:nvPr/>
+        </p:nvSpPr>
+        <p:spPr>
+          <a:xfrm>
+            <a:off x="7534656" y="5330952"/>
+            <a:ext cx="1984248" cy="457200"/>
+          </a:xfrm>
+          <a:prstGeom prst="roundRect">
+            <a:avLst>
+              <a:gd name="adj" fmla="val 12000"/>
+            </a:avLst>
+          </a:prstGeom>
+          <a:solidFill>
+            <a:srgbClr val="F2F2F2"/>
+          </a:solidFill>
+          <a:ln w="9525">
+            <a:solidFill>
+              <a:srgbClr val="BFBFBF"/>
+            </a:solidFill>
+            <a:prstDash val="solid"/>
+          </a:ln>
+        </p:spPr>
+      </p:sp>
+      <p:sp>
+        <p:nvSpPr>
+          <p:cNvPr id="65" name="Text 63"/>
+          <p:cNvSpPr txBox="1"/>
+          <p:nvPr/>
+        </p:nvSpPr>
+        <p:spPr>
+          <a:xfrm>
+            <a:off x="7607808" y="5330952"/>
+            <a:ext cx="1837944" cy="457200"/>
+          </a:xfrm>
+          <a:prstGeom prst="rect">
+            <a:avLst/>
+          </a:prstGeom>
+          <a:noFill/>
+          <a:ln/>
+        </p:spPr>
+        <p:txBody>
+          <a:bodyPr wrap="square" lIns="0" tIns="0" rIns="0" bIns="0" rtlCol="0" anchor="ctr"/>
+          <a:lstStyle/>
+          <a:p>
+            <a:pPr algn="ctr" indent="0" marL="0">
+              <a:buNone/>
+            </a:pPr>
             <a:endParaRPr lang="en-US" sz="1500" dirty="0"/>
           </a:p>
         </p:txBody>
       </p:sp>
       <p:sp>
         <p:nvSpPr>
-          <p:cNvPr id="36" name="Text 34"/>
-          <p:cNvSpPr txBox="1"/>
-          <p:nvPr/>
-        </p:nvSpPr>
-        <p:spPr>
-          <a:xfrm>
-            <a:off x="10186416" y="2331720"/>
-            <a:ext cx="1298448" cy="1234440"/>
-          </a:xfrm>
-          <a:prstGeom prst="rect">
-            <a:avLst/>
-          </a:prstGeom>
-          <a:noFill/>
-          <a:ln/>
-        </p:spPr>
-        <p:txBody>
-          <a:bodyPr wrap="square" lIns="0" tIns="0" rIns="0" bIns="0" rtlCol="0" anchor="t"/>
-          <a:lstStyle/>
-          <a:p>
-            <a:pPr indent="0" marL="0">
-              <a:buNone/>
-            </a:pPr>
-            <a:r>
-              <a:rPr lang="en-US" sz="1350" dirty="0">
+          <p:cNvPr id="66" name="Text 64"/>
+          <p:cNvSpPr txBox="1"/>
+          <p:nvPr/>
+        </p:nvSpPr>
+        <p:spPr>
+          <a:xfrm>
+            <a:off x="7580376" y="5330952"/>
+            <a:ext cx="1892808" cy="457200"/>
+          </a:xfrm>
+          <a:prstGeom prst="rect">
+            <a:avLst/>
+          </a:prstGeom>
+          <a:noFill/>
+          <a:ln/>
+        </p:spPr>
+        <p:txBody>
+          <a:bodyPr wrap="square" lIns="0" tIns="0" rIns="0" bIns="0" rtlCol="0" anchor="ctr"/>
+          <a:lstStyle/>
+          <a:p>
+            <a:pPr algn="ctr" indent="0" marL="0">
+              <a:buNone/>
+            </a:pPr>
+            <a:r>
+              <a:rPr lang="en-US" sz="1300" b="1" dirty="0">
                 <a:solidFill>
                   <a:schemeClr val="tx1"/>
                 </a:solidFill>
               </a:rPr>
-              <a:t>same kind of problem with new data: run the checked program again</a:t>
-            </a:r>
-            <a:endParaRPr lang="en-US" sz="1350" dirty="0"/>
-          </a:p>
-        </p:txBody>
-      </p:sp>
-      <p:sp>
-        <p:nvSpPr>
-          <p:cNvPr id="37" name="Text 35"/>
-          <p:cNvSpPr txBox="1"/>
-          <p:nvPr/>
-        </p:nvSpPr>
-        <p:spPr>
-          <a:xfrm>
-            <a:off x="10058400" y="3675888"/>
-            <a:ext cx="1554480" cy="320040"/>
-          </a:xfrm>
-          <a:prstGeom prst="rect">
-            <a:avLst/>
-          </a:prstGeom>
-          <a:noFill/>
-          <a:ln/>
-        </p:spPr>
-        <p:txBody>
-          <a:bodyPr wrap="square" lIns="0" tIns="0" rIns="0" bIns="0" rtlCol="0" anchor="ctr"/>
-          <a:lstStyle/>
-          <a:p>
+              <a:t>routing: </a:t>
+            </a:r>
             <a:pPr algn="ctr" indent="0" marL="0">
               <a:buNone/>
             </a:pPr>
             <a:r>
-              <a:rPr lang="en-US" sz="1500" b="1" dirty="0">
-                <a:solidFill>
-                  <a:schemeClr val="tx2"/>
-                </a:solidFill>
-              </a:rPr>
-              <a:t>≈ 0 tokens</a:t>
-            </a:r>
+              <a:rPr lang="en-US" sz="1300" dirty="0">
+                <a:solidFill>
+                  <a:schemeClr val="tx1"/>
+                </a:solidFill>
+              </a:rPr>
+              <a:t>plan obeys rules</a:t>
+            </a:r>
+            <a:endParaRPr lang="en-US" sz="1300" dirty="0"/>
+          </a:p>
+        </p:txBody>
+      </p:sp>
+      <p:sp>
+        <p:nvSpPr>
+          <p:cNvPr id="67" name="box "/>
+          <p:cNvSpPr/>
+          <p:nvPr/>
+        </p:nvSpPr>
+        <p:spPr>
+          <a:xfrm>
+            <a:off x="9610344" y="5330952"/>
+            <a:ext cx="1984248" cy="457200"/>
+          </a:xfrm>
+          <a:prstGeom prst="roundRect">
+            <a:avLst>
+              <a:gd name="adj" fmla="val 12000"/>
+            </a:avLst>
+          </a:prstGeom>
+          <a:solidFill>
+            <a:srgbClr val="F2F2F2"/>
+          </a:solidFill>
+          <a:ln w="9525">
+            <a:solidFill>
+              <a:srgbClr val="BFBFBF"/>
+            </a:solidFill>
+            <a:prstDash val="solid"/>
+          </a:ln>
+        </p:spPr>
+      </p:sp>
+      <p:sp>
+        <p:nvSpPr>
+          <p:cNvPr id="68" name="Text 66"/>
+          <p:cNvSpPr txBox="1"/>
+          <p:nvPr/>
+        </p:nvSpPr>
+        <p:spPr>
+          <a:xfrm>
+            <a:off x="9683496" y="5330952"/>
+            <a:ext cx="1837944" cy="457200"/>
+          </a:xfrm>
+          <a:prstGeom prst="rect">
+            <a:avLst/>
+          </a:prstGeom>
+          <a:noFill/>
+          <a:ln/>
+        </p:spPr>
+        <p:txBody>
+          <a:bodyPr wrap="square" lIns="0" tIns="0" rIns="0" bIns="0" rtlCol="0" anchor="ctr"/>
+          <a:lstStyle/>
+          <a:p>
+            <a:pPr algn="ctr" indent="0" marL="0">
+              <a:buNone/>
+            </a:pPr>
             <a:endParaRPr lang="en-US" sz="1500" dirty="0"/>
           </a:p>
         </p:txBody>
       </p:sp>
       <p:sp>
         <p:nvSpPr>
-          <p:cNvPr id="38" name="Text 36"/>
-          <p:cNvSpPr txBox="1"/>
-          <p:nvPr/>
-        </p:nvSpPr>
-        <p:spPr>
-          <a:xfrm>
-            <a:off x="548640" y="4114800"/>
-            <a:ext cx="11064240" cy="365760"/>
-          </a:xfrm>
-          <a:prstGeom prst="rect">
-            <a:avLst/>
-          </a:prstGeom>
-          <a:noFill/>
-          <a:ln/>
-        </p:spPr>
-        <p:txBody>
-          <a:bodyPr wrap="square" lIns="0" tIns="0" rIns="0" bIns="0" rtlCol="0" anchor="ctr"/>
-          <a:lstStyle/>
-          <a:p>
-            <a:pPr indent="0" marL="0">
-              <a:buNone/>
-            </a:pPr>
-            <a:r>
-              <a:rPr lang="en-US" sz="1600" b="1" dirty="0">
+          <p:cNvPr id="69" name="Text 67"/>
+          <p:cNvSpPr txBox="1"/>
+          <p:nvPr/>
+        </p:nvSpPr>
+        <p:spPr>
+          <a:xfrm>
+            <a:off x="9656064" y="5330952"/>
+            <a:ext cx="1892808" cy="457200"/>
+          </a:xfrm>
+          <a:prstGeom prst="rect">
+            <a:avLst/>
+          </a:prstGeom>
+          <a:noFill/>
+          <a:ln/>
+        </p:spPr>
+        <p:txBody>
+          <a:bodyPr wrap="square" lIns="0" tIns="0" rIns="0" bIns="0" rtlCol="0" anchor="ctr"/>
+          <a:lstStyle/>
+          <a:p>
+            <a:pPr algn="ctr" indent="0" marL="0">
+              <a:buNone/>
+            </a:pPr>
+            <a:r>
+              <a:rPr lang="en-US" sz="1300" b="1" dirty="0">
                 <a:solidFill>
                   <a:schemeClr val="tx1"/>
                 </a:solidFill>
               </a:rPr>
-              <a:t>The free check depends on the kind of problem (no answers needed)</a:t>
-            </a:r>
-            <a:endParaRPr lang="en-US" sz="1600" dirty="0"/>
-          </a:p>
-        </p:txBody>
-      </p:sp>
-      <p:graphicFrame>
-        <p:nvGraphicFramePr>
-          <p:cNvPr id="14" name="Table 0"/>
-          <p:cNvGraphicFramePr>
-            <a:graphicFrameLocks noGrp="1"/>
-          </p:cNvGraphicFramePr>
-          <p:nvPr>
-            <p:extLst>
-              <p:ext uri="{D42A27DB-BD31-4B8C-83A1-F6EECF244321}">
-                <p14:modId xmlns:p14="http://schemas.microsoft.com/office/powerpoint/2010/main" val="1579011935"/>
-              </p:ext>
-            </p:extLst>
-          </p:nvPr>
-        </p:nvGraphicFramePr>
-        <p:xfrm>
-          <a:off x="548640" y="4498848"/>
-          <a:ext cx="11064240" cy="914400"/>
-        </p:xfrm>
-        <a:graphic>
-          <a:graphicData uri="http://schemas.openxmlformats.org/drawingml/2006/table">
-            <a:tbl>
-              <a:tblPr/>
-              <a:tblGrid>
-                <a:gridCol w="2743200"/>
-                <a:gridCol w="2834640"/>
-                <a:gridCol w="2743200"/>
-                <a:gridCol w="2743200"/>
-              </a:tblGrid>
-              <a:tr h="384048">
-                <a:tc>
-                  <a:txBody>
-                    <a:bodyPr/>
-                    <a:lstStyle/>
-                    <a:p>
-                      <a:pPr indent="0" marL="0">
-                        <a:buNone/>
-                      </a:pPr>
-                      <a:r>
-                        <a:rPr lang="en-US" sz="1400" b="1" dirty="0">
-                          <a:solidFill>
-                            <a:srgbClr val="FFFFFF"/>
-                          </a:solidFill>
-                        </a:rPr>
-                        <a:t>Contest problems</a:t>
-                      </a:r>
-                      <a:endParaRPr lang="en-US" sz="1400" dirty="0"/>
-                    </a:p>
-                  </a:txBody>
-                  <a:tcPr marL="54864" marR="54864" marT="54864" marB="54864" anchor="ctr">
-                    <a:lnL w="9525" cap="flat" cmpd="sng" algn="ctr">
-                      <a:solidFill>
-                        <a:srgbClr val="BFBFBF"/>
-                      </a:solidFill>
-                      <a:prstDash val="solid"/>
-                      <a:round/>
-                      <a:headEnd type="none" w="med" len="med"/>
-                      <a:tailEnd type="none" w="med" len="med"/>
-                    </a:lnL>
-                    <a:lnR w="9525" cap="flat" cmpd="sng" algn="ctr">
-                      <a:solidFill>
-                        <a:srgbClr val="BFBFBF"/>
-                      </a:solidFill>
-                      <a:prstDash val="solid"/>
-                      <a:round/>
-                      <a:headEnd type="none" w="med" len="med"/>
-                      <a:tailEnd type="none" w="med" len="med"/>
-                    </a:lnR>
-                    <a:lnT w="9525" cap="flat" cmpd="sng" algn="ctr">
-                      <a:solidFill>
-                        <a:srgbClr val="BFBFBF"/>
-                      </a:solidFill>
-                      <a:prstDash val="solid"/>
-                      <a:round/>
-                      <a:headEnd type="none" w="med" len="med"/>
-                      <a:tailEnd type="none" w="med" len="med"/>
-                    </a:lnT>
-                    <a:lnB w="9525" cap="flat" cmpd="sng" algn="ctr">
-                      <a:solidFill>
-                        <a:srgbClr val="BFBFBF"/>
-                      </a:solidFill>
-                      <a:prstDash val="solid"/>
-                      <a:round/>
-                      <a:headEnd type="none" w="med" len="med"/>
-                      <a:tailEnd type="none" w="med" len="med"/>
-                    </a:lnB>
-                    <a:solidFill>
-                      <a:srgbClr val="4472C4"/>
-                    </a:solidFill>
-                  </a:tcPr>
-                </a:tc>
-                <a:tc>
-                  <a:txBody>
-                    <a:bodyPr/>
-                    <a:lstStyle/>
-                    <a:p>
-                      <a:pPr indent="0" marL="0">
-                        <a:buNone/>
-                      </a:pPr>
-                      <a:r>
-                        <a:rPr lang="en-US" sz="1400" b="1" dirty="0">
-                          <a:solidFill>
-                            <a:srgbClr val="FFFFFF"/>
-                          </a:solidFill>
-                        </a:rPr>
-                        <a:t>Geometry</a:t>
-                      </a:r>
-                      <a:endParaRPr lang="en-US" sz="1400" dirty="0"/>
-                    </a:p>
-                  </a:txBody>
-                  <a:tcPr marL="54864" marR="54864" marT="54864" marB="54864" anchor="ctr">
-                    <a:lnL w="9525" cap="flat" cmpd="sng" algn="ctr">
-                      <a:solidFill>
-                        <a:srgbClr val="BFBFBF"/>
-                      </a:solidFill>
-                      <a:prstDash val="solid"/>
-                      <a:round/>
-                      <a:headEnd type="none" w="med" len="med"/>
-                      <a:tailEnd type="none" w="med" len="med"/>
-                    </a:lnL>
-                    <a:lnR w="9525" cap="flat" cmpd="sng" algn="ctr">
-                      <a:solidFill>
-                        <a:srgbClr val="BFBFBF"/>
-                      </a:solidFill>
-                      <a:prstDash val="solid"/>
-                      <a:round/>
-                      <a:headEnd type="none" w="med" len="med"/>
-                      <a:tailEnd type="none" w="med" len="med"/>
-                    </a:lnR>
-                    <a:lnT w="9525" cap="flat" cmpd="sng" algn="ctr">
-                      <a:solidFill>
-                        <a:srgbClr val="BFBFBF"/>
-                      </a:solidFill>
-                      <a:prstDash val="solid"/>
-                      <a:round/>
-                      <a:headEnd type="none" w="med" len="med"/>
-                      <a:tailEnd type="none" w="med" len="med"/>
-                    </a:lnT>
-                    <a:lnB w="9525" cap="flat" cmpd="sng" algn="ctr">
-                      <a:solidFill>
-                        <a:srgbClr val="BFBFBF"/>
-                      </a:solidFill>
-                      <a:prstDash val="solid"/>
-                      <a:round/>
-                      <a:headEnd type="none" w="med" len="med"/>
-                      <a:tailEnd type="none" w="med" len="med"/>
-                    </a:lnB>
-                    <a:solidFill>
-                      <a:srgbClr val="4472C4"/>
-                    </a:solidFill>
-                  </a:tcPr>
-                </a:tc>
-                <a:tc>
-                  <a:txBody>
-                    <a:bodyPr/>
-                    <a:lstStyle/>
-                    <a:p>
-                      <a:pPr indent="0" marL="0">
-                        <a:buNone/>
-                      </a:pPr>
-                      <a:r>
-                        <a:rPr lang="en-US" sz="1400" b="1" dirty="0">
-                          <a:solidFill>
-                            <a:srgbClr val="FFFFFF"/>
-                          </a:solidFill>
-                        </a:rPr>
-                        <a:t>Routing and scheduling</a:t>
-                      </a:r>
-                      <a:endParaRPr lang="en-US" sz="1400" dirty="0"/>
-                    </a:p>
-                  </a:txBody>
-                  <a:tcPr marL="54864" marR="54864" marT="54864" marB="54864" anchor="ctr">
-                    <a:lnL w="9525" cap="flat" cmpd="sng" algn="ctr">
-                      <a:solidFill>
-                        <a:srgbClr val="BFBFBF"/>
-                      </a:solidFill>
-                      <a:prstDash val="solid"/>
-                      <a:round/>
-                      <a:headEnd type="none" w="med" len="med"/>
-                      <a:tailEnd type="none" w="med" len="med"/>
-                    </a:lnL>
-                    <a:lnR w="9525" cap="flat" cmpd="sng" algn="ctr">
-                      <a:solidFill>
-                        <a:srgbClr val="BFBFBF"/>
-                      </a:solidFill>
-                      <a:prstDash val="solid"/>
-                      <a:round/>
-                      <a:headEnd type="none" w="med" len="med"/>
-                      <a:tailEnd type="none" w="med" len="med"/>
-                    </a:lnR>
-                    <a:lnT w="9525" cap="flat" cmpd="sng" algn="ctr">
-                      <a:solidFill>
-                        <a:srgbClr val="BFBFBF"/>
-                      </a:solidFill>
-                      <a:prstDash val="solid"/>
-                      <a:round/>
-                      <a:headEnd type="none" w="med" len="med"/>
-                      <a:tailEnd type="none" w="med" len="med"/>
-                    </a:lnT>
-                    <a:lnB w="9525" cap="flat" cmpd="sng" algn="ctr">
-                      <a:solidFill>
-                        <a:srgbClr val="BFBFBF"/>
-                      </a:solidFill>
-                      <a:prstDash val="solid"/>
-                      <a:round/>
-                      <a:headEnd type="none" w="med" len="med"/>
-                      <a:tailEnd type="none" w="med" len="med"/>
-                    </a:lnB>
-                    <a:solidFill>
-                      <a:srgbClr val="4472C4"/>
-                    </a:solidFill>
-                  </a:tcPr>
-                </a:tc>
-                <a:tc>
-                  <a:txBody>
-                    <a:bodyPr/>
-                    <a:lstStyle/>
-                    <a:p>
-                      <a:pPr indent="0" marL="0">
-                        <a:buNone/>
-                      </a:pPr>
-                      <a:r>
-                        <a:rPr lang="en-US" sz="1400" b="1" dirty="0">
-                          <a:solidFill>
-                            <a:srgbClr val="FFFFFF"/>
-                          </a:solidFill>
-                        </a:rPr>
-                        <a:t>Word problems and math</a:t>
-                      </a:r>
-                      <a:endParaRPr lang="en-US" sz="1400" dirty="0"/>
-                    </a:p>
-                  </a:txBody>
-                  <a:tcPr marL="54864" marR="54864" marT="54864" marB="54864" anchor="ctr">
-                    <a:lnL w="9525" cap="flat" cmpd="sng" algn="ctr">
-                      <a:solidFill>
-                        <a:srgbClr val="BFBFBF"/>
-                      </a:solidFill>
-                      <a:prstDash val="solid"/>
-                      <a:round/>
-                      <a:headEnd type="none" w="med" len="med"/>
-                      <a:tailEnd type="none" w="med" len="med"/>
-                    </a:lnL>
-                    <a:lnR w="9525" cap="flat" cmpd="sng" algn="ctr">
-                      <a:solidFill>
-                        <a:srgbClr val="BFBFBF"/>
-                      </a:solidFill>
-                      <a:prstDash val="solid"/>
-                      <a:round/>
-                      <a:headEnd type="none" w="med" len="med"/>
-                      <a:tailEnd type="none" w="med" len="med"/>
-                    </a:lnR>
-                    <a:lnT w="9525" cap="flat" cmpd="sng" algn="ctr">
-                      <a:solidFill>
-                        <a:srgbClr val="BFBFBF"/>
-                      </a:solidFill>
-                      <a:prstDash val="solid"/>
-                      <a:round/>
-                      <a:headEnd type="none" w="med" len="med"/>
-                      <a:tailEnd type="none" w="med" len="med"/>
-                    </a:lnT>
-                    <a:lnB w="9525" cap="flat" cmpd="sng" algn="ctr">
-                      <a:solidFill>
-                        <a:srgbClr val="BFBFBF"/>
-                      </a:solidFill>
-                      <a:prstDash val="solid"/>
-                      <a:round/>
-                      <a:headEnd type="none" w="med" len="med"/>
-                      <a:tailEnd type="none" w="med" len="med"/>
-                    </a:lnB>
-                    <a:solidFill>
-                      <a:srgbClr val="4472C4"/>
-                    </a:solidFill>
-                  </a:tcPr>
-                </a:tc>
-              </a:tr>
-              <a:tr h="777240">
-                <a:tc>
-                  <a:txBody>
-                    <a:bodyPr/>
-                    <a:lstStyle/>
-                    <a:p>
-                      <a:pPr indent="0" marL="0">
-                        <a:buNone/>
-                      </a:pPr>
-                      <a:r>
-                        <a:rPr lang="en-US" sz="1400" dirty="0">
-                          <a:solidFill>
-                            <a:schemeClr val="tx1"/>
-                          </a:solidFill>
-                        </a:rPr>
-                        <a:t>run the sample tests printed in the statement</a:t>
-                      </a:r>
-                      <a:endParaRPr lang="en-US" sz="1400" dirty="0"/>
-                    </a:p>
-                  </a:txBody>
-                  <a:tcPr marL="54864" marR="54864" marT="54864" marB="54864" anchor="ctr">
-                    <a:lnL w="9525" cap="flat" cmpd="sng" algn="ctr">
-                      <a:solidFill>
-                        <a:srgbClr val="BFBFBF"/>
-                      </a:solidFill>
-                      <a:prstDash val="solid"/>
-                      <a:round/>
-                      <a:headEnd type="none" w="med" len="med"/>
-                      <a:tailEnd type="none" w="med" len="med"/>
-                    </a:lnL>
-                    <a:lnR w="9525" cap="flat" cmpd="sng" algn="ctr">
-                      <a:solidFill>
-                        <a:srgbClr val="BFBFBF"/>
-                      </a:solidFill>
-                      <a:prstDash val="solid"/>
-                      <a:round/>
-                      <a:headEnd type="none" w="med" len="med"/>
-                      <a:tailEnd type="none" w="med" len="med"/>
-                    </a:lnR>
-                    <a:lnT w="9525" cap="flat" cmpd="sng" algn="ctr">
-                      <a:solidFill>
-                        <a:srgbClr val="BFBFBF"/>
-                      </a:solidFill>
-                      <a:prstDash val="solid"/>
-                      <a:round/>
-                      <a:headEnd type="none" w="med" len="med"/>
-                      <a:tailEnd type="none" w="med" len="med"/>
-                    </a:lnT>
-                    <a:lnB w="9525" cap="flat" cmpd="sng" algn="ctr">
-                      <a:solidFill>
-                        <a:srgbClr val="BFBFBF"/>
-                      </a:solidFill>
-                      <a:prstDash val="solid"/>
-                      <a:round/>
-                      <a:headEnd type="none" w="med" len="med"/>
-                      <a:tailEnd type="none" w="med" len="med"/>
-                    </a:lnB>
-                  </a:tcPr>
-                </a:tc>
-                <a:tc>
-                  <a:txBody>
-                    <a:bodyPr/>
-                    <a:lstStyle/>
-                    <a:p>
-                      <a:pPr indent="0" marL="0">
-                        <a:buNone/>
-                      </a:pPr>
-                      <a:r>
-                        <a:rPr lang="en-US" sz="1400" dirty="0">
-                          <a:solidFill>
-                            <a:schemeClr val="tx1"/>
-                          </a:solidFill>
-                        </a:rPr>
-                        <a:t>same answer on moved, turned and mirrored copies; or two versions agree</a:t>
-                      </a:r>
-                      <a:endParaRPr lang="en-US" sz="1400" dirty="0"/>
-                    </a:p>
-                  </a:txBody>
-                  <a:tcPr marL="54864" marR="54864" marT="54864" marB="54864" anchor="ctr">
-                    <a:lnL w="9525" cap="flat" cmpd="sng" algn="ctr">
-                      <a:solidFill>
-                        <a:srgbClr val="BFBFBF"/>
-                      </a:solidFill>
-                      <a:prstDash val="solid"/>
-                      <a:round/>
-                      <a:headEnd type="none" w="med" len="med"/>
-                      <a:tailEnd type="none" w="med" len="med"/>
-                    </a:lnL>
-                    <a:lnR w="9525" cap="flat" cmpd="sng" algn="ctr">
-                      <a:solidFill>
-                        <a:srgbClr val="BFBFBF"/>
-                      </a:solidFill>
-                      <a:prstDash val="solid"/>
-                      <a:round/>
-                      <a:headEnd type="none" w="med" len="med"/>
-                      <a:tailEnd type="none" w="med" len="med"/>
-                    </a:lnR>
-                    <a:lnT w="9525" cap="flat" cmpd="sng" algn="ctr">
-                      <a:solidFill>
-                        <a:srgbClr val="BFBFBF"/>
-                      </a:solidFill>
-                      <a:prstDash val="solid"/>
-                      <a:round/>
-                      <a:headEnd type="none" w="med" len="med"/>
-                      <a:tailEnd type="none" w="med" len="med"/>
-                    </a:lnT>
-                    <a:lnB w="9525" cap="flat" cmpd="sng" algn="ctr">
-                      <a:solidFill>
-                        <a:srgbClr val="BFBFBF"/>
-                      </a:solidFill>
-                      <a:prstDash val="solid"/>
-                      <a:round/>
-                      <a:headEnd type="none" w="med" len="med"/>
-                      <a:tailEnd type="none" w="med" len="med"/>
-                    </a:lnB>
-                  </a:tcPr>
-                </a:tc>
-                <a:tc>
-                  <a:txBody>
-                    <a:bodyPr/>
-                    <a:lstStyle/>
-                    <a:p>
-                      <a:pPr indent="0" marL="0">
-                        <a:buNone/>
-                      </a:pPr>
-                      <a:r>
-                        <a:rPr lang="en-US" sz="1400" dirty="0">
-                          <a:solidFill>
-                            <a:schemeClr val="tx1"/>
-                          </a:solidFill>
-                        </a:rPr>
-                        <a:t>the plan obeys every rule (capacity, time windows)</a:t>
-                      </a:r>
-                      <a:endParaRPr lang="en-US" sz="1400" dirty="0"/>
-                    </a:p>
-                  </a:txBody>
-                  <a:tcPr marL="54864" marR="54864" marT="54864" marB="54864" anchor="ctr">
-                    <a:lnL w="9525" cap="flat" cmpd="sng" algn="ctr">
-                      <a:solidFill>
-                        <a:srgbClr val="BFBFBF"/>
-                      </a:solidFill>
-                      <a:prstDash val="solid"/>
-                      <a:round/>
-                      <a:headEnd type="none" w="med" len="med"/>
-                      <a:tailEnd type="none" w="med" len="med"/>
-                    </a:lnL>
-                    <a:lnR w="9525" cap="flat" cmpd="sng" algn="ctr">
-                      <a:solidFill>
-                        <a:srgbClr val="BFBFBF"/>
-                      </a:solidFill>
-                      <a:prstDash val="solid"/>
-                      <a:round/>
-                      <a:headEnd type="none" w="med" len="med"/>
-                      <a:tailEnd type="none" w="med" len="med"/>
-                    </a:lnR>
-                    <a:lnT w="9525" cap="flat" cmpd="sng" algn="ctr">
-                      <a:solidFill>
-                        <a:srgbClr val="BFBFBF"/>
-                      </a:solidFill>
-                      <a:prstDash val="solid"/>
-                      <a:round/>
-                      <a:headEnd type="none" w="med" len="med"/>
-                      <a:tailEnd type="none" w="med" len="med"/>
-                    </a:lnT>
-                    <a:lnB w="9525" cap="flat" cmpd="sng" algn="ctr">
-                      <a:solidFill>
-                        <a:srgbClr val="BFBFBF"/>
-                      </a:solidFill>
-                      <a:prstDash val="solid"/>
-                      <a:round/>
-                      <a:headEnd type="none" w="med" len="med"/>
-                      <a:tailEnd type="none" w="med" len="med"/>
-                    </a:lnB>
-                  </a:tcPr>
-                </a:tc>
-                <a:tc>
-                  <a:txBody>
-                    <a:bodyPr/>
-                    <a:lstStyle/>
-                    <a:p>
-                      <a:pPr indent="0" marL="0">
-                        <a:buNone/>
-                      </a:pPr>
-                      <a:r>
-                        <a:rPr lang="en-US" sz="1400" dirty="0">
-                          <a:solidFill>
-                            <a:schemeClr val="tx1"/>
-                          </a:solidFill>
-                        </a:rPr>
-                        <a:t>the program runs and prints a value; two versions (or text and program) agree</a:t>
-                      </a:r>
-                      <a:endParaRPr lang="en-US" sz="1400" dirty="0"/>
-                    </a:p>
-                  </a:txBody>
-                  <a:tcPr marL="54864" marR="54864" marT="54864" marB="54864" anchor="ctr">
-                    <a:lnL w="9525" cap="flat" cmpd="sng" algn="ctr">
-                      <a:solidFill>
-                        <a:srgbClr val="BFBFBF"/>
-                      </a:solidFill>
-                      <a:prstDash val="solid"/>
-                      <a:round/>
-                      <a:headEnd type="none" w="med" len="med"/>
-                      <a:tailEnd type="none" w="med" len="med"/>
-                    </a:lnL>
-                    <a:lnR w="9525" cap="flat" cmpd="sng" algn="ctr">
-                      <a:solidFill>
-                        <a:srgbClr val="BFBFBF"/>
-                      </a:solidFill>
-                      <a:prstDash val="solid"/>
-                      <a:round/>
-                      <a:headEnd type="none" w="med" len="med"/>
-                      <a:tailEnd type="none" w="med" len="med"/>
-                    </a:lnR>
-                    <a:lnT w="9525" cap="flat" cmpd="sng" algn="ctr">
-                      <a:solidFill>
-                        <a:srgbClr val="BFBFBF"/>
-                      </a:solidFill>
-                      <a:prstDash val="solid"/>
-                      <a:round/>
-                      <a:headEnd type="none" w="med" len="med"/>
-                      <a:tailEnd type="none" w="med" len="med"/>
-                    </a:lnT>
-                    <a:lnB w="9525" cap="flat" cmpd="sng" algn="ctr">
-                      <a:solidFill>
-                        <a:srgbClr val="BFBFBF"/>
-                      </a:solidFill>
-                      <a:prstDash val="solid"/>
-                      <a:round/>
-                      <a:headEnd type="none" w="med" len="med"/>
-                      <a:tailEnd type="none" w="med" len="med"/>
-                    </a:lnB>
-                  </a:tcPr>
-                </a:tc>
-              </a:tr>
-            </a:tbl>
-          </a:graphicData>
-        </a:graphic>
-      </p:graphicFrame>
-      <p:sp>
-        <p:nvSpPr>
-          <p:cNvPr id="40" name="Text 37"/>
-          <p:cNvSpPr txBox="1"/>
-          <p:nvPr/>
-        </p:nvSpPr>
-        <p:spPr>
-          <a:xfrm>
-            <a:off x="548640" y="5669280"/>
-            <a:ext cx="11064240" cy="548640"/>
-          </a:xfrm>
-          <a:prstGeom prst="rect">
-            <a:avLst/>
-          </a:prstGeom>
-          <a:noFill/>
-          <a:ln/>
-        </p:spPr>
-        <p:txBody>
-          <a:bodyPr wrap="square" lIns="0" tIns="0" rIns="0" bIns="0" rtlCol="0" anchor="ctr"/>
-          <a:lstStyle/>
-          <a:p>
+              <a:t>word problems: </a:t>
+            </a:r>
             <a:pPr algn="ctr" indent="0" marL="0">
               <a:buNone/>
             </a:pPr>
             <a:r>
-              <a:rPr lang="en-US" sz="2000" dirty="0">
+              <a:rPr lang="en-US" sz="1300" dirty="0">
                 <a:solidFill>
                   <a:schemeClr val="tx1"/>
                 </a:solidFill>
               </a:rPr>
-              <a:t>Cheap steps first: this problem cost 0.6k tokens instead of 5.3k, and it is right</a:t>
-            </a:r>
-            <a:endParaRPr lang="en-US" sz="2000" dirty="0"/>
+              <a:t>two versions agree</a:t>
+            </a:r>
+            <a:endParaRPr lang="en-US" sz="1300" dirty="0"/>
           </a:p>
         </p:txBody>
       </p:sp>

</xml_diff>

<commit_message>
Related research and comparison: research map, same-harness specialist baseline, reported numbers
PROPOSAL / PROPOSAL_ko section 6: where this work sits (8 themes: closest work, what they do, what we
add), the same-harness comparison with the fine-tuned ORLM-8B on held-out MAMO added, numbers reported
in papers next to ours (MAMO specialists, Goedel-Prover-V2, AlphaGeometry), and what is new. Slides:
ORLM row on the comparison page, and two new pages (research map, reported numbers) in the full deck
and in the talk's extra pages.

Co-Authored-By: Claude Opus 5.5 (1M context) <noreply@anthropic.com>
</commit_message>
<xml_diff>
--- a/PROPOSAL_slides_full.pptx
+++ b/PROPOSAL_slides_full.pptx
@@ -21,9 +21,11 @@
     <p:sldId id="269" r:id="rId15"/>
     <p:sldId id="270" r:id="rId16"/>
     <p:sldId id="271" r:id="rId17"/>
+    <p:sldId id="272" r:id="rId18"/>
+    <p:sldId id="273" r:id="rId19"/>
   </p:sldIdLst>
   <p:notesMasterIdLst>
-    <p:notesMasterId r:id="rId18"/>
+    <p:notesMasterId r:id="rId20"/>
   </p:notesMasterIdLst>
   <p:sldSz cx="12192000" cy="6858000"/>
   <p:notesSz cx="6858000" cy="12192000"/>
@@ -122,14 +124,14 @@
   <p:extLst>
     <p:ext uri="{521415D9-36F7-43E2-AB2F-B90AF26B5E84}">
       <p14:sectionLst xmlns:p14="http://schemas.microsoft.com/office/powerpoint/2010/main">
-        <p14:section name="Problem" id="{0bdecb0b-d3b8-96c1-042c-70c0fe612fdb}">
+        <p14:section name="Problem" id="{207b7af8-0d45-fee9-54c1-6f536fee8b92}">
           <p14:sldIdLst>
             <p14:sldId id="256"/>
             <p14:sldId id="257"/>
             <p14:sldId id="258"/>
           </p14:sldIdLst>
         </p14:section>
-        <p14:section name="Findings" id="{267cb479-4171-bda6-6e4a-c3f0fbd5c6ec}">
+        <p14:section name="Findings" id="{af3ebc8c-8186-11e9-ef29-0ab697cb3026}">
           <p14:sldIdLst>
             <p14:sldId id="259"/>
             <p14:sldId id="260"/>
@@ -141,17 +143,19 @@
             <p14:sldId id="266"/>
           </p14:sldIdLst>
         </p14:section>
-        <p14:section name="Method" id="{e966aa3e-fadb-29aa-4859-8f9ffd0a7d0b}">
+        <p14:section name="Method" id="{5fe8f486-2449-bfe1-1691-a50957c0b2ef}">
           <p14:sldIdLst>
             <p14:sldId id="267"/>
             <p14:sldId id="268"/>
             <p14:sldId id="269"/>
             <p14:sldId id="270"/>
+            <p14:sldId id="271"/>
+            <p14:sldId id="272"/>
           </p14:sldIdLst>
         </p14:section>
-        <p14:section name="Next" id="{36cdafd7-d6ef-62b1-02da-f1fecc1734c8}">
+        <p14:section name="Next" id="{73034ec4-7a0a-0783-2d57-56f25331f5ab}">
           <p14:sldIdLst>
-            <p14:sldId id="271"/>
+            <p14:sldId id="273"/>
           </p14:sldIdLst>
         </p14:section>
       </p14:sectionLst>
@@ -1906,7 +1910,7 @@
           <a:p>
             <a:r>
               <a:rPr lang="en-US" dirty="0"/>
-              <a:t>All baselines were run by us on our benchmarks. Models: U1 policies over Qwen3-8B / Qwen3-32B / Qwen3.6 (624 problems); contest geometry gpt-oss-120b (311); selection Qwen3-8B (300 geometry instances, 3 candidates); documentation Qwen3-32B on CVRP; tools Qwen3-32B on 5 geometry tasks; daily routing gpt-oss-120b on 48 held-out Solomon instances. Tokens are output tokens per problem. More rows (MBR-exec, majority vote, DeepConf, Self-Debugging, Mixture-of-Thought cascade, BM25 retrieval) are in PROPOSAL.md section 7.</a:t>
+              <a:t>All baselines were run by us on our benchmarks. Models: U1 policies over Qwen3-8B / Qwen3-32B / Qwen3.6 (624 problems); contest geometry gpt-oss-120b (311); selection Qwen3-8B (300 geometry instances, 3 candidates); documentation Qwen3-32B on CVRP; tools Qwen3-32B on 5 geometry tasks; daily routing gpt-oss-120b on 48 held-out Solomon instances. Tokens are output tokens per problem. ORLM-LLaMA-3-8B was run in our harness on MAMO (863 held-out word problems; greedy 80.5 / 35.5% on Easy / Complex, as reported). More rows (MBR-exec, majority vote, DeepConf, Self-Debugging, Mixture-of-Thought cascade, BM25 retrieval) are in PROPOSAL.md section 6.</a:t>
             </a:r>
             <a:endParaRPr lang="en-US" dirty="0"/>
           </a:p>
@@ -1994,7 +1998,7 @@
           <a:p>
             <a:r>
               <a:rPr lang="en-US" dirty="0"/>
-              <a:t>Updated 2026-10-19. Done since the last version: contest geometry and competition math on 24 GB GPUs, Qwen3.6 with the model card settings (headline unchanged), automatic facts and the held-out MAMO test, the policy model, proofs. Older notes: for Lean proofs an invented lemma stands for a missing proof step (similar-name feedback fixes 2.7%, a fresh try 3.2%); for PopQA thinking adds 1.8-5 points at 70-200 times the tokens, only for well-known facts. Checks leak, which caps every policy. Facts were hand-written; BM25 retrieval recovers most of the gain. Next: SIZE-CC (gpt-oss-20b on contest geometry with check-gated escalation), X1-SIZE (competition math for Qwen3-4B/8B/14B), automatic facts, a closed API model, final report.</a:t>
+              <a:t>Closest work per theme (details and how we differ: PROPOSAL.md section 6.1 and docs/notes/RELATED_WORK.md). Closest overall: OptiSkill (2609.22987) builds a skill bank from a strong teacher's programs validated against answers and routes it by problem type; our facts are the same small model's own programs chosen by a label-free check, and we show why routing by problem type is needed (a fact from another type costs 14-21 points). For when-to-think, Thinkless and AdaptThink train a switch with RL; we decide with an execution check after giving the fact; a same-backbone comparison with AdaptThink-7B is running.</a:t>
             </a:r>
             <a:endParaRPr lang="en-US" dirty="0"/>
           </a:p>
@@ -2018,6 +2022,182 @@
             <a:fld id="{F7021451-1387-4CA6-816F-3879F97B5CBC}" type="slidenum">
               <a:rPr lang="en-US"/>
               <a:t>16</a:t>
+            </a:fld>
+            <a:endParaRPr lang="en-US"/>
+          </a:p>
+        </p:txBody>
+      </p:sp>
+    </p:spTree>
+    <p:extLst>
+      <p:ext uri="{BB962C8B-B14F-4D97-AF65-F5344CB8AC3E}">
+        <p14:creationId xmlns:p14="http://schemas.microsoft.com/office/powerpoint/2010/main" val="1024086991"/>
+      </p:ext>
+    </p:extLst>
+  </p:cSld>
+  <p:clrMapOvr>
+    <a:masterClrMapping/>
+  </p:clrMapOvr>
+</p:notes>
+</file>
+
+<file path=ppt/notesSlides/notesSlide17.xml><?xml version="1.0" encoding="utf-8"?>
+<p:notes xmlns:a="http://schemas.openxmlformats.org/drawingml/2006/main" xmlns:r="http://schemas.openxmlformats.org/officeDocument/2006/relationships" xmlns:p="http://schemas.openxmlformats.org/presentationml/2006/main">
+  <p:cSld>
+    <p:spTree>
+      <p:nvGrpSpPr>
+        <p:cNvPr id="1" name=""/>
+        <p:cNvGrpSpPr/>
+        <p:nvPr/>
+      </p:nvGrpSpPr>
+      <p:grpSpPr>
+        <a:xfrm>
+          <a:off x="0" y="0"/>
+          <a:ext cx="0" cy="0"/>
+          <a:chOff x="0" y="0"/>
+          <a:chExt cx="0" cy="0"/>
+        </a:xfrm>
+      </p:grpSpPr>
+      <p:sp>
+        <p:nvSpPr>
+          <p:cNvPr id="2" name="Slide Image Placeholder 1"/>
+          <p:cNvSpPr>
+            <a:spLocks noGrp="1" noRot="1" noChangeAspect="1"/>
+          </p:cNvSpPr>
+          <p:nvPr>
+            <p:ph type="sldImg"/>
+          </p:nvPr>
+        </p:nvSpPr>
+        <p:spPr/>
+      </p:sp>
+      <p:sp>
+        <p:nvSpPr>
+          <p:cNvPr id="3" name="Notes Placeholder 2"/>
+          <p:cNvSpPr>
+            <a:spLocks noGrp="1"/>
+          </p:cNvSpPr>
+          <p:nvPr>
+            <p:ph type="body" idx="1"/>
+          </p:nvPr>
+        </p:nvSpPr>
+        <p:spPr/>
+        <p:txBody>
+          <a:bodyPr/>
+          <a:lstStyle/>
+          <a:p>
+            <a:r>
+              <a:rPr lang="en-US" dirty="0"/>
+              <a:t>Numbers as reported by the papers or model cards; our harness, prompts and graders differ (MAMO labels are noisy; reported ORLM numbers range 81.6-88.2% on Easy). ORLM-8B rerun in our harness gives 80.5 / 35.5%, close to its report. STORM-Qwen3-4B is being run in our harness. Goedel-Prover-V2-8B: 187 of 244 with 32 tries in our Lean setup vs 84.6% on its card. AlphaGeometry's DD+AR engine proves 12 of IMO-AG-30 here (14 in the paper; one problem does not parse in this engine version).</a:t>
+            </a:r>
+            <a:endParaRPr lang="en-US" dirty="0"/>
+          </a:p>
+        </p:txBody>
+      </p:sp>
+      <p:sp>
+        <p:nvSpPr>
+          <p:cNvPr id="4" name="Slide Number Placeholder 3"/>
+          <p:cNvSpPr>
+            <a:spLocks noGrp="1"/>
+          </p:cNvSpPr>
+          <p:nvPr>
+            <p:ph type="sldNum" sz="quarter" idx="10"/>
+          </p:nvPr>
+        </p:nvSpPr>
+        <p:spPr/>
+        <p:txBody>
+          <a:bodyPr/>
+          <a:lstStyle/>
+          <a:p>
+            <a:fld id="{F7021451-1387-4CA6-816F-3879F97B5CBC}" type="slidenum">
+              <a:rPr lang="en-US"/>
+              <a:t>17</a:t>
+            </a:fld>
+            <a:endParaRPr lang="en-US"/>
+          </a:p>
+        </p:txBody>
+      </p:sp>
+    </p:spTree>
+    <p:extLst>
+      <p:ext uri="{BB962C8B-B14F-4D97-AF65-F5344CB8AC3E}">
+        <p14:creationId xmlns:p14="http://schemas.microsoft.com/office/powerpoint/2010/main" val="1024086991"/>
+      </p:ext>
+    </p:extLst>
+  </p:cSld>
+  <p:clrMapOvr>
+    <a:masterClrMapping/>
+  </p:clrMapOvr>
+</p:notes>
+</file>
+
+<file path=ppt/notesSlides/notesSlide18.xml><?xml version="1.0" encoding="utf-8"?>
+<p:notes xmlns:a="http://schemas.openxmlformats.org/drawingml/2006/main" xmlns:r="http://schemas.openxmlformats.org/officeDocument/2006/relationships" xmlns:p="http://schemas.openxmlformats.org/presentationml/2006/main">
+  <p:cSld>
+    <p:spTree>
+      <p:nvGrpSpPr>
+        <p:cNvPr id="1" name=""/>
+        <p:cNvGrpSpPr/>
+        <p:nvPr/>
+      </p:nvGrpSpPr>
+      <p:grpSpPr>
+        <a:xfrm>
+          <a:off x="0" y="0"/>
+          <a:ext cx="0" cy="0"/>
+          <a:chOff x="0" y="0"/>
+          <a:chExt cx="0" cy="0"/>
+        </a:xfrm>
+      </p:grpSpPr>
+      <p:sp>
+        <p:nvSpPr>
+          <p:cNvPr id="2" name="Slide Image Placeholder 1"/>
+          <p:cNvSpPr>
+            <a:spLocks noGrp="1" noRot="1" noChangeAspect="1"/>
+          </p:cNvSpPr>
+          <p:nvPr>
+            <p:ph type="sldImg"/>
+          </p:nvPr>
+        </p:nvSpPr>
+        <p:spPr/>
+      </p:sp>
+      <p:sp>
+        <p:nvSpPr>
+          <p:cNvPr id="3" name="Notes Placeholder 2"/>
+          <p:cNvSpPr>
+            <a:spLocks noGrp="1"/>
+          </p:cNvSpPr>
+          <p:nvPr>
+            <p:ph type="body" idx="1"/>
+          </p:nvPr>
+        </p:nvSpPr>
+        <p:spPr/>
+        <p:txBody>
+          <a:bodyPr/>
+          <a:lstStyle/>
+          <a:p>
+            <a:r>
+              <a:rPr lang="en-US" dirty="0"/>
+              <a:t>Updated 2026-10-19. Done since the last version: contest geometry and competition math on 24 GB GPUs, Qwen3.6 with the model card settings (headline unchanged), automatic facts and the held-out MAMO test, the policy model, proofs. Older notes: for Lean proofs an invented lemma stands for a missing proof step (similar-name feedback fixes 2.7%, a fresh try 3.2%); for PopQA thinking adds 1.8-5 points at 70-200 times the tokens, only for well-known facts. Checks leak, which caps every policy. Facts were hand-written; BM25 retrieval recovers most of the gain. Next: SIZE-CC (gpt-oss-20b on contest geometry with check-gated escalation), X1-SIZE (competition math for Qwen3-4B/8B/14B), automatic facts, a closed API model, final report.</a:t>
+            </a:r>
+            <a:endParaRPr lang="en-US" dirty="0"/>
+          </a:p>
+        </p:txBody>
+      </p:sp>
+      <p:sp>
+        <p:nvSpPr>
+          <p:cNvPr id="4" name="Slide Number Placeholder 3"/>
+          <p:cNvSpPr>
+            <a:spLocks noGrp="1"/>
+          </p:cNvSpPr>
+          <p:nvPr>
+            <p:ph type="sldNum" sz="quarter" idx="10"/>
+          </p:nvPr>
+        </p:nvSpPr>
+        <p:spPr/>
+        <p:txBody>
+          <a:bodyPr/>
+          <a:lstStyle/>
+          <a:p>
+            <a:fld id="{F7021451-1387-4CA6-816F-3879F97B5CBC}" type="slidenum">
+              <a:rPr lang="en-US"/>
+              <a:t>18</a:t>
             </a:fld>
             <a:endParaRPr lang="en-US"/>
           </a:p>
@@ -9946,7 +10126,7 @@
                 <a:gridCol w="2011680"/>
                 <a:gridCol w="3383280"/>
               </a:tblGrid>
-              <a:tr h="566928">
+              <a:tr h="521208">
                 <a:tc>
                   <a:txBody>
                     <a:bodyPr/>
@@ -10192,7 +10372,7 @@
                   </a:tcPr>
                 </a:tc>
               </a:tr>
-              <a:tr h="566928">
+              <a:tr h="521208">
                 <a:tc>
                   <a:txBody>
                     <a:bodyPr/>
@@ -10426,7 +10606,7 @@
                   </a:tcPr>
                 </a:tc>
               </a:tr>
-              <a:tr h="566928">
+              <a:tr h="521208">
                 <a:tc>
                   <a:txBody>
                     <a:bodyPr/>
@@ -10660,7 +10840,7 @@
                   </a:tcPr>
                 </a:tc>
               </a:tr>
-              <a:tr h="566928">
+              <a:tr h="521208">
                 <a:tc>
                   <a:txBody>
                     <a:bodyPr/>
@@ -10894,7 +11074,7 @@
                   </a:tcPr>
                 </a:tc>
               </a:tr>
-              <a:tr h="566928">
+              <a:tr h="521208">
                 <a:tc>
                   <a:txBody>
                     <a:bodyPr/>
@@ -11128,7 +11308,7 @@
                   </a:tcPr>
                 </a:tc>
               </a:tr>
-              <a:tr h="566928">
+              <a:tr h="521208">
                 <a:tc>
                   <a:txBody>
                     <a:bodyPr/>
@@ -11362,7 +11542,7 @@
                   </a:tcPr>
                 </a:tc>
               </a:tr>
-              <a:tr h="566928">
+              <a:tr h="521208">
                 <a:tc>
                   <a:txBody>
                     <a:bodyPr/>
@@ -11552,6 +11732,240 @@
                           </a:solidFill>
                         </a:rPr>
                         <a:t>reuse a checked program: 94%</a:t>
+                      </a:r>
+                      <a:endParaRPr lang="en-US" sz="1500" dirty="0"/>
+                    </a:p>
+                  </a:txBody>
+                  <a:tcPr marL="54864" marR="54864" marT="54864" marB="54864" anchor="ctr">
+                    <a:lnL w="9525" cap="flat" cmpd="sng" algn="ctr">
+                      <a:solidFill>
+                        <a:srgbClr val="BFBFBF"/>
+                      </a:solidFill>
+                      <a:prstDash val="solid"/>
+                      <a:round/>
+                      <a:headEnd type="none" w="med" len="med"/>
+                      <a:tailEnd type="none" w="med" len="med"/>
+                    </a:lnL>
+                    <a:lnR w="9525" cap="flat" cmpd="sng" algn="ctr">
+                      <a:solidFill>
+                        <a:srgbClr val="BFBFBF"/>
+                      </a:solidFill>
+                      <a:prstDash val="solid"/>
+                      <a:round/>
+                      <a:headEnd type="none" w="med" len="med"/>
+                      <a:tailEnd type="none" w="med" len="med"/>
+                    </a:lnR>
+                    <a:lnT w="9525" cap="flat" cmpd="sng" algn="ctr">
+                      <a:solidFill>
+                        <a:srgbClr val="BFBFBF"/>
+                      </a:solidFill>
+                      <a:prstDash val="solid"/>
+                      <a:round/>
+                      <a:headEnd type="none" w="med" len="med"/>
+                      <a:tailEnd type="none" w="med" len="med"/>
+                    </a:lnT>
+                    <a:lnB w="9525" cap="flat" cmpd="sng" algn="ctr">
+                      <a:solidFill>
+                        <a:srgbClr val="BFBFBF"/>
+                      </a:solidFill>
+                      <a:prstDash val="solid"/>
+                      <a:round/>
+                      <a:headEnd type="none" w="med" len="med"/>
+                      <a:tailEnd type="none" w="med" len="med"/>
+                    </a:lnB>
+                  </a:tcPr>
+                </a:tc>
+              </a:tr>
+              <a:tr h="521208">
+                <a:tc>
+                  <a:txBody>
+                    <a:bodyPr/>
+                    <a:lstStyle/>
+                    <a:p>
+                      <a:pPr indent="0" marL="0">
+                        <a:buNone/>
+                      </a:pPr>
+                      <a:r>
+                        <a:rPr lang="en-US" sz="1500" dirty="0">
+                          <a:solidFill>
+                            <a:schemeClr val="tx1"/>
+                          </a:solidFill>
+                        </a:rPr>
+                        <a:t>Word problems (held-out MAMO)</a:t>
+                      </a:r>
+                      <a:endParaRPr lang="en-US" sz="1500" dirty="0"/>
+                    </a:p>
+                  </a:txBody>
+                  <a:tcPr marL="54864" marR="54864" marT="54864" marB="54864" anchor="ctr">
+                    <a:lnL w="9525" cap="flat" cmpd="sng" algn="ctr">
+                      <a:solidFill>
+                        <a:srgbClr val="BFBFBF"/>
+                      </a:solidFill>
+                      <a:prstDash val="solid"/>
+                      <a:round/>
+                      <a:headEnd type="none" w="med" len="med"/>
+                      <a:tailEnd type="none" w="med" len="med"/>
+                    </a:lnL>
+                    <a:lnR w="9525" cap="flat" cmpd="sng" algn="ctr">
+                      <a:solidFill>
+                        <a:srgbClr val="BFBFBF"/>
+                      </a:solidFill>
+                      <a:prstDash val="solid"/>
+                      <a:round/>
+                      <a:headEnd type="none" w="med" len="med"/>
+                      <a:tailEnd type="none" w="med" len="med"/>
+                    </a:lnR>
+                    <a:lnT w="9525" cap="flat" cmpd="sng" algn="ctr">
+                      <a:solidFill>
+                        <a:srgbClr val="BFBFBF"/>
+                      </a:solidFill>
+                      <a:prstDash val="solid"/>
+                      <a:round/>
+                      <a:headEnd type="none" w="med" len="med"/>
+                      <a:tailEnd type="none" w="med" len="med"/>
+                    </a:lnT>
+                    <a:lnB w="9525" cap="flat" cmpd="sng" algn="ctr">
+                      <a:solidFill>
+                        <a:srgbClr val="BFBFBF"/>
+                      </a:solidFill>
+                      <a:prstDash val="solid"/>
+                      <a:round/>
+                      <a:headEnd type="none" w="med" len="med"/>
+                      <a:tailEnd type="none" w="med" len="med"/>
+                    </a:lnB>
+                  </a:tcPr>
+                </a:tc>
+                <a:tc>
+                  <a:txBody>
+                    <a:bodyPr/>
+                    <a:lstStyle/>
+                    <a:p>
+                      <a:pPr indent="0" marL="0">
+                        <a:buNone/>
+                      </a:pPr>
+                      <a:r>
+                        <a:rPr lang="en-US" sz="1500" dirty="0">
+                          <a:solidFill>
+                            <a:schemeClr val="tx1"/>
+                          </a:solidFill>
+                        </a:rPr>
+                        <a:t>ORLM-8B: a fine-tuned modeling specialist</a:t>
+                      </a:r>
+                      <a:endParaRPr lang="en-US" sz="1500" dirty="0"/>
+                    </a:p>
+                  </a:txBody>
+                  <a:tcPr marL="54864" marR="54864" marT="54864" marB="54864" anchor="ctr">
+                    <a:lnL w="9525" cap="flat" cmpd="sng" algn="ctr">
+                      <a:solidFill>
+                        <a:srgbClr val="BFBFBF"/>
+                      </a:solidFill>
+                      <a:prstDash val="solid"/>
+                      <a:round/>
+                      <a:headEnd type="none" w="med" len="med"/>
+                      <a:tailEnd type="none" w="med" len="med"/>
+                    </a:lnL>
+                    <a:lnR w="9525" cap="flat" cmpd="sng" algn="ctr">
+                      <a:solidFill>
+                        <a:srgbClr val="BFBFBF"/>
+                      </a:solidFill>
+                      <a:prstDash val="solid"/>
+                      <a:round/>
+                      <a:headEnd type="none" w="med" len="med"/>
+                      <a:tailEnd type="none" w="med" len="med"/>
+                    </a:lnR>
+                    <a:lnT w="9525" cap="flat" cmpd="sng" algn="ctr">
+                      <a:solidFill>
+                        <a:srgbClr val="BFBFBF"/>
+                      </a:solidFill>
+                      <a:prstDash val="solid"/>
+                      <a:round/>
+                      <a:headEnd type="none" w="med" len="med"/>
+                      <a:tailEnd type="none" w="med" len="med"/>
+                    </a:lnT>
+                    <a:lnB w="9525" cap="flat" cmpd="sng" algn="ctr">
+                      <a:solidFill>
+                        <a:srgbClr val="BFBFBF"/>
+                      </a:solidFill>
+                      <a:prstDash val="solid"/>
+                      <a:round/>
+                      <a:headEnd type="none" w="med" len="med"/>
+                      <a:tailEnd type="none" w="med" len="med"/>
+                    </a:lnB>
+                  </a:tcPr>
+                </a:tc>
+                <a:tc>
+                  <a:txBody>
+                    <a:bodyPr/>
+                    <a:lstStyle/>
+                    <a:p>
+                      <a:pPr indent="0" marL="0">
+                        <a:buNone/>
+                      </a:pPr>
+                      <a:r>
+                        <a:rPr lang="en-US" sz="1500" dirty="0">
+                          <a:solidFill>
+                            <a:schemeClr val="tx1"/>
+                          </a:solidFill>
+                        </a:rPr>
+                        <a:t>69.5% · 1.1k</a:t>
+                      </a:r>
+                      <a:endParaRPr lang="en-US" sz="1500" dirty="0"/>
+                    </a:p>
+                  </a:txBody>
+                  <a:tcPr marL="54864" marR="54864" marT="54864" marB="54864" anchor="ctr">
+                    <a:lnL w="9525" cap="flat" cmpd="sng" algn="ctr">
+                      <a:solidFill>
+                        <a:srgbClr val="BFBFBF"/>
+                      </a:solidFill>
+                      <a:prstDash val="solid"/>
+                      <a:round/>
+                      <a:headEnd type="none" w="med" len="med"/>
+                      <a:tailEnd type="none" w="med" len="med"/>
+                    </a:lnL>
+                    <a:lnR w="9525" cap="flat" cmpd="sng" algn="ctr">
+                      <a:solidFill>
+                        <a:srgbClr val="BFBFBF"/>
+                      </a:solidFill>
+                      <a:prstDash val="solid"/>
+                      <a:round/>
+                      <a:headEnd type="none" w="med" len="med"/>
+                      <a:tailEnd type="none" w="med" len="med"/>
+                    </a:lnR>
+                    <a:lnT w="9525" cap="flat" cmpd="sng" algn="ctr">
+                      <a:solidFill>
+                        <a:srgbClr val="BFBFBF"/>
+                      </a:solidFill>
+                      <a:prstDash val="solid"/>
+                      <a:round/>
+                      <a:headEnd type="none" w="med" len="med"/>
+                      <a:tailEnd type="none" w="med" len="med"/>
+                    </a:lnT>
+                    <a:lnB w="9525" cap="flat" cmpd="sng" algn="ctr">
+                      <a:solidFill>
+                        <a:srgbClr val="BFBFBF"/>
+                      </a:solidFill>
+                      <a:prstDash val="solid"/>
+                      <a:round/>
+                      <a:headEnd type="none" w="med" len="med"/>
+                      <a:tailEnd type="none" w="med" len="med"/>
+                    </a:lnB>
+                  </a:tcPr>
+                </a:tc>
+                <a:tc>
+                  <a:txBody>
+                    <a:bodyPr/>
+                    <a:lstStyle/>
+                    <a:p>
+                      <a:pPr indent="0" marL="0">
+                        <a:buNone/>
+                      </a:pPr>
+                      <a:r>
+                        <a:rPr lang="en-US" sz="1500" b="1" dirty="0">
+                          <a:solidFill>
+                            <a:srgbClr val="38761D"/>
+                          </a:solidFill>
+                        </a:rPr>
+                        <a:t>Qwen3-8B, no training: 69.5% · 1.0k; gpt-oss-20b 78.8%</a:t>
                       </a:r>
                       <a:endParaRPr lang="en-US" sz="1500" dirty="0"/>
                     </a:p>
@@ -11738,6 +12152,2668 @@
                   <a:schemeClr val="tx1"/>
                 </a:solidFill>
               </a:rPr>
+              <a:t>Where this work sits in related research</a:t>
+            </a:r>
+            <a:endParaRPr lang="en-US" sz="3600" dirty="0"/>
+          </a:p>
+        </p:txBody>
+      </p:sp>
+      <p:graphicFrame>
+        <p:nvGraphicFramePr>
+          <p:cNvPr id="17" name="Table 0"/>
+          <p:cNvGraphicFramePr>
+            <a:graphicFrameLocks noGrp="1"/>
+          </p:cNvGraphicFramePr>
+          <p:nvPr>
+            <p:extLst>
+              <p:ext uri="{D42A27DB-BD31-4B8C-83A1-F6EECF244321}">
+                <p14:modId xmlns:p14="http://schemas.microsoft.com/office/powerpoint/2010/main" val="1579011935"/>
+              </p:ext>
+            </p:extLst>
+          </p:nvPr>
+        </p:nvGraphicFramePr>
+        <p:xfrm>
+          <a:off x="548640" y="1234440"/>
+          <a:ext cx="11064240" cy="914400"/>
+        </p:xfrm>
+        <a:graphic>
+          <a:graphicData uri="http://schemas.openxmlformats.org/drawingml/2006/table">
+            <a:tbl>
+              <a:tblPr/>
+              <a:tblGrid>
+                <a:gridCol w="2377440"/>
+                <a:gridCol w="4480560"/>
+                <a:gridCol w="4206240"/>
+              </a:tblGrid>
+              <a:tr h="521208">
+                <a:tc>
+                  <a:txBody>
+                    <a:bodyPr/>
+                    <a:lstStyle/>
+                    <a:p>
+                      <a:pPr indent="0" marL="0">
+                        <a:buNone/>
+                      </a:pPr>
+                      <a:r>
+                        <a:rPr lang="en-US" sz="1300" b="1" dirty="0">
+                          <a:solidFill>
+                            <a:srgbClr val="FFFFFF"/>
+                          </a:solidFill>
+                        </a:rPr>
+                        <a:t>Theme</a:t>
+                      </a:r>
+                      <a:endParaRPr lang="en-US" sz="1300" dirty="0"/>
+                    </a:p>
+                  </a:txBody>
+                  <a:tcPr marL="54864" marR="54864" marT="54864" marB="54864" anchor="ctr">
+                    <a:lnL w="9525" cap="flat" cmpd="sng" algn="ctr">
+                      <a:solidFill>
+                        <a:srgbClr val="BFBFBF"/>
+                      </a:solidFill>
+                      <a:prstDash val="solid"/>
+                      <a:round/>
+                      <a:headEnd type="none" w="med" len="med"/>
+                      <a:tailEnd type="none" w="med" len="med"/>
+                    </a:lnL>
+                    <a:lnR w="9525" cap="flat" cmpd="sng" algn="ctr">
+                      <a:solidFill>
+                        <a:srgbClr val="BFBFBF"/>
+                      </a:solidFill>
+                      <a:prstDash val="solid"/>
+                      <a:round/>
+                      <a:headEnd type="none" w="med" len="med"/>
+                      <a:tailEnd type="none" w="med" len="med"/>
+                    </a:lnR>
+                    <a:lnT w="9525" cap="flat" cmpd="sng" algn="ctr">
+                      <a:solidFill>
+                        <a:srgbClr val="BFBFBF"/>
+                      </a:solidFill>
+                      <a:prstDash val="solid"/>
+                      <a:round/>
+                      <a:headEnd type="none" w="med" len="med"/>
+                      <a:tailEnd type="none" w="med" len="med"/>
+                    </a:lnT>
+                    <a:lnB w="9525" cap="flat" cmpd="sng" algn="ctr">
+                      <a:solidFill>
+                        <a:srgbClr val="BFBFBF"/>
+                      </a:solidFill>
+                      <a:prstDash val="solid"/>
+                      <a:round/>
+                      <a:headEnd type="none" w="med" len="med"/>
+                      <a:tailEnd type="none" w="med" len="med"/>
+                    </a:lnB>
+                    <a:solidFill>
+                      <a:srgbClr val="4472C4"/>
+                    </a:solidFill>
+                  </a:tcPr>
+                </a:tc>
+                <a:tc>
+                  <a:txBody>
+                    <a:bodyPr/>
+                    <a:lstStyle/>
+                    <a:p>
+                      <a:pPr indent="0" marL="0">
+                        <a:buNone/>
+                      </a:pPr>
+                      <a:r>
+                        <a:rPr lang="en-US" sz="1300" b="1" dirty="0">
+                          <a:solidFill>
+                            <a:srgbClr val="FFFFFF"/>
+                          </a:solidFill>
+                        </a:rPr>
+                        <a:t>Closest work</a:t>
+                      </a:r>
+                      <a:endParaRPr lang="en-US" sz="1300" dirty="0"/>
+                    </a:p>
+                  </a:txBody>
+                  <a:tcPr marL="54864" marR="54864" marT="54864" marB="54864" anchor="ctr">
+                    <a:lnL w="9525" cap="flat" cmpd="sng" algn="ctr">
+                      <a:solidFill>
+                        <a:srgbClr val="BFBFBF"/>
+                      </a:solidFill>
+                      <a:prstDash val="solid"/>
+                      <a:round/>
+                      <a:headEnd type="none" w="med" len="med"/>
+                      <a:tailEnd type="none" w="med" len="med"/>
+                    </a:lnL>
+                    <a:lnR w="9525" cap="flat" cmpd="sng" algn="ctr">
+                      <a:solidFill>
+                        <a:srgbClr val="BFBFBF"/>
+                      </a:solidFill>
+                      <a:prstDash val="solid"/>
+                      <a:round/>
+                      <a:headEnd type="none" w="med" len="med"/>
+                      <a:tailEnd type="none" w="med" len="med"/>
+                    </a:lnR>
+                    <a:lnT w="9525" cap="flat" cmpd="sng" algn="ctr">
+                      <a:solidFill>
+                        <a:srgbClr val="BFBFBF"/>
+                      </a:solidFill>
+                      <a:prstDash val="solid"/>
+                      <a:round/>
+                      <a:headEnd type="none" w="med" len="med"/>
+                      <a:tailEnd type="none" w="med" len="med"/>
+                    </a:lnT>
+                    <a:lnB w="9525" cap="flat" cmpd="sng" algn="ctr">
+                      <a:solidFill>
+                        <a:srgbClr val="BFBFBF"/>
+                      </a:solidFill>
+                      <a:prstDash val="solid"/>
+                      <a:round/>
+                      <a:headEnd type="none" w="med" len="med"/>
+                      <a:tailEnd type="none" w="med" len="med"/>
+                    </a:lnB>
+                    <a:solidFill>
+                      <a:srgbClr val="4472C4"/>
+                    </a:solidFill>
+                  </a:tcPr>
+                </a:tc>
+                <a:tc>
+                  <a:txBody>
+                    <a:bodyPr/>
+                    <a:lstStyle/>
+                    <a:p>
+                      <a:pPr indent="0" marL="0">
+                        <a:buNone/>
+                      </a:pPr>
+                      <a:r>
+                        <a:rPr lang="en-US" sz="1300" b="1" dirty="0">
+                          <a:solidFill>
+                            <a:srgbClr val="FFFFFF"/>
+                          </a:solidFill>
+                        </a:rPr>
+                        <a:t>What we add</a:t>
+                      </a:r>
+                      <a:endParaRPr lang="en-US" sz="1300" dirty="0"/>
+                    </a:p>
+                  </a:txBody>
+                  <a:tcPr marL="54864" marR="54864" marT="54864" marB="54864" anchor="ctr">
+                    <a:lnL w="9525" cap="flat" cmpd="sng" algn="ctr">
+                      <a:solidFill>
+                        <a:srgbClr val="BFBFBF"/>
+                      </a:solidFill>
+                      <a:prstDash val="solid"/>
+                      <a:round/>
+                      <a:headEnd type="none" w="med" len="med"/>
+                      <a:tailEnd type="none" w="med" len="med"/>
+                    </a:lnL>
+                    <a:lnR w="9525" cap="flat" cmpd="sng" algn="ctr">
+                      <a:solidFill>
+                        <a:srgbClr val="BFBFBF"/>
+                      </a:solidFill>
+                      <a:prstDash val="solid"/>
+                      <a:round/>
+                      <a:headEnd type="none" w="med" len="med"/>
+                      <a:tailEnd type="none" w="med" len="med"/>
+                    </a:lnR>
+                    <a:lnT w="9525" cap="flat" cmpd="sng" algn="ctr">
+                      <a:solidFill>
+                        <a:srgbClr val="BFBFBF"/>
+                      </a:solidFill>
+                      <a:prstDash val="solid"/>
+                      <a:round/>
+                      <a:headEnd type="none" w="med" len="med"/>
+                      <a:tailEnd type="none" w="med" len="med"/>
+                    </a:lnT>
+                    <a:lnB w="9525" cap="flat" cmpd="sng" algn="ctr">
+                      <a:solidFill>
+                        <a:srgbClr val="BFBFBF"/>
+                      </a:solidFill>
+                      <a:prstDash val="solid"/>
+                      <a:round/>
+                      <a:headEnd type="none" w="med" len="med"/>
+                      <a:tailEnd type="none" w="med" len="med"/>
+                    </a:lnB>
+                    <a:solidFill>
+                      <a:srgbClr val="4472C4"/>
+                    </a:solidFill>
+                  </a:tcPr>
+                </a:tc>
+              </a:tr>
+              <a:tr h="521208">
+                <a:tc>
+                  <a:txBody>
+                    <a:bodyPr/>
+                    <a:lstStyle/>
+                    <a:p>
+                      <a:pPr indent="0" marL="0">
+                        <a:buNone/>
+                      </a:pPr>
+                      <a:r>
+                        <a:rPr lang="en-US" sz="1300" dirty="0">
+                          <a:solidFill>
+                            <a:schemeClr val="tx1"/>
+                          </a:solidFill>
+                        </a:rPr>
+                        <a:t>Programs instead of text</a:t>
+                      </a:r>
+                      <a:endParaRPr lang="en-US" sz="1300" dirty="0"/>
+                    </a:p>
+                  </a:txBody>
+                  <a:tcPr marL="54864" marR="54864" marT="54864" marB="54864" anchor="ctr">
+                    <a:lnL w="9525" cap="flat" cmpd="sng" algn="ctr">
+                      <a:solidFill>
+                        <a:srgbClr val="BFBFBF"/>
+                      </a:solidFill>
+                      <a:prstDash val="solid"/>
+                      <a:round/>
+                      <a:headEnd type="none" w="med" len="med"/>
+                      <a:tailEnd type="none" w="med" len="med"/>
+                    </a:lnL>
+                    <a:lnR w="9525" cap="flat" cmpd="sng" algn="ctr">
+                      <a:solidFill>
+                        <a:srgbClr val="BFBFBF"/>
+                      </a:solidFill>
+                      <a:prstDash val="solid"/>
+                      <a:round/>
+                      <a:headEnd type="none" w="med" len="med"/>
+                      <a:tailEnd type="none" w="med" len="med"/>
+                    </a:lnR>
+                    <a:lnT w="9525" cap="flat" cmpd="sng" algn="ctr">
+                      <a:solidFill>
+                        <a:srgbClr val="BFBFBF"/>
+                      </a:solidFill>
+                      <a:prstDash val="solid"/>
+                      <a:round/>
+                      <a:headEnd type="none" w="med" len="med"/>
+                      <a:tailEnd type="none" w="med" len="med"/>
+                    </a:lnT>
+                    <a:lnB w="9525" cap="flat" cmpd="sng" algn="ctr">
+                      <a:solidFill>
+                        <a:srgbClr val="BFBFBF"/>
+                      </a:solidFill>
+                      <a:prstDash val="solid"/>
+                      <a:round/>
+                      <a:headEnd type="none" w="med" len="med"/>
+                      <a:tailEnd type="none" w="med" len="med"/>
+                    </a:lnB>
+                  </a:tcPr>
+                </a:tc>
+                <a:tc>
+                  <a:txBody>
+                    <a:bodyPr/>
+                    <a:lstStyle/>
+                    <a:p>
+                      <a:pPr indent="0" marL="0">
+                        <a:buNone/>
+                      </a:pPr>
+                      <a:r>
+                        <a:rPr lang="en-US" sz="1300" dirty="0">
+                          <a:solidFill>
+                            <a:schemeClr val="tx1"/>
+                          </a:solidFill>
+                        </a:rPr>
+                        <a:t>PAL, Program-of-Thoughts, Mixture-of-Thought (ICLR 2024)</a:t>
+                      </a:r>
+                      <a:endParaRPr lang="en-US" sz="1300" dirty="0"/>
+                    </a:p>
+                  </a:txBody>
+                  <a:tcPr marL="54864" marR="54864" marT="54864" marB="54864" anchor="ctr">
+                    <a:lnL w="9525" cap="flat" cmpd="sng" algn="ctr">
+                      <a:solidFill>
+                        <a:srgbClr val="BFBFBF"/>
+                      </a:solidFill>
+                      <a:prstDash val="solid"/>
+                      <a:round/>
+                      <a:headEnd type="none" w="med" len="med"/>
+                      <a:tailEnd type="none" w="med" len="med"/>
+                    </a:lnL>
+                    <a:lnR w="9525" cap="flat" cmpd="sng" algn="ctr">
+                      <a:solidFill>
+                        <a:srgbClr val="BFBFBF"/>
+                      </a:solidFill>
+                      <a:prstDash val="solid"/>
+                      <a:round/>
+                      <a:headEnd type="none" w="med" len="med"/>
+                      <a:tailEnd type="none" w="med" len="med"/>
+                    </a:lnR>
+                    <a:lnT w="9525" cap="flat" cmpd="sng" algn="ctr">
+                      <a:solidFill>
+                        <a:srgbClr val="BFBFBF"/>
+                      </a:solidFill>
+                      <a:prstDash val="solid"/>
+                      <a:round/>
+                      <a:headEnd type="none" w="med" len="med"/>
+                      <a:tailEnd type="none" w="med" len="med"/>
+                    </a:lnT>
+                    <a:lnB w="9525" cap="flat" cmpd="sng" algn="ctr">
+                      <a:solidFill>
+                        <a:srgbClr val="BFBFBF"/>
+                      </a:solidFill>
+                      <a:prstDash val="solid"/>
+                      <a:round/>
+                      <a:headEnd type="none" w="med" len="med"/>
+                      <a:tailEnd type="none" w="med" len="med"/>
+                    </a:lnB>
+                  </a:tcPr>
+                </a:tc>
+                <a:tc>
+                  <a:txBody>
+                    <a:bodyPr/>
+                    <a:lstStyle/>
+                    <a:p>
+                      <a:pPr indent="0" marL="0">
+                        <a:buNone/>
+                      </a:pPr>
+                      <a:r>
+                        <a:rPr lang="en-US" sz="1300" dirty="0">
+                          <a:solidFill>
+                            <a:srgbClr val="38761D"/>
+                          </a:solidFill>
+                        </a:rPr>
+                        <a:t>when a program helps; text vs program as a free check</a:t>
+                      </a:r>
+                      <a:endParaRPr lang="en-US" sz="1300" dirty="0"/>
+                    </a:p>
+                  </a:txBody>
+                  <a:tcPr marL="54864" marR="54864" marT="54864" marB="54864" anchor="ctr">
+                    <a:lnL w="9525" cap="flat" cmpd="sng" algn="ctr">
+                      <a:solidFill>
+                        <a:srgbClr val="BFBFBF"/>
+                      </a:solidFill>
+                      <a:prstDash val="solid"/>
+                      <a:round/>
+                      <a:headEnd type="none" w="med" len="med"/>
+                      <a:tailEnd type="none" w="med" len="med"/>
+                    </a:lnL>
+                    <a:lnR w="9525" cap="flat" cmpd="sng" algn="ctr">
+                      <a:solidFill>
+                        <a:srgbClr val="BFBFBF"/>
+                      </a:solidFill>
+                      <a:prstDash val="solid"/>
+                      <a:round/>
+                      <a:headEnd type="none" w="med" len="med"/>
+                      <a:tailEnd type="none" w="med" len="med"/>
+                    </a:lnR>
+                    <a:lnT w="9525" cap="flat" cmpd="sng" algn="ctr">
+                      <a:solidFill>
+                        <a:srgbClr val="BFBFBF"/>
+                      </a:solidFill>
+                      <a:prstDash val="solid"/>
+                      <a:round/>
+                      <a:headEnd type="none" w="med" len="med"/>
+                      <a:tailEnd type="none" w="med" len="med"/>
+                    </a:lnT>
+                    <a:lnB w="9525" cap="flat" cmpd="sng" algn="ctr">
+                      <a:solidFill>
+                        <a:srgbClr val="BFBFBF"/>
+                      </a:solidFill>
+                      <a:prstDash val="solid"/>
+                      <a:round/>
+                      <a:headEnd type="none" w="med" len="med"/>
+                      <a:tailEnd type="none" w="med" len="med"/>
+                    </a:lnB>
+                  </a:tcPr>
+                </a:tc>
+              </a:tr>
+              <a:tr h="521208">
+                <a:tc>
+                  <a:txBody>
+                    <a:bodyPr/>
+                    <a:lstStyle/>
+                    <a:p>
+                      <a:pPr indent="0" marL="0">
+                        <a:buNone/>
+                      </a:pPr>
+                      <a:r>
+                        <a:rPr lang="en-US" sz="1300" dirty="0">
+                          <a:solidFill>
+                            <a:schemeClr val="tx1"/>
+                          </a:solidFill>
+                        </a:rPr>
+                        <a:t>Library facts for code</a:t>
+                      </a:r>
+                      <a:endParaRPr lang="en-US" sz="1300" dirty="0"/>
+                    </a:p>
+                  </a:txBody>
+                  <a:tcPr marL="54864" marR="54864" marT="54864" marB="54864" anchor="ctr">
+                    <a:lnL w="9525" cap="flat" cmpd="sng" algn="ctr">
+                      <a:solidFill>
+                        <a:srgbClr val="BFBFBF"/>
+                      </a:solidFill>
+                      <a:prstDash val="solid"/>
+                      <a:round/>
+                      <a:headEnd type="none" w="med" len="med"/>
+                      <a:tailEnd type="none" w="med" len="med"/>
+                    </a:lnL>
+                    <a:lnR w="9525" cap="flat" cmpd="sng" algn="ctr">
+                      <a:solidFill>
+                        <a:srgbClr val="BFBFBF"/>
+                      </a:solidFill>
+                      <a:prstDash val="solid"/>
+                      <a:round/>
+                      <a:headEnd type="none" w="med" len="med"/>
+                      <a:tailEnd type="none" w="med" len="med"/>
+                    </a:lnR>
+                    <a:lnT w="9525" cap="flat" cmpd="sng" algn="ctr">
+                      <a:solidFill>
+                        <a:srgbClr val="BFBFBF"/>
+                      </a:solidFill>
+                      <a:prstDash val="solid"/>
+                      <a:round/>
+                      <a:headEnd type="none" w="med" len="med"/>
+                      <a:tailEnd type="none" w="med" len="med"/>
+                    </a:lnT>
+                    <a:lnB w="9525" cap="flat" cmpd="sng" algn="ctr">
+                      <a:solidFill>
+                        <a:srgbClr val="BFBFBF"/>
+                      </a:solidFill>
+                      <a:prstDash val="solid"/>
+                      <a:round/>
+                      <a:headEnd type="none" w="med" len="med"/>
+                      <a:tailEnd type="none" w="med" len="med"/>
+                    </a:lnB>
+                  </a:tcPr>
+                </a:tc>
+                <a:tc>
+                  <a:txBody>
+                    <a:bodyPr/>
+                    <a:lstStyle/>
+                    <a:p>
+                      <a:pPr indent="0" marL="0">
+                        <a:buNone/>
+                      </a:pPr>
+                      <a:r>
+                        <a:rPr lang="en-US" sz="1300" dirty="0">
+                          <a:solidFill>
+                            <a:schemeClr val="tx1"/>
+                          </a:solidFill>
+                        </a:rPr>
+                        <a:t>DRoC (ICLR 2025), CP-Bench, CloudAPIBench, DRAFT</a:t>
+                      </a:r>
+                      <a:endParaRPr lang="en-US" sz="1300" dirty="0"/>
+                    </a:p>
+                  </a:txBody>
+                  <a:tcPr marL="54864" marR="54864" marT="54864" marB="54864" anchor="ctr">
+                    <a:lnL w="9525" cap="flat" cmpd="sng" algn="ctr">
+                      <a:solidFill>
+                        <a:srgbClr val="BFBFBF"/>
+                      </a:solidFill>
+                      <a:prstDash val="solid"/>
+                      <a:round/>
+                      <a:headEnd type="none" w="med" len="med"/>
+                      <a:tailEnd type="none" w="med" len="med"/>
+                    </a:lnL>
+                    <a:lnR w="9525" cap="flat" cmpd="sng" algn="ctr">
+                      <a:solidFill>
+                        <a:srgbClr val="BFBFBF"/>
+                      </a:solidFill>
+                      <a:prstDash val="solid"/>
+                      <a:round/>
+                      <a:headEnd type="none" w="med" len="med"/>
+                      <a:tailEnd type="none" w="med" len="med"/>
+                    </a:lnR>
+                    <a:lnT w="9525" cap="flat" cmpd="sng" algn="ctr">
+                      <a:solidFill>
+                        <a:srgbClr val="BFBFBF"/>
+                      </a:solidFill>
+                      <a:prstDash val="solid"/>
+                      <a:round/>
+                      <a:headEnd type="none" w="med" len="med"/>
+                      <a:tailEnd type="none" w="med" len="med"/>
+                    </a:lnT>
+                    <a:lnB w="9525" cap="flat" cmpd="sng" algn="ctr">
+                      <a:solidFill>
+                        <a:srgbClr val="BFBFBF"/>
+                      </a:solidFill>
+                      <a:prstDash val="solid"/>
+                      <a:round/>
+                      <a:headEnd type="none" w="med" len="med"/>
+                      <a:tailEnd type="none" w="med" len="med"/>
+                    </a:lnB>
+                  </a:tcPr>
+                </a:tc>
+                <a:tc>
+                  <a:txBody>
+                    <a:bodyPr/>
+                    <a:lstStyle/>
+                    <a:p>
+                      <a:pPr indent="0" marL="0">
+                        <a:buNone/>
+                      </a:pPr>
+                      <a:r>
+                        <a:rPr lang="en-US" sz="1300" dirty="0">
+                          <a:solidFill>
+                            <a:srgbClr val="38761D"/>
+                          </a:solidFill>
+                        </a:rPr>
+                        <a:t>5 exact lines beat the manual and thinking; facts mined without a human</a:t>
+                      </a:r>
+                      <a:endParaRPr lang="en-US" sz="1300" dirty="0"/>
+                    </a:p>
+                  </a:txBody>
+                  <a:tcPr marL="54864" marR="54864" marT="54864" marB="54864" anchor="ctr">
+                    <a:lnL w="9525" cap="flat" cmpd="sng" algn="ctr">
+                      <a:solidFill>
+                        <a:srgbClr val="BFBFBF"/>
+                      </a:solidFill>
+                      <a:prstDash val="solid"/>
+                      <a:round/>
+                      <a:headEnd type="none" w="med" len="med"/>
+                      <a:tailEnd type="none" w="med" len="med"/>
+                    </a:lnL>
+                    <a:lnR w="9525" cap="flat" cmpd="sng" algn="ctr">
+                      <a:solidFill>
+                        <a:srgbClr val="BFBFBF"/>
+                      </a:solidFill>
+                      <a:prstDash val="solid"/>
+                      <a:round/>
+                      <a:headEnd type="none" w="med" len="med"/>
+                      <a:tailEnd type="none" w="med" len="med"/>
+                    </a:lnR>
+                    <a:lnT w="9525" cap="flat" cmpd="sng" algn="ctr">
+                      <a:solidFill>
+                        <a:srgbClr val="BFBFBF"/>
+                      </a:solidFill>
+                      <a:prstDash val="solid"/>
+                      <a:round/>
+                      <a:headEnd type="none" w="med" len="med"/>
+                      <a:tailEnd type="none" w="med" len="med"/>
+                    </a:lnT>
+                    <a:lnB w="9525" cap="flat" cmpd="sng" algn="ctr">
+                      <a:solidFill>
+                        <a:srgbClr val="BFBFBF"/>
+                      </a:solidFill>
+                      <a:prstDash val="solid"/>
+                      <a:round/>
+                      <a:headEnd type="none" w="med" len="med"/>
+                      <a:tailEnd type="none" w="med" len="med"/>
+                    </a:lnB>
+                  </a:tcPr>
+                </a:tc>
+              </a:tr>
+              <a:tr h="521208">
+                <a:tc>
+                  <a:txBody>
+                    <a:bodyPr/>
+                    <a:lstStyle/>
+                    <a:p>
+                      <a:pPr indent="0" marL="0">
+                        <a:buNone/>
+                      </a:pPr>
+                      <a:r>
+                        <a:rPr lang="en-US" sz="1300" dirty="0">
+                          <a:solidFill>
+                            <a:schemeClr val="tx1"/>
+                          </a:solidFill>
+                        </a:rPr>
+                        <a:t>Misleading context</a:t>
+                      </a:r>
+                      <a:endParaRPr lang="en-US" sz="1300" dirty="0"/>
+                    </a:p>
+                  </a:txBody>
+                  <a:tcPr marL="54864" marR="54864" marT="54864" marB="54864" anchor="ctr">
+                    <a:lnL w="9525" cap="flat" cmpd="sng" algn="ctr">
+                      <a:solidFill>
+                        <a:srgbClr val="BFBFBF"/>
+                      </a:solidFill>
+                      <a:prstDash val="solid"/>
+                      <a:round/>
+                      <a:headEnd type="none" w="med" len="med"/>
+                      <a:tailEnd type="none" w="med" len="med"/>
+                    </a:lnL>
+                    <a:lnR w="9525" cap="flat" cmpd="sng" algn="ctr">
+                      <a:solidFill>
+                        <a:srgbClr val="BFBFBF"/>
+                      </a:solidFill>
+                      <a:prstDash val="solid"/>
+                      <a:round/>
+                      <a:headEnd type="none" w="med" len="med"/>
+                      <a:tailEnd type="none" w="med" len="med"/>
+                    </a:lnR>
+                    <a:lnT w="9525" cap="flat" cmpd="sng" algn="ctr">
+                      <a:solidFill>
+                        <a:srgbClr val="BFBFBF"/>
+                      </a:solidFill>
+                      <a:prstDash val="solid"/>
+                      <a:round/>
+                      <a:headEnd type="none" w="med" len="med"/>
+                      <a:tailEnd type="none" w="med" len="med"/>
+                    </a:lnT>
+                    <a:lnB w="9525" cap="flat" cmpd="sng" algn="ctr">
+                      <a:solidFill>
+                        <a:srgbClr val="BFBFBF"/>
+                      </a:solidFill>
+                      <a:prstDash val="solid"/>
+                      <a:round/>
+                      <a:headEnd type="none" w="med" len="med"/>
+                      <a:tailEnd type="none" w="med" len="med"/>
+                    </a:lnB>
+                  </a:tcPr>
+                </a:tc>
+                <a:tc>
+                  <a:txBody>
+                    <a:bodyPr/>
+                    <a:lstStyle/>
+                    <a:p>
+                      <a:pPr indent="0" marL="0">
+                        <a:buNone/>
+                      </a:pPr>
+                      <a:r>
+                        <a:rPr lang="en-US" sz="1300" dirty="0">
+                          <a:solidFill>
+                            <a:schemeClr val="tx1"/>
+                          </a:solidFill>
+                        </a:rPr>
+                        <a:t>Invisible Lottery (2606.04057), unneeded tools (2609.14157), CodeCrash, S2A</a:t>
+                      </a:r>
+                      <a:endParaRPr lang="en-US" sz="1300" dirty="0"/>
+                    </a:p>
+                  </a:txBody>
+                  <a:tcPr marL="54864" marR="54864" marT="54864" marB="54864" anchor="ctr">
+                    <a:lnL w="9525" cap="flat" cmpd="sng" algn="ctr">
+                      <a:solidFill>
+                        <a:srgbClr val="BFBFBF"/>
+                      </a:solidFill>
+                      <a:prstDash val="solid"/>
+                      <a:round/>
+                      <a:headEnd type="none" w="med" len="med"/>
+                      <a:tailEnd type="none" w="med" len="med"/>
+                    </a:lnL>
+                    <a:lnR w="9525" cap="flat" cmpd="sng" algn="ctr">
+                      <a:solidFill>
+                        <a:srgbClr val="BFBFBF"/>
+                      </a:solidFill>
+                      <a:prstDash val="solid"/>
+                      <a:round/>
+                      <a:headEnd type="none" w="med" len="med"/>
+                      <a:tailEnd type="none" w="med" len="med"/>
+                    </a:lnR>
+                    <a:lnT w="9525" cap="flat" cmpd="sng" algn="ctr">
+                      <a:solidFill>
+                        <a:srgbClr val="BFBFBF"/>
+                      </a:solidFill>
+                      <a:prstDash val="solid"/>
+                      <a:round/>
+                      <a:headEnd type="none" w="med" len="med"/>
+                      <a:tailEnd type="none" w="med" len="med"/>
+                    </a:lnT>
+                    <a:lnB w="9525" cap="flat" cmpd="sng" algn="ctr">
+                      <a:solidFill>
+                        <a:srgbClr val="BFBFBF"/>
+                      </a:solidFill>
+                      <a:prstDash val="solid"/>
+                      <a:round/>
+                      <a:headEnd type="none" w="med" len="med"/>
+                      <a:tailEnd type="none" w="med" len="med"/>
+                    </a:lnB>
+                  </a:tcPr>
+                </a:tc>
+                <a:tc>
+                  <a:txBody>
+                    <a:bodyPr/>
+                    <a:lstStyle/>
+                    <a:p>
+                      <a:pPr indent="0" marL="0">
+                        <a:buNone/>
+                      </a:pPr>
+                      <a:r>
+                        <a:rPr lang="en-US" sz="1300" dirty="0">
+                          <a:solidFill>
+                            <a:srgbClr val="38761D"/>
+                          </a:solidFill>
+                        </a:rPr>
+                        <a:t>the harm on exact geometry, turned into a check</a:t>
+                      </a:r>
+                      <a:endParaRPr lang="en-US" sz="1300" dirty="0"/>
+                    </a:p>
+                  </a:txBody>
+                  <a:tcPr marL="54864" marR="54864" marT="54864" marB="54864" anchor="ctr">
+                    <a:lnL w="9525" cap="flat" cmpd="sng" algn="ctr">
+                      <a:solidFill>
+                        <a:srgbClr val="BFBFBF"/>
+                      </a:solidFill>
+                      <a:prstDash val="solid"/>
+                      <a:round/>
+                      <a:headEnd type="none" w="med" len="med"/>
+                      <a:tailEnd type="none" w="med" len="med"/>
+                    </a:lnL>
+                    <a:lnR w="9525" cap="flat" cmpd="sng" algn="ctr">
+                      <a:solidFill>
+                        <a:srgbClr val="BFBFBF"/>
+                      </a:solidFill>
+                      <a:prstDash val="solid"/>
+                      <a:round/>
+                      <a:headEnd type="none" w="med" len="med"/>
+                      <a:tailEnd type="none" w="med" len="med"/>
+                    </a:lnR>
+                    <a:lnT w="9525" cap="flat" cmpd="sng" algn="ctr">
+                      <a:solidFill>
+                        <a:srgbClr val="BFBFBF"/>
+                      </a:solidFill>
+                      <a:prstDash val="solid"/>
+                      <a:round/>
+                      <a:headEnd type="none" w="med" len="med"/>
+                      <a:tailEnd type="none" w="med" len="med"/>
+                    </a:lnT>
+                    <a:lnB w="9525" cap="flat" cmpd="sng" algn="ctr">
+                      <a:solidFill>
+                        <a:srgbClr val="BFBFBF"/>
+                      </a:solidFill>
+                      <a:prstDash val="solid"/>
+                      <a:round/>
+                      <a:headEnd type="none" w="med" len="med"/>
+                      <a:tailEnd type="none" w="med" len="med"/>
+                    </a:lnB>
+                  </a:tcPr>
+                </a:tc>
+              </a:tr>
+              <a:tr h="521208">
+                <a:tc>
+                  <a:txBody>
+                    <a:bodyPr/>
+                    <a:lstStyle/>
+                    <a:p>
+                      <a:pPr indent="0" marL="0">
+                        <a:buNone/>
+                      </a:pPr>
+                      <a:r>
+                        <a:rPr lang="en-US" sz="1300" dirty="0">
+                          <a:solidFill>
+                            <a:schemeClr val="tx1"/>
+                          </a:solidFill>
+                        </a:rPr>
+                        <a:t>Choosing a program</a:t>
+                      </a:r>
+                      <a:endParaRPr lang="en-US" sz="1300" dirty="0"/>
+                    </a:p>
+                  </a:txBody>
+                  <a:tcPr marL="54864" marR="54864" marT="54864" marB="54864" anchor="ctr">
+                    <a:lnL w="9525" cap="flat" cmpd="sng" algn="ctr">
+                      <a:solidFill>
+                        <a:srgbClr val="BFBFBF"/>
+                      </a:solidFill>
+                      <a:prstDash val="solid"/>
+                      <a:round/>
+                      <a:headEnd type="none" w="med" len="med"/>
+                      <a:tailEnd type="none" w="med" len="med"/>
+                    </a:lnL>
+                    <a:lnR w="9525" cap="flat" cmpd="sng" algn="ctr">
+                      <a:solidFill>
+                        <a:srgbClr val="BFBFBF"/>
+                      </a:solidFill>
+                      <a:prstDash val="solid"/>
+                      <a:round/>
+                      <a:headEnd type="none" w="med" len="med"/>
+                      <a:tailEnd type="none" w="med" len="med"/>
+                    </a:lnR>
+                    <a:lnT w="9525" cap="flat" cmpd="sng" algn="ctr">
+                      <a:solidFill>
+                        <a:srgbClr val="BFBFBF"/>
+                      </a:solidFill>
+                      <a:prstDash val="solid"/>
+                      <a:round/>
+                      <a:headEnd type="none" w="med" len="med"/>
+                      <a:tailEnd type="none" w="med" len="med"/>
+                    </a:lnT>
+                    <a:lnB w="9525" cap="flat" cmpd="sng" algn="ctr">
+                      <a:solidFill>
+                        <a:srgbClr val="BFBFBF"/>
+                      </a:solidFill>
+                      <a:prstDash val="solid"/>
+                      <a:round/>
+                      <a:headEnd type="none" w="med" len="med"/>
+                      <a:tailEnd type="none" w="med" len="med"/>
+                    </a:lnB>
+                  </a:tcPr>
+                </a:tc>
+                <a:tc>
+                  <a:txBody>
+                    <a:bodyPr/>
+                    <a:lstStyle/>
+                    <a:p>
+                      <a:pPr indent="0" marL="0">
+                        <a:buNone/>
+                      </a:pPr>
+                      <a:r>
+                        <a:rPr lang="en-US" sz="1300" dirty="0">
+                          <a:solidFill>
+                            <a:schemeClr val="tx1"/>
+                          </a:solidFill>
+                        </a:rPr>
+                        <a:t>CodeT, MBR-exec, AlphaCode's example filter, DeepConf</a:t>
+                      </a:r>
+                      <a:endParaRPr lang="en-US" sz="1300" dirty="0"/>
+                    </a:p>
+                  </a:txBody>
+                  <a:tcPr marL="54864" marR="54864" marT="54864" marB="54864" anchor="ctr">
+                    <a:lnL w="9525" cap="flat" cmpd="sng" algn="ctr">
+                      <a:solidFill>
+                        <a:srgbClr val="BFBFBF"/>
+                      </a:solidFill>
+                      <a:prstDash val="solid"/>
+                      <a:round/>
+                      <a:headEnd type="none" w="med" len="med"/>
+                      <a:tailEnd type="none" w="med" len="med"/>
+                    </a:lnL>
+                    <a:lnR w="9525" cap="flat" cmpd="sng" algn="ctr">
+                      <a:solidFill>
+                        <a:srgbClr val="BFBFBF"/>
+                      </a:solidFill>
+                      <a:prstDash val="solid"/>
+                      <a:round/>
+                      <a:headEnd type="none" w="med" len="med"/>
+                      <a:tailEnd type="none" w="med" len="med"/>
+                    </a:lnR>
+                    <a:lnT w="9525" cap="flat" cmpd="sng" algn="ctr">
+                      <a:solidFill>
+                        <a:srgbClr val="BFBFBF"/>
+                      </a:solidFill>
+                      <a:prstDash val="solid"/>
+                      <a:round/>
+                      <a:headEnd type="none" w="med" len="med"/>
+                      <a:tailEnd type="none" w="med" len="med"/>
+                    </a:lnT>
+                    <a:lnB w="9525" cap="flat" cmpd="sng" algn="ctr">
+                      <a:solidFill>
+                        <a:srgbClr val="BFBFBF"/>
+                      </a:solidFill>
+                      <a:prstDash val="solid"/>
+                      <a:round/>
+                      <a:headEnd type="none" w="med" len="med"/>
+                      <a:tailEnd type="none" w="med" len="med"/>
+                    </a:lnB>
+                  </a:tcPr>
+                </a:tc>
+                <a:tc>
+                  <a:txBody>
+                    <a:bodyPr/>
+                    <a:lstStyle/>
+                    <a:p>
+                      <a:pPr indent="0" marL="0">
+                        <a:buNone/>
+                      </a:pPr>
+                      <a:r>
+                        <a:rPr lang="en-US" sz="1300" dirty="0">
+                          <a:solidFill>
+                            <a:srgbClr val="38761D"/>
+                          </a:solidFill>
+                        </a:rPr>
+                        <a:t>symmetry check of one program: 99.7% vs CodeT 96.0%</a:t>
+                      </a:r>
+                      <a:endParaRPr lang="en-US" sz="1300" dirty="0"/>
+                    </a:p>
+                  </a:txBody>
+                  <a:tcPr marL="54864" marR="54864" marT="54864" marB="54864" anchor="ctr">
+                    <a:lnL w="9525" cap="flat" cmpd="sng" algn="ctr">
+                      <a:solidFill>
+                        <a:srgbClr val="BFBFBF"/>
+                      </a:solidFill>
+                      <a:prstDash val="solid"/>
+                      <a:round/>
+                      <a:headEnd type="none" w="med" len="med"/>
+                      <a:tailEnd type="none" w="med" len="med"/>
+                    </a:lnL>
+                    <a:lnR w="9525" cap="flat" cmpd="sng" algn="ctr">
+                      <a:solidFill>
+                        <a:srgbClr val="BFBFBF"/>
+                      </a:solidFill>
+                      <a:prstDash val="solid"/>
+                      <a:round/>
+                      <a:headEnd type="none" w="med" len="med"/>
+                      <a:tailEnd type="none" w="med" len="med"/>
+                    </a:lnR>
+                    <a:lnT w="9525" cap="flat" cmpd="sng" algn="ctr">
+                      <a:solidFill>
+                        <a:srgbClr val="BFBFBF"/>
+                      </a:solidFill>
+                      <a:prstDash val="solid"/>
+                      <a:round/>
+                      <a:headEnd type="none" w="med" len="med"/>
+                      <a:tailEnd type="none" w="med" len="med"/>
+                    </a:lnT>
+                    <a:lnB w="9525" cap="flat" cmpd="sng" algn="ctr">
+                      <a:solidFill>
+                        <a:srgbClr val="BFBFBF"/>
+                      </a:solidFill>
+                      <a:prstDash val="solid"/>
+                      <a:round/>
+                      <a:headEnd type="none" w="med" len="med"/>
+                      <a:tailEnd type="none" w="med" len="med"/>
+                    </a:lnB>
+                  </a:tcPr>
+                </a:tc>
+              </a:tr>
+              <a:tr h="521208">
+                <a:tc>
+                  <a:txBody>
+                    <a:bodyPr/>
+                    <a:lstStyle/>
+                    <a:p>
+                      <a:pPr indent="0" marL="0">
+                        <a:buNone/>
+                      </a:pPr>
+                      <a:r>
+                        <a:rPr lang="en-US" sz="1300" dirty="0">
+                          <a:solidFill>
+                            <a:schemeClr val="tx1"/>
+                          </a:solidFill>
+                        </a:rPr>
+                        <a:t>Spending test-time compute</a:t>
+                      </a:r>
+                      <a:endParaRPr lang="en-US" sz="1300" dirty="0"/>
+                    </a:p>
+                  </a:txBody>
+                  <a:tcPr marL="54864" marR="54864" marT="54864" marB="54864" anchor="ctr">
+                    <a:lnL w="9525" cap="flat" cmpd="sng" algn="ctr">
+                      <a:solidFill>
+                        <a:srgbClr val="BFBFBF"/>
+                      </a:solidFill>
+                      <a:prstDash val="solid"/>
+                      <a:round/>
+                      <a:headEnd type="none" w="med" len="med"/>
+                      <a:tailEnd type="none" w="med" len="med"/>
+                    </a:lnL>
+                    <a:lnR w="9525" cap="flat" cmpd="sng" algn="ctr">
+                      <a:solidFill>
+                        <a:srgbClr val="BFBFBF"/>
+                      </a:solidFill>
+                      <a:prstDash val="solid"/>
+                      <a:round/>
+                      <a:headEnd type="none" w="med" len="med"/>
+                      <a:tailEnd type="none" w="med" len="med"/>
+                    </a:lnR>
+                    <a:lnT w="9525" cap="flat" cmpd="sng" algn="ctr">
+                      <a:solidFill>
+                        <a:srgbClr val="BFBFBF"/>
+                      </a:solidFill>
+                      <a:prstDash val="solid"/>
+                      <a:round/>
+                      <a:headEnd type="none" w="med" len="med"/>
+                      <a:tailEnd type="none" w="med" len="med"/>
+                    </a:lnT>
+                    <a:lnB w="9525" cap="flat" cmpd="sng" algn="ctr">
+                      <a:solidFill>
+                        <a:srgbClr val="BFBFBF"/>
+                      </a:solidFill>
+                      <a:prstDash val="solid"/>
+                      <a:round/>
+                      <a:headEnd type="none" w="med" len="med"/>
+                      <a:tailEnd type="none" w="med" len="med"/>
+                    </a:lnB>
+                  </a:tcPr>
+                </a:tc>
+                <a:tc>
+                  <a:txBody>
+                    <a:bodyPr/>
+                    <a:lstStyle/>
+                    <a:p>
+                      <a:pPr indent="0" marL="0">
+                        <a:buNone/>
+                      </a:pPr>
+                      <a:r>
+                        <a:rPr lang="en-US" sz="1300" dirty="0">
+                          <a:solidFill>
+                            <a:schemeClr val="tx1"/>
+                          </a:solidFill>
+                        </a:rPr>
+                        <a:t>Snell et al. 2025, FrugalGPT, DART, Thinkless, AdaptThink</a:t>
+                      </a:r>
+                      <a:endParaRPr lang="en-US" sz="1300" dirty="0"/>
+                    </a:p>
+                  </a:txBody>
+                  <a:tcPr marL="54864" marR="54864" marT="54864" marB="54864" anchor="ctr">
+                    <a:lnL w="9525" cap="flat" cmpd="sng" algn="ctr">
+                      <a:solidFill>
+                        <a:srgbClr val="BFBFBF"/>
+                      </a:solidFill>
+                      <a:prstDash val="solid"/>
+                      <a:round/>
+                      <a:headEnd type="none" w="med" len="med"/>
+                      <a:tailEnd type="none" w="med" len="med"/>
+                    </a:lnL>
+                    <a:lnR w="9525" cap="flat" cmpd="sng" algn="ctr">
+                      <a:solidFill>
+                        <a:srgbClr val="BFBFBF"/>
+                      </a:solidFill>
+                      <a:prstDash val="solid"/>
+                      <a:round/>
+                      <a:headEnd type="none" w="med" len="med"/>
+                      <a:tailEnd type="none" w="med" len="med"/>
+                    </a:lnR>
+                    <a:lnT w="9525" cap="flat" cmpd="sng" algn="ctr">
+                      <a:solidFill>
+                        <a:srgbClr val="BFBFBF"/>
+                      </a:solidFill>
+                      <a:prstDash val="solid"/>
+                      <a:round/>
+                      <a:headEnd type="none" w="med" len="med"/>
+                      <a:tailEnd type="none" w="med" len="med"/>
+                    </a:lnT>
+                    <a:lnB w="9525" cap="flat" cmpd="sng" algn="ctr">
+                      <a:solidFill>
+                        <a:srgbClr val="BFBFBF"/>
+                      </a:solidFill>
+                      <a:prstDash val="solid"/>
+                      <a:round/>
+                      <a:headEnd type="none" w="med" len="med"/>
+                      <a:tailEnd type="none" w="med" len="med"/>
+                    </a:lnB>
+                  </a:tcPr>
+                </a:tc>
+                <a:tc>
+                  <a:txBody>
+                    <a:bodyPr/>
+                    <a:lstStyle/>
+                    <a:p>
+                      <a:pPr indent="0" marL="0">
+                        <a:buNone/>
+                      </a:pPr>
+                      <a:r>
+                        <a:rPr lang="en-US" sz="1300" dirty="0">
+                          <a:solidFill>
+                            <a:srgbClr val="38761D"/>
+                          </a:solidFill>
+                        </a:rPr>
+                        <a:t>fact + execution check, no training: 87% vs 74%</a:t>
+                      </a:r>
+                      <a:endParaRPr lang="en-US" sz="1300" dirty="0"/>
+                    </a:p>
+                  </a:txBody>
+                  <a:tcPr marL="54864" marR="54864" marT="54864" marB="54864" anchor="ctr">
+                    <a:lnL w="9525" cap="flat" cmpd="sng" algn="ctr">
+                      <a:solidFill>
+                        <a:srgbClr val="BFBFBF"/>
+                      </a:solidFill>
+                      <a:prstDash val="solid"/>
+                      <a:round/>
+                      <a:headEnd type="none" w="med" len="med"/>
+                      <a:tailEnd type="none" w="med" len="med"/>
+                    </a:lnL>
+                    <a:lnR w="9525" cap="flat" cmpd="sng" algn="ctr">
+                      <a:solidFill>
+                        <a:srgbClr val="BFBFBF"/>
+                      </a:solidFill>
+                      <a:prstDash val="solid"/>
+                      <a:round/>
+                      <a:headEnd type="none" w="med" len="med"/>
+                      <a:tailEnd type="none" w="med" len="med"/>
+                    </a:lnR>
+                    <a:lnT w="9525" cap="flat" cmpd="sng" algn="ctr">
+                      <a:solidFill>
+                        <a:srgbClr val="BFBFBF"/>
+                      </a:solidFill>
+                      <a:prstDash val="solid"/>
+                      <a:round/>
+                      <a:headEnd type="none" w="med" len="med"/>
+                      <a:tailEnd type="none" w="med" len="med"/>
+                    </a:lnT>
+                    <a:lnB w="9525" cap="flat" cmpd="sng" algn="ctr">
+                      <a:solidFill>
+                        <a:srgbClr val="BFBFBF"/>
+                      </a:solidFill>
+                      <a:prstDash val="solid"/>
+                      <a:round/>
+                      <a:headEnd type="none" w="med" len="med"/>
+                      <a:tailEnd type="none" w="med" len="med"/>
+                    </a:lnB>
+                  </a:tcPr>
+                </a:tc>
+              </a:tr>
+              <a:tr h="521208">
+                <a:tc>
+                  <a:txBody>
+                    <a:bodyPr/>
+                    <a:lstStyle/>
+                    <a:p>
+                      <a:pPr indent="0" marL="0">
+                        <a:buNone/>
+                      </a:pPr>
+                      <a:r>
+                        <a:rPr lang="en-US" sz="1300" dirty="0">
+                          <a:solidFill>
+                            <a:schemeClr val="tx1"/>
+                          </a:solidFill>
+                        </a:rPr>
+                        <a:t>Optimization modeling</a:t>
+                      </a:r>
+                      <a:endParaRPr lang="en-US" sz="1300" dirty="0"/>
+                    </a:p>
+                  </a:txBody>
+                  <a:tcPr marL="54864" marR="54864" marT="54864" marB="54864" anchor="ctr">
+                    <a:lnL w="9525" cap="flat" cmpd="sng" algn="ctr">
+                      <a:solidFill>
+                        <a:srgbClr val="BFBFBF"/>
+                      </a:solidFill>
+                      <a:prstDash val="solid"/>
+                      <a:round/>
+                      <a:headEnd type="none" w="med" len="med"/>
+                      <a:tailEnd type="none" w="med" len="med"/>
+                    </a:lnL>
+                    <a:lnR w="9525" cap="flat" cmpd="sng" algn="ctr">
+                      <a:solidFill>
+                        <a:srgbClr val="BFBFBF"/>
+                      </a:solidFill>
+                      <a:prstDash val="solid"/>
+                      <a:round/>
+                      <a:headEnd type="none" w="med" len="med"/>
+                      <a:tailEnd type="none" w="med" len="med"/>
+                    </a:lnR>
+                    <a:lnT w="9525" cap="flat" cmpd="sng" algn="ctr">
+                      <a:solidFill>
+                        <a:srgbClr val="BFBFBF"/>
+                      </a:solidFill>
+                      <a:prstDash val="solid"/>
+                      <a:round/>
+                      <a:headEnd type="none" w="med" len="med"/>
+                      <a:tailEnd type="none" w="med" len="med"/>
+                    </a:lnT>
+                    <a:lnB w="9525" cap="flat" cmpd="sng" algn="ctr">
+                      <a:solidFill>
+                        <a:srgbClr val="BFBFBF"/>
+                      </a:solidFill>
+                      <a:prstDash val="solid"/>
+                      <a:round/>
+                      <a:headEnd type="none" w="med" len="med"/>
+                      <a:tailEnd type="none" w="med" len="med"/>
+                    </a:lnB>
+                  </a:tcPr>
+                </a:tc>
+                <a:tc>
+                  <a:txBody>
+                    <a:bodyPr/>
+                    <a:lstStyle/>
+                    <a:p>
+                      <a:pPr indent="0" marL="0">
+                        <a:buNone/>
+                      </a:pPr>
+                      <a:r>
+                        <a:rPr lang="en-US" sz="1300" dirty="0">
+                          <a:solidFill>
+                            <a:schemeClr val="tx1"/>
+                          </a:solidFill>
+                        </a:rPr>
+                        <a:t>ORLM, STORM, EVOM, OR-R1 (trained); OptiMUS, OptiSkill (agents)</a:t>
+                      </a:r>
+                      <a:endParaRPr lang="en-US" sz="1300" dirty="0"/>
+                    </a:p>
+                  </a:txBody>
+                  <a:tcPr marL="54864" marR="54864" marT="54864" marB="54864" anchor="ctr">
+                    <a:lnL w="9525" cap="flat" cmpd="sng" algn="ctr">
+                      <a:solidFill>
+                        <a:srgbClr val="BFBFBF"/>
+                      </a:solidFill>
+                      <a:prstDash val="solid"/>
+                      <a:round/>
+                      <a:headEnd type="none" w="med" len="med"/>
+                      <a:tailEnd type="none" w="med" len="med"/>
+                    </a:lnL>
+                    <a:lnR w="9525" cap="flat" cmpd="sng" algn="ctr">
+                      <a:solidFill>
+                        <a:srgbClr val="BFBFBF"/>
+                      </a:solidFill>
+                      <a:prstDash val="solid"/>
+                      <a:round/>
+                      <a:headEnd type="none" w="med" len="med"/>
+                      <a:tailEnd type="none" w="med" len="med"/>
+                    </a:lnR>
+                    <a:lnT w="9525" cap="flat" cmpd="sng" algn="ctr">
+                      <a:solidFill>
+                        <a:srgbClr val="BFBFBF"/>
+                      </a:solidFill>
+                      <a:prstDash val="solid"/>
+                      <a:round/>
+                      <a:headEnd type="none" w="med" len="med"/>
+                      <a:tailEnd type="none" w="med" len="med"/>
+                    </a:lnT>
+                    <a:lnB w="9525" cap="flat" cmpd="sng" algn="ctr">
+                      <a:solidFill>
+                        <a:srgbClr val="BFBFBF"/>
+                      </a:solidFill>
+                      <a:prstDash val="solid"/>
+                      <a:round/>
+                      <a:headEnd type="none" w="med" len="med"/>
+                      <a:tailEnd type="none" w="med" len="med"/>
+                    </a:lnB>
+                  </a:tcPr>
+                </a:tc>
+                <a:tc>
+                  <a:txBody>
+                    <a:bodyPr/>
+                    <a:lstStyle/>
+                    <a:p>
+                      <a:pPr indent="0" marL="0">
+                        <a:buNone/>
+                      </a:pPr>
+                      <a:r>
+                        <a:rPr lang="en-US" sz="1300" dirty="0">
+                          <a:solidFill>
+                            <a:srgbClr val="38761D"/>
+                          </a:solidFill>
+                        </a:rPr>
+                        <a:t>training-free, no answers; matches fine-tuned ORLM-8B</a:t>
+                      </a:r>
+                      <a:endParaRPr lang="en-US" sz="1300" dirty="0"/>
+                    </a:p>
+                  </a:txBody>
+                  <a:tcPr marL="54864" marR="54864" marT="54864" marB="54864" anchor="ctr">
+                    <a:lnL w="9525" cap="flat" cmpd="sng" algn="ctr">
+                      <a:solidFill>
+                        <a:srgbClr val="BFBFBF"/>
+                      </a:solidFill>
+                      <a:prstDash val="solid"/>
+                      <a:round/>
+                      <a:headEnd type="none" w="med" len="med"/>
+                      <a:tailEnd type="none" w="med" len="med"/>
+                    </a:lnL>
+                    <a:lnR w="9525" cap="flat" cmpd="sng" algn="ctr">
+                      <a:solidFill>
+                        <a:srgbClr val="BFBFBF"/>
+                      </a:solidFill>
+                      <a:prstDash val="solid"/>
+                      <a:round/>
+                      <a:headEnd type="none" w="med" len="med"/>
+                      <a:tailEnd type="none" w="med" len="med"/>
+                    </a:lnR>
+                    <a:lnT w="9525" cap="flat" cmpd="sng" algn="ctr">
+                      <a:solidFill>
+                        <a:srgbClr val="BFBFBF"/>
+                      </a:solidFill>
+                      <a:prstDash val="solid"/>
+                      <a:round/>
+                      <a:headEnd type="none" w="med" len="med"/>
+                      <a:tailEnd type="none" w="med" len="med"/>
+                    </a:lnT>
+                    <a:lnB w="9525" cap="flat" cmpd="sng" algn="ctr">
+                      <a:solidFill>
+                        <a:srgbClr val="BFBFBF"/>
+                      </a:solidFill>
+                      <a:prstDash val="solid"/>
+                      <a:round/>
+                      <a:headEnd type="none" w="med" len="med"/>
+                      <a:tailEnd type="none" w="med" len="med"/>
+                    </a:lnB>
+                  </a:tcPr>
+                </a:tc>
+              </a:tr>
+              <a:tr h="521208">
+                <a:tc>
+                  <a:txBody>
+                    <a:bodyPr/>
+                    <a:lstStyle/>
+                    <a:p>
+                      <a:pPr indent="0" marL="0">
+                        <a:buNone/>
+                      </a:pPr>
+                      <a:r>
+                        <a:rPr lang="en-US" sz="1300" dirty="0">
+                          <a:solidFill>
+                            <a:schemeClr val="tx1"/>
+                          </a:solidFill>
+                        </a:rPr>
+                        <a:t>One program, many instances</a:t>
+                      </a:r>
+                      <a:endParaRPr lang="en-US" sz="1300" dirty="0"/>
+                    </a:p>
+                  </a:txBody>
+                  <a:tcPr marL="54864" marR="54864" marT="54864" marB="54864" anchor="ctr">
+                    <a:lnL w="9525" cap="flat" cmpd="sng" algn="ctr">
+                      <a:solidFill>
+                        <a:srgbClr val="BFBFBF"/>
+                      </a:solidFill>
+                      <a:prstDash val="solid"/>
+                      <a:round/>
+                      <a:headEnd type="none" w="med" len="med"/>
+                      <a:tailEnd type="none" w="med" len="med"/>
+                    </a:lnL>
+                    <a:lnR w="9525" cap="flat" cmpd="sng" algn="ctr">
+                      <a:solidFill>
+                        <a:srgbClr val="BFBFBF"/>
+                      </a:solidFill>
+                      <a:prstDash val="solid"/>
+                      <a:round/>
+                      <a:headEnd type="none" w="med" len="med"/>
+                      <a:tailEnd type="none" w="med" len="med"/>
+                    </a:lnR>
+                    <a:lnT w="9525" cap="flat" cmpd="sng" algn="ctr">
+                      <a:solidFill>
+                        <a:srgbClr val="BFBFBF"/>
+                      </a:solidFill>
+                      <a:prstDash val="solid"/>
+                      <a:round/>
+                      <a:headEnd type="none" w="med" len="med"/>
+                      <a:tailEnd type="none" w="med" len="med"/>
+                    </a:lnT>
+                    <a:lnB w="9525" cap="flat" cmpd="sng" algn="ctr">
+                      <a:solidFill>
+                        <a:srgbClr val="BFBFBF"/>
+                      </a:solidFill>
+                      <a:prstDash val="solid"/>
+                      <a:round/>
+                      <a:headEnd type="none" w="med" len="med"/>
+                      <a:tailEnd type="none" w="med" len="med"/>
+                    </a:lnB>
+                  </a:tcPr>
+                </a:tc>
+                <a:tc>
+                  <a:txBody>
+                    <a:bodyPr/>
+                    <a:lstStyle/>
+                    <a:p>
+                      <a:pPr indent="0" marL="0">
+                        <a:buNone/>
+                      </a:pPr>
+                      <a:r>
+                        <a:rPr lang="en-US" sz="1300" dirty="0">
+                          <a:solidFill>
+                            <a:schemeClr val="tx1"/>
+                          </a:solidFill>
+                        </a:rPr>
+                        <a:t>FunSearch, HeuriGym, ARS, 2605.14141</a:t>
+                      </a:r>
+                      <a:endParaRPr lang="en-US" sz="1300" dirty="0"/>
+                    </a:p>
+                  </a:txBody>
+                  <a:tcPr marL="54864" marR="54864" marT="54864" marB="54864" anchor="ctr">
+                    <a:lnL w="9525" cap="flat" cmpd="sng" algn="ctr">
+                      <a:solidFill>
+                        <a:srgbClr val="BFBFBF"/>
+                      </a:solidFill>
+                      <a:prstDash val="solid"/>
+                      <a:round/>
+                      <a:headEnd type="none" w="med" len="med"/>
+                      <a:tailEnd type="none" w="med" len="med"/>
+                    </a:lnL>
+                    <a:lnR w="9525" cap="flat" cmpd="sng" algn="ctr">
+                      <a:solidFill>
+                        <a:srgbClr val="BFBFBF"/>
+                      </a:solidFill>
+                      <a:prstDash val="solid"/>
+                      <a:round/>
+                      <a:headEnd type="none" w="med" len="med"/>
+                      <a:tailEnd type="none" w="med" len="med"/>
+                    </a:lnR>
+                    <a:lnT w="9525" cap="flat" cmpd="sng" algn="ctr">
+                      <a:solidFill>
+                        <a:srgbClr val="BFBFBF"/>
+                      </a:solidFill>
+                      <a:prstDash val="solid"/>
+                      <a:round/>
+                      <a:headEnd type="none" w="med" len="med"/>
+                      <a:tailEnd type="none" w="med" len="med"/>
+                    </a:lnT>
+                    <a:lnB w="9525" cap="flat" cmpd="sng" algn="ctr">
+                      <a:solidFill>
+                        <a:srgbClr val="BFBFBF"/>
+                      </a:solidFill>
+                      <a:prstDash val="solid"/>
+                      <a:round/>
+                      <a:headEnd type="none" w="med" len="med"/>
+                      <a:tailEnd type="none" w="med" len="med"/>
+                    </a:lnB>
+                  </a:tcPr>
+                </a:tc>
+                <a:tc>
+                  <a:txBody>
+                    <a:bodyPr/>
+                    <a:lstStyle/>
+                    <a:p>
+                      <a:pPr indent="0" marL="0">
+                        <a:buNone/>
+                      </a:pPr>
+                      <a:r>
+                        <a:rPr lang="en-US" sz="1300" dirty="0">
+                          <a:solidFill>
+                            <a:srgbClr val="38761D"/>
+                          </a:solidFill>
+                        </a:rPr>
+                        <a:t>measured 7% → 94%; edit a verified program for new rules</a:t>
+                      </a:r>
+                      <a:endParaRPr lang="en-US" sz="1300" dirty="0"/>
+                    </a:p>
+                  </a:txBody>
+                  <a:tcPr marL="54864" marR="54864" marT="54864" marB="54864" anchor="ctr">
+                    <a:lnL w="9525" cap="flat" cmpd="sng" algn="ctr">
+                      <a:solidFill>
+                        <a:srgbClr val="BFBFBF"/>
+                      </a:solidFill>
+                      <a:prstDash val="solid"/>
+                      <a:round/>
+                      <a:headEnd type="none" w="med" len="med"/>
+                      <a:tailEnd type="none" w="med" len="med"/>
+                    </a:lnL>
+                    <a:lnR w="9525" cap="flat" cmpd="sng" algn="ctr">
+                      <a:solidFill>
+                        <a:srgbClr val="BFBFBF"/>
+                      </a:solidFill>
+                      <a:prstDash val="solid"/>
+                      <a:round/>
+                      <a:headEnd type="none" w="med" len="med"/>
+                      <a:tailEnd type="none" w="med" len="med"/>
+                    </a:lnR>
+                    <a:lnT w="9525" cap="flat" cmpd="sng" algn="ctr">
+                      <a:solidFill>
+                        <a:srgbClr val="BFBFBF"/>
+                      </a:solidFill>
+                      <a:prstDash val="solid"/>
+                      <a:round/>
+                      <a:headEnd type="none" w="med" len="med"/>
+                      <a:tailEnd type="none" w="med" len="med"/>
+                    </a:lnT>
+                    <a:lnB w="9525" cap="flat" cmpd="sng" algn="ctr">
+                      <a:solidFill>
+                        <a:srgbClr val="BFBFBF"/>
+                      </a:solidFill>
+                      <a:prstDash val="solid"/>
+                      <a:round/>
+                      <a:headEnd type="none" w="med" len="med"/>
+                      <a:tailEnd type="none" w="med" len="med"/>
+                    </a:lnB>
+                  </a:tcPr>
+                </a:tc>
+              </a:tr>
+              <a:tr h="521208">
+                <a:tc>
+                  <a:txBody>
+                    <a:bodyPr/>
+                    <a:lstStyle/>
+                    <a:p>
+                      <a:pPr indent="0" marL="0">
+                        <a:buNone/>
+                      </a:pPr>
+                      <a:r>
+                        <a:rPr lang="en-US" sz="1300" dirty="0">
+                          <a:solidFill>
+                            <a:schemeClr val="tx1"/>
+                          </a:solidFill>
+                        </a:rPr>
+                        <a:t>Proofs</a:t>
+                      </a:r>
+                      <a:endParaRPr lang="en-US" sz="1300" dirty="0"/>
+                    </a:p>
+                  </a:txBody>
+                  <a:tcPr marL="54864" marR="54864" marT="54864" marB="54864" anchor="ctr">
+                    <a:lnL w="9525" cap="flat" cmpd="sng" algn="ctr">
+                      <a:solidFill>
+                        <a:srgbClr val="BFBFBF"/>
+                      </a:solidFill>
+                      <a:prstDash val="solid"/>
+                      <a:round/>
+                      <a:headEnd type="none" w="med" len="med"/>
+                      <a:tailEnd type="none" w="med" len="med"/>
+                    </a:lnL>
+                    <a:lnR w="9525" cap="flat" cmpd="sng" algn="ctr">
+                      <a:solidFill>
+                        <a:srgbClr val="BFBFBF"/>
+                      </a:solidFill>
+                      <a:prstDash val="solid"/>
+                      <a:round/>
+                      <a:headEnd type="none" w="med" len="med"/>
+                      <a:tailEnd type="none" w="med" len="med"/>
+                    </a:lnR>
+                    <a:lnT w="9525" cap="flat" cmpd="sng" algn="ctr">
+                      <a:solidFill>
+                        <a:srgbClr val="BFBFBF"/>
+                      </a:solidFill>
+                      <a:prstDash val="solid"/>
+                      <a:round/>
+                      <a:headEnd type="none" w="med" len="med"/>
+                      <a:tailEnd type="none" w="med" len="med"/>
+                    </a:lnT>
+                    <a:lnB w="9525" cap="flat" cmpd="sng" algn="ctr">
+                      <a:solidFill>
+                        <a:srgbClr val="BFBFBF"/>
+                      </a:solidFill>
+                      <a:prstDash val="solid"/>
+                      <a:round/>
+                      <a:headEnd type="none" w="med" len="med"/>
+                      <a:tailEnd type="none" w="med" len="med"/>
+                    </a:lnB>
+                  </a:tcPr>
+                </a:tc>
+                <a:tc>
+                  <a:txBody>
+                    <a:bodyPr/>
+                    <a:lstStyle/>
+                    <a:p>
+                      <a:pPr indent="0" marL="0">
+                        <a:buNone/>
+                      </a:pPr>
+                      <a:r>
+                        <a:rPr lang="en-US" sz="1300" dirty="0">
+                          <a:solidFill>
+                            <a:schemeClr val="tx1"/>
+                          </a:solidFill>
+                        </a:rPr>
+                        <a:t>Goedel-Prover-V2, DeepSeek-Prover-V2, AlphaGeometry</a:t>
+                      </a:r>
+                      <a:endParaRPr lang="en-US" sz="1300" dirty="0"/>
+                    </a:p>
+                  </a:txBody>
+                  <a:tcPr marL="54864" marR="54864" marT="54864" marB="54864" anchor="ctr">
+                    <a:lnL w="9525" cap="flat" cmpd="sng" algn="ctr">
+                      <a:solidFill>
+                        <a:srgbClr val="BFBFBF"/>
+                      </a:solidFill>
+                      <a:prstDash val="solid"/>
+                      <a:round/>
+                      <a:headEnd type="none" w="med" len="med"/>
+                      <a:tailEnd type="none" w="med" len="med"/>
+                    </a:lnL>
+                    <a:lnR w="9525" cap="flat" cmpd="sng" algn="ctr">
+                      <a:solidFill>
+                        <a:srgbClr val="BFBFBF"/>
+                      </a:solidFill>
+                      <a:prstDash val="solid"/>
+                      <a:round/>
+                      <a:headEnd type="none" w="med" len="med"/>
+                      <a:tailEnd type="none" w="med" len="med"/>
+                    </a:lnR>
+                    <a:lnT w="9525" cap="flat" cmpd="sng" algn="ctr">
+                      <a:solidFill>
+                        <a:srgbClr val="BFBFBF"/>
+                      </a:solidFill>
+                      <a:prstDash val="solid"/>
+                      <a:round/>
+                      <a:headEnd type="none" w="med" len="med"/>
+                      <a:tailEnd type="none" w="med" len="med"/>
+                    </a:lnT>
+                    <a:lnB w="9525" cap="flat" cmpd="sng" algn="ctr">
+                      <a:solidFill>
+                        <a:srgbClr val="BFBFBF"/>
+                      </a:solidFill>
+                      <a:prstDash val="solid"/>
+                      <a:round/>
+                      <a:headEnd type="none" w="med" len="med"/>
+                      <a:tailEnd type="none" w="med" len="med"/>
+                    </a:lnB>
+                  </a:tcPr>
+                </a:tc>
+                <a:tc>
+                  <a:txBody>
+                    <a:bodyPr/>
+                    <a:lstStyle/>
+                    <a:p>
+                      <a:pPr indent="0" marL="0">
+                        <a:buNone/>
+                      </a:pPr>
+                      <a:r>
+                        <a:rPr lang="en-US" sz="1300" dirty="0">
+                          <a:solidFill>
+                            <a:srgbClr val="38761D"/>
+                          </a:solidFill>
+                        </a:rPr>
+                        <a:t>facts and checks do not carry over: use a specialized prover</a:t>
+                      </a:r>
+                      <a:endParaRPr lang="en-US" sz="1300" dirty="0"/>
+                    </a:p>
+                  </a:txBody>
+                  <a:tcPr marL="54864" marR="54864" marT="54864" marB="54864" anchor="ctr">
+                    <a:lnL w="9525" cap="flat" cmpd="sng" algn="ctr">
+                      <a:solidFill>
+                        <a:srgbClr val="BFBFBF"/>
+                      </a:solidFill>
+                      <a:prstDash val="solid"/>
+                      <a:round/>
+                      <a:headEnd type="none" w="med" len="med"/>
+                      <a:tailEnd type="none" w="med" len="med"/>
+                    </a:lnL>
+                    <a:lnR w="9525" cap="flat" cmpd="sng" algn="ctr">
+                      <a:solidFill>
+                        <a:srgbClr val="BFBFBF"/>
+                      </a:solidFill>
+                      <a:prstDash val="solid"/>
+                      <a:round/>
+                      <a:headEnd type="none" w="med" len="med"/>
+                      <a:tailEnd type="none" w="med" len="med"/>
+                    </a:lnR>
+                    <a:lnT w="9525" cap="flat" cmpd="sng" algn="ctr">
+                      <a:solidFill>
+                        <a:srgbClr val="BFBFBF"/>
+                      </a:solidFill>
+                      <a:prstDash val="solid"/>
+                      <a:round/>
+                      <a:headEnd type="none" w="med" len="med"/>
+                      <a:tailEnd type="none" w="med" len="med"/>
+                    </a:lnT>
+                    <a:lnB w="9525" cap="flat" cmpd="sng" algn="ctr">
+                      <a:solidFill>
+                        <a:srgbClr val="BFBFBF"/>
+                      </a:solidFill>
+                      <a:prstDash val="solid"/>
+                      <a:round/>
+                      <a:headEnd type="none" w="med" len="med"/>
+                      <a:tailEnd type="none" w="med" len="med"/>
+                    </a:lnB>
+                  </a:tcPr>
+                </a:tc>
+              </a:tr>
+            </a:tbl>
+          </a:graphicData>
+        </a:graphic>
+      </p:graphicFrame>
+      <p:sp>
+        <p:nvSpPr>
+          <p:cNvPr id="25" name="Slide Number Placeholder 0"/>
+          <p:cNvSpPr>
+            <a:spLocks noGrp="1"/>
+          </p:cNvSpPr>
+          <p:nvPr>
+            <p:ph type="sldNum" sz="quarter" idx="4294967295"/>
+          </p:nvPr>
+        </p:nvSpPr>
+        <p:spPr>
+          <a:xfrm>
+            <a:off x="11155680" y="6355080"/>
+            <a:ext cx="731520" cy="320040"/>
+          </a:xfrm>
+          <a:prstGeom prst="rect">
+            <a:avLst/>
+          </a:prstGeom>
+          <a:extLst>
+            <a:ext uri="{C572A759-6A51-4108-AA02-DFA0A04FC94B}">
+              <ma14:wrappingTextBoxFlag xmlns:ma14="http://schemas.microsoft.com/office/mac/drawingml/2011/main" val="0"/>
+            </a:ext>
+          </a:extLst>
+        </p:spPr>
+        <p:txBody>
+          <a:bodyPr/>
+          <a:lstStyle>
+            <a:lvl1pPr>
+              <a:defRPr sz="1200">
+                <a:solidFill>
+                  <a:srgbClr val="8C8C8C"/>
+                </a:solidFill>
+              </a:defRPr>
+            </a:lvl1pPr>
+          </a:lstStyle>
+          <a:p>
+            <a:pPr algn="r"/>
+            <a:fld id="{F7021451-1387-4CA6-816F-3879F97B5CBC}" type="slidenum">
+              <a:rPr b="0" lang="en-US"/>
+              <a:t>16</a:t>
+            </a:fld>
+            <a:endParaRPr lang="en-US"/>
+          </a:p>
+        </p:txBody>
+      </p:sp>
+    </p:spTree>
+  </p:cSld>
+  <p:clrMapOvr>
+    <a:masterClrMapping/>
+  </p:clrMapOvr>
+</p:sld>
+</file>
+
+<file path=ppt/slides/slide17.xml><?xml version="1.0" encoding="utf-8"?>
+<p:sld xmlns:a="http://schemas.openxmlformats.org/drawingml/2006/main" xmlns:r="http://schemas.openxmlformats.org/officeDocument/2006/relationships" xmlns:p="http://schemas.openxmlformats.org/presentationml/2006/main">
+  <p:cSld name="Slide 17">
+    <p:spTree>
+      <p:nvGrpSpPr>
+        <p:cNvPr id="1" name=""/>
+        <p:cNvGrpSpPr/>
+        <p:nvPr/>
+      </p:nvGrpSpPr>
+      <p:grpSpPr>
+        <a:xfrm>
+          <a:off x="0" y="0"/>
+          <a:ext cx="0" cy="0"/>
+          <a:chOff x="0" y="0"/>
+          <a:chExt cx="0" cy="0"/>
+        </a:xfrm>
+      </p:grpSpPr>
+      <p:sp>
+        <p:nvSpPr>
+          <p:cNvPr id="2" name="Text 0"/>
+          <p:cNvSpPr/>
+          <p:nvPr>
+            <p:ph idx="100" type="title" hasCustomPrompt="1"/>
+          </p:nvPr>
+        </p:nvSpPr>
+        <p:spPr>
+          <a:xfrm>
+            <a:off x="548640" y="274320"/>
+            <a:ext cx="11064240" cy="914400"/>
+          </a:xfrm>
+          <a:prstGeom prst="rect">
+            <a:avLst/>
+          </a:prstGeom>
+          <a:noFill/>
+          <a:ln/>
+        </p:spPr>
+        <p:txBody>
+          <a:bodyPr wrap="square" rtlCol="0" anchor="ctr"/>
+          <a:lstStyle/>
+          <a:p>
+            <a:pPr algn="l" indent="0" marL="0">
+              <a:buNone/>
+            </a:pPr>
+            <a:r>
+              <a:rPr lang="en-US" sz="3600" dirty="0">
+                <a:solidFill>
+                  <a:schemeClr val="tx1"/>
+                </a:solidFill>
+              </a:rPr>
+              <a:t>Numbers reported in papers, next to ours</a:t>
+            </a:r>
+            <a:endParaRPr lang="en-US" sz="3600" dirty="0"/>
+          </a:p>
+        </p:txBody>
+      </p:sp>
+      <p:graphicFrame>
+        <p:nvGraphicFramePr>
+          <p:cNvPr id="18" name="Table 0"/>
+          <p:cNvGraphicFramePr>
+            <a:graphicFrameLocks noGrp="1"/>
+          </p:cNvGraphicFramePr>
+          <p:nvPr>
+            <p:extLst>
+              <p:ext uri="{D42A27DB-BD31-4B8C-83A1-F6EECF244321}">
+                <p14:modId xmlns:p14="http://schemas.microsoft.com/office/powerpoint/2010/main" val="1579011935"/>
+              </p:ext>
+            </p:extLst>
+          </p:nvPr>
+        </p:nvGraphicFramePr>
+        <p:xfrm>
+          <a:off x="548640" y="1371600"/>
+          <a:ext cx="11064240" cy="914400"/>
+        </p:xfrm>
+        <a:graphic>
+          <a:graphicData uri="http://schemas.openxmlformats.org/drawingml/2006/table">
+            <a:tbl>
+              <a:tblPr/>
+              <a:tblGrid>
+                <a:gridCol w="2194560"/>
+                <a:gridCol w="4572000"/>
+                <a:gridCol w="4297680"/>
+              </a:tblGrid>
+              <a:tr h="457200">
+                <a:tc>
+                  <a:txBody>
+                    <a:bodyPr/>
+                    <a:lstStyle/>
+                    <a:p>
+                      <a:pPr indent="0" marL="0">
+                        <a:buNone/>
+                      </a:pPr>
+                      <a:r>
+                        <a:rPr lang="en-US" sz="1500" b="1" dirty="0">
+                          <a:solidFill>
+                            <a:srgbClr val="FFFFFF"/>
+                          </a:solidFill>
+                        </a:rPr>
+                        <a:t>Benchmark</a:t>
+                      </a:r>
+                      <a:endParaRPr lang="en-US" sz="1500" dirty="0"/>
+                    </a:p>
+                  </a:txBody>
+                  <a:tcPr marL="54864" marR="54864" marT="54864" marB="54864" anchor="ctr">
+                    <a:lnL w="9525" cap="flat" cmpd="sng" algn="ctr">
+                      <a:solidFill>
+                        <a:srgbClr val="BFBFBF"/>
+                      </a:solidFill>
+                      <a:prstDash val="solid"/>
+                      <a:round/>
+                      <a:headEnd type="none" w="med" len="med"/>
+                      <a:tailEnd type="none" w="med" len="med"/>
+                    </a:lnL>
+                    <a:lnR w="9525" cap="flat" cmpd="sng" algn="ctr">
+                      <a:solidFill>
+                        <a:srgbClr val="BFBFBF"/>
+                      </a:solidFill>
+                      <a:prstDash val="solid"/>
+                      <a:round/>
+                      <a:headEnd type="none" w="med" len="med"/>
+                      <a:tailEnd type="none" w="med" len="med"/>
+                    </a:lnR>
+                    <a:lnT w="9525" cap="flat" cmpd="sng" algn="ctr">
+                      <a:solidFill>
+                        <a:srgbClr val="BFBFBF"/>
+                      </a:solidFill>
+                      <a:prstDash val="solid"/>
+                      <a:round/>
+                      <a:headEnd type="none" w="med" len="med"/>
+                      <a:tailEnd type="none" w="med" len="med"/>
+                    </a:lnT>
+                    <a:lnB w="9525" cap="flat" cmpd="sng" algn="ctr">
+                      <a:solidFill>
+                        <a:srgbClr val="BFBFBF"/>
+                      </a:solidFill>
+                      <a:prstDash val="solid"/>
+                      <a:round/>
+                      <a:headEnd type="none" w="med" len="med"/>
+                      <a:tailEnd type="none" w="med" len="med"/>
+                    </a:lnB>
+                    <a:solidFill>
+                      <a:srgbClr val="4472C4"/>
+                    </a:solidFill>
+                  </a:tcPr>
+                </a:tc>
+                <a:tc>
+                  <a:txBody>
+                    <a:bodyPr/>
+                    <a:lstStyle/>
+                    <a:p>
+                      <a:pPr indent="0" marL="0">
+                        <a:buNone/>
+                      </a:pPr>
+                      <a:r>
+                        <a:rPr lang="en-US" sz="1500" b="1" dirty="0">
+                          <a:solidFill>
+                            <a:srgbClr val="FFFFFF"/>
+                          </a:solidFill>
+                        </a:rPr>
+                        <a:t>Reported in the paper or model card</a:t>
+                      </a:r>
+                      <a:endParaRPr lang="en-US" sz="1500" dirty="0"/>
+                    </a:p>
+                  </a:txBody>
+                  <a:tcPr marL="54864" marR="54864" marT="54864" marB="54864" anchor="ctr">
+                    <a:lnL w="9525" cap="flat" cmpd="sng" algn="ctr">
+                      <a:solidFill>
+                        <a:srgbClr val="BFBFBF"/>
+                      </a:solidFill>
+                      <a:prstDash val="solid"/>
+                      <a:round/>
+                      <a:headEnd type="none" w="med" len="med"/>
+                      <a:tailEnd type="none" w="med" len="med"/>
+                    </a:lnL>
+                    <a:lnR w="9525" cap="flat" cmpd="sng" algn="ctr">
+                      <a:solidFill>
+                        <a:srgbClr val="BFBFBF"/>
+                      </a:solidFill>
+                      <a:prstDash val="solid"/>
+                      <a:round/>
+                      <a:headEnd type="none" w="med" len="med"/>
+                      <a:tailEnd type="none" w="med" len="med"/>
+                    </a:lnR>
+                    <a:lnT w="9525" cap="flat" cmpd="sng" algn="ctr">
+                      <a:solidFill>
+                        <a:srgbClr val="BFBFBF"/>
+                      </a:solidFill>
+                      <a:prstDash val="solid"/>
+                      <a:round/>
+                      <a:headEnd type="none" w="med" len="med"/>
+                      <a:tailEnd type="none" w="med" len="med"/>
+                    </a:lnT>
+                    <a:lnB w="9525" cap="flat" cmpd="sng" algn="ctr">
+                      <a:solidFill>
+                        <a:srgbClr val="BFBFBF"/>
+                      </a:solidFill>
+                      <a:prstDash val="solid"/>
+                      <a:round/>
+                      <a:headEnd type="none" w="med" len="med"/>
+                      <a:tailEnd type="none" w="med" len="med"/>
+                    </a:lnB>
+                    <a:solidFill>
+                      <a:srgbClr val="4472C4"/>
+                    </a:solidFill>
+                  </a:tcPr>
+                </a:tc>
+                <a:tc>
+                  <a:txBody>
+                    <a:bodyPr/>
+                    <a:lstStyle/>
+                    <a:p>
+                      <a:pPr indent="0" marL="0">
+                        <a:buNone/>
+                      </a:pPr>
+                      <a:r>
+                        <a:rPr lang="en-US" sz="1500" b="1" dirty="0">
+                          <a:solidFill>
+                            <a:srgbClr val="FFFFFF"/>
+                          </a:solidFill>
+                        </a:rPr>
+                        <a:t>Ours</a:t>
+                      </a:r>
+                      <a:endParaRPr lang="en-US" sz="1500" dirty="0"/>
+                    </a:p>
+                  </a:txBody>
+                  <a:tcPr marL="54864" marR="54864" marT="54864" marB="54864" anchor="ctr">
+                    <a:lnL w="9525" cap="flat" cmpd="sng" algn="ctr">
+                      <a:solidFill>
+                        <a:srgbClr val="BFBFBF"/>
+                      </a:solidFill>
+                      <a:prstDash val="solid"/>
+                      <a:round/>
+                      <a:headEnd type="none" w="med" len="med"/>
+                      <a:tailEnd type="none" w="med" len="med"/>
+                    </a:lnL>
+                    <a:lnR w="9525" cap="flat" cmpd="sng" algn="ctr">
+                      <a:solidFill>
+                        <a:srgbClr val="BFBFBF"/>
+                      </a:solidFill>
+                      <a:prstDash val="solid"/>
+                      <a:round/>
+                      <a:headEnd type="none" w="med" len="med"/>
+                      <a:tailEnd type="none" w="med" len="med"/>
+                    </a:lnR>
+                    <a:lnT w="9525" cap="flat" cmpd="sng" algn="ctr">
+                      <a:solidFill>
+                        <a:srgbClr val="BFBFBF"/>
+                      </a:solidFill>
+                      <a:prstDash val="solid"/>
+                      <a:round/>
+                      <a:headEnd type="none" w="med" len="med"/>
+                      <a:tailEnd type="none" w="med" len="med"/>
+                    </a:lnT>
+                    <a:lnB w="9525" cap="flat" cmpd="sng" algn="ctr">
+                      <a:solidFill>
+                        <a:srgbClr val="BFBFBF"/>
+                      </a:solidFill>
+                      <a:prstDash val="solid"/>
+                      <a:round/>
+                      <a:headEnd type="none" w="med" len="med"/>
+                      <a:tailEnd type="none" w="med" len="med"/>
+                    </a:lnB>
+                    <a:solidFill>
+                      <a:srgbClr val="4472C4"/>
+                    </a:solidFill>
+                  </a:tcPr>
+                </a:tc>
+              </a:tr>
+              <a:tr h="1188720">
+                <a:tc>
+                  <a:txBody>
+                    <a:bodyPr/>
+                    <a:lstStyle/>
+                    <a:p>
+                      <a:pPr indent="0" marL="0">
+                        <a:buNone/>
+                      </a:pPr>
+                      <a:r>
+                        <a:rPr lang="en-US" sz="1500" dirty="0">
+                          <a:solidFill>
+                            <a:schemeClr val="tx1"/>
+                          </a:solidFill>
+                        </a:rPr>
+                        <a:t>MAMO Easy / Complex</a:t>
+                      </a:r>
+                      <a:endParaRPr lang="en-US" sz="1500" dirty="0"/>
+                    </a:p>
+                  </a:txBody>
+                  <a:tcPr marL="54864" marR="54864" marT="54864" marB="54864" anchor="ctr">
+                    <a:lnL w="9525" cap="flat" cmpd="sng" algn="ctr">
+                      <a:solidFill>
+                        <a:srgbClr val="BFBFBF"/>
+                      </a:solidFill>
+                      <a:prstDash val="solid"/>
+                      <a:round/>
+                      <a:headEnd type="none" w="med" len="med"/>
+                      <a:tailEnd type="none" w="med" len="med"/>
+                    </a:lnL>
+                    <a:lnR w="9525" cap="flat" cmpd="sng" algn="ctr">
+                      <a:solidFill>
+                        <a:srgbClr val="BFBFBF"/>
+                      </a:solidFill>
+                      <a:prstDash val="solid"/>
+                      <a:round/>
+                      <a:headEnd type="none" w="med" len="med"/>
+                      <a:tailEnd type="none" w="med" len="med"/>
+                    </a:lnR>
+                    <a:lnT w="9525" cap="flat" cmpd="sng" algn="ctr">
+                      <a:solidFill>
+                        <a:srgbClr val="BFBFBF"/>
+                      </a:solidFill>
+                      <a:prstDash val="solid"/>
+                      <a:round/>
+                      <a:headEnd type="none" w="med" len="med"/>
+                      <a:tailEnd type="none" w="med" len="med"/>
+                    </a:lnT>
+                    <a:lnB w="9525" cap="flat" cmpd="sng" algn="ctr">
+                      <a:solidFill>
+                        <a:srgbClr val="BFBFBF"/>
+                      </a:solidFill>
+                      <a:prstDash val="solid"/>
+                      <a:round/>
+                      <a:headEnd type="none" w="med" len="med"/>
+                      <a:tailEnd type="none" w="med" len="med"/>
+                    </a:lnB>
+                  </a:tcPr>
+                </a:tc>
+                <a:tc>
+                  <a:txBody>
+                    <a:bodyPr/>
+                    <a:lstStyle/>
+                    <a:p>
+                      <a:pPr indent="0" marL="0">
+                        <a:buNone/>
+                      </a:pPr>
+                      <a:r>
+                        <a:rPr lang="en-US" sz="1500" dirty="0">
+                          <a:solidFill>
+                            <a:schemeClr val="tx1"/>
+                          </a:solidFill>
+                        </a:rPr>
+                        <a:t>ORLM-LLaMA-3-8B 82.3 / 37.4% (fine-tuned)</a:t>
+                      </a:r>
+                      <a:endParaRPr lang="en-US" sz="1500" dirty="0"/>
+                    </a:p>
+                    <a:p>
+                      <a:pPr indent="0" marL="0">
+                        <a:buNone/>
+                      </a:pPr>
+                      <a:r>
+                        <a:rPr lang="en-US" sz="1500" dirty="0">
+                          <a:solidFill>
+                            <a:schemeClr val="tx1"/>
+                          </a:solidFill>
+                        </a:rPr>
+                        <a:t>STORM-Qwen3-4B 86.3 / 70.3% (SFT + RL)</a:t>
+                      </a:r>
+                      <a:endParaRPr lang="en-US" sz="1500" dirty="0"/>
+                    </a:p>
+                    <a:p>
+                      <a:pPr indent="0" marL="0">
+                        <a:buNone/>
+                      </a:pPr>
+                      <a:r>
+                        <a:rPr lang="en-US" sz="1500" dirty="0">
+                          <a:solidFill>
+                            <a:schemeClr val="tx1"/>
+                          </a:solidFill>
+                        </a:rPr>
+                        <a:t>OptiSkill with frontier models 90.8–94.3 / 56.8–64.0%</a:t>
+                      </a:r>
+                      <a:endParaRPr lang="en-US" sz="1500" dirty="0"/>
+                    </a:p>
+                  </a:txBody>
+                  <a:tcPr marL="54864" marR="54864" marT="54864" marB="54864" anchor="ctr">
+                    <a:lnL w="9525" cap="flat" cmpd="sng" algn="ctr">
+                      <a:solidFill>
+                        <a:srgbClr val="BFBFBF"/>
+                      </a:solidFill>
+                      <a:prstDash val="solid"/>
+                      <a:round/>
+                      <a:headEnd type="none" w="med" len="med"/>
+                      <a:tailEnd type="none" w="med" len="med"/>
+                    </a:lnL>
+                    <a:lnR w="9525" cap="flat" cmpd="sng" algn="ctr">
+                      <a:solidFill>
+                        <a:srgbClr val="BFBFBF"/>
+                      </a:solidFill>
+                      <a:prstDash val="solid"/>
+                      <a:round/>
+                      <a:headEnd type="none" w="med" len="med"/>
+                      <a:tailEnd type="none" w="med" len="med"/>
+                    </a:lnR>
+                    <a:lnT w="9525" cap="flat" cmpd="sng" algn="ctr">
+                      <a:solidFill>
+                        <a:srgbClr val="BFBFBF"/>
+                      </a:solidFill>
+                      <a:prstDash val="solid"/>
+                      <a:round/>
+                      <a:headEnd type="none" w="med" len="med"/>
+                      <a:tailEnd type="none" w="med" len="med"/>
+                    </a:lnT>
+                    <a:lnB w="9525" cap="flat" cmpd="sng" algn="ctr">
+                      <a:solidFill>
+                        <a:srgbClr val="BFBFBF"/>
+                      </a:solidFill>
+                      <a:prstDash val="solid"/>
+                      <a:round/>
+                      <a:headEnd type="none" w="med" len="med"/>
+                      <a:tailEnd type="none" w="med" len="med"/>
+                    </a:lnB>
+                  </a:tcPr>
+                </a:tc>
+                <a:tc>
+                  <a:txBody>
+                    <a:bodyPr/>
+                    <a:lstStyle/>
+                    <a:p>
+                      <a:pPr indent="0" marL="0">
+                        <a:buNone/>
+                      </a:pPr>
+                      <a:r>
+                        <a:rPr lang="en-US" sz="1500" b="1" dirty="0">
+                          <a:solidFill>
+                            <a:srgbClr val="38761D"/>
+                          </a:solidFill>
+                        </a:rPr>
+                        <a:t>no training: Qwen3-14B 82.8 / 37.4%, gpt-oss-20b 85.6 / 57.8%</a:t>
+                      </a:r>
+                      <a:endParaRPr lang="en-US" sz="1500" dirty="0"/>
+                    </a:p>
+                    <a:p>
+                      <a:pPr indent="0" marL="0">
+                        <a:buNone/>
+                      </a:pPr>
+                      <a:r>
+                        <a:rPr lang="en-US" sz="1500" b="1" dirty="0">
+                          <a:solidFill>
+                            <a:srgbClr val="38761D"/>
+                          </a:solidFill>
+                        </a:rPr>
+                        <a:t>ORLM-8B in our harness: 80.5 / 35.5%</a:t>
+                      </a:r>
+                      <a:endParaRPr lang="en-US" sz="1500" dirty="0"/>
+                    </a:p>
+                  </a:txBody>
+                  <a:tcPr marL="54864" marR="54864" marT="54864" marB="54864" anchor="ctr">
+                    <a:lnL w="9525" cap="flat" cmpd="sng" algn="ctr">
+                      <a:solidFill>
+                        <a:srgbClr val="BFBFBF"/>
+                      </a:solidFill>
+                      <a:prstDash val="solid"/>
+                      <a:round/>
+                      <a:headEnd type="none" w="med" len="med"/>
+                      <a:tailEnd type="none" w="med" len="med"/>
+                    </a:lnL>
+                    <a:lnR w="9525" cap="flat" cmpd="sng" algn="ctr">
+                      <a:solidFill>
+                        <a:srgbClr val="BFBFBF"/>
+                      </a:solidFill>
+                      <a:prstDash val="solid"/>
+                      <a:round/>
+                      <a:headEnd type="none" w="med" len="med"/>
+                      <a:tailEnd type="none" w="med" len="med"/>
+                    </a:lnR>
+                    <a:lnT w="9525" cap="flat" cmpd="sng" algn="ctr">
+                      <a:solidFill>
+                        <a:srgbClr val="BFBFBF"/>
+                      </a:solidFill>
+                      <a:prstDash val="solid"/>
+                      <a:round/>
+                      <a:headEnd type="none" w="med" len="med"/>
+                      <a:tailEnd type="none" w="med" len="med"/>
+                    </a:lnT>
+                    <a:lnB w="9525" cap="flat" cmpd="sng" algn="ctr">
+                      <a:solidFill>
+                        <a:srgbClr val="BFBFBF"/>
+                      </a:solidFill>
+                      <a:prstDash val="solid"/>
+                      <a:round/>
+                      <a:headEnd type="none" w="med" len="med"/>
+                      <a:tailEnd type="none" w="med" len="med"/>
+                    </a:lnB>
+                  </a:tcPr>
+                </a:tc>
+              </a:tr>
+              <a:tr h="548640">
+                <a:tc>
+                  <a:txBody>
+                    <a:bodyPr/>
+                    <a:lstStyle/>
+                    <a:p>
+                      <a:pPr indent="0" marL="0">
+                        <a:buNone/>
+                      </a:pPr>
+                      <a:r>
+                        <a:rPr lang="en-US" sz="1500" dirty="0">
+                          <a:solidFill>
+                            <a:schemeClr val="tx1"/>
+                          </a:solidFill>
+                        </a:rPr>
+                        <a:t>miniF2F, 32 tries</a:t>
+                      </a:r>
+                      <a:endParaRPr lang="en-US" sz="1500" dirty="0"/>
+                    </a:p>
+                  </a:txBody>
+                  <a:tcPr marL="54864" marR="54864" marT="54864" marB="54864" anchor="ctr">
+                    <a:lnL w="9525" cap="flat" cmpd="sng" algn="ctr">
+                      <a:solidFill>
+                        <a:srgbClr val="BFBFBF"/>
+                      </a:solidFill>
+                      <a:prstDash val="solid"/>
+                      <a:round/>
+                      <a:headEnd type="none" w="med" len="med"/>
+                      <a:tailEnd type="none" w="med" len="med"/>
+                    </a:lnL>
+                    <a:lnR w="9525" cap="flat" cmpd="sng" algn="ctr">
+                      <a:solidFill>
+                        <a:srgbClr val="BFBFBF"/>
+                      </a:solidFill>
+                      <a:prstDash val="solid"/>
+                      <a:round/>
+                      <a:headEnd type="none" w="med" len="med"/>
+                      <a:tailEnd type="none" w="med" len="med"/>
+                    </a:lnR>
+                    <a:lnT w="9525" cap="flat" cmpd="sng" algn="ctr">
+                      <a:solidFill>
+                        <a:srgbClr val="BFBFBF"/>
+                      </a:solidFill>
+                      <a:prstDash val="solid"/>
+                      <a:round/>
+                      <a:headEnd type="none" w="med" len="med"/>
+                      <a:tailEnd type="none" w="med" len="med"/>
+                    </a:lnT>
+                    <a:lnB w="9525" cap="flat" cmpd="sng" algn="ctr">
+                      <a:solidFill>
+                        <a:srgbClr val="BFBFBF"/>
+                      </a:solidFill>
+                      <a:prstDash val="solid"/>
+                      <a:round/>
+                      <a:headEnd type="none" w="med" len="med"/>
+                      <a:tailEnd type="none" w="med" len="med"/>
+                    </a:lnB>
+                  </a:tcPr>
+                </a:tc>
+                <a:tc>
+                  <a:txBody>
+                    <a:bodyPr/>
+                    <a:lstStyle/>
+                    <a:p>
+                      <a:pPr indent="0" marL="0">
+                        <a:buNone/>
+                      </a:pPr>
+                      <a:r>
+                        <a:rPr lang="en-US" sz="1500" dirty="0">
+                          <a:solidFill>
+                            <a:schemeClr val="tx1"/>
+                          </a:solidFill>
+                        </a:rPr>
+                        <a:t>Goedel-Prover-V2-8B 84.6%</a:t>
+                      </a:r>
+                      <a:endParaRPr lang="en-US" sz="1500" dirty="0"/>
+                    </a:p>
+                  </a:txBody>
+                  <a:tcPr marL="54864" marR="54864" marT="54864" marB="54864" anchor="ctr">
+                    <a:lnL w="9525" cap="flat" cmpd="sng" algn="ctr">
+                      <a:solidFill>
+                        <a:srgbClr val="BFBFBF"/>
+                      </a:solidFill>
+                      <a:prstDash val="solid"/>
+                      <a:round/>
+                      <a:headEnd type="none" w="med" len="med"/>
+                      <a:tailEnd type="none" w="med" len="med"/>
+                    </a:lnL>
+                    <a:lnR w="9525" cap="flat" cmpd="sng" algn="ctr">
+                      <a:solidFill>
+                        <a:srgbClr val="BFBFBF"/>
+                      </a:solidFill>
+                      <a:prstDash val="solid"/>
+                      <a:round/>
+                      <a:headEnd type="none" w="med" len="med"/>
+                      <a:tailEnd type="none" w="med" len="med"/>
+                    </a:lnR>
+                    <a:lnT w="9525" cap="flat" cmpd="sng" algn="ctr">
+                      <a:solidFill>
+                        <a:srgbClr val="BFBFBF"/>
+                      </a:solidFill>
+                      <a:prstDash val="solid"/>
+                      <a:round/>
+                      <a:headEnd type="none" w="med" len="med"/>
+                      <a:tailEnd type="none" w="med" len="med"/>
+                    </a:lnT>
+                    <a:lnB w="9525" cap="flat" cmpd="sng" algn="ctr">
+                      <a:solidFill>
+                        <a:srgbClr val="BFBFBF"/>
+                      </a:solidFill>
+                      <a:prstDash val="solid"/>
+                      <a:round/>
+                      <a:headEnd type="none" w="med" len="med"/>
+                      <a:tailEnd type="none" w="med" len="med"/>
+                    </a:lnB>
+                  </a:tcPr>
+                </a:tc>
+                <a:tc>
+                  <a:txBody>
+                    <a:bodyPr/>
+                    <a:lstStyle/>
+                    <a:p>
+                      <a:pPr indent="0" marL="0">
+                        <a:buNone/>
+                      </a:pPr>
+                      <a:r>
+                        <a:rPr lang="en-US" sz="1500" b="1" dirty="0">
+                          <a:solidFill>
+                            <a:srgbClr val="38761D"/>
+                          </a:solidFill>
+                        </a:rPr>
+                        <a:t>the same model in our harness: 76.6%</a:t>
+                      </a:r>
+                      <a:endParaRPr lang="en-US" sz="1500" dirty="0"/>
+                    </a:p>
+                  </a:txBody>
+                  <a:tcPr marL="54864" marR="54864" marT="54864" marB="54864" anchor="ctr">
+                    <a:lnL w="9525" cap="flat" cmpd="sng" algn="ctr">
+                      <a:solidFill>
+                        <a:srgbClr val="BFBFBF"/>
+                      </a:solidFill>
+                      <a:prstDash val="solid"/>
+                      <a:round/>
+                      <a:headEnd type="none" w="med" len="med"/>
+                      <a:tailEnd type="none" w="med" len="med"/>
+                    </a:lnL>
+                    <a:lnR w="9525" cap="flat" cmpd="sng" algn="ctr">
+                      <a:solidFill>
+                        <a:srgbClr val="BFBFBF"/>
+                      </a:solidFill>
+                      <a:prstDash val="solid"/>
+                      <a:round/>
+                      <a:headEnd type="none" w="med" len="med"/>
+                      <a:tailEnd type="none" w="med" len="med"/>
+                    </a:lnR>
+                    <a:lnT w="9525" cap="flat" cmpd="sng" algn="ctr">
+                      <a:solidFill>
+                        <a:srgbClr val="BFBFBF"/>
+                      </a:solidFill>
+                      <a:prstDash val="solid"/>
+                      <a:round/>
+                      <a:headEnd type="none" w="med" len="med"/>
+                      <a:tailEnd type="none" w="med" len="med"/>
+                    </a:lnT>
+                    <a:lnB w="9525" cap="flat" cmpd="sng" algn="ctr">
+                      <a:solidFill>
+                        <a:srgbClr val="BFBFBF"/>
+                      </a:solidFill>
+                      <a:prstDash val="solid"/>
+                      <a:round/>
+                      <a:headEnd type="none" w="med" len="med"/>
+                      <a:tailEnd type="none" w="med" len="med"/>
+                    </a:lnB>
+                  </a:tcPr>
+                </a:tc>
+              </a:tr>
+              <a:tr h="548640">
+                <a:tc>
+                  <a:txBody>
+                    <a:bodyPr/>
+                    <a:lstStyle/>
+                    <a:p>
+                      <a:pPr indent="0" marL="0">
+                        <a:buNone/>
+                      </a:pPr>
+                      <a:r>
+                        <a:rPr lang="en-US" sz="1500" dirty="0">
+                          <a:solidFill>
+                            <a:schemeClr val="tx1"/>
+                          </a:solidFill>
+                        </a:rPr>
+                        <a:t>IMO-AG-30 geometry</a:t>
+                      </a:r>
+                      <a:endParaRPr lang="en-US" sz="1500" dirty="0"/>
+                    </a:p>
+                  </a:txBody>
+                  <a:tcPr marL="54864" marR="54864" marT="54864" marB="54864" anchor="ctr">
+                    <a:lnL w="9525" cap="flat" cmpd="sng" algn="ctr">
+                      <a:solidFill>
+                        <a:srgbClr val="BFBFBF"/>
+                      </a:solidFill>
+                      <a:prstDash val="solid"/>
+                      <a:round/>
+                      <a:headEnd type="none" w="med" len="med"/>
+                      <a:tailEnd type="none" w="med" len="med"/>
+                    </a:lnL>
+                    <a:lnR w="9525" cap="flat" cmpd="sng" algn="ctr">
+                      <a:solidFill>
+                        <a:srgbClr val="BFBFBF"/>
+                      </a:solidFill>
+                      <a:prstDash val="solid"/>
+                      <a:round/>
+                      <a:headEnd type="none" w="med" len="med"/>
+                      <a:tailEnd type="none" w="med" len="med"/>
+                    </a:lnR>
+                    <a:lnT w="9525" cap="flat" cmpd="sng" algn="ctr">
+                      <a:solidFill>
+                        <a:srgbClr val="BFBFBF"/>
+                      </a:solidFill>
+                      <a:prstDash val="solid"/>
+                      <a:round/>
+                      <a:headEnd type="none" w="med" len="med"/>
+                      <a:tailEnd type="none" w="med" len="med"/>
+                    </a:lnT>
+                    <a:lnB w="9525" cap="flat" cmpd="sng" algn="ctr">
+                      <a:solidFill>
+                        <a:srgbClr val="BFBFBF"/>
+                      </a:solidFill>
+                      <a:prstDash val="solid"/>
+                      <a:round/>
+                      <a:headEnd type="none" w="med" len="med"/>
+                      <a:tailEnd type="none" w="med" len="med"/>
+                    </a:lnB>
+                  </a:tcPr>
+                </a:tc>
+                <a:tc>
+                  <a:txBody>
+                    <a:bodyPr/>
+                    <a:lstStyle/>
+                    <a:p>
+                      <a:pPr indent="0" marL="0">
+                        <a:buNone/>
+                      </a:pPr>
+                      <a:r>
+                        <a:rPr lang="en-US" sz="1500" dirty="0">
+                          <a:solidFill>
+                            <a:schemeClr val="tx1"/>
+                          </a:solidFill>
+                        </a:rPr>
+                        <a:t>AlphaGeometry 25 of 30; its symbolic engine alone 14</a:t>
+                      </a:r>
+                      <a:endParaRPr lang="en-US" sz="1500" dirty="0"/>
+                    </a:p>
+                  </a:txBody>
+                  <a:tcPr marL="54864" marR="54864" marT="54864" marB="54864" anchor="ctr">
+                    <a:lnL w="9525" cap="flat" cmpd="sng" algn="ctr">
+                      <a:solidFill>
+                        <a:srgbClr val="BFBFBF"/>
+                      </a:solidFill>
+                      <a:prstDash val="solid"/>
+                      <a:round/>
+                      <a:headEnd type="none" w="med" len="med"/>
+                      <a:tailEnd type="none" w="med" len="med"/>
+                    </a:lnL>
+                    <a:lnR w="9525" cap="flat" cmpd="sng" algn="ctr">
+                      <a:solidFill>
+                        <a:srgbClr val="BFBFBF"/>
+                      </a:solidFill>
+                      <a:prstDash val="solid"/>
+                      <a:round/>
+                      <a:headEnd type="none" w="med" len="med"/>
+                      <a:tailEnd type="none" w="med" len="med"/>
+                    </a:lnR>
+                    <a:lnT w="9525" cap="flat" cmpd="sng" algn="ctr">
+                      <a:solidFill>
+                        <a:srgbClr val="BFBFBF"/>
+                      </a:solidFill>
+                      <a:prstDash val="solid"/>
+                      <a:round/>
+                      <a:headEnd type="none" w="med" len="med"/>
+                      <a:tailEnd type="none" w="med" len="med"/>
+                    </a:lnT>
+                    <a:lnB w="9525" cap="flat" cmpd="sng" algn="ctr">
+                      <a:solidFill>
+                        <a:srgbClr val="BFBFBF"/>
+                      </a:solidFill>
+                      <a:prstDash val="solid"/>
+                      <a:round/>
+                      <a:headEnd type="none" w="med" len="med"/>
+                      <a:tailEnd type="none" w="med" len="med"/>
+                    </a:lnB>
+                  </a:tcPr>
+                </a:tc>
+                <a:tc>
+                  <a:txBody>
+                    <a:bodyPr/>
+                    <a:lstStyle/>
+                    <a:p>
+                      <a:pPr indent="0" marL="0">
+                        <a:buNone/>
+                      </a:pPr>
+                      <a:r>
+                        <a:rPr lang="en-US" sz="1500" b="1" dirty="0">
+                          <a:solidFill>
+                            <a:srgbClr val="38761D"/>
+                          </a:solidFill>
+                        </a:rPr>
+                        <a:t>engine alone 12 in our setup; with our models' points 13</a:t>
+                      </a:r>
+                      <a:endParaRPr lang="en-US" sz="1500" dirty="0"/>
+                    </a:p>
+                  </a:txBody>
+                  <a:tcPr marL="54864" marR="54864" marT="54864" marB="54864" anchor="ctr">
+                    <a:lnL w="9525" cap="flat" cmpd="sng" algn="ctr">
+                      <a:solidFill>
+                        <a:srgbClr val="BFBFBF"/>
+                      </a:solidFill>
+                      <a:prstDash val="solid"/>
+                      <a:round/>
+                      <a:headEnd type="none" w="med" len="med"/>
+                      <a:tailEnd type="none" w="med" len="med"/>
+                    </a:lnL>
+                    <a:lnR w="9525" cap="flat" cmpd="sng" algn="ctr">
+                      <a:solidFill>
+                        <a:srgbClr val="BFBFBF"/>
+                      </a:solidFill>
+                      <a:prstDash val="solid"/>
+                      <a:round/>
+                      <a:headEnd type="none" w="med" len="med"/>
+                      <a:tailEnd type="none" w="med" len="med"/>
+                    </a:lnR>
+                    <a:lnT w="9525" cap="flat" cmpd="sng" algn="ctr">
+                      <a:solidFill>
+                        <a:srgbClr val="BFBFBF"/>
+                      </a:solidFill>
+                      <a:prstDash val="solid"/>
+                      <a:round/>
+                      <a:headEnd type="none" w="med" len="med"/>
+                      <a:tailEnd type="none" w="med" len="med"/>
+                    </a:lnT>
+                    <a:lnB w="9525" cap="flat" cmpd="sng" algn="ctr">
+                      <a:solidFill>
+                        <a:srgbClr val="BFBFBF"/>
+                      </a:solidFill>
+                      <a:prstDash val="solid"/>
+                      <a:round/>
+                      <a:headEnd type="none" w="med" len="med"/>
+                      <a:tailEnd type="none" w="med" len="med"/>
+                    </a:lnB>
+                  </a:tcPr>
+                </a:tc>
+              </a:tr>
+            </a:tbl>
+          </a:graphicData>
+        </a:graphic>
+      </p:graphicFrame>
+      <p:sp>
+        <p:nvSpPr>
+          <p:cNvPr id="4" name="Text 1"/>
+          <p:cNvSpPr txBox="1"/>
+          <p:nvPr/>
+        </p:nvSpPr>
+        <p:spPr>
+          <a:xfrm>
+            <a:off x="548640" y="5669280"/>
+            <a:ext cx="11064240" cy="548640"/>
+          </a:xfrm>
+          <a:prstGeom prst="rect">
+            <a:avLst/>
+          </a:prstGeom>
+          <a:noFill/>
+          <a:ln/>
+        </p:spPr>
+        <p:txBody>
+          <a:bodyPr wrap="square" lIns="0" tIns="0" rIns="0" bIns="0" rtlCol="0" anchor="ctr"/>
+          <a:lstStyle/>
+          <a:p>
+            <a:pPr algn="ctr" indent="0" marL="0">
+              <a:buNone/>
+            </a:pPr>
+            <a:r>
+              <a:rPr lang="en-US" sz="2000" dirty="0">
+                <a:solidFill>
+                  <a:schemeClr val="tx1"/>
+                </a:solidFill>
+              </a:rPr>
+              <a:t>Different harnesses and graders: for orientation only</a:t>
+            </a:r>
+            <a:endParaRPr lang="en-US" sz="2000" dirty="0"/>
+          </a:p>
+        </p:txBody>
+      </p:sp>
+      <p:sp>
+        <p:nvSpPr>
+          <p:cNvPr id="25" name="Slide Number Placeholder 0"/>
+          <p:cNvSpPr>
+            <a:spLocks noGrp="1"/>
+          </p:cNvSpPr>
+          <p:nvPr>
+            <p:ph type="sldNum" sz="quarter" idx="4294967295"/>
+          </p:nvPr>
+        </p:nvSpPr>
+        <p:spPr>
+          <a:xfrm>
+            <a:off x="11155680" y="6355080"/>
+            <a:ext cx="731520" cy="320040"/>
+          </a:xfrm>
+          <a:prstGeom prst="rect">
+            <a:avLst/>
+          </a:prstGeom>
+          <a:extLst>
+            <a:ext uri="{C572A759-6A51-4108-AA02-DFA0A04FC94B}">
+              <ma14:wrappingTextBoxFlag xmlns:ma14="http://schemas.microsoft.com/office/mac/drawingml/2011/main" val="0"/>
+            </a:ext>
+          </a:extLst>
+        </p:spPr>
+        <p:txBody>
+          <a:bodyPr/>
+          <a:lstStyle>
+            <a:lvl1pPr>
+              <a:defRPr sz="1200">
+                <a:solidFill>
+                  <a:srgbClr val="8C8C8C"/>
+                </a:solidFill>
+              </a:defRPr>
+            </a:lvl1pPr>
+          </a:lstStyle>
+          <a:p>
+            <a:pPr algn="r"/>
+            <a:fld id="{F7021451-1387-4CA6-816F-3879F97B5CBC}" type="slidenum">
+              <a:rPr b="0" lang="en-US"/>
+              <a:t>17</a:t>
+            </a:fld>
+            <a:endParaRPr lang="en-US"/>
+          </a:p>
+        </p:txBody>
+      </p:sp>
+    </p:spTree>
+  </p:cSld>
+  <p:clrMapOvr>
+    <a:masterClrMapping/>
+  </p:clrMapOvr>
+</p:sld>
+</file>
+
+<file path=ppt/slides/slide18.xml><?xml version="1.0" encoding="utf-8"?>
+<p:sld xmlns:a="http://schemas.openxmlformats.org/drawingml/2006/main" xmlns:r="http://schemas.openxmlformats.org/officeDocument/2006/relationships" xmlns:p="http://schemas.openxmlformats.org/presentationml/2006/main">
+  <p:cSld name="Slide 18">
+    <p:spTree>
+      <p:nvGrpSpPr>
+        <p:cNvPr id="1" name=""/>
+        <p:cNvGrpSpPr/>
+        <p:nvPr/>
+      </p:nvGrpSpPr>
+      <p:grpSpPr>
+        <a:xfrm>
+          <a:off x="0" y="0"/>
+          <a:ext cx="0" cy="0"/>
+          <a:chOff x="0" y="0"/>
+          <a:chExt cx="0" cy="0"/>
+        </a:xfrm>
+      </p:grpSpPr>
+      <p:sp>
+        <p:nvSpPr>
+          <p:cNvPr id="2" name="Text 0"/>
+          <p:cNvSpPr/>
+          <p:nvPr>
+            <p:ph idx="100" type="title" hasCustomPrompt="1"/>
+          </p:nvPr>
+        </p:nvSpPr>
+        <p:spPr>
+          <a:xfrm>
+            <a:off x="548640" y="274320"/>
+            <a:ext cx="11064240" cy="914400"/>
+          </a:xfrm>
+          <a:prstGeom prst="rect">
+            <a:avLst/>
+          </a:prstGeom>
+          <a:noFill/>
+          <a:ln/>
+        </p:spPr>
+        <p:txBody>
+          <a:bodyPr wrap="square" rtlCol="0" anchor="ctr"/>
+          <a:lstStyle/>
+          <a:p>
+            <a:pPr algn="l" indent="0" marL="0">
+              <a:buNone/>
+            </a:pPr>
+            <a:r>
+              <a:rPr lang="en-US" sz="3600" dirty="0">
+                <a:solidFill>
+                  <a:schemeClr val="tx1"/>
+                </a:solidFill>
+              </a:rPr>
               <a:t>Where the recipe stops, and what is next</a:t>
             </a:r>
             <a:endParaRPr lang="en-US" sz="3600" dirty="0"/>
@@ -12115,7 +15191,7 @@
             <a:pPr algn="r"/>
             <a:fld id="{F7021451-1387-4CA6-816F-3879F97B5CBC}" type="slidenum">
               <a:rPr b="0" lang="en-US"/>
-              <a:t>16</a:t>
+              <a:t>18</a:t>
             </a:fld>
             <a:endParaRPr lang="en-US"/>
           </a:p>

</xml_diff>

<commit_message>
Talk rebuilt for 5 minutes + 5 minutes of Q&A: 8 slides, ~650-word script, nothing under 14 pt
Problem (programs help, but fail silently; thinking is expensive), what we solve and how hard, two
findings with examples, the method on one problem with the overall results, what is new + plan +
takeaway, and a questions slide indexing 16 extra pages (incl. new "Setup and fairness").

Co-Authored-By: Claude Opus 5.5 (1M context) <noreply@anthropic.com>
</commit_message>
<xml_diff>
--- a/PROPOSAL_slides_full.pptx
+++ b/PROPOSAL_slides_full.pptx
@@ -25,9 +25,10 @@
     <p:sldId id="273" r:id="rId19"/>
     <p:sldId id="274" r:id="rId20"/>
     <p:sldId id="275" r:id="rId21"/>
+    <p:sldId id="276" r:id="rId22"/>
   </p:sldIdLst>
   <p:notesMasterIdLst>
-    <p:notesMasterId r:id="rId22"/>
+    <p:notesMasterId r:id="rId23"/>
   </p:notesMasterIdLst>
   <p:sldSz cx="12192000" cy="6858000"/>
   <p:notesSz cx="6858000" cy="12192000"/>
@@ -126,7 +127,7 @@
   <p:extLst>
     <p:ext uri="{521415D9-36F7-43E2-AB2F-B90AF26B5E84}">
       <p14:sectionLst xmlns:p14="http://schemas.microsoft.com/office/powerpoint/2010/main">
-        <p14:section name="Problem" id="{c2c1e25c-7978-565f-230d-4c4aea7ad792}">
+        <p14:section name="Problem" id="{a510f7ea-ace1-d77b-bcca-910aa462349e}">
           <p14:sldIdLst>
             <p14:sldId id="256"/>
             <p14:sldId id="257"/>
@@ -135,7 +136,7 @@
             <p14:sldId id="260"/>
           </p14:sldIdLst>
         </p14:section>
-        <p14:section name="Findings" id="{c8e9cedc-e9e1-cc6e-0628-2909473ec307}">
+        <p14:section name="Findings" id="{4a05eb01-9a64-d453-4813-19ffa859e914}">
           <p14:sldIdLst>
             <p14:sldId id="261"/>
             <p14:sldId id="262"/>
@@ -147,7 +148,7 @@
             <p14:sldId id="268"/>
           </p14:sldIdLst>
         </p14:section>
-        <p14:section name="Method" id="{c32a1d66-9f0d-e300-5af3-3a26be3a4b55}">
+        <p14:section name="Method" id="{473addb1-b270-a5e1-97ef-dff5d210d164}">
           <p14:sldIdLst>
             <p14:sldId id="269"/>
             <p14:sldId id="270"/>
@@ -155,11 +156,12 @@
             <p14:sldId id="272"/>
             <p14:sldId id="273"/>
             <p14:sldId id="274"/>
+            <p14:sldId id="275"/>
           </p14:sldIdLst>
         </p14:section>
-        <p14:section name="Next" id="{709f7a11-188e-b100-1dcf-415bfbc56d39}">
+        <p14:section name="Next" id="{43ac47c1-ce4c-c20c-dd7f-7c94bf8a370e}">
           <p14:sldIdLst>
-            <p14:sldId id="275"/>
+            <p14:sldId id="276"/>
           </p14:sldIdLst>
         </p14:section>
       </p14:sectionLst>
@@ -2442,7 +2444,7 @@
           <a:p>
             <a:r>
               <a:rPr lang="en-US" dirty="0"/>
-              <a:t>Updated 2026-10-19. Done since the last version: contest geometry and competition math on 24 GB GPUs, Qwen3.6 with the model card settings (headline unchanged), automatic facts and the held-out MAMO test, the policy model, proofs. Older notes: for Lean proofs an invented lemma stands for a missing proof step (similar-name feedback fixes 2.7%, a fresh try 3.2%); for PopQA thinking adds 1.8-5 points at 70-200 times the tokens, only for well-known facts. Checks leak, which caps every policy. Facts were hand-written; BM25 retrieval recovers most of the gain. Next: SIZE-CC (gpt-oss-20b on contest geometry with check-gated escalation), X1-SIZE (competition math for Qwen3-4B/8B/14B), automatic facts, a closed API model, final report.</a:t>
+              <a:t>How we test. Models: open models run locally (Qwen3 1.7B, 4B, 8B, 14B, 32B; Qwen3.6-35B-A3B; gpt-oss-20b and 120b; Goedel-Prover-V2-8B and DeepSeek-Prover-V2-7B for Lean). Benchmarks with exact answers. Every comparison changes one thing, is pre-registered (predictions written before the run, docs/prereg), replicated on 3 seeds, and reports output tokens per problem; published baselines are rerun in the same harness.</a:t>
             </a:r>
             <a:endParaRPr lang="en-US" dirty="0"/>
           </a:p>
@@ -2466,6 +2468,94 @@
             <a:fld id="{F7021451-1387-4CA6-816F-3879F97B5CBC}" type="slidenum">
               <a:rPr lang="en-US"/>
               <a:t>20</a:t>
+            </a:fld>
+            <a:endParaRPr lang="en-US"/>
+          </a:p>
+        </p:txBody>
+      </p:sp>
+    </p:spTree>
+    <p:extLst>
+      <p:ext uri="{BB962C8B-B14F-4D97-AF65-F5344CB8AC3E}">
+        <p14:creationId xmlns:p14="http://schemas.microsoft.com/office/powerpoint/2010/main" val="1024086991"/>
+      </p:ext>
+    </p:extLst>
+  </p:cSld>
+  <p:clrMapOvr>
+    <a:masterClrMapping/>
+  </p:clrMapOvr>
+</p:notes>
+</file>
+
+<file path=ppt/notesSlides/notesSlide21.xml><?xml version="1.0" encoding="utf-8"?>
+<p:notes xmlns:a="http://schemas.openxmlformats.org/drawingml/2006/main" xmlns:r="http://schemas.openxmlformats.org/officeDocument/2006/relationships" xmlns:p="http://schemas.openxmlformats.org/presentationml/2006/main">
+  <p:cSld>
+    <p:spTree>
+      <p:nvGrpSpPr>
+        <p:cNvPr id="1" name=""/>
+        <p:cNvGrpSpPr/>
+        <p:nvPr/>
+      </p:nvGrpSpPr>
+      <p:grpSpPr>
+        <a:xfrm>
+          <a:off x="0" y="0"/>
+          <a:ext cx="0" cy="0"/>
+          <a:chOff x="0" y="0"/>
+          <a:chExt cx="0" cy="0"/>
+        </a:xfrm>
+      </p:grpSpPr>
+      <p:sp>
+        <p:nvSpPr>
+          <p:cNvPr id="2" name="Slide Image Placeholder 1"/>
+          <p:cNvSpPr>
+            <a:spLocks noGrp="1" noRot="1" noChangeAspect="1"/>
+          </p:cNvSpPr>
+          <p:nvPr>
+            <p:ph type="sldImg"/>
+          </p:nvPr>
+        </p:nvSpPr>
+        <p:spPr/>
+      </p:sp>
+      <p:sp>
+        <p:nvSpPr>
+          <p:cNvPr id="3" name="Notes Placeholder 2"/>
+          <p:cNvSpPr>
+            <a:spLocks noGrp="1"/>
+          </p:cNvSpPr>
+          <p:nvPr>
+            <p:ph type="body" idx="1"/>
+          </p:nvPr>
+        </p:nvSpPr>
+        <p:spPr/>
+        <p:txBody>
+          <a:bodyPr/>
+          <a:lstStyle/>
+          <a:p>
+            <a:r>
+              <a:rPr lang="en-US" dirty="0"/>
+              <a:t>Updated 2026-10-19. Done since the last version: contest geometry and competition math on 24 GB GPUs, Qwen3.6 with the model card settings (headline unchanged), automatic facts and the held-out MAMO test, the policy model, proofs. Older notes: for Lean proofs an invented lemma stands for a missing proof step (similar-name feedback fixes 2.7%, a fresh try 3.2%); for PopQA thinking adds 1.8-5 points at 70-200 times the tokens, only for well-known facts. Checks leak, which caps every policy. Facts were hand-written; BM25 retrieval recovers most of the gain. Next: SIZE-CC (gpt-oss-20b on contest geometry with check-gated escalation), X1-SIZE (competition math for Qwen3-4B/8B/14B), automatic facts, a closed API model, final report.</a:t>
+            </a:r>
+            <a:endParaRPr lang="en-US" dirty="0"/>
+          </a:p>
+        </p:txBody>
+      </p:sp>
+      <p:sp>
+        <p:nvSpPr>
+          <p:cNvPr id="4" name="Slide Number Placeholder 3"/>
+          <p:cNvSpPr>
+            <a:spLocks noGrp="1"/>
+          </p:cNvSpPr>
+          <p:nvPr>
+            <p:ph type="sldNum" sz="quarter" idx="10"/>
+          </p:nvPr>
+        </p:nvSpPr>
+        <p:spPr/>
+        <p:txBody>
+          <a:bodyPr/>
+          <a:lstStyle/>
+          <a:p>
+            <a:fld id="{F7021451-1387-4CA6-816F-3879F97B5CBC}" type="slidenum">
+              <a:rPr lang="en-US"/>
+              <a:t>21</a:t>
             </a:fld>
             <a:endParaRPr lang="en-US"/>
           </a:p>
@@ -20090,7 +20180,7 @@
                   <a:schemeClr val="tx1"/>
                 </a:solidFill>
               </a:rPr>
-              <a:t>Where the recipe stops, and what is next</a:t>
+              <a:t>Setup and fairness</a:t>
             </a:r>
             <a:endParaRPr lang="en-US" sz="3600" dirty="0"/>
           </a:p>
@@ -20098,18 +20188,18 @@
       </p:sp>
       <p:sp>
         <p:nvSpPr>
-          <p:cNvPr id="3" name="Where it stops"/>
+          <p:cNvPr id="3" name="Models"/>
           <p:cNvSpPr/>
           <p:nvPr/>
         </p:nvSpPr>
         <p:spPr>
           <a:xfrm>
-            <a:off x="548640" y="1417320"/>
-            <a:ext cx="5440680" cy="3749040"/>
+            <a:off x="548640" y="1280160"/>
+            <a:ext cx="5440680" cy="1463040"/>
           </a:xfrm>
           <a:prstGeom prst="roundRect">
             <a:avLst>
-              <a:gd name="adj" fmla="val 1951"/>
+              <a:gd name="adj" fmla="val 5000"/>
             </a:avLst>
           </a:prstGeom>
           <a:solidFill>
@@ -20123,16 +20213,40 @@
           </a:ln>
         </p:spPr>
       </p:sp>
-      <p:sp>
-        <p:nvSpPr>
-          <p:cNvPr id="4" name="Text 2"/>
-          <p:cNvSpPr txBox="1"/>
-          <p:nvPr/>
-        </p:nvSpPr>
-        <p:spPr>
-          <a:xfrm>
-            <a:off x="822960" y="1554480"/>
-            <a:ext cx="4892040" cy="548640"/>
+      <p:pic>
+        <p:nvPicPr>
+          <p:cNvPr id="4" name="icon robot" descr="/NAS/SJ/POSTECH/nlp/figs/icons/robot.png">    </p:cNvPr>
+          <p:cNvPicPr>
+            <a:picLocks noChangeAspect="1"/>
+          </p:cNvPicPr>
+          <p:nvPr/>
+        </p:nvPicPr>
+        <p:blipFill>
+          <a:blip r:embed="rId1"/>
+          <a:stretch>
+            <a:fillRect/>
+          </a:stretch>
+        </p:blipFill>
+        <p:spPr>
+          <a:xfrm>
+            <a:off x="731520" y="1463040"/>
+            <a:ext cx="457200" cy="457200"/>
+          </a:xfrm>
+          <a:prstGeom prst="rect">
+            <a:avLst/>
+          </a:prstGeom>
+        </p:spPr>
+      </p:pic>
+      <p:sp>
+        <p:nvSpPr>
+          <p:cNvPr id="5" name="Text 2"/>
+          <p:cNvSpPr txBox="1"/>
+          <p:nvPr/>
+        </p:nvSpPr>
+        <p:spPr>
+          <a:xfrm>
+            <a:off x="1325880" y="1417320"/>
+            <a:ext cx="4480560" cy="457200"/>
           </a:xfrm>
           <a:prstGeom prst="rect">
             <a:avLst/>
@@ -20148,125 +20262,67 @@
               <a:buNone/>
             </a:pPr>
             <a:r>
-              <a:rPr lang="en-US" sz="2600" b="1" dirty="0">
-                <a:solidFill>
-                  <a:srgbClr val="C00000"/>
-                </a:solidFill>
-              </a:rPr>
-              <a:t>Where it stops</a:t>
-            </a:r>
-            <a:endParaRPr lang="en-US" sz="2600" dirty="0"/>
-          </a:p>
-        </p:txBody>
-      </p:sp>
-      <p:sp>
-        <p:nvSpPr>
-          <p:cNvPr id="5" name="Text 3"/>
-          <p:cNvSpPr txBox="1"/>
-          <p:nvPr/>
-        </p:nvSpPr>
-        <p:spPr>
-          <a:xfrm>
-            <a:off x="822960" y="2194560"/>
-            <a:ext cx="4892040" cy="2834640"/>
-          </a:xfrm>
-          <a:prstGeom prst="rect">
-            <a:avLst/>
-          </a:prstGeom>
-          <a:noFill/>
-          <a:ln/>
-        </p:spPr>
-        <p:txBody>
-          <a:bodyPr wrap="square" lIns="635" tIns="635" rIns="635" bIns="635" rtlCol="0" anchor="t"/>
-          <a:lstStyle/>
-          <a:p>
-            <a:pPr marL="342900" indent="-342900">
-              <a:spcAft>
-                <a:spcPts val="800"/>
-              </a:spcAft>
-              <a:buSzPct val="100000"/>
-              <a:buChar char="•"/>
-            </a:pPr>
-            <a:r>
-              <a:rPr lang="en-US" sz="1700" dirty="0">
+              <a:rPr lang="en-US" sz="1800" b="1" dirty="0">
                 <a:solidFill>
                   <a:schemeClr val="tx1"/>
                 </a:solidFill>
               </a:rPr>
-              <a:t>Proofs: a skill, not a fact (use a specialized prover)</a:t>
-            </a:r>
-            <a:endParaRPr lang="en-US" sz="1700" dirty="0"/>
-          </a:p>
-          <a:p>
-            <a:pPr marL="342900" indent="-342900">
-              <a:spcAft>
-                <a:spcPts val="800"/>
-              </a:spcAft>
-              <a:buSzPct val="100000"/>
-              <a:buChar char="•"/>
-            </a:pPr>
-            <a:r>
-              <a:rPr lang="en-US" sz="1700" dirty="0">
+              <a:t>Models</a:t>
+            </a:r>
+            <a:endParaRPr lang="en-US" sz="1800" dirty="0"/>
+          </a:p>
+        </p:txBody>
+      </p:sp>
+      <p:sp>
+        <p:nvSpPr>
+          <p:cNvPr id="6" name="Text 3"/>
+          <p:cNvSpPr txBox="1"/>
+          <p:nvPr/>
+        </p:nvSpPr>
+        <p:spPr>
+          <a:xfrm>
+            <a:off x="1325880" y="1874520"/>
+            <a:ext cx="4526280" cy="822960"/>
+          </a:xfrm>
+          <a:prstGeom prst="rect">
+            <a:avLst/>
+          </a:prstGeom>
+          <a:noFill/>
+          <a:ln/>
+        </p:spPr>
+        <p:txBody>
+          <a:bodyPr wrap="square" lIns="0" tIns="0" rIns="0" bIns="0" rtlCol="0" anchor="t"/>
+          <a:lstStyle/>
+          <a:p>
+            <a:pPr indent="0" marL="0">
+              <a:buNone/>
+            </a:pPr>
+            <a:r>
+              <a:rPr lang="en-US" sz="1400" dirty="0">
                 <a:solidFill>
                   <a:schemeClr val="tx1"/>
                 </a:solidFill>
               </a:rPr>
-              <a:t>Automatic facts only within one kind of problem</a:t>
-            </a:r>
-            <a:endParaRPr lang="en-US" sz="1700" dirty="0"/>
-          </a:p>
-          <a:p>
-            <a:pPr marL="342900" indent="-342900">
-              <a:spcAft>
-                <a:spcPts val="800"/>
-              </a:spcAft>
-              <a:buSzPct val="100000"/>
-              <a:buChar char="•"/>
-            </a:pPr>
-            <a:r>
-              <a:rPr lang="en-US" sz="1700" dirty="0">
-                <a:solidFill>
-                  <a:schemeClr val="tx1"/>
-                </a:solidFill>
-              </a:rPr>
-              <a:t>Checks leak: 24–37% of wrong contest programs pass the examples</a:t>
-            </a:r>
-            <a:endParaRPr lang="en-US" sz="1700" dirty="0"/>
-          </a:p>
-          <a:p>
-            <a:pPr marL="342900" indent="-342900">
-              <a:spcAft>
-                <a:spcPts val="800"/>
-              </a:spcAft>
-              <a:buSzPct val="100000"/>
-              <a:buChar char="•"/>
-            </a:pPr>
-            <a:r>
-              <a:rPr lang="en-US" sz="1700" dirty="0">
-                <a:solidFill>
-                  <a:schemeClr val="tx1"/>
-                </a:solidFill>
-              </a:rPr>
-              <a:t>Missing world knowledge: thinking adds 2–5 points at 70–200× tokens</a:t>
-            </a:r>
-            <a:endParaRPr lang="en-US" sz="1700" dirty="0"/>
-          </a:p>
-        </p:txBody>
-      </p:sp>
-      <p:sp>
-        <p:nvSpPr>
-          <p:cNvPr id="6" name="Next"/>
+              <a:t>open models run locally: Qwen3 1.7B–32B, Qwen3.6-35B, gpt-oss-20b and 120b; Goedel- and DeepSeek-Prover for proofs</a:t>
+            </a:r>
+            <a:endParaRPr lang="en-US" sz="1400" dirty="0"/>
+          </a:p>
+        </p:txBody>
+      </p:sp>
+      <p:sp>
+        <p:nvSpPr>
+          <p:cNvPr id="7" name="Benchmarks"/>
           <p:cNvSpPr/>
           <p:nvPr/>
         </p:nvSpPr>
         <p:spPr>
           <a:xfrm>
-            <a:off x="6172200" y="1417320"/>
-            <a:ext cx="5440680" cy="3749040"/>
+            <a:off x="6172200" y="1280160"/>
+            <a:ext cx="5440680" cy="1463040"/>
           </a:xfrm>
           <a:prstGeom prst="roundRect">
             <a:avLst>
-              <a:gd name="adj" fmla="val 1951"/>
+              <a:gd name="adj" fmla="val 5000"/>
             </a:avLst>
           </a:prstGeom>
           <a:solidFill>
@@ -20280,16 +20336,40 @@
           </a:ln>
         </p:spPr>
       </p:sp>
-      <p:sp>
-        <p:nvSpPr>
-          <p:cNvPr id="7" name="Text 5"/>
-          <p:cNvSpPr txBox="1"/>
-          <p:nvPr/>
-        </p:nvSpPr>
-        <p:spPr>
-          <a:xfrm>
-            <a:off x="6446520" y="1554480"/>
-            <a:ext cx="4892040" cy="548640"/>
+      <p:pic>
+        <p:nvPicPr>
+          <p:cNvPr id="8" name="icon shapes" descr="/NAS/SJ/POSTECH/nlp/figs/icons/shapes.png">    </p:cNvPr>
+          <p:cNvPicPr>
+            <a:picLocks noChangeAspect="1"/>
+          </p:cNvPicPr>
+          <p:nvPr/>
+        </p:nvPicPr>
+        <p:blipFill>
+          <a:blip r:embed="rId2"/>
+          <a:stretch>
+            <a:fillRect/>
+          </a:stretch>
+        </p:blipFill>
+        <p:spPr>
+          <a:xfrm>
+            <a:off x="6355080" y="1463040"/>
+            <a:ext cx="457200" cy="457200"/>
+          </a:xfrm>
+          <a:prstGeom prst="rect">
+            <a:avLst/>
+          </a:prstGeom>
+        </p:spPr>
+      </p:pic>
+      <p:sp>
+        <p:nvSpPr>
+          <p:cNvPr id="9" name="Text 5"/>
+          <p:cNvSpPr txBox="1"/>
+          <p:nvPr/>
+        </p:nvSpPr>
+        <p:spPr>
+          <a:xfrm>
+            <a:off x="6949440" y="1417320"/>
+            <a:ext cx="4480560" cy="457200"/>
           </a:xfrm>
           <a:prstGeom prst="rect">
             <a:avLst/>
@@ -20305,103 +20385,237 @@
               <a:buNone/>
             </a:pPr>
             <a:r>
-              <a:rPr lang="en-US" sz="2600" b="1" dirty="0">
-                <a:solidFill>
-                  <a:srgbClr val="4472C4"/>
-                </a:solidFill>
-              </a:rPr>
-              <a:t>Next</a:t>
-            </a:r>
-            <a:endParaRPr lang="en-US" sz="2600" dirty="0"/>
-          </a:p>
-        </p:txBody>
-      </p:sp>
-      <p:sp>
-        <p:nvSpPr>
-          <p:cNvPr id="8" name="Text 6"/>
-          <p:cNvSpPr txBox="1"/>
-          <p:nvPr/>
-        </p:nvSpPr>
-        <p:spPr>
-          <a:xfrm>
-            <a:off x="6446520" y="2194560"/>
-            <a:ext cx="4892040" cy="2834640"/>
-          </a:xfrm>
-          <a:prstGeom prst="rect">
-            <a:avLst/>
-          </a:prstGeom>
-          <a:noFill/>
-          <a:ln/>
-        </p:spPr>
-        <p:txBody>
-          <a:bodyPr wrap="square" lIns="635" tIns="635" rIns="635" bIns="635" rtlCol="0" anchor="t"/>
-          <a:lstStyle/>
-          <a:p>
-            <a:pPr marL="342900" indent="-342900">
-              <a:spcAft>
-                <a:spcPts val="800"/>
-              </a:spcAft>
-              <a:buSzPct val="100000"/>
-              <a:buChar char="•"/>
-            </a:pPr>
-            <a:r>
-              <a:rPr lang="en-US" sz="1700" dirty="0">
+              <a:rPr lang="en-US" sz="1800" b="1" dirty="0">
                 <a:solidFill>
                   <a:schemeClr val="tx1"/>
                 </a:solidFill>
               </a:rPr>
-              <a:t>Repeat the held-out MAMO test for 3 more models (3 seeds)</a:t>
-            </a:r>
-            <a:endParaRPr lang="en-US" sz="1700" dirty="0"/>
-          </a:p>
-          <a:p>
-            <a:pPr marL="342900" indent="-342900">
-              <a:spcAft>
-                <a:spcPts val="800"/>
-              </a:spcAft>
-              <a:buSzPct val="100000"/>
-              <a:buChar char="•"/>
-            </a:pPr>
-            <a:r>
-              <a:rPr lang="en-US" sz="1700" dirty="0">
+              <a:t>Benchmarks</a:t>
+            </a:r>
+            <a:endParaRPr lang="en-US" sz="1800" dirty="0"/>
+          </a:p>
+        </p:txBody>
+      </p:sp>
+      <p:sp>
+        <p:nvSpPr>
+          <p:cNvPr id="10" name="Text 6"/>
+          <p:cNvSpPr txBox="1"/>
+          <p:nvPr/>
+        </p:nvSpPr>
+        <p:spPr>
+          <a:xfrm>
+            <a:off x="6949440" y="1874520"/>
+            <a:ext cx="4526280" cy="822960"/>
+          </a:xfrm>
+          <a:prstGeom prst="rect">
+            <a:avLst/>
+          </a:prstGeom>
+          <a:noFill/>
+          <a:ln/>
+        </p:spPr>
+        <p:txBody>
+          <a:bodyPr wrap="square" lIns="0" tIns="0" rIns="0" bIns="0" rtlCol="0" anchor="t"/>
+          <a:lstStyle/>
+          <a:p>
+            <a:pPr indent="0" marL="0">
+              <a:buNone/>
+            </a:pPr>
+            <a:r>
+              <a:rPr lang="en-US" sz="1400" dirty="0">
                 <a:solidFill>
                   <a:schemeClr val="tx1"/>
                 </a:solidFill>
               </a:rPr>
-              <a:t>Automatic facts for each problem type</a:t>
-            </a:r>
-            <a:endParaRPr lang="en-US" sz="1700" dirty="0"/>
-          </a:p>
-          <a:p>
-            <a:pPr marL="342900" indent="-342900">
-              <a:spcAft>
-                <a:spcPts val="800"/>
-              </a:spcAft>
-              <a:buSzPct val="100000"/>
-              <a:buChar char="•"/>
-            </a:pPr>
-            <a:r>
-              <a:rPr lang="en-US" sz="1700" dirty="0">
+              <a:t>13 geometry and 8 optimization tasks (generated); 311 Codeforces geometry; 56 Solomon routing; 82 job-shop; 1,208 word problems (NL4OPT, IndustryOR, MAMO); MATH-500 + AIME; miniF2F</a:t>
+            </a:r>
+            <a:endParaRPr lang="en-US" sz="1400" dirty="0"/>
+          </a:p>
+        </p:txBody>
+      </p:sp>
+      <p:sp>
+        <p:nvSpPr>
+          <p:cNvPr id="11" name="Exact scoring"/>
+          <p:cNvSpPr/>
+          <p:nvPr/>
+        </p:nvSpPr>
+        <p:spPr>
+          <a:xfrm>
+            <a:off x="548640" y="2880360"/>
+            <a:ext cx="5440680" cy="1463040"/>
+          </a:xfrm>
+          <a:prstGeom prst="roundRect">
+            <a:avLst>
+              <a:gd name="adj" fmla="val 5000"/>
+            </a:avLst>
+          </a:prstGeom>
+          <a:solidFill>
+            <a:srgbClr val="F2F2F2"/>
+          </a:solidFill>
+          <a:ln w="9525">
+            <a:solidFill>
+              <a:srgbClr val="D9D9D9"/>
+            </a:solidFill>
+            <a:prstDash val="solid"/>
+          </a:ln>
+        </p:spPr>
+      </p:sp>
+      <p:pic>
+        <p:nvPicPr>
+          <p:cNvPr id="12" name="icon check" descr="/NAS/SJ/POSTECH/nlp/figs/icons/check.png">    </p:cNvPr>
+          <p:cNvPicPr>
+            <a:picLocks noChangeAspect="1"/>
+          </p:cNvPicPr>
+          <p:nvPr/>
+        </p:nvPicPr>
+        <p:blipFill>
+          <a:blip r:embed="rId3"/>
+          <a:stretch>
+            <a:fillRect/>
+          </a:stretch>
+        </p:blipFill>
+        <p:spPr>
+          <a:xfrm>
+            <a:off x="731520" y="3063240"/>
+            <a:ext cx="457200" cy="457200"/>
+          </a:xfrm>
+          <a:prstGeom prst="rect">
+            <a:avLst/>
+          </a:prstGeom>
+        </p:spPr>
+      </p:pic>
+      <p:sp>
+        <p:nvSpPr>
+          <p:cNvPr id="13" name="Text 8"/>
+          <p:cNvSpPr txBox="1"/>
+          <p:nvPr/>
+        </p:nvSpPr>
+        <p:spPr>
+          <a:xfrm>
+            <a:off x="1325880" y="3017520"/>
+            <a:ext cx="4480560" cy="457200"/>
+          </a:xfrm>
+          <a:prstGeom prst="rect">
+            <a:avLst/>
+          </a:prstGeom>
+          <a:noFill/>
+          <a:ln/>
+        </p:spPr>
+        <p:txBody>
+          <a:bodyPr wrap="square" lIns="0" tIns="0" rIns="0" bIns="0" rtlCol="0" anchor="ctr"/>
+          <a:lstStyle/>
+          <a:p>
+            <a:pPr indent="0" marL="0">
+              <a:buNone/>
+            </a:pPr>
+            <a:r>
+              <a:rPr lang="en-US" sz="1800" b="1" dirty="0">
                 <a:solidFill>
                   <a:schemeClr val="tx1"/>
                 </a:solidFill>
               </a:rPr>
-              <a:t>Final report; a commercial model if available</a:t>
-            </a:r>
-            <a:endParaRPr lang="en-US" sz="1700" dirty="0"/>
-          </a:p>
-        </p:txBody>
-      </p:sp>
-      <p:sp>
-        <p:nvSpPr>
-          <p:cNvPr id="9" name="Text 7"/>
-          <p:cNvSpPr txBox="1"/>
-          <p:nvPr/>
-        </p:nvSpPr>
-        <p:spPr>
-          <a:xfrm>
-            <a:off x="548640" y="5669280"/>
-            <a:ext cx="11064240" cy="548640"/>
+              <a:t>Exact scoring</a:t>
+            </a:r>
+            <a:endParaRPr lang="en-US" sz="1800" dirty="0"/>
+          </a:p>
+        </p:txBody>
+      </p:sp>
+      <p:sp>
+        <p:nvSpPr>
+          <p:cNvPr id="14" name="Text 9"/>
+          <p:cNvSpPr txBox="1"/>
+          <p:nvPr/>
+        </p:nvSpPr>
+        <p:spPr>
+          <a:xfrm>
+            <a:off x="1325880" y="3474720"/>
+            <a:ext cx="4526280" cy="822960"/>
+          </a:xfrm>
+          <a:prstGeom prst="rect">
+            <a:avLst/>
+          </a:prstGeom>
+          <a:noFill/>
+          <a:ln/>
+        </p:spPr>
+        <p:txBody>
+          <a:bodyPr wrap="square" lIns="0" tIns="0" rIns="0" bIns="0" rtlCol="0" anchor="t"/>
+          <a:lstStyle/>
+          <a:p>
+            <a:pPr indent="0" marL="0">
+              <a:buNone/>
+            </a:pPr>
+            <a:r>
+              <a:rPr lang="en-US" sz="1400" dirty="0">
+                <a:solidFill>
+                  <a:schemeClr val="tx1"/>
+                </a:solidFill>
+              </a:rPr>
+              <a:t>geometry right on all 8 moved copies; plans obey every rule; contest programs pass all official tests; math and word problems by exact answer</a:t>
+            </a:r>
+            <a:endParaRPr lang="en-US" sz="1400" dirty="0"/>
+          </a:p>
+        </p:txBody>
+      </p:sp>
+      <p:sp>
+        <p:nvSpPr>
+          <p:cNvPr id="15" name="Fair comparisons"/>
+          <p:cNvSpPr/>
+          <p:nvPr/>
+        </p:nvSpPr>
+        <p:spPr>
+          <a:xfrm>
+            <a:off x="6172200" y="2880360"/>
+            <a:ext cx="5440680" cy="1463040"/>
+          </a:xfrm>
+          <a:prstGeom prst="roundRect">
+            <a:avLst>
+              <a:gd name="adj" fmla="val 5000"/>
+            </a:avLst>
+          </a:prstGeom>
+          <a:solidFill>
+            <a:srgbClr val="F2F2F2"/>
+          </a:solidFill>
+          <a:ln w="9525">
+            <a:solidFill>
+              <a:srgbClr val="D9D9D9"/>
+            </a:solidFill>
+            <a:prstDash val="solid"/>
+          </a:ln>
+        </p:spPr>
+      </p:sp>
+      <p:pic>
+        <p:nvPicPr>
+          <p:cNvPr id="16" name="icon fact" descr="/NAS/SJ/POSTECH/nlp/figs/icons/fact.png">    </p:cNvPr>
+          <p:cNvPicPr>
+            <a:picLocks noChangeAspect="1"/>
+          </p:cNvPicPr>
+          <p:nvPr/>
+        </p:nvPicPr>
+        <p:blipFill>
+          <a:blip r:embed="rId4"/>
+          <a:stretch>
+            <a:fillRect/>
+          </a:stretch>
+        </p:blipFill>
+        <p:spPr>
+          <a:xfrm>
+            <a:off x="6355080" y="3063240"/>
+            <a:ext cx="457200" cy="457200"/>
+          </a:xfrm>
+          <a:prstGeom prst="rect">
+            <a:avLst/>
+          </a:prstGeom>
+        </p:spPr>
+      </p:pic>
+      <p:sp>
+        <p:nvSpPr>
+          <p:cNvPr id="17" name="Text 11"/>
+          <p:cNvSpPr txBox="1"/>
+          <p:nvPr/>
+        </p:nvSpPr>
+        <p:spPr>
+          <a:xfrm>
+            <a:off x="6949440" y="3017520"/>
+            <a:ext cx="4480560" cy="457200"/>
           </a:xfrm>
           <a:prstGeom prst="rect">
             <a:avLst/>
@@ -20413,18 +20627,300 @@
           <a:bodyPr wrap="square" lIns="0" tIns="0" rIns="0" bIns="0" rtlCol="0" anchor="ctr"/>
           <a:lstStyle/>
           <a:p>
-            <a:pPr algn="ctr" indent="0" marL="0">
-              <a:buNone/>
-            </a:pPr>
-            <a:r>
-              <a:rPr lang="en-US" sz="2000" dirty="0">
+            <a:pPr indent="0" marL="0">
+              <a:buNone/>
+            </a:pPr>
+            <a:r>
+              <a:rPr lang="en-US" sz="1800" b="1" dirty="0">
                 <a:solidFill>
                   <a:schemeClr val="tx1"/>
                 </a:solidFill>
               </a:rPr>
-              <a:t>Every claim pre-registered and checked on 3 seeds; accuracy always reported with its token cost</a:t>
-            </a:r>
-            <a:endParaRPr lang="en-US" sz="2000" dirty="0"/>
+              <a:t>Fair comparisons</a:t>
+            </a:r>
+            <a:endParaRPr lang="en-US" sz="1800" dirty="0"/>
+          </a:p>
+        </p:txBody>
+      </p:sp>
+      <p:sp>
+        <p:nvSpPr>
+          <p:cNvPr id="18" name="Text 12"/>
+          <p:cNvSpPr txBox="1"/>
+          <p:nvPr/>
+        </p:nvSpPr>
+        <p:spPr>
+          <a:xfrm>
+            <a:off x="6949440" y="3474720"/>
+            <a:ext cx="4526280" cy="822960"/>
+          </a:xfrm>
+          <a:prstGeom prst="rect">
+            <a:avLst/>
+          </a:prstGeom>
+          <a:noFill/>
+          <a:ln/>
+        </p:spPr>
+        <p:txBody>
+          <a:bodyPr wrap="square" lIns="0" tIns="0" rIns="0" bIns="0" rtlCol="0" anchor="t"/>
+          <a:lstStyle/>
+          <a:p>
+            <a:pPr indent="0" marL="0">
+              <a:buNone/>
+            </a:pPr>
+            <a:r>
+              <a:rPr lang="en-US" sz="1400" dirty="0">
+                <a:solidFill>
+                  <a:schemeClr val="tx1"/>
+                </a:solidFill>
+              </a:rPr>
+              <a:t>one change at a time; predictions written before each run; every claim on 3 seeds; baselines run in our own harness</a:t>
+            </a:r>
+            <a:endParaRPr lang="en-US" sz="1400" dirty="0"/>
+          </a:p>
+        </p:txBody>
+      </p:sp>
+      <p:sp>
+        <p:nvSpPr>
+          <p:cNvPr id="19" name="Cost"/>
+          <p:cNvSpPr/>
+          <p:nvPr/>
+        </p:nvSpPr>
+        <p:spPr>
+          <a:xfrm>
+            <a:off x="548640" y="4480560"/>
+            <a:ext cx="5440680" cy="1463040"/>
+          </a:xfrm>
+          <a:prstGeom prst="roundRect">
+            <a:avLst>
+              <a:gd name="adj" fmla="val 5000"/>
+            </a:avLst>
+          </a:prstGeom>
+          <a:solidFill>
+            <a:srgbClr val="F2F2F2"/>
+          </a:solidFill>
+          <a:ln w="9525">
+            <a:solidFill>
+              <a:srgbClr val="D9D9D9"/>
+            </a:solidFill>
+            <a:prstDash val="solid"/>
+          </a:ln>
+        </p:spPr>
+      </p:sp>
+      <p:pic>
+        <p:nvPicPr>
+          <p:cNvPr id="20" name="icon coins" descr="/NAS/SJ/POSTECH/nlp/figs/icons/coins.png">    </p:cNvPr>
+          <p:cNvPicPr>
+            <a:picLocks noChangeAspect="1"/>
+          </p:cNvPicPr>
+          <p:nvPr/>
+        </p:nvPicPr>
+        <p:blipFill>
+          <a:blip r:embed="rId5"/>
+          <a:stretch>
+            <a:fillRect/>
+          </a:stretch>
+        </p:blipFill>
+        <p:spPr>
+          <a:xfrm>
+            <a:off x="731520" y="4663440"/>
+            <a:ext cx="457200" cy="457200"/>
+          </a:xfrm>
+          <a:prstGeom prst="rect">
+            <a:avLst/>
+          </a:prstGeom>
+        </p:spPr>
+      </p:pic>
+      <p:sp>
+        <p:nvSpPr>
+          <p:cNvPr id="21" name="Text 14"/>
+          <p:cNvSpPr txBox="1"/>
+          <p:nvPr/>
+        </p:nvSpPr>
+        <p:spPr>
+          <a:xfrm>
+            <a:off x="1325880" y="4617720"/>
+            <a:ext cx="4480560" cy="457200"/>
+          </a:xfrm>
+          <a:prstGeom prst="rect">
+            <a:avLst/>
+          </a:prstGeom>
+          <a:noFill/>
+          <a:ln/>
+        </p:spPr>
+        <p:txBody>
+          <a:bodyPr wrap="square" lIns="0" tIns="0" rIns="0" bIns="0" rtlCol="0" anchor="ctr"/>
+          <a:lstStyle/>
+          <a:p>
+            <a:pPr indent="0" marL="0">
+              <a:buNone/>
+            </a:pPr>
+            <a:r>
+              <a:rPr lang="en-US" sz="1800" b="1" dirty="0">
+                <a:solidFill>
+                  <a:schemeClr val="tx1"/>
+                </a:solidFill>
+              </a:rPr>
+              <a:t>Cost</a:t>
+            </a:r>
+            <a:endParaRPr lang="en-US" sz="1800" dirty="0"/>
+          </a:p>
+        </p:txBody>
+      </p:sp>
+      <p:sp>
+        <p:nvSpPr>
+          <p:cNvPr id="22" name="Text 15"/>
+          <p:cNvSpPr txBox="1"/>
+          <p:nvPr/>
+        </p:nvSpPr>
+        <p:spPr>
+          <a:xfrm>
+            <a:off x="1325880" y="5074920"/>
+            <a:ext cx="4526280" cy="822960"/>
+          </a:xfrm>
+          <a:prstGeom prst="rect">
+            <a:avLst/>
+          </a:prstGeom>
+          <a:noFill/>
+          <a:ln/>
+        </p:spPr>
+        <p:txBody>
+          <a:bodyPr wrap="square" lIns="0" tIns="0" rIns="0" bIns="0" rtlCol="0" anchor="t"/>
+          <a:lstStyle/>
+          <a:p>
+            <a:pPr indent="0" marL="0">
+              <a:buNone/>
+            </a:pPr>
+            <a:r>
+              <a:rPr lang="en-US" sz="1400" dirty="0">
+                <a:solidFill>
+                  <a:schemeClr val="tx1"/>
+                </a:solidFill>
+              </a:rPr>
+              <a:t>every result reported with its output tokens per problem</a:t>
+            </a:r>
+            <a:endParaRPr lang="en-US" sz="1400" dirty="0"/>
+          </a:p>
+        </p:txBody>
+      </p:sp>
+      <p:sp>
+        <p:nvSpPr>
+          <p:cNvPr id="23" name="Hardware"/>
+          <p:cNvSpPr/>
+          <p:nvPr/>
+        </p:nvSpPr>
+        <p:spPr>
+          <a:xfrm>
+            <a:off x="6172200" y="4480560"/>
+            <a:ext cx="5440680" cy="1463040"/>
+          </a:xfrm>
+          <a:prstGeom prst="roundRect">
+            <a:avLst>
+              <a:gd name="adj" fmla="val 5000"/>
+            </a:avLst>
+          </a:prstGeom>
+          <a:solidFill>
+            <a:srgbClr val="F2F2F2"/>
+          </a:solidFill>
+          <a:ln w="9525">
+            <a:solidFill>
+              <a:srgbClr val="D9D9D9"/>
+            </a:solidFill>
+            <a:prstDash val="solid"/>
+          </a:ln>
+        </p:spPr>
+      </p:sp>
+      <p:pic>
+        <p:nvPicPr>
+          <p:cNvPr id="24" name="icon gpu" descr="/NAS/SJ/POSTECH/nlp/figs/icons/gpu.png">    </p:cNvPr>
+          <p:cNvPicPr>
+            <a:picLocks noChangeAspect="1"/>
+          </p:cNvPicPr>
+          <p:nvPr/>
+        </p:nvPicPr>
+        <p:blipFill>
+          <a:blip r:embed="rId6"/>
+          <a:stretch>
+            <a:fillRect/>
+          </a:stretch>
+        </p:blipFill>
+        <p:spPr>
+          <a:xfrm>
+            <a:off x="6355080" y="4663440"/>
+            <a:ext cx="457200" cy="457200"/>
+          </a:xfrm>
+          <a:prstGeom prst="rect">
+            <a:avLst/>
+          </a:prstGeom>
+        </p:spPr>
+      </p:pic>
+      <p:sp>
+        <p:nvSpPr>
+          <p:cNvPr id="25" name="Text 17"/>
+          <p:cNvSpPr txBox="1"/>
+          <p:nvPr/>
+        </p:nvSpPr>
+        <p:spPr>
+          <a:xfrm>
+            <a:off x="6949440" y="4617720"/>
+            <a:ext cx="4480560" cy="457200"/>
+          </a:xfrm>
+          <a:prstGeom prst="rect">
+            <a:avLst/>
+          </a:prstGeom>
+          <a:noFill/>
+          <a:ln/>
+        </p:spPr>
+        <p:txBody>
+          <a:bodyPr wrap="square" lIns="0" tIns="0" rIns="0" bIns="0" rtlCol="0" anchor="ctr"/>
+          <a:lstStyle/>
+          <a:p>
+            <a:pPr indent="0" marL="0">
+              <a:buNone/>
+            </a:pPr>
+            <a:r>
+              <a:rPr lang="en-US" sz="1800" b="1" dirty="0">
+                <a:solidFill>
+                  <a:schemeClr val="tx1"/>
+                </a:solidFill>
+              </a:rPr>
+              <a:t>Hardware</a:t>
+            </a:r>
+            <a:endParaRPr lang="en-US" sz="1800" dirty="0"/>
+          </a:p>
+        </p:txBody>
+      </p:sp>
+      <p:sp>
+        <p:nvSpPr>
+          <p:cNvPr id="26" name="Text 18"/>
+          <p:cNvSpPr txBox="1"/>
+          <p:nvPr/>
+        </p:nvSpPr>
+        <p:spPr>
+          <a:xfrm>
+            <a:off x="6949440" y="5074920"/>
+            <a:ext cx="4526280" cy="822960"/>
+          </a:xfrm>
+          <a:prstGeom prst="rect">
+            <a:avLst/>
+          </a:prstGeom>
+          <a:noFill/>
+          <a:ln/>
+        </p:spPr>
+        <p:txBody>
+          <a:bodyPr wrap="square" lIns="0" tIns="0" rIns="0" bIns="0" rtlCol="0" anchor="t"/>
+          <a:lstStyle/>
+          <a:p>
+            <a:pPr indent="0" marL="0">
+              <a:buNone/>
+            </a:pPr>
+            <a:r>
+              <a:rPr lang="en-US" sz="1400" dirty="0">
+                <a:solidFill>
+                  <a:schemeClr val="tx1"/>
+                </a:solidFill>
+              </a:rPr>
+              <a:t>one model per GPU (RTX PRO 6000, 96 GB); the small models fit one 24 GB GPU</a:t>
+            </a:r>
+            <a:endParaRPr lang="en-US" sz="1400" dirty="0"/>
           </a:p>
         </p:txBody>
       </p:sp>
@@ -20468,6 +20964,446 @@
             <a:fld id="{F7021451-1387-4CA6-816F-3879F97B5CBC}" type="slidenum">
               <a:rPr b="0" lang="en-US"/>
               <a:t>20</a:t>
+            </a:fld>
+            <a:endParaRPr lang="en-US"/>
+          </a:p>
+        </p:txBody>
+      </p:sp>
+    </p:spTree>
+  </p:cSld>
+  <p:clrMapOvr>
+    <a:masterClrMapping/>
+  </p:clrMapOvr>
+</p:sld>
+</file>
+
+<file path=ppt/slides/slide21.xml><?xml version="1.0" encoding="utf-8"?>
+<p:sld xmlns:a="http://schemas.openxmlformats.org/drawingml/2006/main" xmlns:r="http://schemas.openxmlformats.org/officeDocument/2006/relationships" xmlns:p="http://schemas.openxmlformats.org/presentationml/2006/main">
+  <p:cSld name="Slide 21">
+    <p:spTree>
+      <p:nvGrpSpPr>
+        <p:cNvPr id="1" name=""/>
+        <p:cNvGrpSpPr/>
+        <p:nvPr/>
+      </p:nvGrpSpPr>
+      <p:grpSpPr>
+        <a:xfrm>
+          <a:off x="0" y="0"/>
+          <a:ext cx="0" cy="0"/>
+          <a:chOff x="0" y="0"/>
+          <a:chExt cx="0" cy="0"/>
+        </a:xfrm>
+      </p:grpSpPr>
+      <p:sp>
+        <p:nvSpPr>
+          <p:cNvPr id="2" name="Text 0"/>
+          <p:cNvSpPr/>
+          <p:nvPr>
+            <p:ph idx="100" type="title" hasCustomPrompt="1"/>
+          </p:nvPr>
+        </p:nvSpPr>
+        <p:spPr>
+          <a:xfrm>
+            <a:off x="548640" y="274320"/>
+            <a:ext cx="11064240" cy="914400"/>
+          </a:xfrm>
+          <a:prstGeom prst="rect">
+            <a:avLst/>
+          </a:prstGeom>
+          <a:noFill/>
+          <a:ln/>
+        </p:spPr>
+        <p:txBody>
+          <a:bodyPr wrap="square" rtlCol="0" anchor="ctr"/>
+          <a:lstStyle/>
+          <a:p>
+            <a:pPr algn="l" indent="0" marL="0">
+              <a:buNone/>
+            </a:pPr>
+            <a:r>
+              <a:rPr lang="en-US" sz="3600" dirty="0">
+                <a:solidFill>
+                  <a:schemeClr val="tx1"/>
+                </a:solidFill>
+              </a:rPr>
+              <a:t>Where the recipe stops, and what is next</a:t>
+            </a:r>
+            <a:endParaRPr lang="en-US" sz="3600" dirty="0"/>
+          </a:p>
+        </p:txBody>
+      </p:sp>
+      <p:sp>
+        <p:nvSpPr>
+          <p:cNvPr id="3" name="Where it stops"/>
+          <p:cNvSpPr/>
+          <p:nvPr/>
+        </p:nvSpPr>
+        <p:spPr>
+          <a:xfrm>
+            <a:off x="548640" y="1417320"/>
+            <a:ext cx="5440680" cy="3749040"/>
+          </a:xfrm>
+          <a:prstGeom prst="roundRect">
+            <a:avLst>
+              <a:gd name="adj" fmla="val 1951"/>
+            </a:avLst>
+          </a:prstGeom>
+          <a:solidFill>
+            <a:srgbClr val="F2F2F2"/>
+          </a:solidFill>
+          <a:ln w="9525">
+            <a:solidFill>
+              <a:srgbClr val="D9D9D9"/>
+            </a:solidFill>
+            <a:prstDash val="solid"/>
+          </a:ln>
+        </p:spPr>
+      </p:sp>
+      <p:sp>
+        <p:nvSpPr>
+          <p:cNvPr id="4" name="Text 2"/>
+          <p:cNvSpPr txBox="1"/>
+          <p:nvPr/>
+        </p:nvSpPr>
+        <p:spPr>
+          <a:xfrm>
+            <a:off x="822960" y="1554480"/>
+            <a:ext cx="4892040" cy="548640"/>
+          </a:xfrm>
+          <a:prstGeom prst="rect">
+            <a:avLst/>
+          </a:prstGeom>
+          <a:noFill/>
+          <a:ln/>
+        </p:spPr>
+        <p:txBody>
+          <a:bodyPr wrap="square" lIns="0" tIns="0" rIns="0" bIns="0" rtlCol="0" anchor="ctr"/>
+          <a:lstStyle/>
+          <a:p>
+            <a:pPr indent="0" marL="0">
+              <a:buNone/>
+            </a:pPr>
+            <a:r>
+              <a:rPr lang="en-US" sz="2600" b="1" dirty="0">
+                <a:solidFill>
+                  <a:srgbClr val="C00000"/>
+                </a:solidFill>
+              </a:rPr>
+              <a:t>Where it stops</a:t>
+            </a:r>
+            <a:endParaRPr lang="en-US" sz="2600" dirty="0"/>
+          </a:p>
+        </p:txBody>
+      </p:sp>
+      <p:sp>
+        <p:nvSpPr>
+          <p:cNvPr id="5" name="Text 3"/>
+          <p:cNvSpPr txBox="1"/>
+          <p:nvPr/>
+        </p:nvSpPr>
+        <p:spPr>
+          <a:xfrm>
+            <a:off x="822960" y="2194560"/>
+            <a:ext cx="4892040" cy="2834640"/>
+          </a:xfrm>
+          <a:prstGeom prst="rect">
+            <a:avLst/>
+          </a:prstGeom>
+          <a:noFill/>
+          <a:ln/>
+        </p:spPr>
+        <p:txBody>
+          <a:bodyPr wrap="square" lIns="635" tIns="635" rIns="635" bIns="635" rtlCol="0" anchor="t"/>
+          <a:lstStyle/>
+          <a:p>
+            <a:pPr marL="342900" indent="-342900">
+              <a:spcAft>
+                <a:spcPts val="800"/>
+              </a:spcAft>
+              <a:buSzPct val="100000"/>
+              <a:buChar char="•"/>
+            </a:pPr>
+            <a:r>
+              <a:rPr lang="en-US" sz="1700" dirty="0">
+                <a:solidFill>
+                  <a:schemeClr val="tx1"/>
+                </a:solidFill>
+              </a:rPr>
+              <a:t>Proofs: a skill, not a fact (use a specialized prover)</a:t>
+            </a:r>
+            <a:endParaRPr lang="en-US" sz="1700" dirty="0"/>
+          </a:p>
+          <a:p>
+            <a:pPr marL="342900" indent="-342900">
+              <a:spcAft>
+                <a:spcPts val="800"/>
+              </a:spcAft>
+              <a:buSzPct val="100000"/>
+              <a:buChar char="•"/>
+            </a:pPr>
+            <a:r>
+              <a:rPr lang="en-US" sz="1700" dirty="0">
+                <a:solidFill>
+                  <a:schemeClr val="tx1"/>
+                </a:solidFill>
+              </a:rPr>
+              <a:t>Automatic facts only within one kind of problem</a:t>
+            </a:r>
+            <a:endParaRPr lang="en-US" sz="1700" dirty="0"/>
+          </a:p>
+          <a:p>
+            <a:pPr marL="342900" indent="-342900">
+              <a:spcAft>
+                <a:spcPts val="800"/>
+              </a:spcAft>
+              <a:buSzPct val="100000"/>
+              <a:buChar char="•"/>
+            </a:pPr>
+            <a:r>
+              <a:rPr lang="en-US" sz="1700" dirty="0">
+                <a:solidFill>
+                  <a:schemeClr val="tx1"/>
+                </a:solidFill>
+              </a:rPr>
+              <a:t>Checks leak: 24–37% of wrong contest programs pass the examples</a:t>
+            </a:r>
+            <a:endParaRPr lang="en-US" sz="1700" dirty="0"/>
+          </a:p>
+          <a:p>
+            <a:pPr marL="342900" indent="-342900">
+              <a:spcAft>
+                <a:spcPts val="800"/>
+              </a:spcAft>
+              <a:buSzPct val="100000"/>
+              <a:buChar char="•"/>
+            </a:pPr>
+            <a:r>
+              <a:rPr lang="en-US" sz="1700" dirty="0">
+                <a:solidFill>
+                  <a:schemeClr val="tx1"/>
+                </a:solidFill>
+              </a:rPr>
+              <a:t>Missing world knowledge: thinking adds 2–5 points at 70–200× tokens</a:t>
+            </a:r>
+            <a:endParaRPr lang="en-US" sz="1700" dirty="0"/>
+          </a:p>
+        </p:txBody>
+      </p:sp>
+      <p:sp>
+        <p:nvSpPr>
+          <p:cNvPr id="6" name="Next"/>
+          <p:cNvSpPr/>
+          <p:nvPr/>
+        </p:nvSpPr>
+        <p:spPr>
+          <a:xfrm>
+            <a:off x="6172200" y="1417320"/>
+            <a:ext cx="5440680" cy="3749040"/>
+          </a:xfrm>
+          <a:prstGeom prst="roundRect">
+            <a:avLst>
+              <a:gd name="adj" fmla="val 1951"/>
+            </a:avLst>
+          </a:prstGeom>
+          <a:solidFill>
+            <a:srgbClr val="F2F2F2"/>
+          </a:solidFill>
+          <a:ln w="9525">
+            <a:solidFill>
+              <a:srgbClr val="D9D9D9"/>
+            </a:solidFill>
+            <a:prstDash val="solid"/>
+          </a:ln>
+        </p:spPr>
+      </p:sp>
+      <p:sp>
+        <p:nvSpPr>
+          <p:cNvPr id="7" name="Text 5"/>
+          <p:cNvSpPr txBox="1"/>
+          <p:nvPr/>
+        </p:nvSpPr>
+        <p:spPr>
+          <a:xfrm>
+            <a:off x="6446520" y="1554480"/>
+            <a:ext cx="4892040" cy="548640"/>
+          </a:xfrm>
+          <a:prstGeom prst="rect">
+            <a:avLst/>
+          </a:prstGeom>
+          <a:noFill/>
+          <a:ln/>
+        </p:spPr>
+        <p:txBody>
+          <a:bodyPr wrap="square" lIns="0" tIns="0" rIns="0" bIns="0" rtlCol="0" anchor="ctr"/>
+          <a:lstStyle/>
+          <a:p>
+            <a:pPr indent="0" marL="0">
+              <a:buNone/>
+            </a:pPr>
+            <a:r>
+              <a:rPr lang="en-US" sz="2600" b="1" dirty="0">
+                <a:solidFill>
+                  <a:srgbClr val="4472C4"/>
+                </a:solidFill>
+              </a:rPr>
+              <a:t>Next</a:t>
+            </a:r>
+            <a:endParaRPr lang="en-US" sz="2600" dirty="0"/>
+          </a:p>
+        </p:txBody>
+      </p:sp>
+      <p:sp>
+        <p:nvSpPr>
+          <p:cNvPr id="8" name="Text 6"/>
+          <p:cNvSpPr txBox="1"/>
+          <p:nvPr/>
+        </p:nvSpPr>
+        <p:spPr>
+          <a:xfrm>
+            <a:off x="6446520" y="2194560"/>
+            <a:ext cx="4892040" cy="2834640"/>
+          </a:xfrm>
+          <a:prstGeom prst="rect">
+            <a:avLst/>
+          </a:prstGeom>
+          <a:noFill/>
+          <a:ln/>
+        </p:spPr>
+        <p:txBody>
+          <a:bodyPr wrap="square" lIns="635" tIns="635" rIns="635" bIns="635" rtlCol="0" anchor="t"/>
+          <a:lstStyle/>
+          <a:p>
+            <a:pPr marL="342900" indent="-342900">
+              <a:spcAft>
+                <a:spcPts val="800"/>
+              </a:spcAft>
+              <a:buSzPct val="100000"/>
+              <a:buChar char="•"/>
+            </a:pPr>
+            <a:r>
+              <a:rPr lang="en-US" sz="1700" dirty="0">
+                <a:solidFill>
+                  <a:schemeClr val="tx1"/>
+                </a:solidFill>
+              </a:rPr>
+              <a:t>Repeat the held-out MAMO test for 3 more models (3 seeds)</a:t>
+            </a:r>
+            <a:endParaRPr lang="en-US" sz="1700" dirty="0"/>
+          </a:p>
+          <a:p>
+            <a:pPr marL="342900" indent="-342900">
+              <a:spcAft>
+                <a:spcPts val="800"/>
+              </a:spcAft>
+              <a:buSzPct val="100000"/>
+              <a:buChar char="•"/>
+            </a:pPr>
+            <a:r>
+              <a:rPr lang="en-US" sz="1700" dirty="0">
+                <a:solidFill>
+                  <a:schemeClr val="tx1"/>
+                </a:solidFill>
+              </a:rPr>
+              <a:t>Automatic facts for each problem type</a:t>
+            </a:r>
+            <a:endParaRPr lang="en-US" sz="1700" dirty="0"/>
+          </a:p>
+          <a:p>
+            <a:pPr marL="342900" indent="-342900">
+              <a:spcAft>
+                <a:spcPts val="800"/>
+              </a:spcAft>
+              <a:buSzPct val="100000"/>
+              <a:buChar char="•"/>
+            </a:pPr>
+            <a:r>
+              <a:rPr lang="en-US" sz="1700" dirty="0">
+                <a:solidFill>
+                  <a:schemeClr val="tx1"/>
+                </a:solidFill>
+              </a:rPr>
+              <a:t>Final report; a commercial model if available</a:t>
+            </a:r>
+            <a:endParaRPr lang="en-US" sz="1700" dirty="0"/>
+          </a:p>
+        </p:txBody>
+      </p:sp>
+      <p:sp>
+        <p:nvSpPr>
+          <p:cNvPr id="9" name="Text 7"/>
+          <p:cNvSpPr txBox="1"/>
+          <p:nvPr/>
+        </p:nvSpPr>
+        <p:spPr>
+          <a:xfrm>
+            <a:off x="548640" y="5669280"/>
+            <a:ext cx="11064240" cy="548640"/>
+          </a:xfrm>
+          <a:prstGeom prst="rect">
+            <a:avLst/>
+          </a:prstGeom>
+          <a:noFill/>
+          <a:ln/>
+        </p:spPr>
+        <p:txBody>
+          <a:bodyPr wrap="square" lIns="0" tIns="0" rIns="0" bIns="0" rtlCol="0" anchor="ctr"/>
+          <a:lstStyle/>
+          <a:p>
+            <a:pPr algn="ctr" indent="0" marL="0">
+              <a:buNone/>
+            </a:pPr>
+            <a:r>
+              <a:rPr lang="en-US" sz="2000" dirty="0">
+                <a:solidFill>
+                  <a:schemeClr val="tx1"/>
+                </a:solidFill>
+              </a:rPr>
+              <a:t>Every claim pre-registered and checked on 3 seeds; accuracy always reported with its token cost</a:t>
+            </a:r>
+            <a:endParaRPr lang="en-US" sz="2000" dirty="0"/>
+          </a:p>
+        </p:txBody>
+      </p:sp>
+      <p:sp>
+        <p:nvSpPr>
+          <p:cNvPr id="25" name="Slide Number Placeholder 0"/>
+          <p:cNvSpPr>
+            <a:spLocks noGrp="1"/>
+          </p:cNvSpPr>
+          <p:nvPr>
+            <p:ph type="sldNum" sz="quarter" idx="4294967295"/>
+          </p:nvPr>
+        </p:nvSpPr>
+        <p:spPr>
+          <a:xfrm>
+            <a:off x="11155680" y="6355080"/>
+            <a:ext cx="731520" cy="320040"/>
+          </a:xfrm>
+          <a:prstGeom prst="rect">
+            <a:avLst/>
+          </a:prstGeom>
+          <a:extLst>
+            <a:ext uri="{C572A759-6A51-4108-AA02-DFA0A04FC94B}">
+              <ma14:wrappingTextBoxFlag xmlns:ma14="http://schemas.microsoft.com/office/mac/drawingml/2011/main" val="0"/>
+            </a:ext>
+          </a:extLst>
+        </p:spPr>
+        <p:txBody>
+          <a:bodyPr/>
+          <a:lstStyle>
+            <a:lvl1pPr>
+              <a:defRPr sz="1200">
+                <a:solidFill>
+                  <a:srgbClr val="8C8C8C"/>
+                </a:solidFill>
+              </a:defRPr>
+            </a:lvl1pPr>
+          </a:lstStyle>
+          <a:p>
+            <a:pPr algn="r"/>
+            <a:fld id="{F7021451-1387-4CA6-816F-3879F97B5CBC}" type="slidenum">
+              <a:rPr b="0" lang="en-US"/>
+              <a:t>21</a:t>
             </a:fld>
             <a:endParaRPr lang="en-US"/>
           </a:p>

</xml_diff>

<commit_message>
Talk opening for beginners: one idea per slide (let the computer do the math; but two things go wrong)
Co-Authored-By: Claude Opus 5.5 (1M context) <noreply@anthropic.com>
</commit_message>
<xml_diff>
--- a/PROPOSAL_slides_full.pptx
+++ b/PROPOSAL_slides_full.pptx
@@ -127,7 +127,7 @@
   <p:extLst>
     <p:ext uri="{521415D9-36F7-43E2-AB2F-B90AF26B5E84}">
       <p14:sectionLst xmlns:p14="http://schemas.microsoft.com/office/powerpoint/2010/main">
-        <p14:section name="Problem" id="{8b94a9a6-b5bf-c6bd-506f-7605566673a9}">
+        <p14:section name="Problem" id="{269ae58e-58bd-21fa-fb7f-4875c5b6ff82}">
           <p14:sldIdLst>
             <p14:sldId id="256"/>
             <p14:sldId id="257"/>
@@ -136,7 +136,7 @@
             <p14:sldId id="260"/>
           </p14:sldIdLst>
         </p14:section>
-        <p14:section name="Findings" id="{50b8d416-3ba5-9783-68e7-43464c7f7ef9}">
+        <p14:section name="Findings" id="{7a3e5991-1752-7ebf-779d-e4c2a4fbe7c9}">
           <p14:sldIdLst>
             <p14:sldId id="261"/>
             <p14:sldId id="262"/>
@@ -148,7 +148,7 @@
             <p14:sldId id="268"/>
           </p14:sldIdLst>
         </p14:section>
-        <p14:section name="Method" id="{e3455711-e404-48c7-7769-1b26ba2db8d0}">
+        <p14:section name="Method" id="{98d166cd-6c14-f673-1c54-a87b5337f41b}">
           <p14:sldIdLst>
             <p14:sldId id="269"/>
             <p14:sldId id="270"/>
@@ -159,7 +159,7 @@
             <p14:sldId id="275"/>
           </p14:sldIdLst>
         </p14:section>
-        <p14:section name="Next" id="{65127d01-e3dc-c2f3-6fc1-e808b3382e72}">
+        <p14:section name="Next" id="{51043abb-00af-ffb3-58f5-69666bece9d8}">
           <p14:sldIdLst>
             <p14:sldId id="276"/>
           </p14:sldIdLst>

</xml_diff>

<commit_message>
Talk: problem kinds first, answer badges on findings, consistent program names, plainer labels
Co-Authored-By: Claude Opus 5.5 (1M context) <noreply@anthropic.com>
</commit_message>
<xml_diff>
--- a/PROPOSAL_slides_full.pptx
+++ b/PROPOSAL_slides_full.pptx
@@ -127,7 +127,7 @@
   <p:extLst>
     <p:ext uri="{521415D9-36F7-43E2-AB2F-B90AF26B5E84}">
       <p14:sectionLst xmlns:p14="http://schemas.microsoft.com/office/powerpoint/2010/main">
-        <p14:section name="Problem" id="{269ae58e-58bd-21fa-fb7f-4875c5b6ff82}">
+        <p14:section name="Problem" id="{ce6a789c-ffd0-a728-195c-1428c030edba}">
           <p14:sldIdLst>
             <p14:sldId id="256"/>
             <p14:sldId id="257"/>
@@ -136,7 +136,7 @@
             <p14:sldId id="260"/>
           </p14:sldIdLst>
         </p14:section>
-        <p14:section name="Findings" id="{7a3e5991-1752-7ebf-779d-e4c2a4fbe7c9}">
+        <p14:section name="Findings" id="{1453d720-c310-6b85-2091-6da3f2786c0b}">
           <p14:sldIdLst>
             <p14:sldId id="261"/>
             <p14:sldId id="262"/>
@@ -148,7 +148,7 @@
             <p14:sldId id="268"/>
           </p14:sldIdLst>
         </p14:section>
-        <p14:section name="Method" id="{98d166cd-6c14-f673-1c54-a87b5337f41b}">
+        <p14:section name="Method" id="{1bfd19f8-bdab-8cda-2289-5c6615a48809}">
           <p14:sldIdLst>
             <p14:sldId id="269"/>
             <p14:sldId id="270"/>
@@ -159,7 +159,7 @@
             <p14:sldId id="275"/>
           </p14:sldIdLst>
         </p14:section>
-        <p14:section name="Next" id="{51043abb-00af-ffb3-58f5-69666bece9d8}">
+        <p14:section name="Next" id="{c2c3b4d0-afbe-5ca3-6b67-c31969de78fb}">
           <p14:sldIdLst>
             <p14:sldId id="276"/>
           </p14:sldIdLst>

</xml_diff>

<commit_message>
Talk: expected-question index, five question pages, Korean speaker script on the 9 talk slides
Co-Authored-By: Claude Opus 5.5 (1M context) <noreply@anthropic.com>
</commit_message>
<xml_diff>
--- a/PROPOSAL_slides_full.pptx
+++ b/PROPOSAL_slides_full.pptx
@@ -127,7 +127,7 @@
   <p:extLst>
     <p:ext uri="{521415D9-36F7-43E2-AB2F-B90AF26B5E84}">
       <p14:sectionLst xmlns:p14="http://schemas.microsoft.com/office/powerpoint/2010/main">
-        <p14:section name="Problem" id="{30dbc911-6b24-8d81-6018-b2862f84252b}">
+        <p14:section name="Problem" id="{593bb27f-4392-4011-da8b-7f421abd44bf}">
           <p14:sldIdLst>
             <p14:sldId id="256"/>
             <p14:sldId id="257"/>
@@ -136,7 +136,7 @@
             <p14:sldId id="260"/>
           </p14:sldIdLst>
         </p14:section>
-        <p14:section name="Findings" id="{20eae6fa-d0cb-7e37-33af-907f70ffa849}">
+        <p14:section name="Findings" id="{eb1a6273-1c5c-f0b5-6213-75c9795abc89}">
           <p14:sldIdLst>
             <p14:sldId id="261"/>
             <p14:sldId id="262"/>
@@ -148,7 +148,7 @@
             <p14:sldId id="268"/>
           </p14:sldIdLst>
         </p14:section>
-        <p14:section name="Method" id="{38362659-db73-c4c2-a972-b183ae13091e}">
+        <p14:section name="Method" id="{750f4a58-7636-48a3-cb72-ac74823ff78e}">
           <p14:sldIdLst>
             <p14:sldId id="269"/>
             <p14:sldId id="270"/>
@@ -159,7 +159,7 @@
             <p14:sldId id="275"/>
           </p14:sldIdLst>
         </p14:section>
-        <p14:section name="Next" id="{431d4dc3-4747-1d3a-7e21-c9c5ac5c18f6}">
+        <p14:section name="Next" id="{b652aac9-b272-40ce-4db1-5810c119bad3}">
           <p14:sldIdLst>
             <p14:sldId id="276"/>
           </p14:sldIdLst>

</xml_diff>

<commit_message>
Talk: questions raised by each talk slide with answer pages, four fewer extras; Finding 1 counts 30 problems and an 11-line snippet
Co-Authored-By: Claude Opus 5.5 (1M context) <noreply@anthropic.com>
</commit_message>
<xml_diff>
--- a/PROPOSAL_slides_full.pptx
+++ b/PROPOSAL_slides_full.pptx
@@ -127,7 +127,7 @@
   <p:extLst>
     <p:ext uri="{521415D9-36F7-43E2-AB2F-B90AF26B5E84}">
       <p14:sectionLst xmlns:p14="http://schemas.microsoft.com/office/powerpoint/2010/main">
-        <p14:section name="Problem" id="{593bb27f-4392-4011-da8b-7f421abd44bf}">
+        <p14:section name="Problem" id="{98ba3b3e-b56d-5537-5b53-7357399bf26e}">
           <p14:sldIdLst>
             <p14:sldId id="256"/>
             <p14:sldId id="257"/>
@@ -136,7 +136,7 @@
             <p14:sldId id="260"/>
           </p14:sldIdLst>
         </p14:section>
-        <p14:section name="Findings" id="{eb1a6273-1c5c-f0b5-6213-75c9795abc89}">
+        <p14:section name="Findings" id="{e9914dc0-81fd-9676-34bd-7a965f109d13}">
           <p14:sldIdLst>
             <p14:sldId id="261"/>
             <p14:sldId id="262"/>
@@ -148,7 +148,7 @@
             <p14:sldId id="268"/>
           </p14:sldIdLst>
         </p14:section>
-        <p14:section name="Method" id="{750f4a58-7636-48a3-cb72-ac74823ff78e}">
+        <p14:section name="Method" id="{b8e51dca-099f-6427-73c3-7f1cadea9c31}">
           <p14:sldIdLst>
             <p14:sldId id="269"/>
             <p14:sldId id="270"/>
@@ -159,7 +159,7 @@
             <p14:sldId id="275"/>
           </p14:sldIdLst>
         </p14:section>
-        <p14:section name="Next" id="{b652aac9-b272-40ce-4db1-5810c119bad3}">
+        <p14:section name="Next" id="{b43fac82-f3a2-6a4c-ba50-b05e9fb4d7a7}">
           <p14:sldIdLst>
             <p14:sldId id="276"/>
           </p14:sldIdLst>
@@ -2884,7 +2884,7 @@
           <a:p>
             <a:r>
               <a:rPr lang="en-US" dirty="0"/>
-              <a:t>One panel per result. Add the fact: routing 23% to 77-90% (thinking longer 3%, whole manual 7%). Small models gain most: Qwen3-1.7B 0% to 45%, Qwen3-32B 65% to 66% (word problems). Compare two versions: 99% at 4.3k tokens vs always thinking 98% at 5.9k; with 8 extra tools 59%. Think only on a failed check (gpt-oss-120b, contest): 66.3% at 24.7k vs 66.2% at 30.1k. Reuse: 94% of 48 routing days vs 7% with a new program per day; Dynamic Cheatsheet (DC, the model's own notes) 31-40%. All together: fact first then think on failure 87% at 2.5k vs 74% at 4.1k for thinking on the hardest-looking problems (Snell-style) and 83% for choosing the fix by failure type.</a:t>
+              <a:t>One panel per result. Add the fact: routing 23% to 77-90% (thinking longer 3%, long reference sheet 7%). Small models gain most: Qwen3-1.7B 0% to 45%, Qwen3-32B 65% to 66% (word problems). Compare two versions: 99% at 4.3k tokens vs always thinking 98% at 5.9k; with 8 extra tools 59%. Think only on a failed check (gpt-oss-120b, contest): 66.3% at 24.7k vs 66.2% at 30.1k. Reuse: 94% of 48 routing days vs 7% with a new program per day; Dynamic Cheatsheet (DC, the model's own notes) 31-40%. All together: fact first then think on failure 87% at 2.5k vs 74% at 4.1k for thinking on the hardest-looking problems (Snell-style) and 83% for choosing the fix by failure type.</a:t>
             </a:r>
             <a:endParaRPr lang="en-US" dirty="0"/>
           </a:p>
@@ -2972,7 +2972,7 @@
           <a:p>
             <a:r>
               <a:rPr lang="en-US" dirty="0"/>
-              <a:t>The model writes the program (the right side shows the line that matters). With a long reference sheet it guesses a plausible function name that does not exist and crashes; with five lines showing the exact call it writes the right one. Thinking longer cannot supply a fact it does not have (3 of 100). On the 56 standard Solomon routing problems, three such facts together take gpt-oss-120b to a valid plan on every instance.</a:t>
+              <a:t>The model writes the program (the right side shows the line that matters). With a long reference sheet it guesses a plausible function name that does not exist and crashes; with the exact usage (11 lines) it writes the right one. Thinking longer cannot supply a fact it does not have (3%). On the 56 standard Solomon routing problems, three such facts together take gpt-oss-120b to a valid plan on every instance.</a:t>
             </a:r>
             <a:endParaRPr lang="en-US" dirty="0"/>
           </a:p>
@@ -15273,7 +15273,7 @@
                             <a:srgbClr val="38761D"/>
                           </a:solidFill>
                         </a:rPr>
-                        <a:t>exact 5-line snippet: 77% · 1.7k</a:t>
+                        <a:t>exact snippet: 77% · 1.7k</a:t>
                       </a:r>
                       <a:endParaRPr lang="en-US" sz="1500" dirty="0"/>
                     </a:p>
@@ -16687,7 +16687,7 @@
                             <a:srgbClr val="38761D"/>
                           </a:solidFill>
                         </a:rPr>
-                        <a:t>5 exact lines beat the manual and thinking; facts mined without a human</a:t>
+                        <a:t>an exact snippet beats the manual and thinking; facts mined without a human</a:t>
                       </a:r>
                       <a:endParaRPr lang="en-US" sz="1300" dirty="0"/>
                     </a:p>
@@ -27502,7 +27502,7 @@
                   <a:schemeClr val="tx1"/>
                 </a:solidFill>
               </a:rPr>
-              <a:t>whole manual</a:t>
+              <a:t>long manual</a:t>
             </a:r>
             <a:endParaRPr lang="en-US" sz="1300" dirty="0"/>
           </a:p>
@@ -27510,7 +27510,7 @@
       </p:sp>
       <p:sp>
         <p:nvSpPr>
-          <p:cNvPr id="13" name="Add the missing fact whole manual"/>
+          <p:cNvPr id="13" name="Add the missing fact long manual"/>
           <p:cNvSpPr/>
           <p:nvPr/>
         </p:nvSpPr>
@@ -27599,7 +27599,7 @@
                   <a:schemeClr val="tx1"/>
                 </a:solidFill>
               </a:rPr>
-              <a:t>5 exact lines</a:t>
+              <a:t>exact usage</a:t>
             </a:r>
             <a:endParaRPr lang="en-US" sz="1300" dirty="0"/>
           </a:p>
@@ -27607,7 +27607,7 @@
       </p:sp>
       <p:sp>
         <p:nvSpPr>
-          <p:cNvPr id="16" name="Add the missing fact 5 exact lines"/>
+          <p:cNvPr id="16" name="Add the missing fact exact usage"/>
           <p:cNvSpPr/>
           <p:nvPr/>
         </p:nvSpPr>
@@ -29866,7 +29866,7 @@
       </p:sp>
       <p:sp>
         <p:nvSpPr>
-          <p:cNvPr id="10" name="prompt Prompt B: task + 5 lines of exact usage"/>
+          <p:cNvPr id="10" name="prompt Prompt B: task + the exact usage (11 lines)"/>
           <p:cNvSpPr/>
           <p:nvPr/>
         </p:nvSpPr>
@@ -29922,7 +29922,7 @@
                 <a:ea typeface="Calibri" pitchFamily="34" charset="-122"/>
                 <a:cs typeface="Calibri" pitchFamily="34" charset="-120"/>
               </a:rPr>
-              <a:t>Prompt B: task + 5 lines of exact usage</a:t>
+              <a:t>Prompt B: task + the exact usage (11 lines)</a:t>
             </a:r>
             <a:endParaRPr lang="en-US" sz="1150" dirty="0"/>
           </a:p>
@@ -30133,7 +30133,7 @@
                   <a:schemeClr val="tx1"/>
                 </a:solidFill>
               </a:rPr>
-              <a:t>Out of 100 routing problems, how many it solves best:</a:t>
+              <a:t>% of 30 routing problems solved optimally:</a:t>
             </a:r>
             <a:endParaRPr lang="en-US" sz="1700" dirty="0"/>
           </a:p>
@@ -30230,7 +30230,7 @@
                   <a:srgbClr val="7F7F7F"/>
                 </a:solidFill>
               </a:rPr>
-              <a:t>23</a:t>
+              <a:t>23%</a:t>
             </a:r>
             <a:endParaRPr lang="en-US" sz="1800" dirty="0"/>
           </a:p>
@@ -30327,7 +30327,7 @@
                   <a:srgbClr val="C00000"/>
                 </a:solidFill>
               </a:rPr>
-              <a:t>3</a:t>
+              <a:t>3%</a:t>
             </a:r>
             <a:endParaRPr lang="en-US" sz="1800" dirty="0"/>
           </a:p>
@@ -30424,7 +30424,7 @@
                   <a:srgbClr val="C00000"/>
                 </a:solidFill>
               </a:rPr>
-              <a:t>7</a:t>
+              <a:t>7%</a:t>
             </a:r>
             <a:endParaRPr lang="en-US" sz="1800" dirty="0"/>
           </a:p>
@@ -30460,7 +30460,7 @@
                   <a:schemeClr val="tx1"/>
                 </a:solidFill>
               </a:rPr>
-              <a:t>5 exact lines</a:t>
+              <a:t>Exact usage</a:t>
             </a:r>
             <a:endParaRPr lang="en-US" sz="1600" dirty="0"/>
           </a:p>
@@ -30468,7 +30468,7 @@
       </p:sp>
       <p:sp>
         <p:nvSpPr>
-          <p:cNvPr id="27" name="bar 5 exact lines"/>
+          <p:cNvPr id="27" name="bar Exact usage"/>
           <p:cNvSpPr/>
           <p:nvPr/>
         </p:nvSpPr>
@@ -30521,7 +30521,7 @@
                   <a:srgbClr val="70AD47"/>
                 </a:solidFill>
               </a:rPr>
-              <a:t>77–90</a:t>
+              <a:t>77–90%</a:t>
             </a:r>
             <a:endParaRPr lang="en-US" sz="1800" dirty="0"/>
           </a:p>

</xml_diff>

<commit_message>
Scope of each finding: 'holds on' strips, a coverage page, proofs marked as an extension; 624 runs = 208 problems x 3 models
Co-Authored-By: Claude Opus 5.5 (1M context) <noreply@anthropic.com>
</commit_message>
<xml_diff>
--- a/PROPOSAL_slides_full.pptx
+++ b/PROPOSAL_slides_full.pptx
@@ -127,7 +127,7 @@
   <p:extLst>
     <p:ext uri="{521415D9-36F7-43E2-AB2F-B90AF26B5E84}">
       <p14:sectionLst xmlns:p14="http://schemas.microsoft.com/office/powerpoint/2010/main">
-        <p14:section name="Problem" id="{98ba3b3e-b56d-5537-5b53-7357399bf26e}">
+        <p14:section name="Problem" id="{e18d1547-2d64-ca9f-a368-baa64ebd6b84}">
           <p14:sldIdLst>
             <p14:sldId id="256"/>
             <p14:sldId id="257"/>
@@ -136,7 +136,7 @@
             <p14:sldId id="260"/>
           </p14:sldIdLst>
         </p14:section>
-        <p14:section name="Findings" id="{e9914dc0-81fd-9676-34bd-7a965f109d13}">
+        <p14:section name="Findings" id="{8dc2ffc2-c344-9381-3151-6c99d772e962}">
           <p14:sldIdLst>
             <p14:sldId id="261"/>
             <p14:sldId id="262"/>
@@ -148,7 +148,7 @@
             <p14:sldId id="268"/>
           </p14:sldIdLst>
         </p14:section>
-        <p14:section name="Method" id="{b8e51dca-099f-6427-73c3-7f1cadea9c31}">
+        <p14:section name="Method" id="{ae14a483-0c13-875b-2736-2c67b6ee1eac}">
           <p14:sldIdLst>
             <p14:sldId id="269"/>
             <p14:sldId id="270"/>
@@ -159,7 +159,7 @@
             <p14:sldId id="275"/>
           </p14:sldIdLst>
         </p14:section>
-        <p14:section name="Next" id="{b43fac82-f3a2-6a4c-ba50-b05e9fb4d7a7}">
+        <p14:section name="Next" id="{58d2d34b-8ef8-59ab-2743-ad9e30546fe5}">
           <p14:sldIdLst>
             <p14:sldId id="276"/>
           </p14:sldIdLst>
@@ -2092,7 +2092,7 @@
           <a:p>
             <a:r>
               <a:rPr lang="en-US" dirty="0"/>
-              <a:t>All baselines were run by us on our benchmarks. Models: U1 policies over Qwen3-8B / Qwen3-32B / Qwen3.6 (624 problems); contest geometry gpt-oss-120b (311); selection Qwen3-8B (300 geometry instances, 3 candidates); documentation Qwen3-32B on CVRP; tools Qwen3-32B on 5 geometry tasks; daily routing gpt-oss-120b on 48 held-out Solomon instances. Tokens are output tokens per problem. ORLM-LLaMA-3-8B was run in our harness on MAMO (863 held-out word problems; greedy 80.5 / 35.5% on Easy / Complex, as reported). More rows (MBR-exec, majority vote, DeepConf, Self-Debugging, Mixture-of-Thought cascade, BM25 retrieval) are in PROPOSAL.md section 6.</a:t>
+              <a:t>All baselines were run by us on our benchmarks. Models: U1 policies over Qwen3-8B / Qwen3-32B / Qwen3.6 (208 problems × 3 models); contest geometry gpt-oss-120b (311); selection Qwen3-8B (300 geometry instances, 3 candidates); documentation Qwen3-32B on CVRP; tools Qwen3-32B on 5 geometry tasks; daily routing gpt-oss-120b on 48 held-out Solomon instances. Tokens are output tokens per problem. ORLM-LLaMA-3-8B was run in our harness on MAMO (863 held-out word problems; greedy 80.5 / 35.5% on Easy / Complex, as reported). More rows (MBR-exec, majority vote, DeepConf, Self-Debugging, Mixture-of-Thought cascade, BM25 retrieval) are in PROPOSAL.md section 6.</a:t>
             </a:r>
             <a:endParaRPr lang="en-US" dirty="0"/>
           </a:p>
@@ -12204,7 +12204,7 @@
                   <a:schemeClr val="tx1"/>
                 </a:solidFill>
               </a:rPr>
-              <a:t>All 624 problems, 3 models: % solved · tokens</a:t>
+              <a:t>208 problems × 3 models: % solved · tokens</a:t>
             </a:r>
             <a:endParaRPr lang="en-US" sz="1500" dirty="0"/>
           </a:p>
@@ -12248,7 +12248,7 @@
       </p:sp>
       <p:sp>
         <p:nvSpPr>
-          <p:cNvPr id="52" name="All 624 problems, 3 models: % solved · tokens think on hardest"/>
+          <p:cNvPr id="52" name="208 problems × 3 models: % solved · tokens think on hardest"/>
           <p:cNvSpPr/>
           <p:nvPr/>
         </p:nvSpPr>
@@ -12345,7 +12345,7 @@
       </p:sp>
       <p:sp>
         <p:nvSpPr>
-          <p:cNvPr id="55" name="All 624 problems, 3 models: % solved · tokens our method"/>
+          <p:cNvPr id="55" name="208 problems × 3 models: % solved · tokens our method"/>
           <p:cNvSpPr/>
           <p:nvPr/>
         </p:nvSpPr>
@@ -12986,7 +12986,7 @@
                   <a:schemeClr val="tx1"/>
                 </a:solidFill>
               </a:rPr>
-              <a:t>Same 624 geometry and optimization problems, 3 models: % solved · tokens per problem</a:t>
+              <a:t>Same 208 geometry and optimization problems × 3 models: % solved · tokens per problem</a:t>
             </a:r>
             <a:endParaRPr lang="en-US" sz="1800" dirty="0"/>
           </a:p>
@@ -29184,7 +29184,7 @@
                   <a:schemeClr val="tx2"/>
                 </a:solidFill>
               </a:rPr>
-              <a:t>624 problems, 3 models: % · tokens</a:t>
+              <a:t>208 problems × 3 models: % · tokens</a:t>
             </a:r>
             <a:endParaRPr lang="en-US" sz="1200" dirty="0"/>
           </a:p>

</xml_diff>

<commit_message>
Talk deck rename: generator, README and log follow the new name
Co-Authored-By: Claude Opus 5.5 (1M context) <noreply@anthropic.com>
</commit_message>
<xml_diff>
--- a/PROPOSAL_slides_full.pptx
+++ b/PROPOSAL_slides_full.pptx
@@ -127,7 +127,7 @@
   <p:extLst>
     <p:ext uri="{521415D9-36F7-43E2-AB2F-B90AF26B5E84}">
       <p14:sectionLst xmlns:p14="http://schemas.microsoft.com/office/powerpoint/2010/main">
-        <p14:section name="Problem" id="{e18d1547-2d64-ca9f-a368-baa64ebd6b84}">
+        <p14:section name="Problem" id="{6bf18f48-ca73-0f85-fafd-8e24cf34fb27}">
           <p14:sldIdLst>
             <p14:sldId id="256"/>
             <p14:sldId id="257"/>
@@ -136,7 +136,7 @@
             <p14:sldId id="260"/>
           </p14:sldIdLst>
         </p14:section>
-        <p14:section name="Findings" id="{8dc2ffc2-c344-9381-3151-6c99d772e962}">
+        <p14:section name="Findings" id="{4ef3b5dd-937c-89c6-99a4-e5a13340b6cc}">
           <p14:sldIdLst>
             <p14:sldId id="261"/>
             <p14:sldId id="262"/>
@@ -148,7 +148,7 @@
             <p14:sldId id="268"/>
           </p14:sldIdLst>
         </p14:section>
-        <p14:section name="Method" id="{ae14a483-0c13-875b-2736-2c67b6ee1eac}">
+        <p14:section name="Method" id="{a3d86d18-4903-a13a-481b-1e6030a9652a}">
           <p14:sldIdLst>
             <p14:sldId id="269"/>
             <p14:sldId id="270"/>
@@ -159,7 +159,7 @@
             <p14:sldId id="275"/>
           </p14:sldIdLst>
         </p14:section>
-        <p14:section name="Next" id="{58d2d34b-8ef8-59ab-2743-ad9e30546fe5}">
+        <p14:section name="Next" id="{52b780b4-f3c1-d331-ca37-c77a79335aa0}">
           <p14:sldIdLst>
             <p14:sldId id="276"/>
           </p14:sldIdLst>

</xml_diff>

<commit_message>
Correct the contest check: 66.3% needs the examples plus a brute-force program; the examples alone give 65.0%
Co-Authored-By: Claude Opus 5.5 (1M context) <noreply@anthropic.com>
</commit_message>
<xml_diff>
--- a/PROPOSAL_slides_full.pptx
+++ b/PROPOSAL_slides_full.pptx
@@ -127,7 +127,7 @@
   <p:extLst>
     <p:ext uri="{521415D9-36F7-43E2-AB2F-B90AF26B5E84}">
       <p14:sectionLst xmlns:p14="http://schemas.microsoft.com/office/powerpoint/2010/main">
-        <p14:section name="Problem" id="{6bf18f48-ca73-0f85-fafd-8e24cf34fb27}">
+        <p14:section name="Problem" id="{d4a5b5d8-ed51-5068-95e5-843092cf3943}">
           <p14:sldIdLst>
             <p14:sldId id="256"/>
             <p14:sldId id="257"/>
@@ -136,7 +136,7 @@
             <p14:sldId id="260"/>
           </p14:sldIdLst>
         </p14:section>
-        <p14:section name="Findings" id="{4ef3b5dd-937c-89c6-99a4-e5a13340b6cc}">
+        <p14:section name="Findings" id="{0d8156f6-7180-2e28-23e6-b75e8ff6d2be}">
           <p14:sldIdLst>
             <p14:sldId id="261"/>
             <p14:sldId id="262"/>
@@ -148,7 +148,7 @@
             <p14:sldId id="268"/>
           </p14:sldIdLst>
         </p14:section>
-        <p14:section name="Method" id="{a3d86d18-4903-a13a-481b-1e6030a9652a}">
+        <p14:section name="Method" id="{d6c75ac8-c6a7-81d8-1052-7c2c92e85838}">
           <p14:sldIdLst>
             <p14:sldId id="269"/>
             <p14:sldId id="270"/>
@@ -159,7 +159,7 @@
             <p14:sldId id="275"/>
           </p14:sldIdLst>
         </p14:section>
-        <p14:section name="Next" id="{52b780b4-f3c1-d331-ca37-c77a79335aa0}">
+        <p14:section name="Next" id="{7d3e9b75-9540-5f71-f440-1371fed8334c}">
           <p14:sldIdLst>
             <p14:sldId id="276"/>
           </p14:sldIdLst>
@@ -4754,7 +4754,7 @@
                   <a:schemeClr val="tx1"/>
                 </a:solidFill>
               </a:rPr>
-              <a:t>Over 311 problems (gpt-oss-120b): same 66% solved as always thinking hard, 18% fewer tokens</a:t>
+              <a:t>Over 311 problems (gpt-oss-120b), with a quick brute-force check added: same 66% as always thinking hard, 18% fewer tokens</a:t>
             </a:r>
             <a:endParaRPr lang="en-US" sz="1700" dirty="0"/>
           </a:p>
@@ -4887,7 +4887,7 @@
                   <a:schemeClr val="tx1"/>
                 </a:solidFill>
               </a:rPr>
-              <a:t>Think hard only on a failed check</a:t>
+              <a:t>Think hard only when a check fails</a:t>
             </a:r>
             <a:endParaRPr lang="en-US" sz="1600" dirty="0"/>
           </a:p>
@@ -4895,7 +4895,7 @@
       </p:sp>
       <p:sp>
         <p:nvSpPr>
-          <p:cNvPr id="26" name="bar Think hard only on a failed check"/>
+          <p:cNvPr id="26" name="bar Think hard only when a check fails"/>
           <p:cNvSpPr/>
           <p:nvPr/>
         </p:nvSpPr>
@@ -14805,7 +14805,7 @@
                             <a:srgbClr val="38761D"/>
                           </a:solidFill>
                         </a:rPr>
-                        <a:t>think only on a failed check: 66.3% · 24.7k</a:t>
+                        <a:t>think when the examples or a brute-force check fail: 66.3% · 24.7k</a:t>
                       </a:r>
                       <a:endParaRPr lang="en-US" sz="1500" dirty="0"/>
                     </a:p>
@@ -28688,7 +28688,7 @@
                   <a:schemeClr val="tx1"/>
                 </a:solidFill>
               </a:rPr>
-              <a:t>high on failure</a:t>
+              <a:t>examples fail</a:t>
             </a:r>
             <a:endParaRPr lang="en-US" sz="1300" dirty="0"/>
           </a:p>
@@ -28696,13 +28696,110 @@
       </p:sp>
       <p:sp>
         <p:nvSpPr>
-          <p:cNvPr id="49" name="Think only on failure high on failure"/>
+          <p:cNvPr id="49" name="Think only on failure examples fail"/>
           <p:cNvSpPr/>
           <p:nvPr/>
         </p:nvSpPr>
         <p:spPr>
           <a:xfrm>
             <a:off x="2029968" y="5212080"/>
+            <a:ext cx="742950" cy="237744"/>
+          </a:xfrm>
+          <a:prstGeom prst="rect">
+            <a:avLst/>
+          </a:prstGeom>
+          <a:solidFill>
+            <a:srgbClr val="5B9BD5"/>
+          </a:solidFill>
+          <a:ln w="6350">
+            <a:solidFill>
+              <a:srgbClr val="5B9BD5"/>
+            </a:solidFill>
+            <a:prstDash val="solid"/>
+          </a:ln>
+        </p:spPr>
+      </p:sp>
+      <p:sp>
+        <p:nvSpPr>
+          <p:cNvPr id="50" name="Text 48"/>
+          <p:cNvSpPr txBox="1"/>
+          <p:nvPr/>
+        </p:nvSpPr>
+        <p:spPr>
+          <a:xfrm>
+            <a:off x="2827782" y="5166360"/>
+            <a:ext cx="1051560" cy="329184"/>
+          </a:xfrm>
+          <a:prstGeom prst="rect">
+            <a:avLst/>
+          </a:prstGeom>
+          <a:noFill/>
+          <a:ln/>
+        </p:spPr>
+        <p:txBody>
+          <a:bodyPr wrap="square" lIns="0" tIns="0" rIns="0" bIns="0" rtlCol="0" anchor="ctr"/>
+          <a:lstStyle/>
+          <a:p>
+            <a:pPr indent="0" marL="0">
+              <a:buNone/>
+            </a:pPr>
+            <a:r>
+              <a:rPr lang="en-US" sz="1300" b="1" dirty="0">
+                <a:solidFill>
+                  <a:srgbClr val="5B9BD5"/>
+                </a:solidFill>
+              </a:rPr>
+              <a:t>65% · 20k</a:t>
+            </a:r>
+            <a:endParaRPr lang="en-US" sz="1300" dirty="0"/>
+          </a:p>
+        </p:txBody>
+      </p:sp>
+      <p:sp>
+        <p:nvSpPr>
+          <p:cNvPr id="51" name="Text 49"/>
+          <p:cNvSpPr txBox="1"/>
+          <p:nvPr/>
+        </p:nvSpPr>
+        <p:spPr>
+          <a:xfrm>
+            <a:off x="548640" y="5550408"/>
+            <a:ext cx="1417320" cy="329184"/>
+          </a:xfrm>
+          <a:prstGeom prst="rect">
+            <a:avLst/>
+          </a:prstGeom>
+          <a:noFill/>
+          <a:ln/>
+        </p:spPr>
+        <p:txBody>
+          <a:bodyPr wrap="square" lIns="0" tIns="0" rIns="0" bIns="0" rtlCol="0" anchor="ctr"/>
+          <a:lstStyle/>
+          <a:p>
+            <a:pPr algn="r" indent="0" marL="0">
+              <a:buNone/>
+            </a:pPr>
+            <a:r>
+              <a:rPr lang="en-US" sz="1300" dirty="0">
+                <a:solidFill>
+                  <a:schemeClr val="tx1"/>
+                </a:solidFill>
+              </a:rPr>
+              <a:t>+ brute force</a:t>
+            </a:r>
+            <a:endParaRPr lang="en-US" sz="1300" dirty="0"/>
+          </a:p>
+        </p:txBody>
+      </p:sp>
+      <p:sp>
+        <p:nvSpPr>
+          <p:cNvPr id="52" name="Think only on failure + brute force"/>
+          <p:cNvSpPr/>
+          <p:nvPr/>
+        </p:nvSpPr>
+        <p:spPr>
+          <a:xfrm>
+            <a:off x="2029968" y="5596128"/>
             <a:ext cx="757809" cy="237744"/>
           </a:xfrm>
           <a:prstGeom prst="rect">
@@ -28721,13 +28818,13 @@
       </p:sp>
       <p:sp>
         <p:nvSpPr>
-          <p:cNvPr id="50" name="Text 48"/>
-          <p:cNvSpPr txBox="1"/>
-          <p:nvPr/>
-        </p:nvSpPr>
-        <p:spPr>
-          <a:xfrm>
-            <a:off x="2842641" y="5166360"/>
+          <p:cNvPr id="53" name="Text 51"/>
+          <p:cNvSpPr txBox="1"/>
+          <p:nvPr/>
+        </p:nvSpPr>
+        <p:spPr>
+          <a:xfrm>
+            <a:off x="2842641" y="5550408"/>
             <a:ext cx="1051560" cy="329184"/>
           </a:xfrm>
           <a:prstGeom prst="rect">
@@ -28757,7 +28854,7 @@
       </p:sp>
       <p:sp>
         <p:nvSpPr>
-          <p:cNvPr id="51" name="Text 49"/>
+          <p:cNvPr id="54" name="Text 52"/>
           <p:cNvSpPr txBox="1"/>
           <p:nvPr/>
         </p:nvSpPr>
@@ -28793,7 +28890,7 @@
       </p:sp>
       <p:sp>
         <p:nvSpPr>
-          <p:cNvPr id="52" name="Text 50"/>
+          <p:cNvPr id="55" name="Text 53"/>
           <p:cNvSpPr txBox="1"/>
           <p:nvPr/>
         </p:nvSpPr>
@@ -28829,7 +28926,7 @@
       </p:sp>
       <p:sp>
         <p:nvSpPr>
-          <p:cNvPr id="53" name="Text 51"/>
+          <p:cNvPr id="56" name="Text 54"/>
           <p:cNvSpPr txBox="1"/>
           <p:nvPr/>
         </p:nvSpPr>
@@ -28865,7 +28962,7 @@
       </p:sp>
       <p:sp>
         <p:nvSpPr>
-          <p:cNvPr id="54" name="Reuse a checked program new each day"/>
+          <p:cNvPr id="57" name="Reuse a checked program new each day"/>
           <p:cNvSpPr/>
           <p:nvPr/>
         </p:nvSpPr>
@@ -28890,7 +28987,7 @@
       </p:sp>
       <p:sp>
         <p:nvSpPr>
-          <p:cNvPr id="55" name="Text 53"/>
+          <p:cNvPr id="58" name="Text 56"/>
           <p:cNvSpPr txBox="1"/>
           <p:nvPr/>
         </p:nvSpPr>
@@ -28926,7 +29023,7 @@
       </p:sp>
       <p:sp>
         <p:nvSpPr>
-          <p:cNvPr id="56" name="Text 54"/>
+          <p:cNvPr id="59" name="Text 57"/>
           <p:cNvSpPr txBox="1"/>
           <p:nvPr/>
         </p:nvSpPr>
@@ -28962,7 +29059,7 @@
       </p:sp>
       <p:sp>
         <p:nvSpPr>
-          <p:cNvPr id="57" name="Reuse a checked program own notes"/>
+          <p:cNvPr id="60" name="Reuse a checked program own notes"/>
           <p:cNvSpPr/>
           <p:nvPr/>
         </p:nvSpPr>
@@ -28987,7 +29084,7 @@
       </p:sp>
       <p:sp>
         <p:nvSpPr>
-          <p:cNvPr id="58" name="Text 56"/>
+          <p:cNvPr id="61" name="Text 59"/>
           <p:cNvSpPr txBox="1"/>
           <p:nvPr/>
         </p:nvSpPr>
@@ -29023,7 +29120,7 @@
       </p:sp>
       <p:sp>
         <p:nvSpPr>
-          <p:cNvPr id="59" name="Text 57"/>
+          <p:cNvPr id="62" name="Text 60"/>
           <p:cNvSpPr txBox="1"/>
           <p:nvPr/>
         </p:nvSpPr>
@@ -29059,7 +29156,7 @@
       </p:sp>
       <p:sp>
         <p:nvSpPr>
-          <p:cNvPr id="60" name="Reuse a checked program reuse one"/>
+          <p:cNvPr id="63" name="Reuse a checked program reuse one"/>
           <p:cNvSpPr/>
           <p:nvPr/>
         </p:nvSpPr>
@@ -29084,7 +29181,7 @@
       </p:sp>
       <p:sp>
         <p:nvSpPr>
-          <p:cNvPr id="61" name="Text 59"/>
+          <p:cNvPr id="64" name="Text 62"/>
           <p:cNvSpPr txBox="1"/>
           <p:nvPr/>
         </p:nvSpPr>
@@ -29120,7 +29217,7 @@
       </p:sp>
       <p:sp>
         <p:nvSpPr>
-          <p:cNvPr id="62" name="Text 60"/>
+          <p:cNvPr id="65" name="Text 63"/>
           <p:cNvSpPr txBox="1"/>
           <p:nvPr/>
         </p:nvSpPr>
@@ -29156,7 +29253,7 @@
       </p:sp>
       <p:sp>
         <p:nvSpPr>
-          <p:cNvPr id="63" name="Text 61"/>
+          <p:cNvPr id="66" name="Text 64"/>
           <p:cNvSpPr txBox="1"/>
           <p:nvPr/>
         </p:nvSpPr>
@@ -29192,7 +29289,7 @@
       </p:sp>
       <p:sp>
         <p:nvSpPr>
-          <p:cNvPr id="64" name="Text 62"/>
+          <p:cNvPr id="67" name="Text 65"/>
           <p:cNvSpPr txBox="1"/>
           <p:nvPr/>
         </p:nvSpPr>
@@ -29228,7 +29325,7 @@
       </p:sp>
       <p:sp>
         <p:nvSpPr>
-          <p:cNvPr id="65" name="All together think on hardest"/>
+          <p:cNvPr id="68" name="All together think on hardest"/>
           <p:cNvSpPr/>
           <p:nvPr/>
         </p:nvSpPr>
@@ -29253,7 +29350,7 @@
       </p:sp>
       <p:sp>
         <p:nvSpPr>
-          <p:cNvPr id="66" name="Text 64"/>
+          <p:cNvPr id="69" name="Text 67"/>
           <p:cNvSpPr txBox="1"/>
           <p:nvPr/>
         </p:nvSpPr>
@@ -29289,7 +29386,7 @@
       </p:sp>
       <p:sp>
         <p:nvSpPr>
-          <p:cNvPr id="67" name="Text 65"/>
+          <p:cNvPr id="70" name="Text 68"/>
           <p:cNvSpPr txBox="1"/>
           <p:nvPr/>
         </p:nvSpPr>
@@ -29325,7 +29422,7 @@
       </p:sp>
       <p:sp>
         <p:nvSpPr>
-          <p:cNvPr id="68" name="All together fix by type"/>
+          <p:cNvPr id="71" name="All together fix by type"/>
           <p:cNvSpPr/>
           <p:nvPr/>
         </p:nvSpPr>
@@ -29350,7 +29447,7 @@
       </p:sp>
       <p:sp>
         <p:nvSpPr>
-          <p:cNvPr id="69" name="Text 67"/>
+          <p:cNvPr id="72" name="Text 70"/>
           <p:cNvSpPr txBox="1"/>
           <p:nvPr/>
         </p:nvSpPr>
@@ -29386,7 +29483,7 @@
       </p:sp>
       <p:sp>
         <p:nvSpPr>
-          <p:cNvPr id="70" name="Text 68"/>
+          <p:cNvPr id="73" name="Text 71"/>
           <p:cNvSpPr txBox="1"/>
           <p:nvPr/>
         </p:nvSpPr>
@@ -29422,7 +29519,7 @@
       </p:sp>
       <p:sp>
         <p:nvSpPr>
-          <p:cNvPr id="71" name="All together fact first"/>
+          <p:cNvPr id="74" name="All together fact first"/>
           <p:cNvSpPr/>
           <p:nvPr/>
         </p:nvSpPr>
@@ -29447,7 +29544,7 @@
       </p:sp>
       <p:sp>
         <p:nvSpPr>
-          <p:cNvPr id="72" name="Text 70"/>
+          <p:cNvPr id="75" name="Text 73"/>
           <p:cNvSpPr txBox="1"/>
           <p:nvPr/>
         </p:nvSpPr>

</xml_diff>

<commit_message>
Speaker notes: Korean talk script follows the current slides; a short Korean answer on every extra page
Co-Authored-By: Claude Opus 5.5 (1M context) <noreply@anthropic.com>
</commit_message>
<xml_diff>
--- a/PROPOSAL_slides_full.pptx
+++ b/PROPOSAL_slides_full.pptx
@@ -127,7 +127,7 @@
   <p:extLst>
     <p:ext uri="{521415D9-36F7-43E2-AB2F-B90AF26B5E84}">
       <p14:sectionLst xmlns:p14="http://schemas.microsoft.com/office/powerpoint/2010/main">
-        <p14:section name="Problem" id="{d4a5b5d8-ed51-5068-95e5-843092cf3943}">
+        <p14:section name="Problem" id="{8ea3e73e-3998-4461-2357-6013af2c42a1}">
           <p14:sldIdLst>
             <p14:sldId id="256"/>
             <p14:sldId id="257"/>
@@ -136,7 +136,7 @@
             <p14:sldId id="260"/>
           </p14:sldIdLst>
         </p14:section>
-        <p14:section name="Findings" id="{0d8156f6-7180-2e28-23e6-b75e8ff6d2be}">
+        <p14:section name="Findings" id="{c2a84c9b-6d50-ea39-7f71-52c2747f2d28}">
           <p14:sldIdLst>
             <p14:sldId id="261"/>
             <p14:sldId id="262"/>
@@ -148,7 +148,7 @@
             <p14:sldId id="268"/>
           </p14:sldIdLst>
         </p14:section>
-        <p14:section name="Method" id="{d6c75ac8-c6a7-81d8-1052-7c2c92e85838}">
+        <p14:section name="Method" id="{6276ede7-f93d-79d1-8db7-90e6202052c5}">
           <p14:sldIdLst>
             <p14:sldId id="269"/>
             <p14:sldId id="270"/>
@@ -159,7 +159,7 @@
             <p14:sldId id="275"/>
           </p14:sldIdLst>
         </p14:section>
-        <p14:section name="Next" id="{7d3e9b75-9540-5f71-f440-1371fed8334c}">
+        <p14:section name="Next" id="{c2ec15f7-4fe1-02c6-a38b-4c8e8c684672}">
           <p14:sldIdLst>
             <p14:sldId id="276"/>
           </p14:sldIdLst>

</xml_diff>

<commit_message>
Talk: why these problems and how they differ (extra page, slide 2 caption, script)
Co-Authored-By: Claude Opus 5.5 (1M context) <noreply@anthropic.com>
</commit_message>
<xml_diff>
--- a/PROPOSAL_slides_full.pptx
+++ b/PROPOSAL_slides_full.pptx
@@ -127,7 +127,7 @@
   <p:extLst>
     <p:ext uri="{521415D9-36F7-43E2-AB2F-B90AF26B5E84}">
       <p14:sectionLst xmlns:p14="http://schemas.microsoft.com/office/powerpoint/2010/main">
-        <p14:section name="Problem" id="{8ea3e73e-3998-4461-2357-6013af2c42a1}">
+        <p14:section name="Problem" id="{dc35fe0d-2fd2-c359-dbe3-1aa8b8ba8d26}">
           <p14:sldIdLst>
             <p14:sldId id="256"/>
             <p14:sldId id="257"/>
@@ -136,7 +136,7 @@
             <p14:sldId id="260"/>
           </p14:sldIdLst>
         </p14:section>
-        <p14:section name="Findings" id="{c2a84c9b-6d50-ea39-7f71-52c2747f2d28}">
+        <p14:section name="Findings" id="{19b7609a-ae34-08fd-c1f8-9a86ee74b82b}">
           <p14:sldIdLst>
             <p14:sldId id="261"/>
             <p14:sldId id="262"/>
@@ -148,7 +148,7 @@
             <p14:sldId id="268"/>
           </p14:sldIdLst>
         </p14:section>
-        <p14:section name="Method" id="{6276ede7-f93d-79d1-8db7-90e6202052c5}">
+        <p14:section name="Method" id="{2f296922-1049-0344-1c34-8bacb321cbb9}">
           <p14:sldIdLst>
             <p14:sldId id="269"/>
             <p14:sldId id="270"/>
@@ -159,7 +159,7 @@
             <p14:sldId id="275"/>
           </p14:sldIdLst>
         </p14:section>
-        <p14:section name="Next" id="{c2ec15f7-4fe1-02c6-a38b-4c8e8c684672}">
+        <p14:section name="Next" id="{5d763f58-1750-9484-6a73-f0dec228d067}">
           <p14:sldIdLst>
             <p14:sldId id="276"/>
           </p14:sldIdLst>

</xml_diff>

<commit_message>
Talk slide 2: the four kinds in two families, no math and proofs in the talk or its script
Co-Authored-By: Claude Opus 5.5 (1M context) <noreply@anthropic.com>
</commit_message>
<xml_diff>
--- a/PROPOSAL_slides_full.pptx
+++ b/PROPOSAL_slides_full.pptx
@@ -127,7 +127,7 @@
   <p:extLst>
     <p:ext uri="{521415D9-36F7-43E2-AB2F-B90AF26B5E84}">
       <p14:sectionLst xmlns:p14="http://schemas.microsoft.com/office/powerpoint/2010/main">
-        <p14:section name="Problem" id="{dc35fe0d-2fd2-c359-dbe3-1aa8b8ba8d26}">
+        <p14:section name="Problem" id="{b960755b-d78f-eddd-e014-254fed8c63b5}">
           <p14:sldIdLst>
             <p14:sldId id="256"/>
             <p14:sldId id="257"/>
@@ -136,7 +136,7 @@
             <p14:sldId id="260"/>
           </p14:sldIdLst>
         </p14:section>
-        <p14:section name="Findings" id="{19b7609a-ae34-08fd-c1f8-9a86ee74b82b}">
+        <p14:section name="Findings" id="{65a36701-a579-56e4-7665-288a5b5b09d7}">
           <p14:sldIdLst>
             <p14:sldId id="261"/>
             <p14:sldId id="262"/>
@@ -148,7 +148,7 @@
             <p14:sldId id="268"/>
           </p14:sldIdLst>
         </p14:section>
-        <p14:section name="Method" id="{2f296922-1049-0344-1c34-8bacb321cbb9}">
+        <p14:section name="Method" id="{34f96340-6d9f-d7ce-9cd0-765c9972e527}">
           <p14:sldIdLst>
             <p14:sldId id="269"/>
             <p14:sldId id="270"/>
@@ -159,7 +159,7 @@
             <p14:sldId id="275"/>
           </p14:sldIdLst>
         </p14:section>
-        <p14:section name="Next" id="{5d763f58-1750-9484-6a73-f0dec228d067}">
+        <p14:section name="Next" id="{91972bd1-e273-260c-d9c1-78f6a6fc9cdf}">
           <p14:sldIdLst>
             <p14:sldId id="276"/>
           </p14:sldIdLst>

</xml_diff>

<commit_message>
Talk deck: no competition math or proofs for now, and 'hint' instead of 'fact' (full deck and proposal unchanged)
Co-Authored-By: Claude Opus 5.5 (1M context) <noreply@anthropic.com>
</commit_message>
<xml_diff>
--- a/PROPOSAL_slides_full.pptx
+++ b/PROPOSAL_slides_full.pptx
@@ -127,7 +127,7 @@
   <p:extLst>
     <p:ext uri="{521415D9-36F7-43E2-AB2F-B90AF26B5E84}">
       <p14:sectionLst xmlns:p14="http://schemas.microsoft.com/office/powerpoint/2010/main">
-        <p14:section name="Problem" id="{b960755b-d78f-eddd-e014-254fed8c63b5}">
+        <p14:section name="Problem" id="{87392113-4f02-23e2-88da-982c9fe910a8}">
           <p14:sldIdLst>
             <p14:sldId id="256"/>
             <p14:sldId id="257"/>
@@ -136,7 +136,7 @@
             <p14:sldId id="260"/>
           </p14:sldIdLst>
         </p14:section>
-        <p14:section name="Findings" id="{65a36701-a579-56e4-7665-288a5b5b09d7}">
+        <p14:section name="Findings" id="{1ef1f40d-85b6-b630-4658-339b57e5452e}">
           <p14:sldIdLst>
             <p14:sldId id="261"/>
             <p14:sldId id="262"/>
@@ -148,7 +148,7 @@
             <p14:sldId id="268"/>
           </p14:sldIdLst>
         </p14:section>
-        <p14:section name="Method" id="{34f96340-6d9f-d7ce-9cd0-765c9972e527}">
+        <p14:section name="Method" id="{5b8e7619-5f52-291e-e73f-804828c240ab}">
           <p14:sldIdLst>
             <p14:sldId id="269"/>
             <p14:sldId id="270"/>
@@ -159,7 +159,7 @@
             <p14:sldId id="275"/>
           </p14:sldIdLst>
         </p14:section>
-        <p14:section name="Next" id="{91972bd1-e273-260c-d9c1-78f6a6fc9cdf}">
+        <p14:section name="Next" id="{39fa0d6b-8ea7-38d4-f235-04980902c1f5}">
           <p14:sldIdLst>
             <p14:sldId id="276"/>
           </p14:sldIdLst>

</xml_diff>

<commit_message>
Talk: which kinds use each step of the method (no hint for contest problems, reuse for routing); team members on the title
Co-Authored-By: Claude Opus 5.5 (1M context) <noreply@anthropic.com>
</commit_message>
<xml_diff>
--- a/PROPOSAL_slides_full.pptx
+++ b/PROPOSAL_slides_full.pptx
@@ -127,7 +127,7 @@
   <p:extLst>
     <p:ext uri="{521415D9-36F7-43E2-AB2F-B90AF26B5E84}">
       <p14:sectionLst xmlns:p14="http://schemas.microsoft.com/office/powerpoint/2010/main">
-        <p14:section name="Problem" id="{87392113-4f02-23e2-88da-982c9fe910a8}">
+        <p14:section name="Problem" id="{d59dc68c-b77f-81ac-6005-6d49075076f4}">
           <p14:sldIdLst>
             <p14:sldId id="256"/>
             <p14:sldId id="257"/>
@@ -136,7 +136,7 @@
             <p14:sldId id="260"/>
           </p14:sldIdLst>
         </p14:section>
-        <p14:section name="Findings" id="{1ef1f40d-85b6-b630-4658-339b57e5452e}">
+        <p14:section name="Findings" id="{c2d11459-5dba-f727-1c4c-f8b05c0ed12c}">
           <p14:sldIdLst>
             <p14:sldId id="261"/>
             <p14:sldId id="262"/>
@@ -148,7 +148,7 @@
             <p14:sldId id="268"/>
           </p14:sldIdLst>
         </p14:section>
-        <p14:section name="Method" id="{5b8e7619-5f52-291e-e73f-804828c240ab}">
+        <p14:section name="Method" id="{241931d1-e418-e5e9-0a12-b633e8f61e6e}">
           <p14:sldIdLst>
             <p14:sldId id="269"/>
             <p14:sldId id="270"/>
@@ -159,7 +159,7 @@
             <p14:sldId id="275"/>
           </p14:sldIdLst>
         </p14:section>
-        <p14:section name="Next" id="{39fa0d6b-8ea7-38d4-f235-04980902c1f5}">
+        <p14:section name="Next" id="{b908e79f-d49b-f575-598d-eeb41b950870}">
           <p14:sldIdLst>
             <p14:sldId id="276"/>
           </p14:sldIdLst>
@@ -4041,7 +4041,7 @@
                   <a:srgbClr val="44546A"/>
                 </a:solidFill>
               </a:rPr>
-              <a:t>POSTECH CSED490E (Graduate NLP) · Team 5 · October 2026</a:t>
+              <a:t>Team 5: Sangjun Lee, Seongbin Park · POSTECH CSED490E (Graduate NLP) · October 2026</a:t>
             </a:r>
             <a:endParaRPr lang="en-US" sz="2200" dirty="0"/>
           </a:p>

</xml_diff>

<commit_message>
Talk: plain thank-you slide; the expected-question index moves to its speaker notes
Co-Authored-By: Claude Opus 5.5 (1M context) <noreply@anthropic.com>
</commit_message>
<xml_diff>
--- a/PROPOSAL_slides_full.pptx
+++ b/PROPOSAL_slides_full.pptx
@@ -127,7 +127,7 @@
   <p:extLst>
     <p:ext uri="{521415D9-36F7-43E2-AB2F-B90AF26B5E84}">
       <p14:sectionLst xmlns:p14="http://schemas.microsoft.com/office/powerpoint/2010/main">
-        <p14:section name="Problem" id="{d59dc68c-b77f-81ac-6005-6d49075076f4}">
+        <p14:section name="Problem" id="{1902cdd7-6de0-822a-8890-53cf311adf4d}">
           <p14:sldIdLst>
             <p14:sldId id="256"/>
             <p14:sldId id="257"/>
@@ -136,7 +136,7 @@
             <p14:sldId id="260"/>
           </p14:sldIdLst>
         </p14:section>
-        <p14:section name="Findings" id="{c2d11459-5dba-f727-1c4c-f8b05c0ed12c}">
+        <p14:section name="Findings" id="{5c6b4139-faca-8bef-e5d5-98008ee3149c}">
           <p14:sldIdLst>
             <p14:sldId id="261"/>
             <p14:sldId id="262"/>
@@ -148,7 +148,7 @@
             <p14:sldId id="268"/>
           </p14:sldIdLst>
         </p14:section>
-        <p14:section name="Method" id="{241931d1-e418-e5e9-0a12-b633e8f61e6e}">
+        <p14:section name="Method" id="{6cfad947-2176-33ce-e362-a43b681f492c}">
           <p14:sldIdLst>
             <p14:sldId id="269"/>
             <p14:sldId id="270"/>
@@ -159,7 +159,7 @@
             <p14:sldId id="275"/>
           </p14:sldIdLst>
         </p14:section>
-        <p14:section name="Next" id="{b908e79f-d49b-f575-598d-eeb41b950870}">
+        <p14:section name="Next" id="{9f0523fe-7492-be23-d400-b5cba25f3664}">
           <p14:sldIdLst>
             <p14:sldId id="276"/>
           </p14:sldIdLst>

</xml_diff>

<commit_message>
Coverage page: the measured contest hint result (8 geometry helpers hurt gpt-oss-20b), with the reason
Co-Authored-By: Claude Opus 5.5 (1M context) <noreply@anthropic.com>
</commit_message>
<xml_diff>
--- a/PROPOSAL_slides_full.pptx
+++ b/PROPOSAL_slides_full.pptx
@@ -127,7 +127,7 @@
   <p:extLst>
     <p:ext uri="{521415D9-36F7-43E2-AB2F-B90AF26B5E84}">
       <p14:sectionLst xmlns:p14="http://schemas.microsoft.com/office/powerpoint/2010/main">
-        <p14:section name="Problem" id="{1902cdd7-6de0-822a-8890-53cf311adf4d}">
+        <p14:section name="Problem" id="{9936f27f-de02-37a1-8009-efaf5fa1bfa3}">
           <p14:sldIdLst>
             <p14:sldId id="256"/>
             <p14:sldId id="257"/>
@@ -136,7 +136,7 @@
             <p14:sldId id="260"/>
           </p14:sldIdLst>
         </p14:section>
-        <p14:section name="Findings" id="{5c6b4139-faca-8bef-e5d5-98008ee3149c}">
+        <p14:section name="Findings" id="{08fb30f0-0315-838a-8cc8-e1ef4ab2be86}">
           <p14:sldIdLst>
             <p14:sldId id="261"/>
             <p14:sldId id="262"/>
@@ -148,7 +148,7 @@
             <p14:sldId id="268"/>
           </p14:sldIdLst>
         </p14:section>
-        <p14:section name="Method" id="{6cfad947-2176-33ce-e362-a43b681f492c}">
+        <p14:section name="Method" id="{535827af-97bf-9e26-2bf3-4b3cffce2766}">
           <p14:sldIdLst>
             <p14:sldId id="269"/>
             <p14:sldId id="270"/>
@@ -159,7 +159,7 @@
             <p14:sldId id="275"/>
           </p14:sldIdLst>
         </p14:section>
-        <p14:section name="Next" id="{9f0523fe-7492-be23-d400-b5cba25f3664}">
+        <p14:section name="Next" id="{eaaefc74-96d6-55b6-6341-c61f66b7c982}">
           <p14:sldIdLst>
             <p14:sldId id="276"/>
           </p14:sldIdLst>

</xml_diff>

<commit_message>
Talk slide 8 notes: a timed core script plus a detailed explanation for questions
Co-Authored-By: Claude Opus 5.5 (1M context) <noreply@anthropic.com>
</commit_message>
<xml_diff>
--- a/PROPOSAL_slides_full.pptx
+++ b/PROPOSAL_slides_full.pptx
@@ -127,7 +127,7 @@
   <p:extLst>
     <p:ext uri="{521415D9-36F7-43E2-AB2F-B90AF26B5E84}">
       <p14:sectionLst xmlns:p14="http://schemas.microsoft.com/office/powerpoint/2010/main">
-        <p14:section name="Problem" id="{9936f27f-de02-37a1-8009-efaf5fa1bfa3}">
+        <p14:section name="Problem" id="{c75fa3a1-03e8-7593-33da-0838a1c47803}">
           <p14:sldIdLst>
             <p14:sldId id="256"/>
             <p14:sldId id="257"/>
@@ -136,7 +136,7 @@
             <p14:sldId id="260"/>
           </p14:sldIdLst>
         </p14:section>
-        <p14:section name="Findings" id="{08fb30f0-0315-838a-8cc8-e1ef4ab2be86}">
+        <p14:section name="Findings" id="{cd08fcd6-7450-872a-8f97-a36b1d98cfdd}">
           <p14:sldIdLst>
             <p14:sldId id="261"/>
             <p14:sldId id="262"/>
@@ -148,7 +148,7 @@
             <p14:sldId id="268"/>
           </p14:sldIdLst>
         </p14:section>
-        <p14:section name="Method" id="{535827af-97bf-9e26-2bf3-4b3cffce2766}">
+        <p14:section name="Method" id="{c173ff01-ef94-0cce-72f9-92fc65b8f9bb}">
           <p14:sldIdLst>
             <p14:sldId id="269"/>
             <p14:sldId id="270"/>
@@ -159,7 +159,7 @@
             <p14:sldId id="275"/>
           </p14:sldIdLst>
         </p14:section>
-        <p14:section name="Next" id="{eaaefc74-96d6-55b6-6341-c61f66b7c982}">
+        <p14:section name="Next" id="{894affb5-77fb-4620-a207-50ca2e50e414}">
           <p14:sldIdLst>
             <p14:sldId id="276"/>
           </p14:sldIdLst>

</xml_diff>

<commit_message>
Talk slide 7: the 87% bar says it uses a hand-written hint; notes give the retrieved-hint 84%
Co-Authored-By: Claude Opus 5.5 (1M context) <noreply@anthropic.com>
</commit_message>
<xml_diff>
--- a/PROPOSAL_slides_full.pptx
+++ b/PROPOSAL_slides_full.pptx
@@ -127,7 +127,7 @@
   <p:extLst>
     <p:ext uri="{521415D9-36F7-43E2-AB2F-B90AF26B5E84}">
       <p14:sectionLst xmlns:p14="http://schemas.microsoft.com/office/powerpoint/2010/main">
-        <p14:section name="Problem" id="{c75fa3a1-03e8-7593-33da-0838a1c47803}">
+        <p14:section name="Problem" id="{e623eecb-07e1-c0e8-68c7-262b26cdb617}">
           <p14:sldIdLst>
             <p14:sldId id="256"/>
             <p14:sldId id="257"/>
@@ -136,7 +136,7 @@
             <p14:sldId id="260"/>
           </p14:sldIdLst>
         </p14:section>
-        <p14:section name="Findings" id="{cd08fcd6-7450-872a-8f97-a36b1d98cfdd}">
+        <p14:section name="Findings" id="{25dfc544-fbbe-1456-3b4c-f955be99caf7}">
           <p14:sldIdLst>
             <p14:sldId id="261"/>
             <p14:sldId id="262"/>
@@ -148,7 +148,7 @@
             <p14:sldId id="268"/>
           </p14:sldIdLst>
         </p14:section>
-        <p14:section name="Method" id="{c173ff01-ef94-0cce-72f9-92fc65b8f9bb}">
+        <p14:section name="Method" id="{7ccb47f1-7eb0-efeb-1cb3-5a68dd7c4469}">
           <p14:sldIdLst>
             <p14:sldId id="269"/>
             <p14:sldId id="270"/>
@@ -159,7 +159,7 @@
             <p14:sldId id="275"/>
           </p14:sldIdLst>
         </p14:section>
-        <p14:section name="Next" id="{894affb5-77fb-4620-a207-50ca2e50e414}">
+        <p14:section name="Next" id="{2faebc04-5c60-97b0-8ae0-0fc08f481435}">
           <p14:sldIdLst>
             <p14:sldId id="276"/>
           </p14:sldIdLst>

</xml_diff>

<commit_message>
Talk slides 7-8: say what each number compares (79% = 79%, 74 vs 87%, 69.5%), in the slides and the Korean script
Co-Authored-By: Claude Opus 5.5 (1M context) <noreply@anthropic.com>
</commit_message>
<xml_diff>
--- a/PROPOSAL_slides_full.pptx
+++ b/PROPOSAL_slides_full.pptx
@@ -127,7 +127,7 @@
   <p:extLst>
     <p:ext uri="{521415D9-36F7-43E2-AB2F-B90AF26B5E84}">
       <p14:sectionLst xmlns:p14="http://schemas.microsoft.com/office/powerpoint/2010/main">
-        <p14:section name="Problem" id="{e623eecb-07e1-c0e8-68c7-262b26cdb617}">
+        <p14:section name="Problem" id="{8b28a6c8-16b3-cb88-b653-9b0521213825}">
           <p14:sldIdLst>
             <p14:sldId id="256"/>
             <p14:sldId id="257"/>
@@ -136,7 +136,7 @@
             <p14:sldId id="260"/>
           </p14:sldIdLst>
         </p14:section>
-        <p14:section name="Findings" id="{25dfc544-fbbe-1456-3b4c-f955be99caf7}">
+        <p14:section name="Findings" id="{acfcf204-df19-7ce4-7c15-0317276e9edf}">
           <p14:sldIdLst>
             <p14:sldId id="261"/>
             <p14:sldId id="262"/>
@@ -148,7 +148,7 @@
             <p14:sldId id="268"/>
           </p14:sldIdLst>
         </p14:section>
-        <p14:section name="Method" id="{7ccb47f1-7eb0-efeb-1cb3-5a68dd7c4469}">
+        <p14:section name="Method" id="{bd522700-be31-7c67-c3cd-55c3b4d6a36a}">
           <p14:sldIdLst>
             <p14:sldId id="269"/>
             <p14:sldId id="270"/>
@@ -159,7 +159,7 @@
             <p14:sldId id="275"/>
           </p14:sldIdLst>
         </p14:section>
-        <p14:section name="Next" id="{2faebc04-5c60-97b0-8ae0-0fc08f481435}">
+        <p14:section name="Next" id="{dea48643-2341-9bb5-8966-a30f8b814df8}">
           <p14:sldIdLst>
             <p14:sldId id="276"/>
           </p14:sldIdLst>

</xml_diff>

<commit_message>
Talk slide 6: what a free check is (pass / fail flow) and one example per check
Co-Authored-By: Claude Opus 5.5 (1M context) <noreply@anthropic.com>
</commit_message>
<xml_diff>
--- a/PROPOSAL_slides_full.pptx
+++ b/PROPOSAL_slides_full.pptx
@@ -127,7 +127,7 @@
   <p:extLst>
     <p:ext uri="{521415D9-36F7-43E2-AB2F-B90AF26B5E84}">
       <p14:sectionLst xmlns:p14="http://schemas.microsoft.com/office/powerpoint/2010/main">
-        <p14:section name="Problem" id="{8b28a6c8-16b3-cb88-b653-9b0521213825}">
+        <p14:section name="Problem" id="{e96cd126-8135-244d-6a7e-5903c49dce17}">
           <p14:sldIdLst>
             <p14:sldId id="256"/>
             <p14:sldId id="257"/>
@@ -136,7 +136,7 @@
             <p14:sldId id="260"/>
           </p14:sldIdLst>
         </p14:section>
-        <p14:section name="Findings" id="{acfcf204-df19-7ce4-7c15-0317276e9edf}">
+        <p14:section name="Findings" id="{6d9f6a6f-aa0a-8916-168d-24ea263fb418}">
           <p14:sldIdLst>
             <p14:sldId id="261"/>
             <p14:sldId id="262"/>
@@ -148,7 +148,7 @@
             <p14:sldId id="268"/>
           </p14:sldIdLst>
         </p14:section>
-        <p14:section name="Method" id="{bd522700-be31-7c67-c3cd-55c3b4d6a36a}">
+        <p14:section name="Method" id="{71d5d9d5-9acc-0434-da7d-950d90a4c0c7}">
           <p14:sldIdLst>
             <p14:sldId id="269"/>
             <p14:sldId id="270"/>
@@ -159,7 +159,7 @@
             <p14:sldId id="275"/>
           </p14:sldIdLst>
         </p14:section>
-        <p14:section name="Next" id="{dea48643-2341-9bb5-8966-a30f8b814df8}">
+        <p14:section name="Next" id="{ffa4a84f-90fb-9e87-9e86-e2a87bd46d69}">
           <p14:sldIdLst>
             <p14:sldId id="276"/>
           </p14:sldIdLst>

</xml_diff>

<commit_message>
Talk: slide 6 shows how the free check runs; an extra page on how the hint is obtained; no 'Graduate NLP' on the title
Co-Authored-By: Claude Opus 5.5 (1M context) <noreply@anthropic.com>
</commit_message>
<xml_diff>
--- a/PROPOSAL_slides_full.pptx
+++ b/PROPOSAL_slides_full.pptx
@@ -127,7 +127,7 @@
   <p:extLst>
     <p:ext uri="{521415D9-36F7-43E2-AB2F-B90AF26B5E84}">
       <p14:sectionLst xmlns:p14="http://schemas.microsoft.com/office/powerpoint/2010/main">
-        <p14:section name="Problem" id="{e96cd126-8135-244d-6a7e-5903c49dce17}">
+        <p14:section name="Problem" id="{3009161b-ef03-6238-d7f3-d54843eef319}">
           <p14:sldIdLst>
             <p14:sldId id="256"/>
             <p14:sldId id="257"/>
@@ -136,7 +136,7 @@
             <p14:sldId id="260"/>
           </p14:sldIdLst>
         </p14:section>
-        <p14:section name="Findings" id="{6d9f6a6f-aa0a-8916-168d-24ea263fb418}">
+        <p14:section name="Findings" id="{9aecb82e-b459-8660-6fa5-d65b3e4a1d4c}">
           <p14:sldIdLst>
             <p14:sldId id="261"/>
             <p14:sldId id="262"/>
@@ -148,7 +148,7 @@
             <p14:sldId id="268"/>
           </p14:sldIdLst>
         </p14:section>
-        <p14:section name="Method" id="{71d5d9d5-9acc-0434-da7d-950d90a4c0c7}">
+        <p14:section name="Method" id="{c3b33efb-1d8e-68c9-e899-3282fbc47c59}">
           <p14:sldIdLst>
             <p14:sldId id="269"/>
             <p14:sldId id="270"/>
@@ -159,7 +159,7 @@
             <p14:sldId id="275"/>
           </p14:sldIdLst>
         </p14:section>
-        <p14:section name="Next" id="{ffa4a84f-90fb-9e87-9e86-e2a87bd46d69}">
+        <p14:section name="Next" id="{dbe16ca0-55a0-444e-f78b-2c3d221de53d}">
           <p14:sldIdLst>
             <p14:sldId id="276"/>
           </p14:sldIdLst>

</xml_diff>

<commit_message>
Talk slide 6 remade: how a free check works on one example, and what it buys
Co-Authored-By: Claude Opus 5.5 (1M context) <noreply@anthropic.com>
</commit_message>
<xml_diff>
--- a/PROPOSAL_slides_full.pptx
+++ b/PROPOSAL_slides_full.pptx
@@ -127,7 +127,7 @@
   <p:extLst>
     <p:ext uri="{521415D9-36F7-43E2-AB2F-B90AF26B5E84}">
       <p14:sectionLst xmlns:p14="http://schemas.microsoft.com/office/powerpoint/2010/main">
-        <p14:section name="Problem" id="{3009161b-ef03-6238-d7f3-d54843eef319}">
+        <p14:section name="Problem" id="{147d37c1-830b-9f21-16fe-1aa57fc970ce}">
           <p14:sldIdLst>
             <p14:sldId id="256"/>
             <p14:sldId id="257"/>
@@ -136,7 +136,7 @@
             <p14:sldId id="260"/>
           </p14:sldIdLst>
         </p14:section>
-        <p14:section name="Findings" id="{9aecb82e-b459-8660-6fa5-d65b3e4a1d4c}">
+        <p14:section name="Findings" id="{5f8a3963-b4d2-3f5a-602d-178e12eb1742}">
           <p14:sldIdLst>
             <p14:sldId id="261"/>
             <p14:sldId id="262"/>
@@ -148,7 +148,7 @@
             <p14:sldId id="268"/>
           </p14:sldIdLst>
         </p14:section>
-        <p14:section name="Method" id="{c3b33efb-1d8e-68c9-e899-3282fbc47c59}">
+        <p14:section name="Method" id="{1069d46a-bdec-21de-4d86-287c56e2a087}">
           <p14:sldIdLst>
             <p14:sldId id="269"/>
             <p14:sldId id="270"/>
@@ -159,7 +159,7 @@
             <p14:sldId id="275"/>
           </p14:sldIdLst>
         </p14:section>
-        <p14:section name="Next" id="{dbe16ca0-55a0-444e-f78b-2c3d221de53d}">
+        <p14:section name="Next" id="{e472d626-401d-cc72-68da-c6e392915cee}">
           <p14:sldIdLst>
             <p14:sldId id="276"/>
           </p14:sldIdLst>

</xml_diff>

<commit_message>
Talk slides 5, 7, 8 remade: how the hint is given and where it comes from; the method in four steps with one real problem; topics on the comparison rows
Co-Authored-By: Claude Opus 5.5 (1M context) <noreply@anthropic.com>
</commit_message>
<xml_diff>
--- a/PROPOSAL_slides_full.pptx
+++ b/PROPOSAL_slides_full.pptx
@@ -127,7 +127,7 @@
   <p:extLst>
     <p:ext uri="{521415D9-36F7-43E2-AB2F-B90AF26B5E84}">
       <p14:sectionLst xmlns:p14="http://schemas.microsoft.com/office/powerpoint/2010/main">
-        <p14:section name="Problem" id="{147d37c1-830b-9f21-16fe-1aa57fc970ce}">
+        <p14:section name="Problem" id="{7a82c4db-d656-5fc3-78c1-b04ed5da6196}">
           <p14:sldIdLst>
             <p14:sldId id="256"/>
             <p14:sldId id="257"/>
@@ -136,7 +136,7 @@
             <p14:sldId id="260"/>
           </p14:sldIdLst>
         </p14:section>
-        <p14:section name="Findings" id="{5f8a3963-b4d2-3f5a-602d-178e12eb1742}">
+        <p14:section name="Findings" id="{b7bf0b2b-6e0d-a264-bf21-ceb24988bbad}">
           <p14:sldIdLst>
             <p14:sldId id="261"/>
             <p14:sldId id="262"/>
@@ -148,7 +148,7 @@
             <p14:sldId id="268"/>
           </p14:sldIdLst>
         </p14:section>
-        <p14:section name="Method" id="{1069d46a-bdec-21de-4d86-287c56e2a087}">
+        <p14:section name="Method" id="{b66f9615-5a93-1d74-61e8-91072bb7bf92}">
           <p14:sldIdLst>
             <p14:sldId id="269"/>
             <p14:sldId id="270"/>
@@ -159,7 +159,7 @@
             <p14:sldId id="275"/>
           </p14:sldIdLst>
         </p14:section>
-        <p14:section name="Next" id="{e472d626-401d-cc72-68da-c6e392915cee}">
+        <p14:section name="Next" id="{44d88976-0037-bab9-53ea-70c5e61e256f}">
           <p14:sldIdLst>
             <p14:sldId id="276"/>
           </p14:sldIdLst>

</xml_diff>

<commit_message>
Talk slide 5: how we pick the hint, as a four-step flow
Co-Authored-By: Claude Opus 5.5 (1M context) <noreply@anthropic.com>
</commit_message>
<xml_diff>
--- a/PROPOSAL_slides_full.pptx
+++ b/PROPOSAL_slides_full.pptx
@@ -127,7 +127,7 @@
   <p:extLst>
     <p:ext uri="{521415D9-36F7-43E2-AB2F-B90AF26B5E84}">
       <p14:sectionLst xmlns:p14="http://schemas.microsoft.com/office/powerpoint/2010/main">
-        <p14:section name="Problem" id="{7a82c4db-d656-5fc3-78c1-b04ed5da6196}">
+        <p14:section name="Problem" id="{5fc0f7f7-2a69-cab9-da5a-a833002a1cd0}">
           <p14:sldIdLst>
             <p14:sldId id="256"/>
             <p14:sldId id="257"/>
@@ -136,7 +136,7 @@
             <p14:sldId id="260"/>
           </p14:sldIdLst>
         </p14:section>
-        <p14:section name="Findings" id="{b7bf0b2b-6e0d-a264-bf21-ceb24988bbad}">
+        <p14:section name="Findings" id="{837791fe-924d-4ebc-1b52-38dfb181deb7}">
           <p14:sldIdLst>
             <p14:sldId id="261"/>
             <p14:sldId id="262"/>
@@ -148,7 +148,7 @@
             <p14:sldId id="268"/>
           </p14:sldIdLst>
         </p14:section>
-        <p14:section name="Method" id="{b66f9615-5a93-1d74-61e8-91072bb7bf92}">
+        <p14:section name="Method" id="{48360841-db4b-5153-5a6e-8f3905a03ba8}">
           <p14:sldIdLst>
             <p14:sldId id="269"/>
             <p14:sldId id="270"/>
@@ -159,7 +159,7 @@
             <p14:sldId id="275"/>
           </p14:sldIdLst>
         </p14:section>
-        <p14:section name="Next" id="{44d88976-0037-bab9-53ea-70c5e61e256f}">
+        <p14:section name="Next" id="{8ccc71fc-cd6e-1682-5b15-198f7f89549b}">
           <p14:sldIdLst>
             <p14:sldId id="276"/>
           </p14:sldIdLst>

</xml_diff>

<commit_message>
Talk: no '3 runs' on the main slides (slide 5 shows the 83% mean; notes explain); 'runs' instead of 'seeds' on the extra pages
Co-Authored-By: Claude Opus 5.5 (1M context) <noreply@anthropic.com>
</commit_message>
<xml_diff>
--- a/PROPOSAL_slides_full.pptx
+++ b/PROPOSAL_slides_full.pptx
@@ -127,7 +127,7 @@
   <p:extLst>
     <p:ext uri="{521415D9-36F7-43E2-AB2F-B90AF26B5E84}">
       <p14:sectionLst xmlns:p14="http://schemas.microsoft.com/office/powerpoint/2010/main">
-        <p14:section name="Problem" id="{5fc0f7f7-2a69-cab9-da5a-a833002a1cd0}">
+        <p14:section name="Problem" id="{e1dc72de-ba43-d1c5-ea9a-45333dc4bdfa}">
           <p14:sldIdLst>
             <p14:sldId id="256"/>
             <p14:sldId id="257"/>
@@ -136,7 +136,7 @@
             <p14:sldId id="260"/>
           </p14:sldIdLst>
         </p14:section>
-        <p14:section name="Findings" id="{837791fe-924d-4ebc-1b52-38dfb181deb7}">
+        <p14:section name="Findings" id="{d5f9b0ef-d5c3-fc30-362f-88b41bbc96be}">
           <p14:sldIdLst>
             <p14:sldId id="261"/>
             <p14:sldId id="262"/>
@@ -148,7 +148,7 @@
             <p14:sldId id="268"/>
           </p14:sldIdLst>
         </p14:section>
-        <p14:section name="Method" id="{48360841-db4b-5153-5a6e-8f3905a03ba8}">
+        <p14:section name="Method" id="{6dae0efe-6ad7-c0c1-8169-3c9f70fc7ad8}">
           <p14:sldIdLst>
             <p14:sldId id="269"/>
             <p14:sldId id="270"/>
@@ -159,7 +159,7 @@
             <p14:sldId id="275"/>
           </p14:sldIdLst>
         </p14:section>
-        <p14:section name="Next" id="{8ccc71fc-cd6e-1682-5b15-198f7f89549b}">
+        <p14:section name="Next" id="{524c89ef-ac54-9d38-9de8-c5a5082c7228}">
           <p14:sldIdLst>
             <p14:sldId id="276"/>
           </p14:sldIdLst>

</xml_diff>

<commit_message>
Talk: scripts tightened to fit 5 minutes (about 4.5 min spoken), presenter notes kept
Co-Authored-By: Claude Opus 5.5 (1M context) <noreply@anthropic.com>
</commit_message>
<xml_diff>
--- a/PROPOSAL_slides_full.pptx
+++ b/PROPOSAL_slides_full.pptx
@@ -127,7 +127,7 @@
   <p:extLst>
     <p:ext uri="{521415D9-36F7-43E2-AB2F-B90AF26B5E84}">
       <p14:sectionLst xmlns:p14="http://schemas.microsoft.com/office/powerpoint/2010/main">
-        <p14:section name="Problem" id="{e1dc72de-ba43-d1c5-ea9a-45333dc4bdfa}">
+        <p14:section name="Problem" id="{1eb142b6-6726-f70f-bd2a-5413c10267d0}">
           <p14:sldIdLst>
             <p14:sldId id="256"/>
             <p14:sldId id="257"/>
@@ -136,7 +136,7 @@
             <p14:sldId id="260"/>
           </p14:sldIdLst>
         </p14:section>
-        <p14:section name="Findings" id="{d5f9b0ef-d5c3-fc30-362f-88b41bbc96be}">
+        <p14:section name="Findings" id="{bb89d16d-5c05-84a3-bb6b-ec4abc6c6dbd}">
           <p14:sldIdLst>
             <p14:sldId id="261"/>
             <p14:sldId id="262"/>
@@ -148,7 +148,7 @@
             <p14:sldId id="268"/>
           </p14:sldIdLst>
         </p14:section>
-        <p14:section name="Method" id="{6dae0efe-6ad7-c0c1-8169-3c9f70fc7ad8}">
+        <p14:section name="Method" id="{f79e4da5-6ee4-2914-a2d8-d828db4694a5}">
           <p14:sldIdLst>
             <p14:sldId id="269"/>
             <p14:sldId id="270"/>
@@ -159,7 +159,7 @@
             <p14:sldId id="275"/>
           </p14:sldIdLst>
         </p14:section>
-        <p14:section name="Next" id="{524c89ef-ac54-9d38-9de8-c5a5082c7228}">
+        <p14:section name="Next" id="{f28ccd5e-c1cb-676d-653f-d13a47d2f325}">
           <p14:sldIdLst>
             <p14:sldId id="276"/>
           </p14:sldIdLst>

</xml_diff>

<commit_message>
Talk slide 5: hint picking in three short boxes
Co-Authored-By: Claude Opus 5.5 (1M context) <noreply@anthropic.com>
</commit_message>
<xml_diff>
--- a/PROPOSAL_slides_full.pptx
+++ b/PROPOSAL_slides_full.pptx
@@ -127,7 +127,7 @@
   <p:extLst>
     <p:ext uri="{521415D9-36F7-43E2-AB2F-B90AF26B5E84}">
       <p14:sectionLst xmlns:p14="http://schemas.microsoft.com/office/powerpoint/2010/main">
-        <p14:section name="Problem" id="{1eb142b6-6726-f70f-bd2a-5413c10267d0}">
+        <p14:section name="Problem" id="{2e9cc04c-6d47-e1fc-2f3f-7e99be2af3b1}">
           <p14:sldIdLst>
             <p14:sldId id="256"/>
             <p14:sldId id="257"/>
@@ -136,7 +136,7 @@
             <p14:sldId id="260"/>
           </p14:sldIdLst>
         </p14:section>
-        <p14:section name="Findings" id="{bb89d16d-5c05-84a3-bb6b-ec4abc6c6dbd}">
+        <p14:section name="Findings" id="{1319def9-61b8-3641-e87d-71edb983d5ed}">
           <p14:sldIdLst>
             <p14:sldId id="261"/>
             <p14:sldId id="262"/>
@@ -148,7 +148,7 @@
             <p14:sldId id="268"/>
           </p14:sldIdLst>
         </p14:section>
-        <p14:section name="Method" id="{f79e4da5-6ee4-2914-a2d8-d828db4694a5}">
+        <p14:section name="Method" id="{085db376-14ea-82e6-434b-d2238d876ae7}">
           <p14:sldIdLst>
             <p14:sldId id="269"/>
             <p14:sldId id="270"/>
@@ -159,7 +159,7 @@
             <p14:sldId id="275"/>
           </p14:sldIdLst>
         </p14:section>
-        <p14:section name="Next" id="{f28ccd5e-c1cb-676d-653f-d13a47d2f325}">
+        <p14:section name="Next" id="{01bd93c6-0243-fbb5-1563-ad143c9b43ab}">
           <p14:sldIdLst>
             <p14:sldId id="276"/>
           </p14:sldIdLst>

</xml_diff>

<commit_message>
Talk: how we pick the hint moves from Finding 1 to the method slide
Co-Authored-By: Claude Opus 5.5 (1M context) <noreply@anthropic.com>
</commit_message>
<xml_diff>
--- a/PROPOSAL_slides_full.pptx
+++ b/PROPOSAL_slides_full.pptx
@@ -127,7 +127,7 @@
   <p:extLst>
     <p:ext uri="{521415D9-36F7-43E2-AB2F-B90AF26B5E84}">
       <p14:sectionLst xmlns:p14="http://schemas.microsoft.com/office/powerpoint/2010/main">
-        <p14:section name="Problem" id="{2e9cc04c-6d47-e1fc-2f3f-7e99be2af3b1}">
+        <p14:section name="Problem" id="{c1e1abfc-d705-8567-bd70-f143fb7c430c}">
           <p14:sldIdLst>
             <p14:sldId id="256"/>
             <p14:sldId id="257"/>
@@ -136,7 +136,7 @@
             <p14:sldId id="260"/>
           </p14:sldIdLst>
         </p14:section>
-        <p14:section name="Findings" id="{1319def9-61b8-3641-e87d-71edb983d5ed}">
+        <p14:section name="Findings" id="{08bf928b-09bb-30ba-4931-91d1b56bfdd5}">
           <p14:sldIdLst>
             <p14:sldId id="261"/>
             <p14:sldId id="262"/>
@@ -148,7 +148,7 @@
             <p14:sldId id="268"/>
           </p14:sldIdLst>
         </p14:section>
-        <p14:section name="Method" id="{085db376-14ea-82e6-434b-d2238d876ae7}">
+        <p14:section name="Method" id="{f80db440-4a18-d111-91a3-beacc4b294fc}">
           <p14:sldIdLst>
             <p14:sldId id="269"/>
             <p14:sldId id="270"/>
@@ -159,7 +159,7 @@
             <p14:sldId id="275"/>
           </p14:sldIdLst>
         </p14:section>
-        <p14:section name="Next" id="{01bd93c6-0243-fbb5-1563-ad143c9b43ab}">
+        <p14:section name="Next" id="{71ff919d-b0f2-ab8c-2541-191922c6c6ff}">
           <p14:sldIdLst>
             <p14:sldId id="276"/>
           </p14:sldIdLst>

</xml_diff>

<commit_message>
Talk slide 1: only the focus (math with an exact answer, solved by LLM-written programs)
Co-Authored-By: Claude Opus 5.5 (1M context) <noreply@anthropic.com>
</commit_message>
<xml_diff>
--- a/PROPOSAL_slides_full.pptx
+++ b/PROPOSAL_slides_full.pptx
@@ -127,7 +127,7 @@
   <p:extLst>
     <p:ext uri="{521415D9-36F7-43E2-AB2F-B90AF26B5E84}">
       <p14:sectionLst xmlns:p14="http://schemas.microsoft.com/office/powerpoint/2010/main">
-        <p14:section name="Problem" id="{c1e1abfc-d705-8567-bd70-f143fb7c430c}">
+        <p14:section name="Problem" id="{48d8d1af-4a29-c603-e0bb-02deb6eec10e}">
           <p14:sldIdLst>
             <p14:sldId id="256"/>
             <p14:sldId id="257"/>
@@ -136,7 +136,7 @@
             <p14:sldId id="260"/>
           </p14:sldIdLst>
         </p14:section>
-        <p14:section name="Findings" id="{08bf928b-09bb-30ba-4931-91d1b56bfdd5}">
+        <p14:section name="Findings" id="{29c05d15-7d43-a2e5-d6da-70a882c51ced}">
           <p14:sldIdLst>
             <p14:sldId id="261"/>
             <p14:sldId id="262"/>
@@ -148,7 +148,7 @@
             <p14:sldId id="268"/>
           </p14:sldIdLst>
         </p14:section>
-        <p14:section name="Method" id="{f80db440-4a18-d111-91a3-beacc4b294fc}">
+        <p14:section name="Method" id="{68e22f4d-a864-bda6-24ab-e753a742ec66}">
           <p14:sldIdLst>
             <p14:sldId id="269"/>
             <p14:sldId id="270"/>
@@ -159,7 +159,7 @@
             <p14:sldId id="275"/>
           </p14:sldIdLst>
         </p14:section>
-        <p14:section name="Next" id="{71ff919d-b0f2-ab8c-2541-191922c6c6ff}">
+        <p14:section name="Next" id="{94813173-62e7-1b6c-fd78-bad79fc8aa0f}">
           <p14:sldIdLst>
             <p14:sldId id="276"/>
           </p14:sldIdLst>

</xml_diff>

<commit_message>
Talk slide 6: a one-line definition of the free check
Co-Authored-By: Claude Opus 5.5 (1M context) <noreply@anthropic.com>
</commit_message>
<xml_diff>
--- a/PROPOSAL_slides_full.pptx
+++ b/PROPOSAL_slides_full.pptx
@@ -127,7 +127,7 @@
   <p:extLst>
     <p:ext uri="{521415D9-36F7-43E2-AB2F-B90AF26B5E84}">
       <p14:sectionLst xmlns:p14="http://schemas.microsoft.com/office/powerpoint/2010/main">
-        <p14:section name="Problem" id="{48d8d1af-4a29-c603-e0bb-02deb6eec10e}">
+        <p14:section name="Problem" id="{2e5db623-0fee-3e39-e267-cc09f3eec6e9}">
           <p14:sldIdLst>
             <p14:sldId id="256"/>
             <p14:sldId id="257"/>
@@ -136,7 +136,7 @@
             <p14:sldId id="260"/>
           </p14:sldIdLst>
         </p14:section>
-        <p14:section name="Findings" id="{29c05d15-7d43-a2e5-d6da-70a882c51ced}">
+        <p14:section name="Findings" id="{cd3176e4-5652-bb4c-2e88-7a845ffac94a}">
           <p14:sldIdLst>
             <p14:sldId id="261"/>
             <p14:sldId id="262"/>
@@ -148,7 +148,7 @@
             <p14:sldId id="268"/>
           </p14:sldIdLst>
         </p14:section>
-        <p14:section name="Method" id="{68e22f4d-a864-bda6-24ab-e753a742ec66}">
+        <p14:section name="Method" id="{68dd327d-1ec8-f412-8774-5763a30c990a}">
           <p14:sldIdLst>
             <p14:sldId id="269"/>
             <p14:sldId id="270"/>
@@ -159,7 +159,7 @@
             <p14:sldId id="275"/>
           </p14:sldIdLst>
         </p14:section>
-        <p14:section name="Next" id="{94813173-62e7-1b6c-fd78-bad79fc8aa0f}">
+        <p14:section name="Next" id="{2c0fdc28-3662-9db2-84f7-f5a109e3012b}">
           <p14:sldIdLst>
             <p14:sldId id="276"/>
           </p14:sldIdLst>

</xml_diff>

<commit_message>
Talk extras: how to get a hint that works, and what a hint costs and saves
Co-Authored-By: Claude Opus 5.5 (1M context) <noreply@anthropic.com>
</commit_message>
<xml_diff>
--- a/PROPOSAL_slides_full.pptx
+++ b/PROPOSAL_slides_full.pptx
@@ -127,7 +127,7 @@
   <p:extLst>
     <p:ext uri="{521415D9-36F7-43E2-AB2F-B90AF26B5E84}">
       <p14:sectionLst xmlns:p14="http://schemas.microsoft.com/office/powerpoint/2010/main">
-        <p14:section name="Problem" id="{2e5db623-0fee-3e39-e267-cc09f3eec6e9}">
+        <p14:section name="Problem" id="{54e9ac7f-3d0a-e568-f855-0d51f278504d}">
           <p14:sldIdLst>
             <p14:sldId id="256"/>
             <p14:sldId id="257"/>
@@ -136,7 +136,7 @@
             <p14:sldId id="260"/>
           </p14:sldIdLst>
         </p14:section>
-        <p14:section name="Findings" id="{cd3176e4-5652-bb4c-2e88-7a845ffac94a}">
+        <p14:section name="Findings" id="{3cbd4c6e-8df2-f904-aafc-0c91b98aca73}">
           <p14:sldIdLst>
             <p14:sldId id="261"/>
             <p14:sldId id="262"/>
@@ -148,7 +148,7 @@
             <p14:sldId id="268"/>
           </p14:sldIdLst>
         </p14:section>
-        <p14:section name="Method" id="{68dd327d-1ec8-f412-8774-5763a30c990a}">
+        <p14:section name="Method" id="{63034e75-b4db-a1e0-1887-0fb9fc724c91}">
           <p14:sldIdLst>
             <p14:sldId id="269"/>
             <p14:sldId id="270"/>
@@ -159,7 +159,7 @@
             <p14:sldId id="275"/>
           </p14:sldIdLst>
         </p14:section>
-        <p14:section name="Next" id="{2c0fdc28-3662-9db2-84f7-f5a109e3012b}">
+        <p14:section name="Next" id="{0658703c-0b1f-d9aa-0f44-c5a984ff7952}">
           <p14:sldIdLst>
             <p14:sldId id="276"/>
           </p14:sldIdLst>

</xml_diff>

<commit_message>
Talk slide 6: name the two checks behind 66.3% instead of the examples-only number
Co-Authored-By: Claude Opus 5.5 (1M context) <noreply@anthropic.com>
</commit_message>
<xml_diff>
--- a/PROPOSAL_slides_full.pptx
+++ b/PROPOSAL_slides_full.pptx
@@ -127,7 +127,7 @@
   <p:extLst>
     <p:ext uri="{521415D9-36F7-43E2-AB2F-B90AF26B5E84}">
       <p14:sectionLst xmlns:p14="http://schemas.microsoft.com/office/powerpoint/2010/main">
-        <p14:section name="Problem" id="{54e9ac7f-3d0a-e568-f855-0d51f278504d}">
+        <p14:section name="Problem" id="{0977d7dd-212e-6418-b14b-e3b8ce1b06f8}">
           <p14:sldIdLst>
             <p14:sldId id="256"/>
             <p14:sldId id="257"/>
@@ -136,7 +136,7 @@
             <p14:sldId id="260"/>
           </p14:sldIdLst>
         </p14:section>
-        <p14:section name="Findings" id="{3cbd4c6e-8df2-f904-aafc-0c91b98aca73}">
+        <p14:section name="Findings" id="{8abd75f2-b88c-57b0-124a-4fa3f5592549}">
           <p14:sldIdLst>
             <p14:sldId id="261"/>
             <p14:sldId id="262"/>
@@ -148,7 +148,7 @@
             <p14:sldId id="268"/>
           </p14:sldIdLst>
         </p14:section>
-        <p14:section name="Method" id="{63034e75-b4db-a1e0-1887-0fb9fc724c91}">
+        <p14:section name="Method" id="{3cb28660-243e-8613-c339-f31ad1f4e7fe}">
           <p14:sldIdLst>
             <p14:sldId id="269"/>
             <p14:sldId id="270"/>
@@ -159,7 +159,7 @@
             <p14:sldId id="275"/>
           </p14:sldIdLst>
         </p14:section>
-        <p14:section name="Next" id="{0658703c-0b1f-d9aa-0f44-c5a984ff7952}">
+        <p14:section name="Next" id="{e8b382bc-5e24-e9ad-7a2e-e3a867cd3f1f}">
           <p14:sldIdLst>
             <p14:sldId id="276"/>
           </p14:sldIdLst>

</xml_diff>

<commit_message>
Talk: extra pages on checking well and cheaply; slide 8's next steps are better, cheaper hints and checks
Co-Authored-By: Claude Opus 5.5 (1M context) <noreply@anthropic.com>
</commit_message>
<xml_diff>
--- a/PROPOSAL_slides_full.pptx
+++ b/PROPOSAL_slides_full.pptx
@@ -127,7 +127,7 @@
   <p:extLst>
     <p:ext uri="{521415D9-36F7-43E2-AB2F-B90AF26B5E84}">
       <p14:sectionLst xmlns:p14="http://schemas.microsoft.com/office/powerpoint/2010/main">
-        <p14:section name="Problem" id="{0977d7dd-212e-6418-b14b-e3b8ce1b06f8}">
+        <p14:section name="Problem" id="{f249e226-3426-33ef-1c1a-06f38c487d0c}">
           <p14:sldIdLst>
             <p14:sldId id="256"/>
             <p14:sldId id="257"/>
@@ -136,7 +136,7 @@
             <p14:sldId id="260"/>
           </p14:sldIdLst>
         </p14:section>
-        <p14:section name="Findings" id="{8abd75f2-b88c-57b0-124a-4fa3f5592549}">
+        <p14:section name="Findings" id="{e49e6084-10a0-7c9a-9e25-9e3cd70d32e9}">
           <p14:sldIdLst>
             <p14:sldId id="261"/>
             <p14:sldId id="262"/>
@@ -148,7 +148,7 @@
             <p14:sldId id="268"/>
           </p14:sldIdLst>
         </p14:section>
-        <p14:section name="Method" id="{3cb28660-243e-8613-c339-f31ad1f4e7fe}">
+        <p14:section name="Method" id="{914ecb50-b732-be45-14bc-bc0a537a3d9e}">
           <p14:sldIdLst>
             <p14:sldId id="269"/>
             <p14:sldId id="270"/>
@@ -159,7 +159,7 @@
             <p14:sldId id="275"/>
           </p14:sldIdLst>
         </p14:section>
-        <p14:section name="Next" id="{e8b382bc-5e24-e9ad-7a2e-e3a867cd3f1f}">
+        <p14:section name="Next" id="{74af37da-f652-479e-f5df-a353c67fa358}">
           <p14:sldIdLst>
             <p14:sldId id="276"/>
           </p14:sldIdLst>

</xml_diff>

<commit_message>
Talk slide 8: next steps get the hints and run the checks automatically
Co-Authored-By: Claude Opus 5.5 (1M context) <noreply@anthropic.com>
</commit_message>
<xml_diff>
--- a/PROPOSAL_slides_full.pptx
+++ b/PROPOSAL_slides_full.pptx
@@ -127,7 +127,7 @@
   <p:extLst>
     <p:ext uri="{521415D9-36F7-43E2-AB2F-B90AF26B5E84}">
       <p14:sectionLst xmlns:p14="http://schemas.microsoft.com/office/powerpoint/2010/main">
-        <p14:section name="Problem" id="{f249e226-3426-33ef-1c1a-06f38c487d0c}">
+        <p14:section name="Problem" id="{d90ab1b4-d037-539a-8079-da0835bed749}">
           <p14:sldIdLst>
             <p14:sldId id="256"/>
             <p14:sldId id="257"/>
@@ -136,7 +136,7 @@
             <p14:sldId id="260"/>
           </p14:sldIdLst>
         </p14:section>
-        <p14:section name="Findings" id="{e49e6084-10a0-7c9a-9e25-9e3cd70d32e9}">
+        <p14:section name="Findings" id="{eca1d984-57c2-2cc1-65bd-db7f60102b84}">
           <p14:sldIdLst>
             <p14:sldId id="261"/>
             <p14:sldId id="262"/>
@@ -148,7 +148,7 @@
             <p14:sldId id="268"/>
           </p14:sldIdLst>
         </p14:section>
-        <p14:section name="Method" id="{914ecb50-b732-be45-14bc-bc0a537a3d9e}">
+        <p14:section name="Method" id="{bd7fe09f-6be0-25a8-ba60-80b53f8d2e7b}">
           <p14:sldIdLst>
             <p14:sldId id="269"/>
             <p14:sldId id="270"/>
@@ -159,7 +159,7 @@
             <p14:sldId id="275"/>
           </p14:sldIdLst>
         </p14:section>
-        <p14:section name="Next" id="{74af37da-f652-479e-f5df-a353c67fa358}">
+        <p14:section name="Next" id="{01218259-f38e-064a-c14e-1b75139513a9}">
           <p14:sldIdLst>
             <p14:sldId id="276"/>
           </p14:sldIdLst>

</xml_diff>

<commit_message>
Talk slide 8: next = getting hints and running checks automatically, effectively and cheaply (two panels)
Co-Authored-By: Claude Opus 5.5 (1M context) <noreply@anthropic.com>
</commit_message>
<xml_diff>
--- a/PROPOSAL_slides_full.pptx
+++ b/PROPOSAL_slides_full.pptx
@@ -127,7 +127,7 @@
   <p:extLst>
     <p:ext uri="{521415D9-36F7-43E2-AB2F-B90AF26B5E84}">
       <p14:sectionLst xmlns:p14="http://schemas.microsoft.com/office/powerpoint/2010/main">
-        <p14:section name="Problem" id="{d90ab1b4-d037-539a-8079-da0835bed749}">
+        <p14:section name="Problem" id="{503f1a82-c134-c760-929e-307ab2a2432f}">
           <p14:sldIdLst>
             <p14:sldId id="256"/>
             <p14:sldId id="257"/>
@@ -136,7 +136,7 @@
             <p14:sldId id="260"/>
           </p14:sldIdLst>
         </p14:section>
-        <p14:section name="Findings" id="{eca1d984-57c2-2cc1-65bd-db7f60102b84}">
+        <p14:section name="Findings" id="{1d84d45b-fc6d-7516-f2a9-0174418cf2bc}">
           <p14:sldIdLst>
             <p14:sldId id="261"/>
             <p14:sldId id="262"/>
@@ -148,7 +148,7 @@
             <p14:sldId id="268"/>
           </p14:sldIdLst>
         </p14:section>
-        <p14:section name="Method" id="{bd7fe09f-6be0-25a8-ba60-80b53f8d2e7b}">
+        <p14:section name="Method" id="{c251a046-40da-4203-80ec-8bf61c644c43}">
           <p14:sldIdLst>
             <p14:sldId id="269"/>
             <p14:sldId id="270"/>
@@ -159,7 +159,7 @@
             <p14:sldId id="275"/>
           </p14:sldIdLst>
         </p14:section>
-        <p14:section name="Next" id="{01218259-f38e-064a-c14e-1b75139513a9}">
+        <p14:section name="Next" id="{5f985e08-090f-f33f-5935-8faaea82a037}">
           <p14:sldIdLst>
             <p14:sldId id="276"/>
           </p14:sldIdLst>

</xml_diff>

<commit_message>
Talk slide 8: next part ends with extending to math proofs
Co-Authored-By: Claude Opus 5.5 (1M context) <noreply@anthropic.com>
</commit_message>
<xml_diff>
--- a/PROPOSAL_slides_full.pptx
+++ b/PROPOSAL_slides_full.pptx
@@ -127,7 +127,7 @@
   <p:extLst>
     <p:ext uri="{521415D9-36F7-43E2-AB2F-B90AF26B5E84}">
       <p14:sectionLst xmlns:p14="http://schemas.microsoft.com/office/powerpoint/2010/main">
-        <p14:section name="Problem" id="{503f1a82-c134-c760-929e-307ab2a2432f}">
+        <p14:section name="Problem" id="{15e617f5-9be5-4159-8078-1d110230df6b}">
           <p14:sldIdLst>
             <p14:sldId id="256"/>
             <p14:sldId id="257"/>
@@ -136,7 +136,7 @@
             <p14:sldId id="260"/>
           </p14:sldIdLst>
         </p14:section>
-        <p14:section name="Findings" id="{1d84d45b-fc6d-7516-f2a9-0174418cf2bc}">
+        <p14:section name="Findings" id="{0818b397-03a9-bd70-e776-cbf5d13b1d7b}">
           <p14:sldIdLst>
             <p14:sldId id="261"/>
             <p14:sldId id="262"/>
@@ -148,7 +148,7 @@
             <p14:sldId id="268"/>
           </p14:sldIdLst>
         </p14:section>
-        <p14:section name="Method" id="{c251a046-40da-4203-80ec-8bf61c644c43}">
+        <p14:section name="Method" id="{f26d0da5-1f58-1e0e-4847-be58d43ec767}">
           <p14:sldIdLst>
             <p14:sldId id="269"/>
             <p14:sldId id="270"/>
@@ -159,7 +159,7 @@
             <p14:sldId id="275"/>
           </p14:sldIdLst>
         </p14:section>
-        <p14:section name="Next" id="{5f985e08-090f-f33f-5935-8faaea82a037}">
+        <p14:section name="Next" id="{6215d250-2ec0-6875-9327-a06c02000093}">
           <p14:sldIdLst>
             <p14:sldId id="276"/>
           </p14:sldIdLst>

</xml_diff>

<commit_message>
Talk slide 8: less text; next = three equal cards (automatic hints, sharper free checks, math proofs)
Co-Authored-By: Claude Opus 5.5 (1M context) <noreply@anthropic.com>
</commit_message>
<xml_diff>
--- a/PROPOSAL_slides_full.pptx
+++ b/PROPOSAL_slides_full.pptx
@@ -127,7 +127,7 @@
   <p:extLst>
     <p:ext uri="{521415D9-36F7-43E2-AB2F-B90AF26B5E84}">
       <p14:sectionLst xmlns:p14="http://schemas.microsoft.com/office/powerpoint/2010/main">
-        <p14:section name="Problem" id="{15e617f5-9be5-4159-8078-1d110230df6b}">
+        <p14:section name="Problem" id="{4fda2878-e236-f408-b8f2-07610f7b07fd}">
           <p14:sldIdLst>
             <p14:sldId id="256"/>
             <p14:sldId id="257"/>
@@ -136,7 +136,7 @@
             <p14:sldId id="260"/>
           </p14:sldIdLst>
         </p14:section>
-        <p14:section name="Findings" id="{0818b397-03a9-bd70-e776-cbf5d13b1d7b}">
+        <p14:section name="Findings" id="{2b079878-bf72-dfbb-bf70-146c7ab119d4}">
           <p14:sldIdLst>
             <p14:sldId id="261"/>
             <p14:sldId id="262"/>
@@ -148,7 +148,7 @@
             <p14:sldId id="268"/>
           </p14:sldIdLst>
         </p14:section>
-        <p14:section name="Method" id="{f26d0da5-1f58-1e0e-4847-be58d43ec767}">
+        <p14:section name="Method" id="{f6a2eb0e-714c-88ec-a4de-ce4998c1cb1d}">
           <p14:sldIdLst>
             <p14:sldId id="269"/>
             <p14:sldId id="270"/>
@@ -159,7 +159,7 @@
             <p14:sldId id="275"/>
           </p14:sldIdLst>
         </p14:section>
-        <p14:section name="Next" id="{6215d250-2ec0-6875-9327-a06c02000093}">
+        <p14:section name="Next" id="{45c074d6-0e49-2323-9043-98a647000819}">
           <p14:sldIdLst>
             <p14:sldId id="276"/>
           </p14:sldIdLst>

</xml_diff>

<commit_message>
Talk slide 8: tidier next cards; the 69.5% row names MAMO
Co-Authored-By: Claude Opus 5.5 (1M context) <noreply@anthropic.com>
</commit_message>
<xml_diff>
--- a/PROPOSAL_slides_full.pptx
+++ b/PROPOSAL_slides_full.pptx
@@ -127,7 +127,7 @@
   <p:extLst>
     <p:ext uri="{521415D9-36F7-43E2-AB2F-B90AF26B5E84}">
       <p14:sectionLst xmlns:p14="http://schemas.microsoft.com/office/powerpoint/2010/main">
-        <p14:section name="Problem" id="{4fda2878-e236-f408-b8f2-07610f7b07fd}">
+        <p14:section name="Problem" id="{7f9347b0-57be-f5a6-1c21-1fadc6db2c92}">
           <p14:sldIdLst>
             <p14:sldId id="256"/>
             <p14:sldId id="257"/>
@@ -136,7 +136,7 @@
             <p14:sldId id="260"/>
           </p14:sldIdLst>
         </p14:section>
-        <p14:section name="Findings" id="{2b079878-bf72-dfbb-bf70-146c7ab119d4}">
+        <p14:section name="Findings" id="{a99293f0-66f4-2033-c170-cab91dc0ad9c}">
           <p14:sldIdLst>
             <p14:sldId id="261"/>
             <p14:sldId id="262"/>
@@ -148,7 +148,7 @@
             <p14:sldId id="268"/>
           </p14:sldIdLst>
         </p14:section>
-        <p14:section name="Method" id="{f6a2eb0e-714c-88ec-a4de-ce4998c1cb1d}">
+        <p14:section name="Method" id="{c0ce0b78-b557-9c72-a5f7-09d9b3e545cf}">
           <p14:sldIdLst>
             <p14:sldId id="269"/>
             <p14:sldId id="270"/>
@@ -159,7 +159,7 @@
             <p14:sldId id="275"/>
           </p14:sldIdLst>
         </p14:section>
-        <p14:section name="Next" id="{45c074d6-0e49-2323-9043-98a647000819}">
+        <p14:section name="Next" id="{6f3afa7a-754c-cacd-3a0c-b4ac33e7d5cf}">
           <p14:sldIdLst>
             <p14:sldId id="276"/>
           </p14:sldIdLst>

</xml_diff>

<commit_message>
Talk slide 8: small reference line at the bottom
Co-Authored-By: Claude Opus 5.5 (1M context) <noreply@anthropic.com>
</commit_message>
<xml_diff>
--- a/PROPOSAL_slides_full.pptx
+++ b/PROPOSAL_slides_full.pptx
@@ -127,7 +127,7 @@
   <p:extLst>
     <p:ext uri="{521415D9-36F7-43E2-AB2F-B90AF26B5E84}">
       <p14:sectionLst xmlns:p14="http://schemas.microsoft.com/office/powerpoint/2010/main">
-        <p14:section name="Problem" id="{7f9347b0-57be-f5a6-1c21-1fadc6db2c92}">
+        <p14:section name="Problem" id="{3c36d31f-c7c0-504b-64c2-5a52cc044822}">
           <p14:sldIdLst>
             <p14:sldId id="256"/>
             <p14:sldId id="257"/>
@@ -136,7 +136,7 @@
             <p14:sldId id="260"/>
           </p14:sldIdLst>
         </p14:section>
-        <p14:section name="Findings" id="{a99293f0-66f4-2033-c170-cab91dc0ad9c}">
+        <p14:section name="Findings" id="{68f76bf0-0881-0590-a66d-e16c8499a72b}">
           <p14:sldIdLst>
             <p14:sldId id="261"/>
             <p14:sldId id="262"/>
@@ -148,7 +148,7 @@
             <p14:sldId id="268"/>
           </p14:sldIdLst>
         </p14:section>
-        <p14:section name="Method" id="{c0ce0b78-b557-9c72-a5f7-09d9b3e545cf}">
+        <p14:section name="Method" id="{c1a66e52-24b2-9400-c99f-a21c9445ad0a}">
           <p14:sldIdLst>
             <p14:sldId id="269"/>
             <p14:sldId id="270"/>
@@ -159,7 +159,7 @@
             <p14:sldId id="275"/>
           </p14:sldIdLst>
         </p14:section>
-        <p14:section name="Next" id="{6f3afa7a-754c-cacd-3a0c-b4ac33e7d5cf}">
+        <p14:section name="Next" id="{e78cf637-0da7-f749-38c7-9656707b4fdd}">
           <p14:sldIdLst>
             <p14:sldId id="276"/>
           </p14:sldIdLst>

</xml_diff>

<commit_message>
Talk slide 8: footnote on where 24 GB comes from
Co-Authored-By: Claude Opus 5.5 (1M context) <noreply@anthropic.com>
</commit_message>
<xml_diff>
--- a/PROPOSAL_slides_full.pptx
+++ b/PROPOSAL_slides_full.pptx
@@ -127,7 +127,7 @@
   <p:extLst>
     <p:ext uri="{521415D9-36F7-43E2-AB2F-B90AF26B5E84}">
       <p14:sectionLst xmlns:p14="http://schemas.microsoft.com/office/powerpoint/2010/main">
-        <p14:section name="Problem" id="{3c36d31f-c7c0-504b-64c2-5a52cc044822}">
+        <p14:section name="Problem" id="{589653c1-012a-ea11-f109-6e206524d789}">
           <p14:sldIdLst>
             <p14:sldId id="256"/>
             <p14:sldId id="257"/>
@@ -136,7 +136,7 @@
             <p14:sldId id="260"/>
           </p14:sldIdLst>
         </p14:section>
-        <p14:section name="Findings" id="{68f76bf0-0881-0590-a66d-e16c8499a72b}">
+        <p14:section name="Findings" id="{d1e14310-c530-5e4a-3e51-3619f8046040}">
           <p14:sldIdLst>
             <p14:sldId id="261"/>
             <p14:sldId id="262"/>
@@ -148,7 +148,7 @@
             <p14:sldId id="268"/>
           </p14:sldIdLst>
         </p14:section>
-        <p14:section name="Method" id="{c1a66e52-24b2-9400-c99f-a21c9445ad0a}">
+        <p14:section name="Method" id="{4654b35b-5f33-9ec0-c170-3c6507a3ec3d}">
           <p14:sldIdLst>
             <p14:sldId id="269"/>
             <p14:sldId id="270"/>
@@ -159,7 +159,7 @@
             <p14:sldId id="275"/>
           </p14:sldIdLst>
         </p14:section>
-        <p14:section name="Next" id="{e78cf637-0da7-f749-38c7-9656707b4fdd}">
+        <p14:section name="Next" id="{f298b5b6-e17b-00f5-9b15-b4c7dc6d51f1}">
           <p14:sldIdLst>
             <p14:sldId id="276"/>
           </p14:sldIdLst>

</xml_diff>

<commit_message>
Talk slide 8: drop the 24 GB footnote
Co-Authored-By: Claude Opus 5.5 (1M context) <noreply@anthropic.com>
</commit_message>
<xml_diff>
--- a/PROPOSAL_slides_full.pptx
+++ b/PROPOSAL_slides_full.pptx
@@ -127,7 +127,7 @@
   <p:extLst>
     <p:ext uri="{521415D9-36F7-43E2-AB2F-B90AF26B5E84}">
       <p14:sectionLst xmlns:p14="http://schemas.microsoft.com/office/powerpoint/2010/main">
-        <p14:section name="Problem" id="{589653c1-012a-ea11-f109-6e206524d789}">
+        <p14:section name="Problem" id="{6eeaf727-b504-38b1-c9cb-6e01ca9bed87}">
           <p14:sldIdLst>
             <p14:sldId id="256"/>
             <p14:sldId id="257"/>
@@ -136,7 +136,7 @@
             <p14:sldId id="260"/>
           </p14:sldIdLst>
         </p14:section>
-        <p14:section name="Findings" id="{d1e14310-c530-5e4a-3e51-3619f8046040}">
+        <p14:section name="Findings" id="{b2ea56f5-bcf5-eb2e-f4d0-6dd1c13b10d8}">
           <p14:sldIdLst>
             <p14:sldId id="261"/>
             <p14:sldId id="262"/>
@@ -148,7 +148,7 @@
             <p14:sldId id="268"/>
           </p14:sldIdLst>
         </p14:section>
-        <p14:section name="Method" id="{4654b35b-5f33-9ec0-c170-3c6507a3ec3d}">
+        <p14:section name="Method" id="{b994445e-f5ee-18ec-0edc-8632b453d5d1}">
           <p14:sldIdLst>
             <p14:sldId id="269"/>
             <p14:sldId id="270"/>
@@ -159,7 +159,7 @@
             <p14:sldId id="275"/>
           </p14:sldIdLst>
         </p14:section>
-        <p14:section name="Next" id="{f298b5b6-e17b-00f5-9b15-b4c7dc6d51f1}">
+        <p14:section name="Next" id="{8edcc0ae-0a07-785b-5774-0d74c306006c}">
           <p14:sldIdLst>
             <p14:sldId id="276"/>
           </p14:sldIdLst>

</xml_diff>

<commit_message>
Talk slide 8: the usual way cites numbered references at the bottom
Co-Authored-By: Claude Opus 5.5 (1M context) <noreply@anthropic.com>
</commit_message>
<xml_diff>
--- a/PROPOSAL_slides_full.pptx
+++ b/PROPOSAL_slides_full.pptx
@@ -127,7 +127,7 @@
   <p:extLst>
     <p:ext uri="{521415D9-36F7-43E2-AB2F-B90AF26B5E84}">
       <p14:sectionLst xmlns:p14="http://schemas.microsoft.com/office/powerpoint/2010/main">
-        <p14:section name="Problem" id="{6eeaf727-b504-38b1-c9cb-6e01ca9bed87}">
+        <p14:section name="Problem" id="{4142ae98-5961-eac0-833f-8dfa04a3bfd5}">
           <p14:sldIdLst>
             <p14:sldId id="256"/>
             <p14:sldId id="257"/>
@@ -136,7 +136,7 @@
             <p14:sldId id="260"/>
           </p14:sldIdLst>
         </p14:section>
-        <p14:section name="Findings" id="{b2ea56f5-bcf5-eb2e-f4d0-6dd1c13b10d8}">
+        <p14:section name="Findings" id="{b2a6057f-0908-ef59-6fe5-55ffb43dd2b6}">
           <p14:sldIdLst>
             <p14:sldId id="261"/>
             <p14:sldId id="262"/>
@@ -148,7 +148,7 @@
             <p14:sldId id="268"/>
           </p14:sldIdLst>
         </p14:section>
-        <p14:section name="Method" id="{b994445e-f5ee-18ec-0edc-8632b453d5d1}">
+        <p14:section name="Method" id="{b5b10fee-a882-4f83-c797-96932d9414ff}">
           <p14:sldIdLst>
             <p14:sldId id="269"/>
             <p14:sldId id="270"/>
@@ -159,7 +159,7 @@
             <p14:sldId id="275"/>
           </p14:sldIdLst>
         </p14:section>
-        <p14:section name="Next" id="{8edcc0ae-0a07-785b-5774-0d74c306006c}">
+        <p14:section name="Next" id="{7510783d-3e95-b2cd-ddb9-2c394b7fc803}">
           <p14:sldIdLst>
             <p14:sldId id="276"/>
           </p14:sldIdLst>

</xml_diff>

<commit_message>
Talk slide 8: compare two 8B models (trained vs untrained) instead of a GPU size; say what MAMO is
Co-Authored-By: Claude Opus 5.5 (1M context) <noreply@anthropic.com>
</commit_message>
<xml_diff>
--- a/PROPOSAL_slides_full.pptx
+++ b/PROPOSAL_slides_full.pptx
@@ -127,7 +127,7 @@
   <p:extLst>
     <p:ext uri="{521415D9-36F7-43E2-AB2F-B90AF26B5E84}">
       <p14:sectionLst xmlns:p14="http://schemas.microsoft.com/office/powerpoint/2010/main">
-        <p14:section name="Problem" id="{4142ae98-5961-eac0-833f-8dfa04a3bfd5}">
+        <p14:section name="Problem" id="{93c9709a-13d9-e71c-0a96-a1ce64a23c88}">
           <p14:sldIdLst>
             <p14:sldId id="256"/>
             <p14:sldId id="257"/>
@@ -136,7 +136,7 @@
             <p14:sldId id="260"/>
           </p14:sldIdLst>
         </p14:section>
-        <p14:section name="Findings" id="{b2a6057f-0908-ef59-6fe5-55ffb43dd2b6}">
+        <p14:section name="Findings" id="{fd344979-2e96-b1ed-8fdf-3e4aa0a7fa8a}">
           <p14:sldIdLst>
             <p14:sldId id="261"/>
             <p14:sldId id="262"/>
@@ -148,7 +148,7 @@
             <p14:sldId id="268"/>
           </p14:sldIdLst>
         </p14:section>
-        <p14:section name="Method" id="{b5b10fee-a882-4f83-c797-96932d9414ff}">
+        <p14:section name="Method" id="{4e7e270f-f22c-84e8-6a49-6ab25842c25d}">
           <p14:sldIdLst>
             <p14:sldId id="269"/>
             <p14:sldId id="270"/>
@@ -159,7 +159,7 @@
             <p14:sldId id="275"/>
           </p14:sldIdLst>
         </p14:section>
-        <p14:section name="Next" id="{7510783d-3e95-b2cd-ddb9-2c394b7fc803}">
+        <p14:section name="Next" id="{3485961f-4856-4f6c-46fc-032492bc2ca5}">
           <p14:sldIdLst>
             <p14:sldId id="276"/>
           </p14:sldIdLst>

</xml_diff>

<commit_message>
Talk extra page: hints the first time, built from checked programs as problems arrive
Co-Authored-By: Claude Opus 5.5 (1M context) <noreply@anthropic.com>
</commit_message>
<xml_diff>
--- a/PROPOSAL_slides_full.pptx
+++ b/PROPOSAL_slides_full.pptx
@@ -127,7 +127,7 @@
   <p:extLst>
     <p:ext uri="{521415D9-36F7-43E2-AB2F-B90AF26B5E84}">
       <p14:sectionLst xmlns:p14="http://schemas.microsoft.com/office/powerpoint/2010/main">
-        <p14:section name="Problem" id="{93c9709a-13d9-e71c-0a96-a1ce64a23c88}">
+        <p14:section name="Problem" id="{90b7200f-aef4-029b-91c2-8f60bd155a1a}">
           <p14:sldIdLst>
             <p14:sldId id="256"/>
             <p14:sldId id="257"/>
@@ -136,7 +136,7 @@
             <p14:sldId id="260"/>
           </p14:sldIdLst>
         </p14:section>
-        <p14:section name="Findings" id="{fd344979-2e96-b1ed-8fdf-3e4aa0a7fa8a}">
+        <p14:section name="Findings" id="{2f0f6590-02fe-dc7b-d0a2-b01e96c21639}">
           <p14:sldIdLst>
             <p14:sldId id="261"/>
             <p14:sldId id="262"/>
@@ -148,7 +148,7 @@
             <p14:sldId id="268"/>
           </p14:sldIdLst>
         </p14:section>
-        <p14:section name="Method" id="{4e7e270f-f22c-84e8-6a49-6ab25842c25d}">
+        <p14:section name="Method" id="{88160ca3-78b2-0013-4743-9e8945c2c199}">
           <p14:sldIdLst>
             <p14:sldId id="269"/>
             <p14:sldId id="270"/>
@@ -159,7 +159,7 @@
             <p14:sldId id="275"/>
           </p14:sldIdLst>
         </p14:section>
-        <p14:section name="Next" id="{3485961f-4856-4f6c-46fc-032492bc2ca5}">
+        <p14:section name="Next" id="{364e72f6-b8aa-ac36-7496-7658f302fc58}">
           <p14:sldIdLst>
             <p14:sldId id="276"/>
           </p14:sldIdLst>

</xml_diff>

<commit_message>
Talk slide 7: name the hint pool (its own checked programs on earlier problems)
Co-Authored-By: Claude Opus 5.5 (1M context) <noreply@anthropic.com>
</commit_message>
<xml_diff>
--- a/PROPOSAL_slides_full.pptx
+++ b/PROPOSAL_slides_full.pptx
@@ -127,7 +127,7 @@
   <p:extLst>
     <p:ext uri="{521415D9-36F7-43E2-AB2F-B90AF26B5E84}">
       <p14:sectionLst xmlns:p14="http://schemas.microsoft.com/office/powerpoint/2010/main">
-        <p14:section name="Problem" id="{90b7200f-aef4-029b-91c2-8f60bd155a1a}">
+        <p14:section name="Problem" id="{274df2db-7840-f1a0-4368-4a8a9273476e}">
           <p14:sldIdLst>
             <p14:sldId id="256"/>
             <p14:sldId id="257"/>
@@ -136,7 +136,7 @@
             <p14:sldId id="260"/>
           </p14:sldIdLst>
         </p14:section>
-        <p14:section name="Findings" id="{2f0f6590-02fe-dc7b-d0a2-b01e96c21639}">
+        <p14:section name="Findings" id="{ae59d444-ae4e-67db-8305-37653c9d0c6a}">
           <p14:sldIdLst>
             <p14:sldId id="261"/>
             <p14:sldId id="262"/>
@@ -148,7 +148,7 @@
             <p14:sldId id="268"/>
           </p14:sldIdLst>
         </p14:section>
-        <p14:section name="Method" id="{88160ca3-78b2-0013-4743-9e8945c2c199}">
+        <p14:section name="Method" id="{005c3ed8-627f-7dcc-3676-be4d19622c62}">
           <p14:sldIdLst>
             <p14:sldId id="269"/>
             <p14:sldId id="270"/>
@@ -159,7 +159,7 @@
             <p14:sldId id="275"/>
           </p14:sldIdLst>
         </p14:section>
-        <p14:section name="Next" id="{364e72f6-b8aa-ac36-7496-7658f302fc58}">
+        <p14:section name="Next" id="{05d5b254-10a4-1c33-5836-83eb8f8dde97}">
           <p14:sldIdLst>
             <p14:sldId id="276"/>
           </p14:sldIdLst>

</xml_diff>

<commit_message>
Talk extra page: what a hint is (usage, not the answer) and what it does
Co-Authored-By: Claude Opus 5.5 (1M context) <noreply@anthropic.com>
</commit_message>
<xml_diff>
--- a/PROPOSAL_slides_full.pptx
+++ b/PROPOSAL_slides_full.pptx
@@ -127,7 +127,7 @@
   <p:extLst>
     <p:ext uri="{521415D9-36F7-43E2-AB2F-B90AF26B5E84}">
       <p14:sectionLst xmlns:p14="http://schemas.microsoft.com/office/powerpoint/2010/main">
-        <p14:section name="Problem" id="{274df2db-7840-f1a0-4368-4a8a9273476e}">
+        <p14:section name="Problem" id="{ca2af707-28af-500a-bfd7-a16c80e1888f}">
           <p14:sldIdLst>
             <p14:sldId id="256"/>
             <p14:sldId id="257"/>
@@ -136,7 +136,7 @@
             <p14:sldId id="260"/>
           </p14:sldIdLst>
         </p14:section>
-        <p14:section name="Findings" id="{ae59d444-ae4e-67db-8305-37653c9d0c6a}">
+        <p14:section name="Findings" id="{0887e2fa-c331-c75b-573b-6bbf54101ec8}">
           <p14:sldIdLst>
             <p14:sldId id="261"/>
             <p14:sldId id="262"/>
@@ -148,7 +148,7 @@
             <p14:sldId id="268"/>
           </p14:sldIdLst>
         </p14:section>
-        <p14:section name="Method" id="{005c3ed8-627f-7dcc-3676-be4d19622c62}">
+        <p14:section name="Method" id="{d359d050-23c7-a044-dca3-4da88b860e80}">
           <p14:sldIdLst>
             <p14:sldId id="269"/>
             <p14:sldId id="270"/>
@@ -159,7 +159,7 @@
             <p14:sldId id="275"/>
           </p14:sldIdLst>
         </p14:section>
-        <p14:section name="Next" id="{05d5b254-10a4-1c33-5836-83eb8f8dde97}">
+        <p14:section name="Next" id="{32531df3-4ce8-55a7-80b8-5ec1615981a9}">
           <p14:sldIdLst>
             <p14:sldId id="276"/>
           </p14:sldIdLst>

</xml_diff>

<commit_message>
Talk slide 4: say what programs A and B are, on the slide and in the script
Co-Authored-By: Claude Opus 5.5 (1M context) <noreply@anthropic.com>
</commit_message>
<xml_diff>
--- a/PROPOSAL_slides_full.pptx
+++ b/PROPOSAL_slides_full.pptx
@@ -127,7 +127,7 @@
   <p:extLst>
     <p:ext uri="{521415D9-36F7-43E2-AB2F-B90AF26B5E84}">
       <p14:sectionLst xmlns:p14="http://schemas.microsoft.com/office/powerpoint/2010/main">
-        <p14:section name="Problem" id="{ca2af707-28af-500a-bfd7-a16c80e1888f}">
+        <p14:section name="Problem" id="{c27a4789-91a8-17f3-0776-09ef9f2cc91a}">
           <p14:sldIdLst>
             <p14:sldId id="256"/>
             <p14:sldId id="257"/>
@@ -136,7 +136,7 @@
             <p14:sldId id="260"/>
           </p14:sldIdLst>
         </p14:section>
-        <p14:section name="Findings" id="{0887e2fa-c331-c75b-573b-6bbf54101ec8}">
+        <p14:section name="Findings" id="{ccdc387b-fb02-2b21-3ded-ddbd04f3db0b}">
           <p14:sldIdLst>
             <p14:sldId id="261"/>
             <p14:sldId id="262"/>
@@ -148,7 +148,7 @@
             <p14:sldId id="268"/>
           </p14:sldIdLst>
         </p14:section>
-        <p14:section name="Method" id="{d359d050-23c7-a044-dca3-4da88b860e80}">
+        <p14:section name="Method" id="{6135007a-f03a-e7b7-1e7f-f9de95e411a8}">
           <p14:sldIdLst>
             <p14:sldId id="269"/>
             <p14:sldId id="270"/>
@@ -159,7 +159,7 @@
             <p14:sldId id="275"/>
           </p14:sldIdLst>
         </p14:section>
-        <p14:section name="Next" id="{32531df3-4ce8-55a7-80b8-5ec1615981a9}">
+        <p14:section name="Next" id="{2d5493c8-84e2-4b1f-fe68-50db728205c2}">
           <p14:sldIdLst>
             <p14:sldId id="276"/>
           </p14:sldIdLst>

</xml_diff>

<commit_message>
Talk slide 7: the hint is the shortest checked program, pasted into the prompt as an example
Co-Authored-By: Claude Opus 5.5 (1M context) <noreply@anthropic.com>
</commit_message>
<xml_diff>
--- a/PROPOSAL_slides_full.pptx
+++ b/PROPOSAL_slides_full.pptx
@@ -127,7 +127,7 @@
   <p:extLst>
     <p:ext uri="{521415D9-36F7-43E2-AB2F-B90AF26B5E84}">
       <p14:sectionLst xmlns:p14="http://schemas.microsoft.com/office/powerpoint/2010/main">
-        <p14:section name="Problem" id="{c27a4789-91a8-17f3-0776-09ef9f2cc91a}">
+        <p14:section name="Problem" id="{82eb5bdc-2e6f-a023-5e9b-05a3b76ec182}">
           <p14:sldIdLst>
             <p14:sldId id="256"/>
             <p14:sldId id="257"/>
@@ -136,7 +136,7 @@
             <p14:sldId id="260"/>
           </p14:sldIdLst>
         </p14:section>
-        <p14:section name="Findings" id="{ccdc387b-fb02-2b21-3ded-ddbd04f3db0b}">
+        <p14:section name="Findings" id="{991ed5d1-5d23-5e40-f0e2-2f75e70fe566}">
           <p14:sldIdLst>
             <p14:sldId id="261"/>
             <p14:sldId id="262"/>
@@ -148,7 +148,7 @@
             <p14:sldId id="268"/>
           </p14:sldIdLst>
         </p14:section>
-        <p14:section name="Method" id="{6135007a-f03a-e7b7-1e7f-f9de95e411a8}">
+        <p14:section name="Method" id="{c6af5180-d6da-63ab-665f-eb95fa96d7a6}">
           <p14:sldIdLst>
             <p14:sldId id="269"/>
             <p14:sldId id="270"/>
@@ -159,7 +159,7 @@
             <p14:sldId id="275"/>
           </p14:sldIdLst>
         </p14:section>
-        <p14:section name="Next" id="{2d5493c8-84e2-4b1f-fe68-50db728205c2}">
+        <p14:section name="Next" id="{ad77028a-3f7c-04a2-b567-dbbb37bc3c7e}">
           <p14:sldIdLst>
             <p14:sldId id="276"/>
           </p14:sldIdLst>

</xml_diff>

<commit_message>
Talk slide 7: the hint pool keeps programs that run and print a number
Co-Authored-By: Claude Opus 5.5 (1M context) <noreply@anthropic.com>
</commit_message>
<xml_diff>
--- a/PROPOSAL_slides_full.pptx
+++ b/PROPOSAL_slides_full.pptx
@@ -127,7 +127,7 @@
   <p:extLst>
     <p:ext uri="{521415D9-36F7-43E2-AB2F-B90AF26B5E84}">
       <p14:sectionLst xmlns:p14="http://schemas.microsoft.com/office/powerpoint/2010/main">
-        <p14:section name="Problem" id="{82eb5bdc-2e6f-a023-5e9b-05a3b76ec182}">
+        <p14:section name="Problem" id="{9a6e2163-4d0d-ca38-b647-a6c2ae405622}">
           <p14:sldIdLst>
             <p14:sldId id="256"/>
             <p14:sldId id="257"/>
@@ -136,7 +136,7 @@
             <p14:sldId id="260"/>
           </p14:sldIdLst>
         </p14:section>
-        <p14:section name="Findings" id="{991ed5d1-5d23-5e40-f0e2-2f75e70fe566}">
+        <p14:section name="Findings" id="{87d0bf9e-f5ec-96a8-5a53-a9544e3e2733}">
           <p14:sldIdLst>
             <p14:sldId id="261"/>
             <p14:sldId id="262"/>
@@ -148,7 +148,7 @@
             <p14:sldId id="268"/>
           </p14:sldIdLst>
         </p14:section>
-        <p14:section name="Method" id="{c6af5180-d6da-63ab-665f-eb95fa96d7a6}">
+        <p14:section name="Method" id="{613ccdda-cd72-4500-b5ad-109f7210fb87}">
           <p14:sldIdLst>
             <p14:sldId id="269"/>
             <p14:sldId id="270"/>
@@ -159,7 +159,7 @@
             <p14:sldId id="275"/>
           </p14:sldIdLst>
         </p14:section>
-        <p14:section name="Next" id="{ad77028a-3f7c-04a2-b567-dbbb37bc3c7e}">
+        <p14:section name="Next" id="{8d76434e-7411-75da-ac50-e74ed7d829bd}">
           <p14:sldIdLst>
             <p14:sldId id="276"/>
           </p14:sldIdLst>

</xml_diff>

<commit_message>
Talk: Korean scripts of slides 6 and 7 rewritten to follow the slides
Co-Authored-By: Claude Opus 5.5 (1M context) <noreply@anthropic.com>
</commit_message>
<xml_diff>
--- a/PROPOSAL_slides_full.pptx
+++ b/PROPOSAL_slides_full.pptx
@@ -127,7 +127,7 @@
   <p:extLst>
     <p:ext uri="{521415D9-36F7-43E2-AB2F-B90AF26B5E84}">
       <p14:sectionLst xmlns:p14="http://schemas.microsoft.com/office/powerpoint/2010/main">
-        <p14:section name="Problem" id="{9a6e2163-4d0d-ca38-b647-a6c2ae405622}">
+        <p14:section name="Problem" id="{42d19dfc-2f29-f3cd-5698-93500a5ea5de}">
           <p14:sldIdLst>
             <p14:sldId id="256"/>
             <p14:sldId id="257"/>
@@ -136,7 +136,7 @@
             <p14:sldId id="260"/>
           </p14:sldIdLst>
         </p14:section>
-        <p14:section name="Findings" id="{87d0bf9e-f5ec-96a8-5a53-a9544e3e2733}">
+        <p14:section name="Findings" id="{930f5a59-1bf1-1147-6b42-1baf436f5c63}">
           <p14:sldIdLst>
             <p14:sldId id="261"/>
             <p14:sldId id="262"/>
@@ -148,7 +148,7 @@
             <p14:sldId id="268"/>
           </p14:sldIdLst>
         </p14:section>
-        <p14:section name="Method" id="{613ccdda-cd72-4500-b5ad-109f7210fb87}">
+        <p14:section name="Method" id="{9a6cb7df-9934-4405-2e69-29575a6ddd09}">
           <p14:sldIdLst>
             <p14:sldId id="269"/>
             <p14:sldId id="270"/>
@@ -159,7 +159,7 @@
             <p14:sldId id="275"/>
           </p14:sldIdLst>
         </p14:section>
-        <p14:section name="Next" id="{8d76434e-7411-75da-ac50-e74ed7d829bd}">
+        <p14:section name="Next" id="{347bb467-e445-2565-2140-cc8fd930711c}">
           <p14:sldIdLst>
             <p14:sldId id="276"/>
           </p14:sldIdLst>

</xml_diff>

<commit_message>
Talk: 87% split into check (77%) and hint (87%); how often pool programs and the chosen hint are wrong
Co-Authored-By: Claude Opus 5.5 (1M context) <noreply@anthropic.com>
</commit_message>
<xml_diff>
--- a/PROPOSAL_slides_full.pptx
+++ b/PROPOSAL_slides_full.pptx
@@ -127,7 +127,7 @@
   <p:extLst>
     <p:ext uri="{521415D9-36F7-43E2-AB2F-B90AF26B5E84}">
       <p14:sectionLst xmlns:p14="http://schemas.microsoft.com/office/powerpoint/2010/main">
-        <p14:section name="Problem" id="{42d19dfc-2f29-f3cd-5698-93500a5ea5de}">
+        <p14:section name="Problem" id="{42cba210-0bbd-0cdf-abb6-88056e2595c5}">
           <p14:sldIdLst>
             <p14:sldId id="256"/>
             <p14:sldId id="257"/>
@@ -136,7 +136,7 @@
             <p14:sldId id="260"/>
           </p14:sldIdLst>
         </p14:section>
-        <p14:section name="Findings" id="{930f5a59-1bf1-1147-6b42-1baf436f5c63}">
+        <p14:section name="Findings" id="{4309c658-37c0-5962-c000-7f543e101033}">
           <p14:sldIdLst>
             <p14:sldId id="261"/>
             <p14:sldId id="262"/>
@@ -148,7 +148,7 @@
             <p14:sldId id="268"/>
           </p14:sldIdLst>
         </p14:section>
-        <p14:section name="Method" id="{9a6cb7df-9934-4405-2e69-29575a6ddd09}">
+        <p14:section name="Method" id="{4a98b612-7bd1-f168-8400-e0ef9814a796}">
           <p14:sldIdLst>
             <p14:sldId id="269"/>
             <p14:sldId id="270"/>
@@ -159,7 +159,7 @@
             <p14:sldId id="275"/>
           </p14:sldIdLst>
         </p14:section>
-        <p14:section name="Next" id="{347bb467-e445-2565-2140-cc8fd930711c}">
+        <p14:section name="Next" id="{d6886bd1-c58a-029b-c293-7068f6745da6}">
           <p14:sldIdLst>
             <p14:sldId id="276"/>
           </p14:sldIdLst>

</xml_diff>

<commit_message>
Talk: scripts rewritten along the flow review (stakes, families, closed loop, principle, bridges)
Co-Authored-By: Claude Opus 5.5 (1M context) <noreply@anthropic.com>
</commit_message>
<xml_diff>
--- a/PROPOSAL_slides_full.pptx
+++ b/PROPOSAL_slides_full.pptx
@@ -127,7 +127,7 @@
   <p:extLst>
     <p:ext uri="{521415D9-36F7-43E2-AB2F-B90AF26B5E84}">
       <p14:sectionLst xmlns:p14="http://schemas.microsoft.com/office/powerpoint/2010/main">
-        <p14:section name="Problem" id="{42cba210-0bbd-0cdf-abb6-88056e2595c5}">
+        <p14:section name="Problem" id="{36dfb915-662c-01f9-38c7-a2599ce22dad}">
           <p14:sldIdLst>
             <p14:sldId id="256"/>
             <p14:sldId id="257"/>
@@ -136,7 +136,7 @@
             <p14:sldId id="260"/>
           </p14:sldIdLst>
         </p14:section>
-        <p14:section name="Findings" id="{4309c658-37c0-5962-c000-7f543e101033}">
+        <p14:section name="Findings" id="{cf6bb900-84c1-f8e9-75a9-55624f7c0b4c}">
           <p14:sldIdLst>
             <p14:sldId id="261"/>
             <p14:sldId id="262"/>
@@ -148,7 +148,7 @@
             <p14:sldId id="268"/>
           </p14:sldIdLst>
         </p14:section>
-        <p14:section name="Method" id="{4a98b612-7bd1-f168-8400-e0ef9814a796}">
+        <p14:section name="Method" id="{a3aceedc-5e00-1c8a-54f6-66c53b1ff48b}">
           <p14:sldIdLst>
             <p14:sldId id="269"/>
             <p14:sldId id="270"/>
@@ -159,7 +159,7 @@
             <p14:sldId id="275"/>
           </p14:sldIdLst>
         </p14:section>
-        <p14:section name="Next" id="{d6886bd1-c58a-029b-c293-7068f6745da6}">
+        <p14:section name="Next" id="{6501e0c2-e207-7a3b-278f-99f16c408cf9}">
           <p14:sldIdLst>
             <p14:sldId id="276"/>
           </p14:sldIdLst>

</xml_diff>